<commit_message>
Sunum: platform ve indirme bilgileri eklendi (Windows x64 + macOS arm64, v1.0.0)
- Kapanis slaytina platform/indirme satirlari eklendi: Windows 10/11 (x64) + macOS (Apple Silicon), GitHub Releases v1.0.0 (ozel repo notu ile)
- macOS paketi icin tek cumlelik notarizasyon dipnotu eklendi (ilk acilis: sag tik -> Ac)
- Acilis slaytindaki platform etiketi "Windows x64 · macOS arm64" olarak guncellendi
- PPTX ve PDF ciktilari yeniden uretildi; uretici betik depoya eklendi

Co-Authored-By: Claude Fable 5 <noreply@anthropic.com>
</commit_message>
<xml_diff>
--- a/docs/presentation/French-Course-AI-Trilingual.pptx
+++ b/docs/presentation/French-Course-AI-Trilingual.pptx
@@ -2,18 +2,18 @@
 <file path=ppt/presentation.xml><?xml version="1.0" encoding="utf-8"?>
 <p:presentation xmlns:p="http://schemas.openxmlformats.org/presentationml/2006/main">
   <p:sldMasterIdLst>
-    <p:sldMasterId xmlns:r="http://schemas.openxmlformats.org/officeDocument/2006/relationships" id="2147483648" r:id="R274f159ec9d842a0"/>
+    <p:sldMasterId xmlns:r="http://schemas.openxmlformats.org/officeDocument/2006/relationships" id="2147483648" r:id="Rf34d4c68d41d44f3"/>
   </p:sldMasterIdLst>
   <p:notesMasterIdLst>
-    <p:notesMasterId xmlns:r="http://schemas.openxmlformats.org/officeDocument/2006/relationships" r:id="Reec88b6c44bb47fd"/>
+    <p:notesMasterId xmlns:r="http://schemas.openxmlformats.org/officeDocument/2006/relationships" r:id="R9a521ef66fa04d2d"/>
   </p:notesMasterIdLst>
   <p:sldIdLst>
-    <p:sldId xmlns:r="http://schemas.openxmlformats.org/officeDocument/2006/relationships" id="256" r:id="R1aea4bc2fb844e8b"/>
-    <p:sldId xmlns:r="http://schemas.openxmlformats.org/officeDocument/2006/relationships" id="257" r:id="Rccea15b022f14725"/>
-    <p:sldId xmlns:r="http://schemas.openxmlformats.org/officeDocument/2006/relationships" id="258" r:id="Re58a1d8681524206"/>
-    <p:sldId xmlns:r="http://schemas.openxmlformats.org/officeDocument/2006/relationships" id="259" r:id="R6868c729d104476b"/>
-    <p:sldId xmlns:r="http://schemas.openxmlformats.org/officeDocument/2006/relationships" id="260" r:id="Rf887e7f6d6dd4848"/>
-    <p:sldId xmlns:r="http://schemas.openxmlformats.org/officeDocument/2006/relationships" id="261" r:id="Re580a034154b4c04"/>
+    <p:sldId xmlns:r="http://schemas.openxmlformats.org/officeDocument/2006/relationships" id="256" r:id="R564dd63254de4c90"/>
+    <p:sldId xmlns:r="http://schemas.openxmlformats.org/officeDocument/2006/relationships" id="257" r:id="Rae00c5c8fae64004"/>
+    <p:sldId xmlns:r="http://schemas.openxmlformats.org/officeDocument/2006/relationships" id="258" r:id="Rdf4a51b2a71e4b37"/>
+    <p:sldId xmlns:r="http://schemas.openxmlformats.org/officeDocument/2006/relationships" id="259" r:id="R8df1746dd399459b"/>
+    <p:sldId xmlns:r="http://schemas.openxmlformats.org/officeDocument/2006/relationships" id="260" r:id="R593f0ce49a5a4ac4"/>
+    <p:sldId xmlns:r="http://schemas.openxmlformats.org/officeDocument/2006/relationships" id="261" r:id="R2af68b8838a14e1f"/>
   </p:sldIdLst>
   <p:sldSz cx="12192000" cy="6858000"/>
   <p:notesSz cx="6858000" cy="9144000"/>
@@ -937,6 +937,11 @@
           </a:p>
           <a:p xmlns:a="http://schemas.openxmlformats.org/drawingml/2006/main">
             <a:r>
+              <a:t>- https://github.com/Azizsekerdil/FrenchCourseAI/releases/tag/v1.0.0</a:t>
+            </a:r>
+          </a:p>
+          <a:p xmlns:a="http://schemas.openxmlformats.org/drawingml/2006/main">
+            <a:r>
               <a:t>[/Sources]</a:t>
             </a:r>
           </a:p>
@@ -1005,7 +1010,7 @@
   </p:cSld>
   <p:clrMap bg1="lt1" tx1="dk1" bg2="lt2" tx2="dk2" accent1="accent1" accent2="accent2" accent3="accent3" accent4="accent4" accent5="accent5" accent6="accent6" hlink="hlink" folHlink="folHlink"/>
   <p:sldLayoutIdLst>
-    <p:sldLayoutId xmlns:r="http://schemas.openxmlformats.org/officeDocument/2006/relationships" id="2147483649" r:id="R0c8e5b84db634114"/>
+    <p:sldLayoutId xmlns:r="http://schemas.openxmlformats.org/officeDocument/2006/relationships" id="2147483649" r:id="Rf292dd6faf6d4c09"/>
   </p:sldLayoutIdLst>
   <p:txStyles>
     <p:titleStyle>
@@ -1553,10 +1558,10 @@
       </p:grpSpPr>
       <p:sp>
         <p:nvSpPr>
-          <p:cNvPr id="13" name="box-93">
-            <a:extLst xmlns:a="http://schemas.openxmlformats.org/drawingml/2006/main">
-              <a:ext uri="{FF2B5EF4-FFF2-40B4-BE49-F238E27FC236}">
-                <a16:creationId xmlns:a16="http://schemas.microsoft.com/office/drawing/2014/main" id="{3D6AE8C3-5910-4141-BCAF-183F71316C23}"/>
+          <p:cNvPr id="13" name="box-1">
+            <a:extLst xmlns:a="http://schemas.openxmlformats.org/drawingml/2006/main">
+              <a:ext uri="{FF2B5EF4-FFF2-40B4-BE49-F238E27FC236}">
+                <a16:creationId xmlns:a16="http://schemas.microsoft.com/office/drawing/2014/main" id="{9140175E-7DF3-449B-8099-C92B72681232}"/>
               </a:ext>
             </a:extLst>
           </p:cNvPr>
@@ -1586,10 +1591,10 @@
       </p:sp>
       <p:sp>
         <p:nvSpPr>
-          <p:cNvPr id="2" name="text-94">
-            <a:extLst xmlns:a="http://schemas.openxmlformats.org/drawingml/2006/main">
-              <a:ext uri="{FF2B5EF4-FFF2-40B4-BE49-F238E27FC236}">
-                <a16:creationId xmlns:a16="http://schemas.microsoft.com/office/drawing/2014/main" id="{5890B876-BC73-4325-93E6-847ED7449702}"/>
+          <p:cNvPr id="2" name="text-2">
+            <a:extLst xmlns:a="http://schemas.openxmlformats.org/drawingml/2006/main">
+              <a:ext uri="{FF2B5EF4-FFF2-40B4-BE49-F238E27FC236}">
+                <a16:creationId xmlns:a16="http://schemas.microsoft.com/office/drawing/2014/main" id="{735A4A76-E9A0-49C2-BD33-9203922945E9}"/>
               </a:ext>
             </a:extLst>
           </p:cNvPr>
@@ -1642,10 +1647,10 @@
       </p:sp>
       <p:sp>
         <p:nvSpPr>
-          <p:cNvPr id="3" name="text-95">
-            <a:extLst xmlns:a="http://schemas.openxmlformats.org/drawingml/2006/main">
-              <a:ext uri="{FF2B5EF4-FFF2-40B4-BE49-F238E27FC236}">
-                <a16:creationId xmlns:a16="http://schemas.microsoft.com/office/drawing/2014/main" id="{A1F9131A-025B-4DFF-A10E-040412A6E817}"/>
+          <p:cNvPr id="3" name="text-3">
+            <a:extLst xmlns:a="http://schemas.openxmlformats.org/drawingml/2006/main">
+              <a:ext uri="{FF2B5EF4-FFF2-40B4-BE49-F238E27FC236}">
+                <a16:creationId xmlns:a16="http://schemas.microsoft.com/office/drawing/2014/main" id="{2BBEB21E-59C3-4DA8-9B57-62E5175537D5}"/>
               </a:ext>
             </a:extLst>
           </p:cNvPr>
@@ -1698,10 +1703,10 @@
       </p:sp>
       <p:sp>
         <p:nvSpPr>
-          <p:cNvPr id="4" name="text-96">
-            <a:extLst xmlns:a="http://schemas.openxmlformats.org/drawingml/2006/main">
-              <a:ext uri="{FF2B5EF4-FFF2-40B4-BE49-F238E27FC236}">
-                <a16:creationId xmlns:a16="http://schemas.microsoft.com/office/drawing/2014/main" id="{C4BE2F12-A022-4967-861A-1CB9EC86E193}"/>
+          <p:cNvPr id="4" name="text-4">
+            <a:extLst xmlns:a="http://schemas.openxmlformats.org/drawingml/2006/main">
+              <a:ext uri="{FF2B5EF4-FFF2-40B4-BE49-F238E27FC236}">
+                <a16:creationId xmlns:a16="http://schemas.microsoft.com/office/drawing/2014/main" id="{9BFA9B81-ABE7-4DA3-8EF6-107F0A719FB0}"/>
               </a:ext>
             </a:extLst>
           </p:cNvPr>
@@ -1754,10 +1759,10 @@
       </p:sp>
       <p:sp>
         <p:nvSpPr>
-          <p:cNvPr id="5" name="text-97">
-            <a:extLst xmlns:a="http://schemas.openxmlformats.org/drawingml/2006/main">
-              <a:ext uri="{FF2B5EF4-FFF2-40B4-BE49-F238E27FC236}">
-                <a16:creationId xmlns:a16="http://schemas.microsoft.com/office/drawing/2014/main" id="{DDC980AB-422A-4BF7-A2CF-E70410F7FB57}"/>
+          <p:cNvPr id="5" name="text-5">
+            <a:extLst xmlns:a="http://schemas.openxmlformats.org/drawingml/2006/main">
+              <a:ext uri="{FF2B5EF4-FFF2-40B4-BE49-F238E27FC236}">
+                <a16:creationId xmlns:a16="http://schemas.microsoft.com/office/drawing/2014/main" id="{BF75E6D6-C50A-466E-BCA1-64F654348ACE}"/>
               </a:ext>
             </a:extLst>
           </p:cNvPr>
@@ -1810,10 +1815,10 @@
       </p:sp>
       <p:sp>
         <p:nvSpPr>
-          <p:cNvPr id="6" name="text-98">
-            <a:extLst xmlns:a="http://schemas.openxmlformats.org/drawingml/2006/main">
-              <a:ext uri="{FF2B5EF4-FFF2-40B4-BE49-F238E27FC236}">
-                <a16:creationId xmlns:a16="http://schemas.microsoft.com/office/drawing/2014/main" id="{CCB24E84-D9CE-4B55-A7CE-011EA689C27A}"/>
+          <p:cNvPr id="6" name="text-6">
+            <a:extLst xmlns:a="http://schemas.openxmlformats.org/drawingml/2006/main">
+              <a:ext uri="{FF2B5EF4-FFF2-40B4-BE49-F238E27FC236}">
+                <a16:creationId xmlns:a16="http://schemas.microsoft.com/office/drawing/2014/main" id="{FE0D0355-FD86-4AD1-BCCE-054A875FCDCA}"/>
               </a:ext>
             </a:extLst>
           </p:cNvPr>
@@ -1866,10 +1871,10 @@
       </p:sp>
       <p:sp>
         <p:nvSpPr>
-          <p:cNvPr id="7" name="text-99">
-            <a:extLst xmlns:a="http://schemas.openxmlformats.org/drawingml/2006/main">
-              <a:ext uri="{FF2B5EF4-FFF2-40B4-BE49-F238E27FC236}">
-                <a16:creationId xmlns:a16="http://schemas.microsoft.com/office/drawing/2014/main" id="{9819C4AC-C4DD-4B32-9C16-FC977971523D}"/>
+          <p:cNvPr id="7" name="text-7">
+            <a:extLst xmlns:a="http://schemas.openxmlformats.org/drawingml/2006/main">
+              <a:ext uri="{FF2B5EF4-FFF2-40B4-BE49-F238E27FC236}">
+                <a16:creationId xmlns:a16="http://schemas.microsoft.com/office/drawing/2014/main" id="{2328EEB9-3C6B-4324-8909-1BCCBCA92067}"/>
               </a:ext>
             </a:extLst>
           </p:cNvPr>
@@ -1922,10 +1927,10 @@
       </p:sp>
       <p:sp>
         <p:nvSpPr>
-          <p:cNvPr id="8" name="text-100">
-            <a:extLst xmlns:a="http://schemas.openxmlformats.org/drawingml/2006/main">
-              <a:ext uri="{FF2B5EF4-FFF2-40B4-BE49-F238E27FC236}">
-                <a16:creationId xmlns:a16="http://schemas.microsoft.com/office/drawing/2014/main" id="{6345A3A3-1BE9-469C-A865-9FC9AE5D4235}"/>
+          <p:cNvPr id="8" name="text-8">
+            <a:extLst xmlns:a="http://schemas.openxmlformats.org/drawingml/2006/main">
+              <a:ext uri="{FF2B5EF4-FFF2-40B4-BE49-F238E27FC236}">
+                <a16:creationId xmlns:a16="http://schemas.microsoft.com/office/drawing/2014/main" id="{FB19D1B5-AB3B-478D-9111-2D90E4BC43B5}"/>
               </a:ext>
             </a:extLst>
           </p:cNvPr>
@@ -1978,10 +1983,10 @@
       </p:sp>
       <p:sp>
         <p:nvSpPr>
-          <p:cNvPr id="9" name="text-101">
-            <a:extLst xmlns:a="http://schemas.openxmlformats.org/drawingml/2006/main">
-              <a:ext uri="{FF2B5EF4-FFF2-40B4-BE49-F238E27FC236}">
-                <a16:creationId xmlns:a16="http://schemas.microsoft.com/office/drawing/2014/main" id="{4D8A6E69-4939-4395-B756-D63534EA8B20}"/>
+          <p:cNvPr id="9" name="text-9">
+            <a:extLst xmlns:a="http://schemas.openxmlformats.org/drawingml/2006/main">
+              <a:ext uri="{FF2B5EF4-FFF2-40B4-BE49-F238E27FC236}">
+                <a16:creationId xmlns:a16="http://schemas.microsoft.com/office/drawing/2014/main" id="{ACFD9834-6112-4C81-9540-A316A5BBEF3D}"/>
               </a:ext>
             </a:extLst>
           </p:cNvPr>
@@ -2034,10 +2039,10 @@
       </p:sp>
       <p:sp>
         <p:nvSpPr>
-          <p:cNvPr id="10" name="box-102">
-            <a:extLst xmlns:a="http://schemas.openxmlformats.org/drawingml/2006/main">
-              <a:ext uri="{FF2B5EF4-FFF2-40B4-BE49-F238E27FC236}">
-                <a16:creationId xmlns:a16="http://schemas.microsoft.com/office/drawing/2014/main" id="{80631586-3871-41CA-834F-0484B32E5E71}"/>
+          <p:cNvPr id="10" name="box-10">
+            <a:extLst xmlns:a="http://schemas.openxmlformats.org/drawingml/2006/main">
+              <a:ext uri="{FF2B5EF4-FFF2-40B4-BE49-F238E27FC236}">
+                <a16:creationId xmlns:a16="http://schemas.microsoft.com/office/drawing/2014/main" id="{CD190AE0-149C-4054-8F43-004C8C56A4A3}"/>
               </a:ext>
             </a:extLst>
           </p:cNvPr>
@@ -2074,7 +2079,7 @@
           <p:nvPr/>
         </p:nvPicPr>
         <p:blipFill>
-          <a:blip xmlns:r="http://schemas.openxmlformats.org/officeDocument/2006/relationships" xmlns:a="http://schemas.openxmlformats.org/drawingml/2006/main" r:embed="R04b5788e36d44617"/>
+          <a:blip xmlns:r="http://schemas.openxmlformats.org/officeDocument/2006/relationships" xmlns:a="http://schemas.openxmlformats.org/drawingml/2006/main" r:embed="Re722dcd3292b4497"/>
           <a:stretch xmlns:a="http://schemas.openxmlformats.org/drawingml/2006/main"/>
         </p:blipFill>
         <p:spPr>
@@ -2089,10 +2094,10 @@
       </p:pic>
       <p:sp>
         <p:nvSpPr>
-          <p:cNvPr id="12" name="text-103">
-            <a:extLst xmlns:a="http://schemas.openxmlformats.org/drawingml/2006/main">
-              <a:ext uri="{FF2B5EF4-FFF2-40B4-BE49-F238E27FC236}">
-                <a16:creationId xmlns:a16="http://schemas.microsoft.com/office/drawing/2014/main" id="{ABC034BF-5D18-4D47-9077-02CEEECD262F}"/>
+          <p:cNvPr id="12" name="text-11">
+            <a:extLst xmlns:a="http://schemas.openxmlformats.org/drawingml/2006/main">
+              <a:ext uri="{FF2B5EF4-FFF2-40B4-BE49-F238E27FC236}">
+                <a16:creationId xmlns:a16="http://schemas.microsoft.com/office/drawing/2014/main" id="{8443A3E1-CEA5-4245-A42B-552CDF786F81}"/>
               </a:ext>
             </a:extLst>
           </p:cNvPr>
@@ -2138,7 +2143,7 @@
                 <a:ea typeface="Arial"/>
                 <a:cs typeface="Arial"/>
               </a:rPr>
-              <a:t>Windows · Python · SQLite</a:t>
+              <a:t>Windows x64 · macOS arm64</a:t>
             </a:r>
           </a:p>
         </p:txBody>
@@ -2146,7 +2151,7 @@
     </p:spTree>
     <p:extLst>
       <p:ext uri="{BB962C8B-B14F-4D97-AF65-F5344CB8AC3E}">
-        <p14:creationId xmlns:p14="http://schemas.microsoft.com/office/powerpoint/2010/main" val="1816530673"/>
+        <p14:creationId xmlns:p14="http://schemas.microsoft.com/office/powerpoint/2010/main" val="73660144"/>
       </p:ext>
     </p:extLst>
   </p:cSld>
@@ -2174,10 +2179,10 @@
       </p:grpSpPr>
       <p:sp>
         <p:nvSpPr>
-          <p:cNvPr id="14" name="box-104">
-            <a:extLst xmlns:a="http://schemas.openxmlformats.org/drawingml/2006/main">
-              <a:ext uri="{FF2B5EF4-FFF2-40B4-BE49-F238E27FC236}">
-                <a16:creationId xmlns:a16="http://schemas.microsoft.com/office/drawing/2014/main" id="{6F975BAC-A172-4F10-8D66-BD71B13A2D10}"/>
+          <p:cNvPr id="14" name="box-12">
+            <a:extLst xmlns:a="http://schemas.openxmlformats.org/drawingml/2006/main">
+              <a:ext uri="{FF2B5EF4-FFF2-40B4-BE49-F238E27FC236}">
+                <a16:creationId xmlns:a16="http://schemas.microsoft.com/office/drawing/2014/main" id="{D7DCD181-E2A5-4055-9422-BBD4094EBC74}"/>
               </a:ext>
             </a:extLst>
           </p:cNvPr>
@@ -2207,10 +2212,10 @@
       </p:sp>
       <p:sp>
         <p:nvSpPr>
-          <p:cNvPr id="2" name="text-105">
-            <a:extLst xmlns:a="http://schemas.openxmlformats.org/drawingml/2006/main">
-              <a:ext uri="{FF2B5EF4-FFF2-40B4-BE49-F238E27FC236}">
-                <a16:creationId xmlns:a16="http://schemas.microsoft.com/office/drawing/2014/main" id="{E64A0654-95D0-4F37-B94B-DB6675ECF2A0}"/>
+          <p:cNvPr id="2" name="text-13">
+            <a:extLst xmlns:a="http://schemas.openxmlformats.org/drawingml/2006/main">
+              <a:ext uri="{FF2B5EF4-FFF2-40B4-BE49-F238E27FC236}">
+                <a16:creationId xmlns:a16="http://schemas.microsoft.com/office/drawing/2014/main" id="{AA6075EB-8A99-407D-9769-E436FEB4E090}"/>
               </a:ext>
             </a:extLst>
           </p:cNvPr>
@@ -2263,10 +2268,10 @@
       </p:sp>
       <p:sp>
         <p:nvSpPr>
-          <p:cNvPr id="3" name="text-106">
-            <a:extLst xmlns:a="http://schemas.openxmlformats.org/drawingml/2006/main">
-              <a:ext uri="{FF2B5EF4-FFF2-40B4-BE49-F238E27FC236}">
-                <a16:creationId xmlns:a16="http://schemas.microsoft.com/office/drawing/2014/main" id="{D971E05B-B1B5-40D0-806F-053F0D85C429}"/>
+          <p:cNvPr id="3" name="text-14">
+            <a:extLst xmlns:a="http://schemas.openxmlformats.org/drawingml/2006/main">
+              <a:ext uri="{FF2B5EF4-FFF2-40B4-BE49-F238E27FC236}">
+                <a16:creationId xmlns:a16="http://schemas.microsoft.com/office/drawing/2014/main" id="{448EBA4C-95EF-4751-948B-029DE3549769}"/>
               </a:ext>
             </a:extLst>
           </p:cNvPr>
@@ -2319,10 +2324,10 @@
       </p:sp>
       <p:sp>
         <p:nvSpPr>
-          <p:cNvPr id="4" name="text-107">
-            <a:extLst xmlns:a="http://schemas.openxmlformats.org/drawingml/2006/main">
-              <a:ext uri="{FF2B5EF4-FFF2-40B4-BE49-F238E27FC236}">
-                <a16:creationId xmlns:a16="http://schemas.microsoft.com/office/drawing/2014/main" id="{83FFEC50-89B0-42EC-82FF-A7C1BEA44039}"/>
+          <p:cNvPr id="4" name="text-15">
+            <a:extLst xmlns:a="http://schemas.openxmlformats.org/drawingml/2006/main">
+              <a:ext uri="{FF2B5EF4-FFF2-40B4-BE49-F238E27FC236}">
+                <a16:creationId xmlns:a16="http://schemas.microsoft.com/office/drawing/2014/main" id="{BF347A30-1F5B-4A39-9C1D-BC092BD94AF1}"/>
               </a:ext>
             </a:extLst>
           </p:cNvPr>
@@ -2375,10 +2380,10 @@
       </p:sp>
       <p:sp>
         <p:nvSpPr>
-          <p:cNvPr id="5" name="text-108">
-            <a:extLst xmlns:a="http://schemas.openxmlformats.org/drawingml/2006/main">
-              <a:ext uri="{FF2B5EF4-FFF2-40B4-BE49-F238E27FC236}">
-                <a16:creationId xmlns:a16="http://schemas.microsoft.com/office/drawing/2014/main" id="{59059D0D-0A54-4F70-AFC3-DB43EBA36A7C}"/>
+          <p:cNvPr id="5" name="text-16">
+            <a:extLst xmlns:a="http://schemas.openxmlformats.org/drawingml/2006/main">
+              <a:ext uri="{FF2B5EF4-FFF2-40B4-BE49-F238E27FC236}">
+                <a16:creationId xmlns:a16="http://schemas.microsoft.com/office/drawing/2014/main" id="{07AE1E89-2FC7-4AF2-85A3-06C4379D3704}"/>
               </a:ext>
             </a:extLst>
           </p:cNvPr>
@@ -2431,10 +2436,10 @@
       </p:sp>
       <p:sp>
         <p:nvSpPr>
-          <p:cNvPr id="6" name="text-109">
-            <a:extLst xmlns:a="http://schemas.openxmlformats.org/drawingml/2006/main">
-              <a:ext uri="{FF2B5EF4-FFF2-40B4-BE49-F238E27FC236}">
-                <a16:creationId xmlns:a16="http://schemas.microsoft.com/office/drawing/2014/main" id="{074BAD88-DD87-44C5-A6AF-BEB8CFBE3A54}"/>
+          <p:cNvPr id="6" name="text-17">
+            <a:extLst xmlns:a="http://schemas.openxmlformats.org/drawingml/2006/main">
+              <a:ext uri="{FF2B5EF4-FFF2-40B4-BE49-F238E27FC236}">
+                <a16:creationId xmlns:a16="http://schemas.microsoft.com/office/drawing/2014/main" id="{ABFC7643-DC26-4153-A99E-00EEB088862F}"/>
               </a:ext>
             </a:extLst>
           </p:cNvPr>
@@ -2487,10 +2492,10 @@
       </p:sp>
       <p:sp>
         <p:nvSpPr>
-          <p:cNvPr id="7" name="box-110">
-            <a:extLst xmlns:a="http://schemas.openxmlformats.org/drawingml/2006/main">
-              <a:ext uri="{FF2B5EF4-FFF2-40B4-BE49-F238E27FC236}">
-                <a16:creationId xmlns:a16="http://schemas.microsoft.com/office/drawing/2014/main" id="{A2632EAA-6220-4EBE-A695-D65B2C19233E}"/>
+          <p:cNvPr id="7" name="box-18">
+            <a:extLst xmlns:a="http://schemas.openxmlformats.org/drawingml/2006/main">
+              <a:ext uri="{FF2B5EF4-FFF2-40B4-BE49-F238E27FC236}">
+                <a16:creationId xmlns:a16="http://schemas.microsoft.com/office/drawing/2014/main" id="{EEBA3134-C90A-4D62-A69D-E817673AF22F}"/>
               </a:ext>
             </a:extLst>
           </p:cNvPr>
@@ -2520,10 +2525,10 @@
       </p:sp>
       <p:sp>
         <p:nvSpPr>
-          <p:cNvPr id="8" name="text-111">
-            <a:extLst xmlns:a="http://schemas.openxmlformats.org/drawingml/2006/main">
-              <a:ext uri="{FF2B5EF4-FFF2-40B4-BE49-F238E27FC236}">
-                <a16:creationId xmlns:a16="http://schemas.microsoft.com/office/drawing/2014/main" id="{4CEBCB48-2EC5-48F2-862F-DFE6EC9E01FA}"/>
+          <p:cNvPr id="8" name="text-19">
+            <a:extLst xmlns:a="http://schemas.openxmlformats.org/drawingml/2006/main">
+              <a:ext uri="{FF2B5EF4-FFF2-40B4-BE49-F238E27FC236}">
+                <a16:creationId xmlns:a16="http://schemas.microsoft.com/office/drawing/2014/main" id="{0DD37BAE-8385-4CBD-9615-7CEDD4713500}"/>
               </a:ext>
             </a:extLst>
           </p:cNvPr>
@@ -2576,10 +2581,10 @@
       </p:sp>
       <p:sp>
         <p:nvSpPr>
-          <p:cNvPr id="9" name="text-112">
-            <a:extLst xmlns:a="http://schemas.openxmlformats.org/drawingml/2006/main">
-              <a:ext uri="{FF2B5EF4-FFF2-40B4-BE49-F238E27FC236}">
-                <a16:creationId xmlns:a16="http://schemas.microsoft.com/office/drawing/2014/main" id="{B79A1899-D35C-49A9-8586-4271C1F08E59}"/>
+          <p:cNvPr id="9" name="text-20">
+            <a:extLst xmlns:a="http://schemas.openxmlformats.org/drawingml/2006/main">
+              <a:ext uri="{FF2B5EF4-FFF2-40B4-BE49-F238E27FC236}">
+                <a16:creationId xmlns:a16="http://schemas.microsoft.com/office/drawing/2014/main" id="{EA8E3825-E33A-425C-91F6-FE5D638E3517}"/>
               </a:ext>
             </a:extLst>
           </p:cNvPr>
@@ -2632,10 +2637,10 @@
       </p:sp>
       <p:sp>
         <p:nvSpPr>
-          <p:cNvPr id="10" name="text-113">
-            <a:extLst xmlns:a="http://schemas.openxmlformats.org/drawingml/2006/main">
-              <a:ext uri="{FF2B5EF4-FFF2-40B4-BE49-F238E27FC236}">
-                <a16:creationId xmlns:a16="http://schemas.microsoft.com/office/drawing/2014/main" id="{F435E173-D50B-47E1-81B2-2B781BC4DE63}"/>
+          <p:cNvPr id="10" name="text-21">
+            <a:extLst xmlns:a="http://schemas.openxmlformats.org/drawingml/2006/main">
+              <a:ext uri="{FF2B5EF4-FFF2-40B4-BE49-F238E27FC236}">
+                <a16:creationId xmlns:a16="http://schemas.microsoft.com/office/drawing/2014/main" id="{841D04E4-79D8-4683-AE30-15C3AF1DBFD1}"/>
               </a:ext>
             </a:extLst>
           </p:cNvPr>
@@ -2688,10 +2693,10 @@
       </p:sp>
       <p:sp>
         <p:nvSpPr>
-          <p:cNvPr id="11" name="box-114">
-            <a:extLst xmlns:a="http://schemas.openxmlformats.org/drawingml/2006/main">
-              <a:ext uri="{FF2B5EF4-FFF2-40B4-BE49-F238E27FC236}">
-                <a16:creationId xmlns:a16="http://schemas.microsoft.com/office/drawing/2014/main" id="{56A28998-A557-4D44-83A6-A5B536A70689}"/>
+          <p:cNvPr id="11" name="box-22">
+            <a:extLst xmlns:a="http://schemas.openxmlformats.org/drawingml/2006/main">
+              <a:ext uri="{FF2B5EF4-FFF2-40B4-BE49-F238E27FC236}">
+                <a16:creationId xmlns:a16="http://schemas.microsoft.com/office/drawing/2014/main" id="{3C4F3CF1-3A18-45B2-B6C3-94D1007B4106}"/>
               </a:ext>
             </a:extLst>
           </p:cNvPr>
@@ -2728,7 +2733,7 @@
           <p:nvPr/>
         </p:nvPicPr>
         <p:blipFill>
-          <a:blip xmlns:r="http://schemas.openxmlformats.org/officeDocument/2006/relationships" xmlns:a="http://schemas.openxmlformats.org/drawingml/2006/main" r:embed="R644d9d946b2541ed"/>
+          <a:blip xmlns:r="http://schemas.openxmlformats.org/officeDocument/2006/relationships" xmlns:a="http://schemas.openxmlformats.org/drawingml/2006/main" r:embed="Rf6fe629e89eb4d73"/>
           <a:stretch xmlns:a="http://schemas.openxmlformats.org/drawingml/2006/main"/>
         </p:blipFill>
         <p:spPr>
@@ -2743,10 +2748,10 @@
       </p:pic>
       <p:sp>
         <p:nvSpPr>
-          <p:cNvPr id="13" name="text-115">
-            <a:extLst xmlns:a="http://schemas.openxmlformats.org/drawingml/2006/main">
-              <a:ext uri="{FF2B5EF4-FFF2-40B4-BE49-F238E27FC236}">
-                <a16:creationId xmlns:a16="http://schemas.microsoft.com/office/drawing/2014/main" id="{85E106C3-902C-4651-8FC0-A68826C3E706}"/>
+          <p:cNvPr id="13" name="text-23">
+            <a:extLst xmlns:a="http://schemas.openxmlformats.org/drawingml/2006/main">
+              <a:ext uri="{FF2B5EF4-FFF2-40B4-BE49-F238E27FC236}">
+                <a16:creationId xmlns:a16="http://schemas.microsoft.com/office/drawing/2014/main" id="{89421157-6C94-4446-864E-8531C9DA167C}"/>
               </a:ext>
             </a:extLst>
           </p:cNvPr>
@@ -2800,7 +2805,7 @@
     </p:spTree>
     <p:extLst>
       <p:ext uri="{BB962C8B-B14F-4D97-AF65-F5344CB8AC3E}">
-        <p14:creationId xmlns:p14="http://schemas.microsoft.com/office/powerpoint/2010/main" val="826435621"/>
+        <p14:creationId xmlns:p14="http://schemas.microsoft.com/office/powerpoint/2010/main" val="2083834490"/>
       </p:ext>
     </p:extLst>
   </p:cSld>
@@ -2828,10 +2833,10 @@
       </p:grpSpPr>
       <p:sp>
         <p:nvSpPr>
-          <p:cNvPr id="19" name="box-116">
-            <a:extLst xmlns:a="http://schemas.openxmlformats.org/drawingml/2006/main">
-              <a:ext uri="{FF2B5EF4-FFF2-40B4-BE49-F238E27FC236}">
-                <a16:creationId xmlns:a16="http://schemas.microsoft.com/office/drawing/2014/main" id="{3B7E2B85-1D55-4F03-942A-D3810FEEE4B7}"/>
+          <p:cNvPr id="19" name="box-24">
+            <a:extLst xmlns:a="http://schemas.openxmlformats.org/drawingml/2006/main">
+              <a:ext uri="{FF2B5EF4-FFF2-40B4-BE49-F238E27FC236}">
+                <a16:creationId xmlns:a16="http://schemas.microsoft.com/office/drawing/2014/main" id="{68DCB4D9-A89C-41AD-BAA8-28BC3B8378EF}"/>
               </a:ext>
             </a:extLst>
           </p:cNvPr>
@@ -2861,10 +2866,10 @@
       </p:sp>
       <p:sp>
         <p:nvSpPr>
-          <p:cNvPr id="2" name="text-117">
-            <a:extLst xmlns:a="http://schemas.openxmlformats.org/drawingml/2006/main">
-              <a:ext uri="{FF2B5EF4-FFF2-40B4-BE49-F238E27FC236}">
-                <a16:creationId xmlns:a16="http://schemas.microsoft.com/office/drawing/2014/main" id="{2938F4DD-C87F-4DA7-9E8B-1A556B5873F7}"/>
+          <p:cNvPr id="2" name="text-25">
+            <a:extLst xmlns:a="http://schemas.openxmlformats.org/drawingml/2006/main">
+              <a:ext uri="{FF2B5EF4-FFF2-40B4-BE49-F238E27FC236}">
+                <a16:creationId xmlns:a16="http://schemas.microsoft.com/office/drawing/2014/main" id="{31EA5935-7E6A-49C9-87C7-0FA51E773D37}"/>
               </a:ext>
             </a:extLst>
           </p:cNvPr>
@@ -2917,10 +2922,10 @@
       </p:sp>
       <p:sp>
         <p:nvSpPr>
-          <p:cNvPr id="3" name="text-118">
-            <a:extLst xmlns:a="http://schemas.openxmlformats.org/drawingml/2006/main">
-              <a:ext uri="{FF2B5EF4-FFF2-40B4-BE49-F238E27FC236}">
-                <a16:creationId xmlns:a16="http://schemas.microsoft.com/office/drawing/2014/main" id="{748F8F29-D614-4873-B5FD-5C37173D917E}"/>
+          <p:cNvPr id="3" name="text-26">
+            <a:extLst xmlns:a="http://schemas.openxmlformats.org/drawingml/2006/main">
+              <a:ext uri="{FF2B5EF4-FFF2-40B4-BE49-F238E27FC236}">
+                <a16:creationId xmlns:a16="http://schemas.microsoft.com/office/drawing/2014/main" id="{E2F1C7C6-8427-48B2-8A62-FBA96E3B29EE}"/>
               </a:ext>
             </a:extLst>
           </p:cNvPr>
@@ -2973,10 +2978,10 @@
       </p:sp>
       <p:sp>
         <p:nvSpPr>
-          <p:cNvPr id="4" name="text-119">
-            <a:extLst xmlns:a="http://schemas.openxmlformats.org/drawingml/2006/main">
-              <a:ext uri="{FF2B5EF4-FFF2-40B4-BE49-F238E27FC236}">
-                <a16:creationId xmlns:a16="http://schemas.microsoft.com/office/drawing/2014/main" id="{AF721E64-AE3D-449F-A518-33CAD8FBCB92}"/>
+          <p:cNvPr id="4" name="text-27">
+            <a:extLst xmlns:a="http://schemas.openxmlformats.org/drawingml/2006/main">
+              <a:ext uri="{FF2B5EF4-FFF2-40B4-BE49-F238E27FC236}">
+                <a16:creationId xmlns:a16="http://schemas.microsoft.com/office/drawing/2014/main" id="{2FECA15F-6271-402C-83BD-8AD2B8033ADA}"/>
               </a:ext>
             </a:extLst>
           </p:cNvPr>
@@ -3029,10 +3034,10 @@
       </p:sp>
       <p:sp>
         <p:nvSpPr>
-          <p:cNvPr id="5" name="text-120">
-            <a:extLst xmlns:a="http://schemas.openxmlformats.org/drawingml/2006/main">
-              <a:ext uri="{FF2B5EF4-FFF2-40B4-BE49-F238E27FC236}">
-                <a16:creationId xmlns:a16="http://schemas.microsoft.com/office/drawing/2014/main" id="{4136ABD1-B3D7-4491-8D1F-3D3F9AFB0925}"/>
+          <p:cNvPr id="5" name="text-28">
+            <a:extLst xmlns:a="http://schemas.openxmlformats.org/drawingml/2006/main">
+              <a:ext uri="{FF2B5EF4-FFF2-40B4-BE49-F238E27FC236}">
+                <a16:creationId xmlns:a16="http://schemas.microsoft.com/office/drawing/2014/main" id="{F346787F-8EDF-4073-8A7A-03979961ACE0}"/>
               </a:ext>
             </a:extLst>
           </p:cNvPr>
@@ -3085,10 +3090,10 @@
       </p:sp>
       <p:sp>
         <p:nvSpPr>
-          <p:cNvPr id="6" name="text-121">
-            <a:extLst xmlns:a="http://schemas.openxmlformats.org/drawingml/2006/main">
-              <a:ext uri="{FF2B5EF4-FFF2-40B4-BE49-F238E27FC236}">
-                <a16:creationId xmlns:a16="http://schemas.microsoft.com/office/drawing/2014/main" id="{4A6CED88-4BD6-47B6-8433-7D4E7728EEFA}"/>
+          <p:cNvPr id="6" name="text-29">
+            <a:extLst xmlns:a="http://schemas.openxmlformats.org/drawingml/2006/main">
+              <a:ext uri="{FF2B5EF4-FFF2-40B4-BE49-F238E27FC236}">
+                <a16:creationId xmlns:a16="http://schemas.microsoft.com/office/drawing/2014/main" id="{F98FBCF8-F57B-4573-AFF8-0FE06FE1C636}"/>
               </a:ext>
             </a:extLst>
           </p:cNvPr>
@@ -3141,10 +3146,10 @@
       </p:sp>
       <p:sp>
         <p:nvSpPr>
-          <p:cNvPr id="7" name="box-122">
-            <a:extLst xmlns:a="http://schemas.openxmlformats.org/drawingml/2006/main">
-              <a:ext uri="{FF2B5EF4-FFF2-40B4-BE49-F238E27FC236}">
-                <a16:creationId xmlns:a16="http://schemas.microsoft.com/office/drawing/2014/main" id="{D42BC98C-F7ED-46C6-9D20-077641DC242C}"/>
+          <p:cNvPr id="7" name="box-30">
+            <a:extLst xmlns:a="http://schemas.openxmlformats.org/drawingml/2006/main">
+              <a:ext uri="{FF2B5EF4-FFF2-40B4-BE49-F238E27FC236}">
+                <a16:creationId xmlns:a16="http://schemas.microsoft.com/office/drawing/2014/main" id="{896C0623-4C47-4C5B-B345-E0574820F6CE}"/>
               </a:ext>
             </a:extLst>
           </p:cNvPr>
@@ -3174,10 +3179,10 @@
       </p:sp>
       <p:sp>
         <p:nvSpPr>
-          <p:cNvPr id="8" name="text-123">
-            <a:extLst xmlns:a="http://schemas.openxmlformats.org/drawingml/2006/main">
-              <a:ext uri="{FF2B5EF4-FFF2-40B4-BE49-F238E27FC236}">
-                <a16:creationId xmlns:a16="http://schemas.microsoft.com/office/drawing/2014/main" id="{43DA7EAB-E648-4904-9F3C-25452BBD970C}"/>
+          <p:cNvPr id="8" name="text-31">
+            <a:extLst xmlns:a="http://schemas.openxmlformats.org/drawingml/2006/main">
+              <a:ext uri="{FF2B5EF4-FFF2-40B4-BE49-F238E27FC236}">
+                <a16:creationId xmlns:a16="http://schemas.microsoft.com/office/drawing/2014/main" id="{FAB4FB8E-A44D-41EE-8D92-A33675A94A25}"/>
               </a:ext>
             </a:extLst>
           </p:cNvPr>
@@ -3230,10 +3235,10 @@
       </p:sp>
       <p:sp>
         <p:nvSpPr>
-          <p:cNvPr id="9" name="text-124">
-            <a:extLst xmlns:a="http://schemas.openxmlformats.org/drawingml/2006/main">
-              <a:ext uri="{FF2B5EF4-FFF2-40B4-BE49-F238E27FC236}">
-                <a16:creationId xmlns:a16="http://schemas.microsoft.com/office/drawing/2014/main" id="{1C5897E4-53A0-462D-9872-C542EE58CBD4}"/>
+          <p:cNvPr id="9" name="text-32">
+            <a:extLst xmlns:a="http://schemas.openxmlformats.org/drawingml/2006/main">
+              <a:ext uri="{FF2B5EF4-FFF2-40B4-BE49-F238E27FC236}">
+                <a16:creationId xmlns:a16="http://schemas.microsoft.com/office/drawing/2014/main" id="{D76DFC98-0662-4CE2-82E5-FA3FE3465D5D}"/>
               </a:ext>
             </a:extLst>
           </p:cNvPr>
@@ -3286,10 +3291,10 @@
       </p:sp>
       <p:sp>
         <p:nvSpPr>
-          <p:cNvPr id="10" name="text-125">
-            <a:extLst xmlns:a="http://schemas.openxmlformats.org/drawingml/2006/main">
-              <a:ext uri="{FF2B5EF4-FFF2-40B4-BE49-F238E27FC236}">
-                <a16:creationId xmlns:a16="http://schemas.microsoft.com/office/drawing/2014/main" id="{077C1EA1-43E6-454F-B1E4-235051ED1DF5}"/>
+          <p:cNvPr id="10" name="text-33">
+            <a:extLst xmlns:a="http://schemas.openxmlformats.org/drawingml/2006/main">
+              <a:ext uri="{FF2B5EF4-FFF2-40B4-BE49-F238E27FC236}">
+                <a16:creationId xmlns:a16="http://schemas.microsoft.com/office/drawing/2014/main" id="{8362E324-E4B3-472C-96CB-F9C357A82B6A}"/>
               </a:ext>
             </a:extLst>
           </p:cNvPr>
@@ -3342,10 +3347,10 @@
       </p:sp>
       <p:sp>
         <p:nvSpPr>
-          <p:cNvPr id="11" name="box-126">
-            <a:extLst xmlns:a="http://schemas.openxmlformats.org/drawingml/2006/main">
-              <a:ext uri="{FF2B5EF4-FFF2-40B4-BE49-F238E27FC236}">
-                <a16:creationId xmlns:a16="http://schemas.microsoft.com/office/drawing/2014/main" id="{EC313C1D-F0AC-492D-A1EF-A1C400F218FC}"/>
+          <p:cNvPr id="11" name="box-34">
+            <a:extLst xmlns:a="http://schemas.openxmlformats.org/drawingml/2006/main">
+              <a:ext uri="{FF2B5EF4-FFF2-40B4-BE49-F238E27FC236}">
+                <a16:creationId xmlns:a16="http://schemas.microsoft.com/office/drawing/2014/main" id="{F4E6576F-E7F2-4591-BF77-2E0A3F3E1FEB}"/>
               </a:ext>
             </a:extLst>
           </p:cNvPr>
@@ -3375,10 +3380,10 @@
       </p:sp>
       <p:sp>
         <p:nvSpPr>
-          <p:cNvPr id="12" name="text-127">
-            <a:extLst xmlns:a="http://schemas.openxmlformats.org/drawingml/2006/main">
-              <a:ext uri="{FF2B5EF4-FFF2-40B4-BE49-F238E27FC236}">
-                <a16:creationId xmlns:a16="http://schemas.microsoft.com/office/drawing/2014/main" id="{F365439D-2176-456B-AB98-378C6CC12754}"/>
+          <p:cNvPr id="12" name="text-35">
+            <a:extLst xmlns:a="http://schemas.openxmlformats.org/drawingml/2006/main">
+              <a:ext uri="{FF2B5EF4-FFF2-40B4-BE49-F238E27FC236}">
+                <a16:creationId xmlns:a16="http://schemas.microsoft.com/office/drawing/2014/main" id="{F9842881-6F97-4EE7-8EB6-81BFCF1C62E1}"/>
               </a:ext>
             </a:extLst>
           </p:cNvPr>
@@ -3431,10 +3436,10 @@
       </p:sp>
       <p:sp>
         <p:nvSpPr>
-          <p:cNvPr id="13" name="text-128">
-            <a:extLst xmlns:a="http://schemas.openxmlformats.org/drawingml/2006/main">
-              <a:ext uri="{FF2B5EF4-FFF2-40B4-BE49-F238E27FC236}">
-                <a16:creationId xmlns:a16="http://schemas.microsoft.com/office/drawing/2014/main" id="{AAB66F13-B924-4D82-90D6-83EC9B8EAF46}"/>
+          <p:cNvPr id="13" name="text-36">
+            <a:extLst xmlns:a="http://schemas.openxmlformats.org/drawingml/2006/main">
+              <a:ext uri="{FF2B5EF4-FFF2-40B4-BE49-F238E27FC236}">
+                <a16:creationId xmlns:a16="http://schemas.microsoft.com/office/drawing/2014/main" id="{B3F649D4-2DF4-4FBD-959D-F7360E7100AA}"/>
               </a:ext>
             </a:extLst>
           </p:cNvPr>
@@ -3487,10 +3492,10 @@
       </p:sp>
       <p:sp>
         <p:nvSpPr>
-          <p:cNvPr id="14" name="text-129">
-            <a:extLst xmlns:a="http://schemas.openxmlformats.org/drawingml/2006/main">
-              <a:ext uri="{FF2B5EF4-FFF2-40B4-BE49-F238E27FC236}">
-                <a16:creationId xmlns:a16="http://schemas.microsoft.com/office/drawing/2014/main" id="{08275AEF-3FC1-4A30-9FE6-949D92BE33A5}"/>
+          <p:cNvPr id="14" name="text-37">
+            <a:extLst xmlns:a="http://schemas.openxmlformats.org/drawingml/2006/main">
+              <a:ext uri="{FF2B5EF4-FFF2-40B4-BE49-F238E27FC236}">
+                <a16:creationId xmlns:a16="http://schemas.microsoft.com/office/drawing/2014/main" id="{79240BBB-16CD-468D-814B-4BB9EF607138}"/>
               </a:ext>
             </a:extLst>
           </p:cNvPr>
@@ -3543,10 +3548,10 @@
       </p:sp>
       <p:sp>
         <p:nvSpPr>
-          <p:cNvPr id="15" name="box-130">
-            <a:extLst xmlns:a="http://schemas.openxmlformats.org/drawingml/2006/main">
-              <a:ext uri="{FF2B5EF4-FFF2-40B4-BE49-F238E27FC236}">
-                <a16:creationId xmlns:a16="http://schemas.microsoft.com/office/drawing/2014/main" id="{BCCDBEC8-0B5C-4D4B-917F-EB63335D8447}"/>
+          <p:cNvPr id="15" name="box-38">
+            <a:extLst xmlns:a="http://schemas.openxmlformats.org/drawingml/2006/main">
+              <a:ext uri="{FF2B5EF4-FFF2-40B4-BE49-F238E27FC236}">
+                <a16:creationId xmlns:a16="http://schemas.microsoft.com/office/drawing/2014/main" id="{D055FB7A-3BAC-4ED5-AF8E-C8EE6F9601F4}"/>
               </a:ext>
             </a:extLst>
           </p:cNvPr>
@@ -3576,10 +3581,10 @@
       </p:sp>
       <p:sp>
         <p:nvSpPr>
-          <p:cNvPr id="16" name="text-131">
-            <a:extLst xmlns:a="http://schemas.openxmlformats.org/drawingml/2006/main">
-              <a:ext uri="{FF2B5EF4-FFF2-40B4-BE49-F238E27FC236}">
-                <a16:creationId xmlns:a16="http://schemas.microsoft.com/office/drawing/2014/main" id="{CE2C12AA-C81E-4453-ADF7-A8EB39D12DCB}"/>
+          <p:cNvPr id="16" name="text-39">
+            <a:extLst xmlns:a="http://schemas.openxmlformats.org/drawingml/2006/main">
+              <a:ext uri="{FF2B5EF4-FFF2-40B4-BE49-F238E27FC236}">
+                <a16:creationId xmlns:a16="http://schemas.microsoft.com/office/drawing/2014/main" id="{0E07A2AC-0DB0-4A34-B07E-D9F9B90F3122}"/>
               </a:ext>
             </a:extLst>
           </p:cNvPr>
@@ -3632,10 +3637,10 @@
       </p:sp>
       <p:sp>
         <p:nvSpPr>
-          <p:cNvPr id="17" name="text-132">
-            <a:extLst xmlns:a="http://schemas.openxmlformats.org/drawingml/2006/main">
-              <a:ext uri="{FF2B5EF4-FFF2-40B4-BE49-F238E27FC236}">
-                <a16:creationId xmlns:a16="http://schemas.microsoft.com/office/drawing/2014/main" id="{A38EFA6C-4BBF-4698-833F-CB6449498ACE}"/>
+          <p:cNvPr id="17" name="text-40">
+            <a:extLst xmlns:a="http://schemas.openxmlformats.org/drawingml/2006/main">
+              <a:ext uri="{FF2B5EF4-FFF2-40B4-BE49-F238E27FC236}">
+                <a16:creationId xmlns:a16="http://schemas.microsoft.com/office/drawing/2014/main" id="{56A693ED-1D2B-42C8-AB90-F5A04EA7216B}"/>
               </a:ext>
             </a:extLst>
           </p:cNvPr>
@@ -3688,10 +3693,10 @@
       </p:sp>
       <p:sp>
         <p:nvSpPr>
-          <p:cNvPr id="18" name="text-133">
-            <a:extLst xmlns:a="http://schemas.openxmlformats.org/drawingml/2006/main">
-              <a:ext uri="{FF2B5EF4-FFF2-40B4-BE49-F238E27FC236}">
-                <a16:creationId xmlns:a16="http://schemas.microsoft.com/office/drawing/2014/main" id="{55CE1323-39E0-42B0-B44A-403271346089}"/>
+          <p:cNvPr id="18" name="text-41">
+            <a:extLst xmlns:a="http://schemas.openxmlformats.org/drawingml/2006/main">
+              <a:ext uri="{FF2B5EF4-FFF2-40B4-BE49-F238E27FC236}">
+                <a16:creationId xmlns:a16="http://schemas.microsoft.com/office/drawing/2014/main" id="{4DFB5966-8D34-4596-8468-11FA961AD94F}"/>
               </a:ext>
             </a:extLst>
           </p:cNvPr>
@@ -3745,7 +3750,7 @@
     </p:spTree>
     <p:extLst>
       <p:ext uri="{BB962C8B-B14F-4D97-AF65-F5344CB8AC3E}">
-        <p14:creationId xmlns:p14="http://schemas.microsoft.com/office/powerpoint/2010/main" val="1785723502"/>
+        <p14:creationId xmlns:p14="http://schemas.microsoft.com/office/powerpoint/2010/main" val="368118747"/>
       </p:ext>
     </p:extLst>
   </p:cSld>
@@ -3773,10 +3778,10 @@
       </p:grpSpPr>
       <p:sp>
         <p:nvSpPr>
-          <p:cNvPr id="18" name="box-134">
-            <a:extLst xmlns:a="http://schemas.openxmlformats.org/drawingml/2006/main">
-              <a:ext uri="{FF2B5EF4-FFF2-40B4-BE49-F238E27FC236}">
-                <a16:creationId xmlns:a16="http://schemas.microsoft.com/office/drawing/2014/main" id="{644A8E9E-4E0A-4963-95E5-09478DF4E0B8}"/>
+          <p:cNvPr id="18" name="box-42">
+            <a:extLst xmlns:a="http://schemas.openxmlformats.org/drawingml/2006/main">
+              <a:ext uri="{FF2B5EF4-FFF2-40B4-BE49-F238E27FC236}">
+                <a16:creationId xmlns:a16="http://schemas.microsoft.com/office/drawing/2014/main" id="{885F7E30-FBF7-41CD-9B1B-F2B769B02F50}"/>
               </a:ext>
             </a:extLst>
           </p:cNvPr>
@@ -3806,10 +3811,10 @@
       </p:sp>
       <p:sp>
         <p:nvSpPr>
-          <p:cNvPr id="2" name="text-135">
-            <a:extLst xmlns:a="http://schemas.openxmlformats.org/drawingml/2006/main">
-              <a:ext uri="{FF2B5EF4-FFF2-40B4-BE49-F238E27FC236}">
-                <a16:creationId xmlns:a16="http://schemas.microsoft.com/office/drawing/2014/main" id="{DF2A74B0-B72B-4ED2-9DD3-32B5658BA9D2}"/>
+          <p:cNvPr id="2" name="text-43">
+            <a:extLst xmlns:a="http://schemas.openxmlformats.org/drawingml/2006/main">
+              <a:ext uri="{FF2B5EF4-FFF2-40B4-BE49-F238E27FC236}">
+                <a16:creationId xmlns:a16="http://schemas.microsoft.com/office/drawing/2014/main" id="{B683918C-80A5-4F31-9933-FF9BD676C304}"/>
               </a:ext>
             </a:extLst>
           </p:cNvPr>
@@ -3862,10 +3867,10 @@
       </p:sp>
       <p:sp>
         <p:nvSpPr>
-          <p:cNvPr id="3" name="text-136">
-            <a:extLst xmlns:a="http://schemas.openxmlformats.org/drawingml/2006/main">
-              <a:ext uri="{FF2B5EF4-FFF2-40B4-BE49-F238E27FC236}">
-                <a16:creationId xmlns:a16="http://schemas.microsoft.com/office/drawing/2014/main" id="{54664793-9404-47C4-AA59-7AF6CA1C0C08}"/>
+          <p:cNvPr id="3" name="text-44">
+            <a:extLst xmlns:a="http://schemas.openxmlformats.org/drawingml/2006/main">
+              <a:ext uri="{FF2B5EF4-FFF2-40B4-BE49-F238E27FC236}">
+                <a16:creationId xmlns:a16="http://schemas.microsoft.com/office/drawing/2014/main" id="{A28ED235-F240-45F3-BE94-BB9E52188031}"/>
               </a:ext>
             </a:extLst>
           </p:cNvPr>
@@ -3918,10 +3923,10 @@
       </p:sp>
       <p:sp>
         <p:nvSpPr>
-          <p:cNvPr id="4" name="text-137">
-            <a:extLst xmlns:a="http://schemas.openxmlformats.org/drawingml/2006/main">
-              <a:ext uri="{FF2B5EF4-FFF2-40B4-BE49-F238E27FC236}">
-                <a16:creationId xmlns:a16="http://schemas.microsoft.com/office/drawing/2014/main" id="{CDBC777D-3F3E-401C-BD68-3BC070EE1B23}"/>
+          <p:cNvPr id="4" name="text-45">
+            <a:extLst xmlns:a="http://schemas.openxmlformats.org/drawingml/2006/main">
+              <a:ext uri="{FF2B5EF4-FFF2-40B4-BE49-F238E27FC236}">
+                <a16:creationId xmlns:a16="http://schemas.microsoft.com/office/drawing/2014/main" id="{8DB93BFF-2764-4FC8-9D1B-7D72497AFD40}"/>
               </a:ext>
             </a:extLst>
           </p:cNvPr>
@@ -3974,10 +3979,10 @@
       </p:sp>
       <p:sp>
         <p:nvSpPr>
-          <p:cNvPr id="5" name="text-138">
-            <a:extLst xmlns:a="http://schemas.openxmlformats.org/drawingml/2006/main">
-              <a:ext uri="{FF2B5EF4-FFF2-40B4-BE49-F238E27FC236}">
-                <a16:creationId xmlns:a16="http://schemas.microsoft.com/office/drawing/2014/main" id="{51187C31-9746-4ABC-A5B0-0CE788F3DABF}"/>
+          <p:cNvPr id="5" name="text-46">
+            <a:extLst xmlns:a="http://schemas.openxmlformats.org/drawingml/2006/main">
+              <a:ext uri="{FF2B5EF4-FFF2-40B4-BE49-F238E27FC236}">
+                <a16:creationId xmlns:a16="http://schemas.microsoft.com/office/drawing/2014/main" id="{A058A660-C360-4E62-B6D0-561D0347E10F}"/>
               </a:ext>
             </a:extLst>
           </p:cNvPr>
@@ -4030,10 +4035,10 @@
       </p:sp>
       <p:sp>
         <p:nvSpPr>
-          <p:cNvPr id="6" name="box-139">
-            <a:extLst xmlns:a="http://schemas.openxmlformats.org/drawingml/2006/main">
-              <a:ext uri="{FF2B5EF4-FFF2-40B4-BE49-F238E27FC236}">
-                <a16:creationId xmlns:a16="http://schemas.microsoft.com/office/drawing/2014/main" id="{6B4ECD9E-6DCF-44F5-B7F2-998FB6B59AFF}"/>
+          <p:cNvPr id="6" name="box-47">
+            <a:extLst xmlns:a="http://schemas.openxmlformats.org/drawingml/2006/main">
+              <a:ext uri="{FF2B5EF4-FFF2-40B4-BE49-F238E27FC236}">
+                <a16:creationId xmlns:a16="http://schemas.microsoft.com/office/drawing/2014/main" id="{E2B1E56B-0949-409C-9813-15B927B06AFA}"/>
               </a:ext>
             </a:extLst>
           </p:cNvPr>
@@ -4063,10 +4068,10 @@
       </p:sp>
       <p:sp>
         <p:nvSpPr>
-          <p:cNvPr id="7" name="text-140">
-            <a:extLst xmlns:a="http://schemas.openxmlformats.org/drawingml/2006/main">
-              <a:ext uri="{FF2B5EF4-FFF2-40B4-BE49-F238E27FC236}">
-                <a16:creationId xmlns:a16="http://schemas.microsoft.com/office/drawing/2014/main" id="{0C515DC2-F9C6-459D-9ACB-188A0458661F}"/>
+          <p:cNvPr id="7" name="text-48">
+            <a:extLst xmlns:a="http://schemas.openxmlformats.org/drawingml/2006/main">
+              <a:ext uri="{FF2B5EF4-FFF2-40B4-BE49-F238E27FC236}">
+                <a16:creationId xmlns:a16="http://schemas.microsoft.com/office/drawing/2014/main" id="{807063C9-54A9-44AD-93B0-CDD163359DD1}"/>
               </a:ext>
             </a:extLst>
           </p:cNvPr>
@@ -4119,10 +4124,10 @@
       </p:sp>
       <p:sp>
         <p:nvSpPr>
-          <p:cNvPr id="8" name="text-141">
-            <a:extLst xmlns:a="http://schemas.openxmlformats.org/drawingml/2006/main">
-              <a:ext uri="{FF2B5EF4-FFF2-40B4-BE49-F238E27FC236}">
-                <a16:creationId xmlns:a16="http://schemas.microsoft.com/office/drawing/2014/main" id="{B81B7B96-B09C-4D26-B5CF-332741E33612}"/>
+          <p:cNvPr id="8" name="text-49">
+            <a:extLst xmlns:a="http://schemas.openxmlformats.org/drawingml/2006/main">
+              <a:ext uri="{FF2B5EF4-FFF2-40B4-BE49-F238E27FC236}">
+                <a16:creationId xmlns:a16="http://schemas.microsoft.com/office/drawing/2014/main" id="{B599C11B-B2C2-4DF7-9C53-7A365F76EBFB}"/>
               </a:ext>
             </a:extLst>
           </p:cNvPr>
@@ -4175,10 +4180,10 @@
       </p:sp>
       <p:sp>
         <p:nvSpPr>
-          <p:cNvPr id="9" name="box-142">
-            <a:extLst xmlns:a="http://schemas.openxmlformats.org/drawingml/2006/main">
-              <a:ext uri="{FF2B5EF4-FFF2-40B4-BE49-F238E27FC236}">
-                <a16:creationId xmlns:a16="http://schemas.microsoft.com/office/drawing/2014/main" id="{90D8C682-C6A5-4C7E-959B-24428DB5EF40}"/>
+          <p:cNvPr id="9" name="box-50">
+            <a:extLst xmlns:a="http://schemas.openxmlformats.org/drawingml/2006/main">
+              <a:ext uri="{FF2B5EF4-FFF2-40B4-BE49-F238E27FC236}">
+                <a16:creationId xmlns:a16="http://schemas.microsoft.com/office/drawing/2014/main" id="{CDC7D70A-616B-4A51-8C95-F4BBA62113D5}"/>
               </a:ext>
             </a:extLst>
           </p:cNvPr>
@@ -4208,10 +4213,10 @@
       </p:sp>
       <p:sp>
         <p:nvSpPr>
-          <p:cNvPr id="10" name="text-143">
-            <a:extLst xmlns:a="http://schemas.openxmlformats.org/drawingml/2006/main">
-              <a:ext uri="{FF2B5EF4-FFF2-40B4-BE49-F238E27FC236}">
-                <a16:creationId xmlns:a16="http://schemas.microsoft.com/office/drawing/2014/main" id="{3294922B-AA7E-48E2-B395-98BF7A429433}"/>
+          <p:cNvPr id="10" name="text-51">
+            <a:extLst xmlns:a="http://schemas.openxmlformats.org/drawingml/2006/main">
+              <a:ext uri="{FF2B5EF4-FFF2-40B4-BE49-F238E27FC236}">
+                <a16:creationId xmlns:a16="http://schemas.microsoft.com/office/drawing/2014/main" id="{D713DBA2-AD10-484E-955B-AC7A6756E53E}"/>
               </a:ext>
             </a:extLst>
           </p:cNvPr>
@@ -4264,10 +4269,10 @@
       </p:sp>
       <p:sp>
         <p:nvSpPr>
-          <p:cNvPr id="11" name="text-144">
-            <a:extLst xmlns:a="http://schemas.openxmlformats.org/drawingml/2006/main">
-              <a:ext uri="{FF2B5EF4-FFF2-40B4-BE49-F238E27FC236}">
-                <a16:creationId xmlns:a16="http://schemas.microsoft.com/office/drawing/2014/main" id="{4E70F1A3-5EB0-4465-96FA-F45B0182E424}"/>
+          <p:cNvPr id="11" name="text-52">
+            <a:extLst xmlns:a="http://schemas.openxmlformats.org/drawingml/2006/main">
+              <a:ext uri="{FF2B5EF4-FFF2-40B4-BE49-F238E27FC236}">
+                <a16:creationId xmlns:a16="http://schemas.microsoft.com/office/drawing/2014/main" id="{BDFBC8F2-FE5B-4F08-8C21-01BDC72F567D}"/>
               </a:ext>
             </a:extLst>
           </p:cNvPr>
@@ -4320,10 +4325,10 @@
       </p:sp>
       <p:sp>
         <p:nvSpPr>
-          <p:cNvPr id="12" name="box-145">
-            <a:extLst xmlns:a="http://schemas.openxmlformats.org/drawingml/2006/main">
-              <a:ext uri="{FF2B5EF4-FFF2-40B4-BE49-F238E27FC236}">
-                <a16:creationId xmlns:a16="http://schemas.microsoft.com/office/drawing/2014/main" id="{4285CE00-2946-43F6-B8DD-F7EB9E97DB27}"/>
+          <p:cNvPr id="12" name="box-53">
+            <a:extLst xmlns:a="http://schemas.openxmlformats.org/drawingml/2006/main">
+              <a:ext uri="{FF2B5EF4-FFF2-40B4-BE49-F238E27FC236}">
+                <a16:creationId xmlns:a16="http://schemas.microsoft.com/office/drawing/2014/main" id="{8ED008B3-B33E-4389-B11F-28138A4D1282}"/>
               </a:ext>
             </a:extLst>
           </p:cNvPr>
@@ -4353,10 +4358,10 @@
       </p:sp>
       <p:sp>
         <p:nvSpPr>
-          <p:cNvPr id="13" name="text-146">
-            <a:extLst xmlns:a="http://schemas.openxmlformats.org/drawingml/2006/main">
-              <a:ext uri="{FF2B5EF4-FFF2-40B4-BE49-F238E27FC236}">
-                <a16:creationId xmlns:a16="http://schemas.microsoft.com/office/drawing/2014/main" id="{D4FB2A22-CA28-4D9A-B916-C480226D1081}"/>
+          <p:cNvPr id="13" name="text-54">
+            <a:extLst xmlns:a="http://schemas.openxmlformats.org/drawingml/2006/main">
+              <a:ext uri="{FF2B5EF4-FFF2-40B4-BE49-F238E27FC236}">
+                <a16:creationId xmlns:a16="http://schemas.microsoft.com/office/drawing/2014/main" id="{A4748E45-0AA6-485A-980A-B74B932F7682}"/>
               </a:ext>
             </a:extLst>
           </p:cNvPr>
@@ -4409,10 +4414,10 @@
       </p:sp>
       <p:sp>
         <p:nvSpPr>
-          <p:cNvPr id="14" name="text-147">
-            <a:extLst xmlns:a="http://schemas.openxmlformats.org/drawingml/2006/main">
-              <a:ext uri="{FF2B5EF4-FFF2-40B4-BE49-F238E27FC236}">
-                <a16:creationId xmlns:a16="http://schemas.microsoft.com/office/drawing/2014/main" id="{9EFE31B0-C57D-4D46-ADA5-3ECAB22878A1}"/>
+          <p:cNvPr id="14" name="text-55">
+            <a:extLst xmlns:a="http://schemas.openxmlformats.org/drawingml/2006/main">
+              <a:ext uri="{FF2B5EF4-FFF2-40B4-BE49-F238E27FC236}">
+                <a16:creationId xmlns:a16="http://schemas.microsoft.com/office/drawing/2014/main" id="{B05A41B2-9F33-4F2C-B5B7-5CC9E88AB99E}"/>
               </a:ext>
             </a:extLst>
           </p:cNvPr>
@@ -4465,10 +4470,10 @@
       </p:sp>
       <p:sp>
         <p:nvSpPr>
-          <p:cNvPr id="15" name="box-148">
-            <a:extLst xmlns:a="http://schemas.openxmlformats.org/drawingml/2006/main">
-              <a:ext uri="{FF2B5EF4-FFF2-40B4-BE49-F238E27FC236}">
-                <a16:creationId xmlns:a16="http://schemas.microsoft.com/office/drawing/2014/main" id="{511D4DB3-40F0-443D-8229-0BCD92D32509}"/>
+          <p:cNvPr id="15" name="box-56">
+            <a:extLst xmlns:a="http://schemas.openxmlformats.org/drawingml/2006/main">
+              <a:ext uri="{FF2B5EF4-FFF2-40B4-BE49-F238E27FC236}">
+                <a16:creationId xmlns:a16="http://schemas.microsoft.com/office/drawing/2014/main" id="{C7A57353-27E6-49D2-8564-18F856026B74}"/>
               </a:ext>
             </a:extLst>
           </p:cNvPr>
@@ -4498,10 +4503,10 @@
       </p:sp>
       <p:sp>
         <p:nvSpPr>
-          <p:cNvPr id="16" name="text-149">
-            <a:extLst xmlns:a="http://schemas.openxmlformats.org/drawingml/2006/main">
-              <a:ext uri="{FF2B5EF4-FFF2-40B4-BE49-F238E27FC236}">
-                <a16:creationId xmlns:a16="http://schemas.microsoft.com/office/drawing/2014/main" id="{64554A85-F567-4886-9462-3ABEA2A36878}"/>
+          <p:cNvPr id="16" name="text-57">
+            <a:extLst xmlns:a="http://schemas.openxmlformats.org/drawingml/2006/main">
+              <a:ext uri="{FF2B5EF4-FFF2-40B4-BE49-F238E27FC236}">
+                <a16:creationId xmlns:a16="http://schemas.microsoft.com/office/drawing/2014/main" id="{244BA28B-5394-40FB-9F50-B2A3D2E2D7AF}"/>
               </a:ext>
             </a:extLst>
           </p:cNvPr>
@@ -4554,10 +4559,10 @@
       </p:sp>
       <p:sp>
         <p:nvSpPr>
-          <p:cNvPr id="17" name="text-150">
-            <a:extLst xmlns:a="http://schemas.openxmlformats.org/drawingml/2006/main">
-              <a:ext uri="{FF2B5EF4-FFF2-40B4-BE49-F238E27FC236}">
-                <a16:creationId xmlns:a16="http://schemas.microsoft.com/office/drawing/2014/main" id="{BCACB060-610A-4FC2-B053-A06E8CD6A2CA}"/>
+          <p:cNvPr id="17" name="text-58">
+            <a:extLst xmlns:a="http://schemas.openxmlformats.org/drawingml/2006/main">
+              <a:ext uri="{FF2B5EF4-FFF2-40B4-BE49-F238E27FC236}">
+                <a16:creationId xmlns:a16="http://schemas.microsoft.com/office/drawing/2014/main" id="{8B79E647-EB9F-4B45-AFD0-26D187B61193}"/>
               </a:ext>
             </a:extLst>
           </p:cNvPr>
@@ -4611,7 +4616,7 @@
     </p:spTree>
     <p:extLst>
       <p:ext uri="{BB962C8B-B14F-4D97-AF65-F5344CB8AC3E}">
-        <p14:creationId xmlns:p14="http://schemas.microsoft.com/office/powerpoint/2010/main" val="198296481"/>
+        <p14:creationId xmlns:p14="http://schemas.microsoft.com/office/powerpoint/2010/main" val="1383582838"/>
       </p:ext>
     </p:extLst>
   </p:cSld>
@@ -4639,10 +4644,10 @@
       </p:grpSpPr>
       <p:sp>
         <p:nvSpPr>
-          <p:cNvPr id="21" name="box-151">
-            <a:extLst xmlns:a="http://schemas.openxmlformats.org/drawingml/2006/main">
-              <a:ext uri="{FF2B5EF4-FFF2-40B4-BE49-F238E27FC236}">
-                <a16:creationId xmlns:a16="http://schemas.microsoft.com/office/drawing/2014/main" id="{BE741397-6ED3-491B-B3EC-2FB8476578C2}"/>
+          <p:cNvPr id="21" name="box-59">
+            <a:extLst xmlns:a="http://schemas.openxmlformats.org/drawingml/2006/main">
+              <a:ext uri="{FF2B5EF4-FFF2-40B4-BE49-F238E27FC236}">
+                <a16:creationId xmlns:a16="http://schemas.microsoft.com/office/drawing/2014/main" id="{E8CA2E55-742A-4DDE-BFDD-BDDF49B3E492}"/>
               </a:ext>
             </a:extLst>
           </p:cNvPr>
@@ -4672,10 +4677,10 @@
       </p:sp>
       <p:sp>
         <p:nvSpPr>
-          <p:cNvPr id="2" name="text-152">
-            <a:extLst xmlns:a="http://schemas.openxmlformats.org/drawingml/2006/main">
-              <a:ext uri="{FF2B5EF4-FFF2-40B4-BE49-F238E27FC236}">
-                <a16:creationId xmlns:a16="http://schemas.microsoft.com/office/drawing/2014/main" id="{9D190F9E-9536-4183-8422-C7547CA70121}"/>
+          <p:cNvPr id="2" name="text-60">
+            <a:extLst xmlns:a="http://schemas.openxmlformats.org/drawingml/2006/main">
+              <a:ext uri="{FF2B5EF4-FFF2-40B4-BE49-F238E27FC236}">
+                <a16:creationId xmlns:a16="http://schemas.microsoft.com/office/drawing/2014/main" id="{EAE0F16B-5A0C-44C9-AFCF-28D837DA076A}"/>
               </a:ext>
             </a:extLst>
           </p:cNvPr>
@@ -4728,10 +4733,10 @@
       </p:sp>
       <p:sp>
         <p:nvSpPr>
-          <p:cNvPr id="3" name="text-153">
-            <a:extLst xmlns:a="http://schemas.openxmlformats.org/drawingml/2006/main">
-              <a:ext uri="{FF2B5EF4-FFF2-40B4-BE49-F238E27FC236}">
-                <a16:creationId xmlns:a16="http://schemas.microsoft.com/office/drawing/2014/main" id="{C0968A03-1607-48DF-8FD5-5BA966669907}"/>
+          <p:cNvPr id="3" name="text-61">
+            <a:extLst xmlns:a="http://schemas.openxmlformats.org/drawingml/2006/main">
+              <a:ext uri="{FF2B5EF4-FFF2-40B4-BE49-F238E27FC236}">
+                <a16:creationId xmlns:a16="http://schemas.microsoft.com/office/drawing/2014/main" id="{348F0AE5-7630-4C1C-B3C5-11B61B082CB6}"/>
               </a:ext>
             </a:extLst>
           </p:cNvPr>
@@ -4784,10 +4789,10 @@
       </p:sp>
       <p:sp>
         <p:nvSpPr>
-          <p:cNvPr id="4" name="text-154">
-            <a:extLst xmlns:a="http://schemas.openxmlformats.org/drawingml/2006/main">
-              <a:ext uri="{FF2B5EF4-FFF2-40B4-BE49-F238E27FC236}">
-                <a16:creationId xmlns:a16="http://schemas.microsoft.com/office/drawing/2014/main" id="{F1719F66-D95C-4D0E-A2EC-43434C98161B}"/>
+          <p:cNvPr id="4" name="text-62">
+            <a:extLst xmlns:a="http://schemas.openxmlformats.org/drawingml/2006/main">
+              <a:ext uri="{FF2B5EF4-FFF2-40B4-BE49-F238E27FC236}">
+                <a16:creationId xmlns:a16="http://schemas.microsoft.com/office/drawing/2014/main" id="{5322831D-A0D0-4523-A243-AD8E4E44E0DA}"/>
               </a:ext>
             </a:extLst>
           </p:cNvPr>
@@ -4840,10 +4845,10 @@
       </p:sp>
       <p:sp>
         <p:nvSpPr>
-          <p:cNvPr id="5" name="text-155">
-            <a:extLst xmlns:a="http://schemas.openxmlformats.org/drawingml/2006/main">
-              <a:ext uri="{FF2B5EF4-FFF2-40B4-BE49-F238E27FC236}">
-                <a16:creationId xmlns:a16="http://schemas.microsoft.com/office/drawing/2014/main" id="{27887B4C-EB40-4128-AD6D-1B9AE7BD3CD8}"/>
+          <p:cNvPr id="5" name="text-63">
+            <a:extLst xmlns:a="http://schemas.openxmlformats.org/drawingml/2006/main">
+              <a:ext uri="{FF2B5EF4-FFF2-40B4-BE49-F238E27FC236}">
+                <a16:creationId xmlns:a16="http://schemas.microsoft.com/office/drawing/2014/main" id="{CD9C9608-1D34-410F-8817-47CF5C7CB081}"/>
               </a:ext>
             </a:extLst>
           </p:cNvPr>
@@ -4896,10 +4901,10 @@
       </p:sp>
       <p:sp>
         <p:nvSpPr>
-          <p:cNvPr id="6" name="box-156">
-            <a:extLst xmlns:a="http://schemas.openxmlformats.org/drawingml/2006/main">
-              <a:ext uri="{FF2B5EF4-FFF2-40B4-BE49-F238E27FC236}">
-                <a16:creationId xmlns:a16="http://schemas.microsoft.com/office/drawing/2014/main" id="{7658875A-D91C-400F-B044-54E8471119BD}"/>
+          <p:cNvPr id="6" name="box-64">
+            <a:extLst xmlns:a="http://schemas.openxmlformats.org/drawingml/2006/main">
+              <a:ext uri="{FF2B5EF4-FFF2-40B4-BE49-F238E27FC236}">
+                <a16:creationId xmlns:a16="http://schemas.microsoft.com/office/drawing/2014/main" id="{BFB652B2-B0FA-4F1D-86AF-6F2F0D2934F8}"/>
               </a:ext>
             </a:extLst>
           </p:cNvPr>
@@ -4929,10 +4934,10 @@
       </p:sp>
       <p:sp>
         <p:nvSpPr>
-          <p:cNvPr id="7" name="dot-157">
-            <a:extLst xmlns:a="http://schemas.openxmlformats.org/drawingml/2006/main">
-              <a:ext uri="{FF2B5EF4-FFF2-40B4-BE49-F238E27FC236}">
-                <a16:creationId xmlns:a16="http://schemas.microsoft.com/office/drawing/2014/main" id="{3F2BE63D-EAD5-4AA2-A277-F0224883F25D}"/>
+          <p:cNvPr id="7" name="dot-65">
+            <a:extLst xmlns:a="http://schemas.openxmlformats.org/drawingml/2006/main">
+              <a:ext uri="{FF2B5EF4-FFF2-40B4-BE49-F238E27FC236}">
+                <a16:creationId xmlns:a16="http://schemas.microsoft.com/office/drawing/2014/main" id="{028109BC-55B0-4025-B174-E777F43CE858}"/>
               </a:ext>
             </a:extLst>
           </p:cNvPr>
@@ -4960,10 +4965,10 @@
       </p:sp>
       <p:sp>
         <p:nvSpPr>
-          <p:cNvPr id="8" name="text-158">
-            <a:extLst xmlns:a="http://schemas.openxmlformats.org/drawingml/2006/main">
-              <a:ext uri="{FF2B5EF4-FFF2-40B4-BE49-F238E27FC236}">
-                <a16:creationId xmlns:a16="http://schemas.microsoft.com/office/drawing/2014/main" id="{A26BEA72-3A58-4889-B23E-8BC11D805C4B}"/>
+          <p:cNvPr id="8" name="text-66">
+            <a:extLst xmlns:a="http://schemas.openxmlformats.org/drawingml/2006/main">
+              <a:ext uri="{FF2B5EF4-FFF2-40B4-BE49-F238E27FC236}">
+                <a16:creationId xmlns:a16="http://schemas.microsoft.com/office/drawing/2014/main" id="{E60AA736-9AB6-412C-9D98-3FE80D3900C1}"/>
               </a:ext>
             </a:extLst>
           </p:cNvPr>
@@ -5016,10 +5021,10 @@
       </p:sp>
       <p:sp>
         <p:nvSpPr>
-          <p:cNvPr id="9" name="text-159">
-            <a:extLst xmlns:a="http://schemas.openxmlformats.org/drawingml/2006/main">
-              <a:ext uri="{FF2B5EF4-FFF2-40B4-BE49-F238E27FC236}">
-                <a16:creationId xmlns:a16="http://schemas.microsoft.com/office/drawing/2014/main" id="{1FC23A5D-964B-4156-B8E5-E9BE831F47E2}"/>
+          <p:cNvPr id="9" name="text-67">
+            <a:extLst xmlns:a="http://schemas.openxmlformats.org/drawingml/2006/main">
+              <a:ext uri="{FF2B5EF4-FFF2-40B4-BE49-F238E27FC236}">
+                <a16:creationId xmlns:a16="http://schemas.microsoft.com/office/drawing/2014/main" id="{9ECB5AB1-EAD9-4E1A-B498-14CF0C2CB719}"/>
               </a:ext>
             </a:extLst>
           </p:cNvPr>
@@ -5072,10 +5077,10 @@
       </p:sp>
       <p:sp>
         <p:nvSpPr>
-          <p:cNvPr id="10" name="text-160">
-            <a:extLst xmlns:a="http://schemas.openxmlformats.org/drawingml/2006/main">
-              <a:ext uri="{FF2B5EF4-FFF2-40B4-BE49-F238E27FC236}">
-                <a16:creationId xmlns:a16="http://schemas.microsoft.com/office/drawing/2014/main" id="{19733261-5D49-4826-9FFE-6B145EF57D06}"/>
+          <p:cNvPr id="10" name="text-68">
+            <a:extLst xmlns:a="http://schemas.openxmlformats.org/drawingml/2006/main">
+              <a:ext uri="{FF2B5EF4-FFF2-40B4-BE49-F238E27FC236}">
+                <a16:creationId xmlns:a16="http://schemas.microsoft.com/office/drawing/2014/main" id="{D4E1B850-1C6C-41B6-BA7B-E09632B594F7}"/>
               </a:ext>
             </a:extLst>
           </p:cNvPr>
@@ -5128,10 +5133,10 @@
       </p:sp>
       <p:sp>
         <p:nvSpPr>
-          <p:cNvPr id="11" name="dot-161">
-            <a:extLst xmlns:a="http://schemas.openxmlformats.org/drawingml/2006/main">
-              <a:ext uri="{FF2B5EF4-FFF2-40B4-BE49-F238E27FC236}">
-                <a16:creationId xmlns:a16="http://schemas.microsoft.com/office/drawing/2014/main" id="{360DA7F1-7C82-47A6-AB7E-F9C284AED7D7}"/>
+          <p:cNvPr id="11" name="dot-69">
+            <a:extLst xmlns:a="http://schemas.openxmlformats.org/drawingml/2006/main">
+              <a:ext uri="{FF2B5EF4-FFF2-40B4-BE49-F238E27FC236}">
+                <a16:creationId xmlns:a16="http://schemas.microsoft.com/office/drawing/2014/main" id="{846E15A0-1CF5-456B-94A3-09EA76B5279A}"/>
               </a:ext>
             </a:extLst>
           </p:cNvPr>
@@ -5159,10 +5164,10 @@
       </p:sp>
       <p:sp>
         <p:nvSpPr>
-          <p:cNvPr id="12" name="text-162">
-            <a:extLst xmlns:a="http://schemas.openxmlformats.org/drawingml/2006/main">
-              <a:ext uri="{FF2B5EF4-FFF2-40B4-BE49-F238E27FC236}">
-                <a16:creationId xmlns:a16="http://schemas.microsoft.com/office/drawing/2014/main" id="{DE9C4D69-4DAF-4E97-90CC-F6DB80C5A331}"/>
+          <p:cNvPr id="12" name="text-70">
+            <a:extLst xmlns:a="http://schemas.openxmlformats.org/drawingml/2006/main">
+              <a:ext uri="{FF2B5EF4-FFF2-40B4-BE49-F238E27FC236}">
+                <a16:creationId xmlns:a16="http://schemas.microsoft.com/office/drawing/2014/main" id="{AED5EDC5-52D4-4728-8C12-801E5F02BE41}"/>
               </a:ext>
             </a:extLst>
           </p:cNvPr>
@@ -5215,10 +5220,10 @@
       </p:sp>
       <p:sp>
         <p:nvSpPr>
-          <p:cNvPr id="13" name="text-163">
-            <a:extLst xmlns:a="http://schemas.openxmlformats.org/drawingml/2006/main">
-              <a:ext uri="{FF2B5EF4-FFF2-40B4-BE49-F238E27FC236}">
-                <a16:creationId xmlns:a16="http://schemas.microsoft.com/office/drawing/2014/main" id="{78463909-8349-4549-9E14-A4C245EC413D}"/>
+          <p:cNvPr id="13" name="text-71">
+            <a:extLst xmlns:a="http://schemas.openxmlformats.org/drawingml/2006/main">
+              <a:ext uri="{FF2B5EF4-FFF2-40B4-BE49-F238E27FC236}">
+                <a16:creationId xmlns:a16="http://schemas.microsoft.com/office/drawing/2014/main" id="{BF9A8BFC-12DC-4923-B789-F3949EF87038}"/>
               </a:ext>
             </a:extLst>
           </p:cNvPr>
@@ -5271,10 +5276,10 @@
       </p:sp>
       <p:sp>
         <p:nvSpPr>
-          <p:cNvPr id="14" name="text-164">
-            <a:extLst xmlns:a="http://schemas.openxmlformats.org/drawingml/2006/main">
-              <a:ext uri="{FF2B5EF4-FFF2-40B4-BE49-F238E27FC236}">
-                <a16:creationId xmlns:a16="http://schemas.microsoft.com/office/drawing/2014/main" id="{33441DBD-0CAD-4060-8935-7AFBBE21BB4D}"/>
+          <p:cNvPr id="14" name="text-72">
+            <a:extLst xmlns:a="http://schemas.openxmlformats.org/drawingml/2006/main">
+              <a:ext uri="{FF2B5EF4-FFF2-40B4-BE49-F238E27FC236}">
+                <a16:creationId xmlns:a16="http://schemas.microsoft.com/office/drawing/2014/main" id="{59C15416-8384-4FC4-89E0-F1FA8EFC8FC3}"/>
               </a:ext>
             </a:extLst>
           </p:cNvPr>
@@ -5327,10 +5332,10 @@
       </p:sp>
       <p:sp>
         <p:nvSpPr>
-          <p:cNvPr id="15" name="dot-165">
-            <a:extLst xmlns:a="http://schemas.openxmlformats.org/drawingml/2006/main">
-              <a:ext uri="{FF2B5EF4-FFF2-40B4-BE49-F238E27FC236}">
-                <a16:creationId xmlns:a16="http://schemas.microsoft.com/office/drawing/2014/main" id="{6D74D34C-6DDC-42A0-AF7A-0A1C0EBBCA40}"/>
+          <p:cNvPr id="15" name="dot-73">
+            <a:extLst xmlns:a="http://schemas.openxmlformats.org/drawingml/2006/main">
+              <a:ext uri="{FF2B5EF4-FFF2-40B4-BE49-F238E27FC236}">
+                <a16:creationId xmlns:a16="http://schemas.microsoft.com/office/drawing/2014/main" id="{C1F775BA-9F50-4576-B8B6-F62D52CA01E9}"/>
               </a:ext>
             </a:extLst>
           </p:cNvPr>
@@ -5358,10 +5363,10 @@
       </p:sp>
       <p:sp>
         <p:nvSpPr>
-          <p:cNvPr id="16" name="text-166">
-            <a:extLst xmlns:a="http://schemas.openxmlformats.org/drawingml/2006/main">
-              <a:ext uri="{FF2B5EF4-FFF2-40B4-BE49-F238E27FC236}">
-                <a16:creationId xmlns:a16="http://schemas.microsoft.com/office/drawing/2014/main" id="{99037446-62FC-4C47-B0A6-31F07B0E8420}"/>
+          <p:cNvPr id="16" name="text-74">
+            <a:extLst xmlns:a="http://schemas.openxmlformats.org/drawingml/2006/main">
+              <a:ext uri="{FF2B5EF4-FFF2-40B4-BE49-F238E27FC236}">
+                <a16:creationId xmlns:a16="http://schemas.microsoft.com/office/drawing/2014/main" id="{F6C3E64C-278E-4C27-A9EC-ECC9724D7895}"/>
               </a:ext>
             </a:extLst>
           </p:cNvPr>
@@ -5414,10 +5419,10 @@
       </p:sp>
       <p:sp>
         <p:nvSpPr>
-          <p:cNvPr id="17" name="text-167">
-            <a:extLst xmlns:a="http://schemas.openxmlformats.org/drawingml/2006/main">
-              <a:ext uri="{FF2B5EF4-FFF2-40B4-BE49-F238E27FC236}">
-                <a16:creationId xmlns:a16="http://schemas.microsoft.com/office/drawing/2014/main" id="{8082348C-6393-4DD0-9DF9-DC2D976BFEB1}"/>
+          <p:cNvPr id="17" name="text-75">
+            <a:extLst xmlns:a="http://schemas.openxmlformats.org/drawingml/2006/main">
+              <a:ext uri="{FF2B5EF4-FFF2-40B4-BE49-F238E27FC236}">
+                <a16:creationId xmlns:a16="http://schemas.microsoft.com/office/drawing/2014/main" id="{2A6A63C0-07E0-40BC-B9E5-47AC479AB39B}"/>
               </a:ext>
             </a:extLst>
           </p:cNvPr>
@@ -5470,10 +5475,10 @@
       </p:sp>
       <p:sp>
         <p:nvSpPr>
-          <p:cNvPr id="18" name="text-168">
-            <a:extLst xmlns:a="http://schemas.openxmlformats.org/drawingml/2006/main">
-              <a:ext uri="{FF2B5EF4-FFF2-40B4-BE49-F238E27FC236}">
-                <a16:creationId xmlns:a16="http://schemas.microsoft.com/office/drawing/2014/main" id="{F1087681-E727-4EC2-BAB6-0A03CE584AC0}"/>
+          <p:cNvPr id="18" name="text-76">
+            <a:extLst xmlns:a="http://schemas.openxmlformats.org/drawingml/2006/main">
+              <a:ext uri="{FF2B5EF4-FFF2-40B4-BE49-F238E27FC236}">
+                <a16:creationId xmlns:a16="http://schemas.microsoft.com/office/drawing/2014/main" id="{8E1B76D9-4BD0-42BF-8AFE-3736BD27A47D}"/>
               </a:ext>
             </a:extLst>
           </p:cNvPr>
@@ -5526,10 +5531,10 @@
       </p:sp>
       <p:sp>
         <p:nvSpPr>
-          <p:cNvPr id="19" name="box-169">
-            <a:extLst xmlns:a="http://schemas.openxmlformats.org/drawingml/2006/main">
-              <a:ext uri="{FF2B5EF4-FFF2-40B4-BE49-F238E27FC236}">
-                <a16:creationId xmlns:a16="http://schemas.microsoft.com/office/drawing/2014/main" id="{2A89ACC1-BCE3-4CB5-A534-5767F8C031A2}"/>
+          <p:cNvPr id="19" name="box-77">
+            <a:extLst xmlns:a="http://schemas.openxmlformats.org/drawingml/2006/main">
+              <a:ext uri="{FF2B5EF4-FFF2-40B4-BE49-F238E27FC236}">
+                <a16:creationId xmlns:a16="http://schemas.microsoft.com/office/drawing/2014/main" id="{6BF0A664-B7E4-4ABD-ABD8-0996CFC8C810}"/>
               </a:ext>
             </a:extLst>
           </p:cNvPr>
@@ -5559,10 +5564,10 @@
       </p:sp>
       <p:sp>
         <p:nvSpPr>
-          <p:cNvPr id="20" name="text-170">
-            <a:extLst xmlns:a="http://schemas.openxmlformats.org/drawingml/2006/main">
-              <a:ext uri="{FF2B5EF4-FFF2-40B4-BE49-F238E27FC236}">
-                <a16:creationId xmlns:a16="http://schemas.microsoft.com/office/drawing/2014/main" id="{8CC9FF0E-5CB3-4274-9878-7D1F3DDDF3E9}"/>
+          <p:cNvPr id="20" name="text-78">
+            <a:extLst xmlns:a="http://schemas.openxmlformats.org/drawingml/2006/main">
+              <a:ext uri="{FF2B5EF4-FFF2-40B4-BE49-F238E27FC236}">
+                <a16:creationId xmlns:a16="http://schemas.microsoft.com/office/drawing/2014/main" id="{19F1713F-AD26-4B0C-A402-F07E48FF3E66}"/>
               </a:ext>
             </a:extLst>
           </p:cNvPr>
@@ -5616,7 +5621,7 @@
     </p:spTree>
     <p:extLst>
       <p:ext uri="{BB962C8B-B14F-4D97-AF65-F5344CB8AC3E}">
-        <p14:creationId xmlns:p14="http://schemas.microsoft.com/office/powerpoint/2010/main" val="566385536"/>
+        <p14:creationId xmlns:p14="http://schemas.microsoft.com/office/powerpoint/2010/main" val="1873940815"/>
       </p:ext>
     </p:extLst>
   </p:cSld>
@@ -5644,10 +5649,10 @@
       </p:grpSpPr>
       <p:sp>
         <p:nvSpPr>
-          <p:cNvPr id="15" name="box-171">
-            <a:extLst xmlns:a="http://schemas.openxmlformats.org/drawingml/2006/main">
-              <a:ext uri="{FF2B5EF4-FFF2-40B4-BE49-F238E27FC236}">
-                <a16:creationId xmlns:a16="http://schemas.microsoft.com/office/drawing/2014/main" id="{C59CC45E-8C91-455B-8F31-E036E9997CC6}"/>
+          <p:cNvPr id="18" name="box-79">
+            <a:extLst xmlns:a="http://schemas.openxmlformats.org/drawingml/2006/main">
+              <a:ext uri="{FF2B5EF4-FFF2-40B4-BE49-F238E27FC236}">
+                <a16:creationId xmlns:a16="http://schemas.microsoft.com/office/drawing/2014/main" id="{39C02A3A-013D-40A7-92EB-E88070BF6E0C}"/>
               </a:ext>
             </a:extLst>
           </p:cNvPr>
@@ -5677,10 +5682,10 @@
       </p:sp>
       <p:sp>
         <p:nvSpPr>
-          <p:cNvPr id="2" name="text-172">
-            <a:extLst xmlns:a="http://schemas.openxmlformats.org/drawingml/2006/main">
-              <a:ext uri="{FF2B5EF4-FFF2-40B4-BE49-F238E27FC236}">
-                <a16:creationId xmlns:a16="http://schemas.microsoft.com/office/drawing/2014/main" id="{4EB1FDE6-CC75-4856-877F-E23611133661}"/>
+          <p:cNvPr id="2" name="text-80">
+            <a:extLst xmlns:a="http://schemas.openxmlformats.org/drawingml/2006/main">
+              <a:ext uri="{FF2B5EF4-FFF2-40B4-BE49-F238E27FC236}">
+                <a16:creationId xmlns:a16="http://schemas.microsoft.com/office/drawing/2014/main" id="{BC8B7B21-C99B-4523-BD8A-E90B66FA938E}"/>
               </a:ext>
             </a:extLst>
           </p:cNvPr>
@@ -5733,10 +5738,10 @@
       </p:sp>
       <p:sp>
         <p:nvSpPr>
-          <p:cNvPr id="3" name="text-173">
-            <a:extLst xmlns:a="http://schemas.openxmlformats.org/drawingml/2006/main">
-              <a:ext uri="{FF2B5EF4-FFF2-40B4-BE49-F238E27FC236}">
-                <a16:creationId xmlns:a16="http://schemas.microsoft.com/office/drawing/2014/main" id="{2BE818A9-7983-4696-9457-33D77C876350}"/>
+          <p:cNvPr id="3" name="text-81">
+            <a:extLst xmlns:a="http://schemas.openxmlformats.org/drawingml/2006/main">
+              <a:ext uri="{FF2B5EF4-FFF2-40B4-BE49-F238E27FC236}">
+                <a16:creationId xmlns:a16="http://schemas.microsoft.com/office/drawing/2014/main" id="{9D3B7AFF-E841-49D5-9CCD-98A5F98E8C85}"/>
               </a:ext>
             </a:extLst>
           </p:cNvPr>
@@ -5789,10 +5794,10 @@
       </p:sp>
       <p:sp>
         <p:nvSpPr>
-          <p:cNvPr id="4" name="text-174">
-            <a:extLst xmlns:a="http://schemas.openxmlformats.org/drawingml/2006/main">
-              <a:ext uri="{FF2B5EF4-FFF2-40B4-BE49-F238E27FC236}">
-                <a16:creationId xmlns:a16="http://schemas.microsoft.com/office/drawing/2014/main" id="{53F2EE92-CF57-4DCE-8549-C587EB36CFDD}"/>
+          <p:cNvPr id="4" name="text-82">
+            <a:extLst xmlns:a="http://schemas.openxmlformats.org/drawingml/2006/main">
+              <a:ext uri="{FF2B5EF4-FFF2-40B4-BE49-F238E27FC236}">
+                <a16:creationId xmlns:a16="http://schemas.microsoft.com/office/drawing/2014/main" id="{272D765D-19F1-4D6A-A6B4-F35B19DD1299}"/>
               </a:ext>
             </a:extLst>
           </p:cNvPr>
@@ -5845,10 +5850,10 @@
       </p:sp>
       <p:sp>
         <p:nvSpPr>
-          <p:cNvPr id="5" name="text-175">
-            <a:extLst xmlns:a="http://schemas.openxmlformats.org/drawingml/2006/main">
-              <a:ext uri="{FF2B5EF4-FFF2-40B4-BE49-F238E27FC236}">
-                <a16:creationId xmlns:a16="http://schemas.microsoft.com/office/drawing/2014/main" id="{CC32A8D9-4C42-479C-A9A7-73F470D9ADED}"/>
+          <p:cNvPr id="5" name="text-83">
+            <a:extLst xmlns:a="http://schemas.openxmlformats.org/drawingml/2006/main">
+              <a:ext uri="{FF2B5EF4-FFF2-40B4-BE49-F238E27FC236}">
+                <a16:creationId xmlns:a16="http://schemas.microsoft.com/office/drawing/2014/main" id="{A9592D8F-3C46-4ED3-9BE5-AA7A0A762142}"/>
               </a:ext>
             </a:extLst>
           </p:cNvPr>
@@ -5901,10 +5906,10 @@
       </p:sp>
       <p:sp>
         <p:nvSpPr>
-          <p:cNvPr id="6" name="text-176">
-            <a:extLst xmlns:a="http://schemas.openxmlformats.org/drawingml/2006/main">
-              <a:ext uri="{FF2B5EF4-FFF2-40B4-BE49-F238E27FC236}">
-                <a16:creationId xmlns:a16="http://schemas.microsoft.com/office/drawing/2014/main" id="{77EB9CF4-282B-43FD-9CD0-2151B9D14C09}"/>
+          <p:cNvPr id="6" name="text-84">
+            <a:extLst xmlns:a="http://schemas.openxmlformats.org/drawingml/2006/main">
+              <a:ext uri="{FF2B5EF4-FFF2-40B4-BE49-F238E27FC236}">
+                <a16:creationId xmlns:a16="http://schemas.microsoft.com/office/drawing/2014/main" id="{23006532-81B9-46C0-A6C1-A2ECBFDCED25}"/>
               </a:ext>
             </a:extLst>
           </p:cNvPr>
@@ -5957,10 +5962,10 @@
       </p:sp>
       <p:sp>
         <p:nvSpPr>
-          <p:cNvPr id="7" name="text-177">
-            <a:extLst xmlns:a="http://schemas.openxmlformats.org/drawingml/2006/main">
-              <a:ext uri="{FF2B5EF4-FFF2-40B4-BE49-F238E27FC236}">
-                <a16:creationId xmlns:a16="http://schemas.microsoft.com/office/drawing/2014/main" id="{ADE6F1BC-4EBC-4560-A12F-CB72EF839A88}"/>
+          <p:cNvPr id="7" name="text-85">
+            <a:extLst xmlns:a="http://schemas.openxmlformats.org/drawingml/2006/main">
+              <a:ext uri="{FF2B5EF4-FFF2-40B4-BE49-F238E27FC236}">
+                <a16:creationId xmlns:a16="http://schemas.microsoft.com/office/drawing/2014/main" id="{A7139CDE-5220-4F96-84FE-3C4A2A51A007}"/>
               </a:ext>
             </a:extLst>
           </p:cNvPr>
@@ -6013,10 +6018,10 @@
       </p:sp>
       <p:sp>
         <p:nvSpPr>
-          <p:cNvPr id="8" name="text-178">
-            <a:extLst xmlns:a="http://schemas.openxmlformats.org/drawingml/2006/main">
-              <a:ext uri="{FF2B5EF4-FFF2-40B4-BE49-F238E27FC236}">
-                <a16:creationId xmlns:a16="http://schemas.microsoft.com/office/drawing/2014/main" id="{AAE08D48-935F-40A3-B668-0460E6AB084F}"/>
+          <p:cNvPr id="8" name="text-86">
+            <a:extLst xmlns:a="http://schemas.openxmlformats.org/drawingml/2006/main">
+              <a:ext uri="{FF2B5EF4-FFF2-40B4-BE49-F238E27FC236}">
+                <a16:creationId xmlns:a16="http://schemas.microsoft.com/office/drawing/2014/main" id="{AF72BF6A-0183-4229-89C3-67CDC45767F0}"/>
               </a:ext>
             </a:extLst>
           </p:cNvPr>
@@ -6069,10 +6074,10 @@
       </p:sp>
       <p:sp>
         <p:nvSpPr>
-          <p:cNvPr id="9" name="text-179">
-            <a:extLst xmlns:a="http://schemas.openxmlformats.org/drawingml/2006/main">
-              <a:ext uri="{FF2B5EF4-FFF2-40B4-BE49-F238E27FC236}">
-                <a16:creationId xmlns:a16="http://schemas.microsoft.com/office/drawing/2014/main" id="{962389B3-07DF-4F71-A2B4-49164E16FE74}"/>
+          <p:cNvPr id="9" name="text-87">
+            <a:extLst xmlns:a="http://schemas.openxmlformats.org/drawingml/2006/main">
+              <a:ext uri="{FF2B5EF4-FFF2-40B4-BE49-F238E27FC236}">
+                <a16:creationId xmlns:a16="http://schemas.microsoft.com/office/drawing/2014/main" id="{AF2AB590-0110-47F4-89DB-416CB4FEDA88}"/>
               </a:ext>
             </a:extLst>
           </p:cNvPr>
@@ -6125,10 +6130,10 @@
       </p:sp>
       <p:sp>
         <p:nvSpPr>
-          <p:cNvPr id="10" name="text-180">
-            <a:extLst xmlns:a="http://schemas.openxmlformats.org/drawingml/2006/main">
-              <a:ext uri="{FF2B5EF4-FFF2-40B4-BE49-F238E27FC236}">
-                <a16:creationId xmlns:a16="http://schemas.microsoft.com/office/drawing/2014/main" id="{CF5FF58B-C883-4174-A0D0-D7F5069B83FC}"/>
+          <p:cNvPr id="10" name="text-88">
+            <a:extLst xmlns:a="http://schemas.openxmlformats.org/drawingml/2006/main">
+              <a:ext uri="{FF2B5EF4-FFF2-40B4-BE49-F238E27FC236}">
+                <a16:creationId xmlns:a16="http://schemas.microsoft.com/office/drawing/2014/main" id="{DA56E555-E322-4DDD-B149-5ED88E8FBE11}"/>
               </a:ext>
             </a:extLst>
           </p:cNvPr>
@@ -6227,10 +6232,10 @@
       </p:sp>
       <p:sp>
         <p:nvSpPr>
-          <p:cNvPr id="11" name="text-181">
-            <a:extLst xmlns:a="http://schemas.openxmlformats.org/drawingml/2006/main">
-              <a:ext uri="{FF2B5EF4-FFF2-40B4-BE49-F238E27FC236}">
-                <a16:creationId xmlns:a16="http://schemas.microsoft.com/office/drawing/2014/main" id="{D4AEDA3A-B751-4C4F-AFAF-C52FE89413F6}"/>
+          <p:cNvPr id="11" name="text-89">
+            <a:extLst xmlns:a="http://schemas.openxmlformats.org/drawingml/2006/main">
+              <a:ext uri="{FF2B5EF4-FFF2-40B4-BE49-F238E27FC236}">
+                <a16:creationId xmlns:a16="http://schemas.microsoft.com/office/drawing/2014/main" id="{577A4B65-1699-4063-845C-A7FDA5F9BCFF}"/>
               </a:ext>
             </a:extLst>
           </p:cNvPr>
@@ -6329,10 +6334,10 @@
       </p:sp>
       <p:sp>
         <p:nvSpPr>
-          <p:cNvPr id="12" name="text-182">
-            <a:extLst xmlns:a="http://schemas.openxmlformats.org/drawingml/2006/main">
-              <a:ext uri="{FF2B5EF4-FFF2-40B4-BE49-F238E27FC236}">
-                <a16:creationId xmlns:a16="http://schemas.microsoft.com/office/drawing/2014/main" id="{7AA9D52A-C55E-4657-967A-22372E836106}"/>
+          <p:cNvPr id="12" name="text-90">
+            <a:extLst xmlns:a="http://schemas.openxmlformats.org/drawingml/2006/main">
+              <a:ext uri="{FF2B5EF4-FFF2-40B4-BE49-F238E27FC236}">
+                <a16:creationId xmlns:a16="http://schemas.microsoft.com/office/drawing/2014/main" id="{4D7DDF37-5CD9-40B0-A25B-CD2546EE88DF}"/>
               </a:ext>
             </a:extLst>
           </p:cNvPr>
@@ -6431,10 +6436,10 @@
       </p:sp>
       <p:sp>
         <p:nvSpPr>
-          <p:cNvPr id="13" name="box-183">
-            <a:extLst xmlns:a="http://schemas.openxmlformats.org/drawingml/2006/main">
-              <a:ext uri="{FF2B5EF4-FFF2-40B4-BE49-F238E27FC236}">
-                <a16:creationId xmlns:a16="http://schemas.microsoft.com/office/drawing/2014/main" id="{BEF8C99F-0548-43FA-AEFF-B7C0D5224C94}"/>
+          <p:cNvPr id="13" name="box-91">
+            <a:extLst xmlns:a="http://schemas.openxmlformats.org/drawingml/2006/main">
+              <a:ext uri="{FF2B5EF4-FFF2-40B4-BE49-F238E27FC236}">
+                <a16:creationId xmlns:a16="http://schemas.microsoft.com/office/drawing/2014/main" id="{75EC0435-A2BE-4517-B492-F7A4EF70FE19}"/>
               </a:ext>
             </a:extLst>
           </p:cNvPr>
@@ -6464,38 +6469,38 @@
       </p:sp>
       <p:sp>
         <p:nvSpPr>
-          <p:cNvPr id="14" name="text-184">
-            <a:extLst xmlns:a="http://schemas.openxmlformats.org/drawingml/2006/main">
-              <a:ext uri="{FF2B5EF4-FFF2-40B4-BE49-F238E27FC236}">
-                <a16:creationId xmlns:a16="http://schemas.microsoft.com/office/drawing/2014/main" id="{63D6C122-E05F-4FC0-B043-A4BF538E6B4B}"/>
-              </a:ext>
-            </a:extLst>
-          </p:cNvPr>
-          <p:cNvSpPr>
-            <a:spLocks xmlns:a="http://schemas.openxmlformats.org/drawingml/2006/main" noGrp="1"/>
-          </p:cNvSpPr>
-          <p:nvPr/>
-        </p:nvSpPr>
-        <p:spPr>
-          <a:xfrm xmlns:a="http://schemas.openxmlformats.org/drawingml/2006/main">
-            <a:off x="400050" y="5810250"/>
-            <a:ext cx="10668000" cy="514350"/>
-          </a:xfrm>
-          <a:prstGeom xmlns:a="http://schemas.openxmlformats.org/drawingml/2006/main" prst="rect">
-            <a:avLst/>
-          </a:prstGeom>
-          <a:noFill xmlns:a="http://schemas.openxmlformats.org/drawingml/2006/main"/>
-          <a:ln xmlns:a="http://schemas.openxmlformats.org/drawingml/2006/main" w="0">
-            <a:noFill/>
-            <a:prstDash val="solid"/>
-          </a:ln>
-        </p:spPr>
-        <p:txBody>
-          <a:bodyPr xmlns:a="http://schemas.openxmlformats.org/drawingml/2006/main" anchor="t"/>
-          <a:lstStyle xmlns:a="http://schemas.openxmlformats.org/drawingml/2006/main"/>
-          <a:p xmlns:a="http://schemas.openxmlformats.org/drawingml/2006/main">
-            <a:pPr algn="l">
-              <a:defRPr sz="1200" b="1">
+          <p:cNvPr id="14" name="text-92">
+            <a:extLst xmlns:a="http://schemas.openxmlformats.org/drawingml/2006/main">
+              <a:ext uri="{FF2B5EF4-FFF2-40B4-BE49-F238E27FC236}">
+                <a16:creationId xmlns:a16="http://schemas.microsoft.com/office/drawing/2014/main" id="{26F9A253-6CD5-4205-91F9-8226A49F4C8D}"/>
+              </a:ext>
+            </a:extLst>
+          </p:cNvPr>
+          <p:cNvSpPr>
+            <a:spLocks xmlns:a="http://schemas.openxmlformats.org/drawingml/2006/main" noGrp="1"/>
+          </p:cNvSpPr>
+          <p:nvPr/>
+        </p:nvSpPr>
+        <p:spPr>
+          <a:xfrm xmlns:a="http://schemas.openxmlformats.org/drawingml/2006/main">
+            <a:off x="400050" y="5715000"/>
+            <a:ext cx="10668000" cy="209550"/>
+          </a:xfrm>
+          <a:prstGeom xmlns:a="http://schemas.openxmlformats.org/drawingml/2006/main" prst="rect">
+            <a:avLst/>
+          </a:prstGeom>
+          <a:noFill xmlns:a="http://schemas.openxmlformats.org/drawingml/2006/main"/>
+          <a:ln xmlns:a="http://schemas.openxmlformats.org/drawingml/2006/main" w="0">
+            <a:noFill/>
+            <a:prstDash val="solid"/>
+          </a:ln>
+        </p:spPr>
+        <p:txBody>
+          <a:bodyPr xmlns:a="http://schemas.openxmlformats.org/drawingml/2006/main" anchor="t"/>
+          <a:lstStyle xmlns:a="http://schemas.openxmlformats.org/drawingml/2006/main"/>
+          <a:p xmlns:a="http://schemas.openxmlformats.org/drawingml/2006/main">
+            <a:pPr algn="l">
+              <a:defRPr sz="1050" b="1">
                 <a:solidFill>
                   <a:srgbClr val="111111"/>
                 </a:solidFill>
@@ -6505,7 +6510,7 @@
               </a:defRPr>
             </a:pPr>
             <a:r>
-              <a:rPr sz="1200" b="1">
+              <a:rPr sz="1050" b="1">
                 <a:solidFill>
                   <a:srgbClr val="111111"/>
                 </a:solidFill>
@@ -6514,6 +6519,174 @@
                 <a:cs typeface="Arial"/>
               </a:rPr>
               <a:t>EXE + source + docs + private GitHub + trilingual deck · EXE + kaynak + belgeler + GitHub privé + sunum trilingue</a:t>
+            </a:r>
+          </a:p>
+        </p:txBody>
+      </p:sp>
+      <p:sp>
+        <p:nvSpPr>
+          <p:cNvPr id="15" name="text-93">
+            <a:extLst xmlns:a="http://schemas.openxmlformats.org/drawingml/2006/main">
+              <a:ext uri="{FF2B5EF4-FFF2-40B4-BE49-F238E27FC236}">
+                <a16:creationId xmlns:a16="http://schemas.microsoft.com/office/drawing/2014/main" id="{DCB11C92-E7FC-4B64-92B3-D21DE908E482}"/>
+              </a:ext>
+            </a:extLst>
+          </p:cNvPr>
+          <p:cNvSpPr>
+            <a:spLocks xmlns:a="http://schemas.openxmlformats.org/drawingml/2006/main" noGrp="1"/>
+          </p:cNvSpPr>
+          <p:nvPr/>
+        </p:nvSpPr>
+        <p:spPr>
+          <a:xfrm xmlns:a="http://schemas.openxmlformats.org/drawingml/2006/main">
+            <a:off x="400050" y="5962650"/>
+            <a:ext cx="10668000" cy="209550"/>
+          </a:xfrm>
+          <a:prstGeom xmlns:a="http://schemas.openxmlformats.org/drawingml/2006/main" prst="rect">
+            <a:avLst/>
+          </a:prstGeom>
+          <a:noFill xmlns:a="http://schemas.openxmlformats.org/drawingml/2006/main"/>
+          <a:ln xmlns:a="http://schemas.openxmlformats.org/drawingml/2006/main" w="0">
+            <a:noFill/>
+            <a:prstDash val="solid"/>
+          </a:ln>
+        </p:spPr>
+        <p:txBody>
+          <a:bodyPr xmlns:a="http://schemas.openxmlformats.org/drawingml/2006/main" anchor="t"/>
+          <a:lstStyle xmlns:a="http://schemas.openxmlformats.org/drawingml/2006/main"/>
+          <a:p xmlns:a="http://schemas.openxmlformats.org/drawingml/2006/main">
+            <a:pPr algn="l">
+              <a:defRPr sz="1050" b="1">
+                <a:solidFill>
+                  <a:srgbClr val="B8323A"/>
+                </a:solidFill>
+                <a:latin typeface="Arial"/>
+                <a:ea typeface="Arial"/>
+                <a:cs typeface="Arial"/>
+              </a:defRPr>
+            </a:pPr>
+            <a:r>
+              <a:rPr sz="1050" b="1">
+                <a:solidFill>
+                  <a:srgbClr val="B8323A"/>
+                </a:solidFill>
+                <a:latin typeface="Arial"/>
+                <a:ea typeface="Arial"/>
+                <a:cs typeface="Arial"/>
+              </a:rPr>
+              <a:t>Windows 10/11 (x64) + macOS (Apple Silicon) — İndirme: github.com/Azizsekerdil/FrenchCourseAI/releases (v1.0.0) · (özel repo)</a:t>
+            </a:r>
+          </a:p>
+        </p:txBody>
+      </p:sp>
+      <p:sp>
+        <p:nvSpPr>
+          <p:cNvPr id="16" name="text-94">
+            <a:extLst xmlns:a="http://schemas.openxmlformats.org/drawingml/2006/main">
+              <a:ext uri="{FF2B5EF4-FFF2-40B4-BE49-F238E27FC236}">
+                <a16:creationId xmlns:a16="http://schemas.microsoft.com/office/drawing/2014/main" id="{C82E9B58-B89D-4288-9403-21CA1E7DBA78}"/>
+              </a:ext>
+            </a:extLst>
+          </p:cNvPr>
+          <p:cNvSpPr>
+            <a:spLocks xmlns:a="http://schemas.openxmlformats.org/drawingml/2006/main" noGrp="1"/>
+          </p:cNvSpPr>
+          <p:nvPr/>
+        </p:nvSpPr>
+        <p:spPr>
+          <a:xfrm xmlns:a="http://schemas.openxmlformats.org/drawingml/2006/main">
+            <a:off x="400050" y="6191250"/>
+            <a:ext cx="10668000" cy="190500"/>
+          </a:xfrm>
+          <a:prstGeom xmlns:a="http://schemas.openxmlformats.org/drawingml/2006/main" prst="rect">
+            <a:avLst/>
+          </a:prstGeom>
+          <a:noFill xmlns:a="http://schemas.openxmlformats.org/drawingml/2006/main"/>
+          <a:ln xmlns:a="http://schemas.openxmlformats.org/drawingml/2006/main" w="0">
+            <a:noFill/>
+            <a:prstDash val="solid"/>
+          </a:ln>
+        </p:spPr>
+        <p:txBody>
+          <a:bodyPr xmlns:a="http://schemas.openxmlformats.org/drawingml/2006/main" anchor="t"/>
+          <a:lstStyle xmlns:a="http://schemas.openxmlformats.org/drawingml/2006/main"/>
+          <a:p xmlns:a="http://schemas.openxmlformats.org/drawingml/2006/main">
+            <a:pPr algn="l">
+              <a:defRPr sz="975" b="0">
+                <a:solidFill>
+                  <a:srgbClr val="5D6470"/>
+                </a:solidFill>
+                <a:latin typeface="Arial"/>
+                <a:ea typeface="Arial"/>
+                <a:cs typeface="Arial"/>
+              </a:defRPr>
+            </a:pPr>
+            <a:r>
+              <a:rPr sz="975" b="0">
+                <a:solidFill>
+                  <a:srgbClr val="5D6470"/>
+                </a:solidFill>
+                <a:latin typeface="Arial"/>
+                <a:ea typeface="Arial"/>
+                <a:cs typeface="Arial"/>
+              </a:rPr>
+              <a:t>Windows 10/11 (x64) &amp; macOS (Apple Silicon) — Download: GitHub Releases (v1.0.0)</a:t>
+            </a:r>
+          </a:p>
+        </p:txBody>
+      </p:sp>
+      <p:sp>
+        <p:nvSpPr>
+          <p:cNvPr id="17" name="text-95">
+            <a:extLst xmlns:a="http://schemas.openxmlformats.org/drawingml/2006/main">
+              <a:ext uri="{FF2B5EF4-FFF2-40B4-BE49-F238E27FC236}">
+                <a16:creationId xmlns:a16="http://schemas.microsoft.com/office/drawing/2014/main" id="{4ED96D4E-39F4-47E9-B866-62D21F542594}"/>
+              </a:ext>
+            </a:extLst>
+          </p:cNvPr>
+          <p:cNvSpPr>
+            <a:spLocks xmlns:a="http://schemas.openxmlformats.org/drawingml/2006/main" noGrp="1"/>
+          </p:cNvSpPr>
+          <p:nvPr/>
+        </p:nvSpPr>
+        <p:spPr>
+          <a:xfrm xmlns:a="http://schemas.openxmlformats.org/drawingml/2006/main">
+            <a:off x="400050" y="6400800"/>
+            <a:ext cx="10668000" cy="190500"/>
+          </a:xfrm>
+          <a:prstGeom xmlns:a="http://schemas.openxmlformats.org/drawingml/2006/main" prst="rect">
+            <a:avLst/>
+          </a:prstGeom>
+          <a:noFill xmlns:a="http://schemas.openxmlformats.org/drawingml/2006/main"/>
+          <a:ln xmlns:a="http://schemas.openxmlformats.org/drawingml/2006/main" w="0">
+            <a:noFill/>
+            <a:prstDash val="solid"/>
+          </a:ln>
+        </p:spPr>
+        <p:txBody>
+          <a:bodyPr xmlns:a="http://schemas.openxmlformats.org/drawingml/2006/main" anchor="t"/>
+          <a:lstStyle xmlns:a="http://schemas.openxmlformats.org/drawingml/2006/main"/>
+          <a:p xmlns:a="http://schemas.openxmlformats.org/drawingml/2006/main">
+            <a:pPr algn="l">
+              <a:defRPr sz="900" b="0">
+                <a:solidFill>
+                  <a:srgbClr val="5D6470"/>
+                </a:solidFill>
+                <a:latin typeface="Arial"/>
+                <a:ea typeface="Arial"/>
+                <a:cs typeface="Arial"/>
+              </a:defRPr>
+            </a:pPr>
+            <a:r>
+              <a:rPr sz="900" b="0">
+                <a:solidFill>
+                  <a:srgbClr val="5D6470"/>
+                </a:solidFill>
+                <a:latin typeface="Arial"/>
+                <a:ea typeface="Arial"/>
+                <a:cs typeface="Arial"/>
+              </a:rPr>
+              <a:t>macOS paketi Apple Silicon (arm64) içindir ve notarize edilmemiştir; ilk açılışta sağ tık → Aç. / Not notarized; first launch: right-click → Open.</a:t>
             </a:r>
           </a:p>
         </p:txBody>
@@ -6521,7 +6694,7 @@
     </p:spTree>
     <p:extLst>
       <p:ext uri="{BB962C8B-B14F-4D97-AF65-F5344CB8AC3E}">
-        <p14:creationId xmlns:p14="http://schemas.microsoft.com/office/powerpoint/2010/main" val="1859526792"/>
+        <p14:creationId xmlns:p14="http://schemas.microsoft.com/office/powerpoint/2010/main" val="178453102"/>
       </p:ext>
     </p:extLst>
   </p:cSld>

</xml_diff>

<commit_message>
Dictionnaire FR-EN: bidirectional French-English dictionary tab
- fca/dictionary.py: search engine merging built-in and user entries
  (automatic direction, accent/œ/elision-tolerant lookup, exact > prefix > substring)
- fca/dict_data.py: 1,210+ A1-B1 entries with gender and irregular plurals
- fca/tabs/dictionary.py: TTS, ask AI, add to word bank, CSV/TSV import/export, history
- db: dict_entries table + DictRepo; i18n keys in TR/EN/FR
- 8 new tests (37 total), README TR/EN and presentation (18 areas) updated

Co-Authored-By: Claude Fable 5.1 <noreply@anthropic.com>
</commit_message>
<xml_diff>
--- a/docs/presentation/French-Course-AI-Trilingual.pptx
+++ b/docs/presentation/French-Course-AI-Trilingual.pptx
@@ -2,18 +2,18 @@
 <file path=ppt/presentation.xml><?xml version="1.0" encoding="utf-8"?>
 <p:presentation xmlns:p="http://schemas.openxmlformats.org/presentationml/2006/main">
   <p:sldMasterIdLst>
-    <p:sldMasterId xmlns:r="http://schemas.openxmlformats.org/officeDocument/2006/relationships" id="2147483648" r:id="Rf34d4c68d41d44f3"/>
+    <p:sldMasterId xmlns:r="http://schemas.openxmlformats.org/officeDocument/2006/relationships" id="2147483648" r:id="R0aafaf07d7d54e61"/>
   </p:sldMasterIdLst>
   <p:notesMasterIdLst>
-    <p:notesMasterId xmlns:r="http://schemas.openxmlformats.org/officeDocument/2006/relationships" r:id="R9a521ef66fa04d2d"/>
+    <p:notesMasterId xmlns:r="http://schemas.openxmlformats.org/officeDocument/2006/relationships" r:id="R0e34adfa64ab47de"/>
   </p:notesMasterIdLst>
   <p:sldIdLst>
-    <p:sldId xmlns:r="http://schemas.openxmlformats.org/officeDocument/2006/relationships" id="256" r:id="R564dd63254de4c90"/>
-    <p:sldId xmlns:r="http://schemas.openxmlformats.org/officeDocument/2006/relationships" id="257" r:id="Rae00c5c8fae64004"/>
-    <p:sldId xmlns:r="http://schemas.openxmlformats.org/officeDocument/2006/relationships" id="258" r:id="Rdf4a51b2a71e4b37"/>
-    <p:sldId xmlns:r="http://schemas.openxmlformats.org/officeDocument/2006/relationships" id="259" r:id="R8df1746dd399459b"/>
-    <p:sldId xmlns:r="http://schemas.openxmlformats.org/officeDocument/2006/relationships" id="260" r:id="R593f0ce49a5a4ac4"/>
-    <p:sldId xmlns:r="http://schemas.openxmlformats.org/officeDocument/2006/relationships" id="261" r:id="R2af68b8838a14e1f"/>
+    <p:sldId xmlns:r="http://schemas.openxmlformats.org/officeDocument/2006/relationships" id="256" r:id="Rbccd80f826694e52"/>
+    <p:sldId xmlns:r="http://schemas.openxmlformats.org/officeDocument/2006/relationships" id="257" r:id="Rfe81daac5efc4698"/>
+    <p:sldId xmlns:r="http://schemas.openxmlformats.org/officeDocument/2006/relationships" id="258" r:id="Rf7bd468dbfce4bf9"/>
+    <p:sldId xmlns:r="http://schemas.openxmlformats.org/officeDocument/2006/relationships" id="259" r:id="Ree57240259bc4489"/>
+    <p:sldId xmlns:r="http://schemas.openxmlformats.org/officeDocument/2006/relationships" id="260" r:id="Rb748d0cc1fed460b"/>
+    <p:sldId xmlns:r="http://schemas.openxmlformats.org/officeDocument/2006/relationships" id="261" r:id="R841f7fefdcc24d28"/>
   </p:sldIdLst>
   <p:sldSz cx="12192000" cy="6858000"/>
   <p:notesSz cx="6858000" cy="9144000"/>
@@ -1010,7 +1010,7 @@
   </p:cSld>
   <p:clrMap bg1="lt1" tx1="dk1" bg2="lt2" tx2="dk2" accent1="accent1" accent2="accent2" accent3="accent3" accent4="accent4" accent5="accent5" accent6="accent6" hlink="hlink" folHlink="folHlink"/>
   <p:sldLayoutIdLst>
-    <p:sldLayoutId xmlns:r="http://schemas.openxmlformats.org/officeDocument/2006/relationships" id="2147483649" r:id="Rf292dd6faf6d4c09"/>
+    <p:sldLayoutId xmlns:r="http://schemas.openxmlformats.org/officeDocument/2006/relationships" id="2147483649" r:id="R1555e332b53044f7"/>
   </p:sldLayoutIdLst>
   <p:txStyles>
     <p:titleStyle>
@@ -1558,10 +1558,10 @@
       </p:grpSpPr>
       <p:sp>
         <p:nvSpPr>
-          <p:cNvPr id="13" name="box-1">
-            <a:extLst xmlns:a="http://schemas.openxmlformats.org/drawingml/2006/main">
-              <a:ext uri="{FF2B5EF4-FFF2-40B4-BE49-F238E27FC236}">
-                <a16:creationId xmlns:a16="http://schemas.microsoft.com/office/drawing/2014/main" id="{9140175E-7DF3-449B-8099-C92B72681232}"/>
+          <p:cNvPr id="13" name="box-96">
+            <a:extLst xmlns:a="http://schemas.openxmlformats.org/drawingml/2006/main">
+              <a:ext uri="{FF2B5EF4-FFF2-40B4-BE49-F238E27FC236}">
+                <a16:creationId xmlns:a16="http://schemas.microsoft.com/office/drawing/2014/main" id="{18F29EAB-4237-4C4D-9636-29185569263E}"/>
               </a:ext>
             </a:extLst>
           </p:cNvPr>
@@ -1591,10 +1591,10 @@
       </p:sp>
       <p:sp>
         <p:nvSpPr>
-          <p:cNvPr id="2" name="text-2">
-            <a:extLst xmlns:a="http://schemas.openxmlformats.org/drawingml/2006/main">
-              <a:ext uri="{FF2B5EF4-FFF2-40B4-BE49-F238E27FC236}">
-                <a16:creationId xmlns:a16="http://schemas.microsoft.com/office/drawing/2014/main" id="{735A4A76-E9A0-49C2-BD33-9203922945E9}"/>
+          <p:cNvPr id="2" name="text-97">
+            <a:extLst xmlns:a="http://schemas.openxmlformats.org/drawingml/2006/main">
+              <a:ext uri="{FF2B5EF4-FFF2-40B4-BE49-F238E27FC236}">
+                <a16:creationId xmlns:a16="http://schemas.microsoft.com/office/drawing/2014/main" id="{0BD50280-6787-419E-B3A6-D891E1130E7E}"/>
               </a:ext>
             </a:extLst>
           </p:cNvPr>
@@ -1647,10 +1647,10 @@
       </p:sp>
       <p:sp>
         <p:nvSpPr>
-          <p:cNvPr id="3" name="text-3">
-            <a:extLst xmlns:a="http://schemas.openxmlformats.org/drawingml/2006/main">
-              <a:ext uri="{FF2B5EF4-FFF2-40B4-BE49-F238E27FC236}">
-                <a16:creationId xmlns:a16="http://schemas.microsoft.com/office/drawing/2014/main" id="{2BBEB21E-59C3-4DA8-9B57-62E5175537D5}"/>
+          <p:cNvPr id="3" name="text-98">
+            <a:extLst xmlns:a="http://schemas.openxmlformats.org/drawingml/2006/main">
+              <a:ext uri="{FF2B5EF4-FFF2-40B4-BE49-F238E27FC236}">
+                <a16:creationId xmlns:a16="http://schemas.microsoft.com/office/drawing/2014/main" id="{5C1A09C7-B03C-49F0-8C85-D1103160DD36}"/>
               </a:ext>
             </a:extLst>
           </p:cNvPr>
@@ -1703,10 +1703,10 @@
       </p:sp>
       <p:sp>
         <p:nvSpPr>
-          <p:cNvPr id="4" name="text-4">
-            <a:extLst xmlns:a="http://schemas.openxmlformats.org/drawingml/2006/main">
-              <a:ext uri="{FF2B5EF4-FFF2-40B4-BE49-F238E27FC236}">
-                <a16:creationId xmlns:a16="http://schemas.microsoft.com/office/drawing/2014/main" id="{9BFA9B81-ABE7-4DA3-8EF6-107F0A719FB0}"/>
+          <p:cNvPr id="4" name="text-99">
+            <a:extLst xmlns:a="http://schemas.openxmlformats.org/drawingml/2006/main">
+              <a:ext uri="{FF2B5EF4-FFF2-40B4-BE49-F238E27FC236}">
+                <a16:creationId xmlns:a16="http://schemas.microsoft.com/office/drawing/2014/main" id="{6A80C699-3C50-470F-BB57-4F444E1D6CED}"/>
               </a:ext>
             </a:extLst>
           </p:cNvPr>
@@ -1759,10 +1759,10 @@
       </p:sp>
       <p:sp>
         <p:nvSpPr>
-          <p:cNvPr id="5" name="text-5">
-            <a:extLst xmlns:a="http://schemas.openxmlformats.org/drawingml/2006/main">
-              <a:ext uri="{FF2B5EF4-FFF2-40B4-BE49-F238E27FC236}">
-                <a16:creationId xmlns:a16="http://schemas.microsoft.com/office/drawing/2014/main" id="{BF75E6D6-C50A-466E-BCA1-64F654348ACE}"/>
+          <p:cNvPr id="5" name="text-100">
+            <a:extLst xmlns:a="http://schemas.openxmlformats.org/drawingml/2006/main">
+              <a:ext uri="{FF2B5EF4-FFF2-40B4-BE49-F238E27FC236}">
+                <a16:creationId xmlns:a16="http://schemas.microsoft.com/office/drawing/2014/main" id="{28E9F89A-F3C3-4C19-82DC-48F1139AB61F}"/>
               </a:ext>
             </a:extLst>
           </p:cNvPr>
@@ -1815,10 +1815,10 @@
       </p:sp>
       <p:sp>
         <p:nvSpPr>
-          <p:cNvPr id="6" name="text-6">
-            <a:extLst xmlns:a="http://schemas.openxmlformats.org/drawingml/2006/main">
-              <a:ext uri="{FF2B5EF4-FFF2-40B4-BE49-F238E27FC236}">
-                <a16:creationId xmlns:a16="http://schemas.microsoft.com/office/drawing/2014/main" id="{FE0D0355-FD86-4AD1-BCCE-054A875FCDCA}"/>
+          <p:cNvPr id="6" name="text-101">
+            <a:extLst xmlns:a="http://schemas.openxmlformats.org/drawingml/2006/main">
+              <a:ext uri="{FF2B5EF4-FFF2-40B4-BE49-F238E27FC236}">
+                <a16:creationId xmlns:a16="http://schemas.microsoft.com/office/drawing/2014/main" id="{D54E8AF7-4E78-4D26-8A20-90C74A16F51E}"/>
               </a:ext>
             </a:extLst>
           </p:cNvPr>
@@ -1871,10 +1871,10 @@
       </p:sp>
       <p:sp>
         <p:nvSpPr>
-          <p:cNvPr id="7" name="text-7">
-            <a:extLst xmlns:a="http://schemas.openxmlformats.org/drawingml/2006/main">
-              <a:ext uri="{FF2B5EF4-FFF2-40B4-BE49-F238E27FC236}">
-                <a16:creationId xmlns:a16="http://schemas.microsoft.com/office/drawing/2014/main" id="{2328EEB9-3C6B-4324-8909-1BCCBCA92067}"/>
+          <p:cNvPr id="7" name="text-102">
+            <a:extLst xmlns:a="http://schemas.openxmlformats.org/drawingml/2006/main">
+              <a:ext uri="{FF2B5EF4-FFF2-40B4-BE49-F238E27FC236}">
+                <a16:creationId xmlns:a16="http://schemas.microsoft.com/office/drawing/2014/main" id="{AB4595D3-AAFE-4C41-8B31-C09F57456D1A}"/>
               </a:ext>
             </a:extLst>
           </p:cNvPr>
@@ -1927,10 +1927,10 @@
       </p:sp>
       <p:sp>
         <p:nvSpPr>
-          <p:cNvPr id="8" name="text-8">
-            <a:extLst xmlns:a="http://schemas.openxmlformats.org/drawingml/2006/main">
-              <a:ext uri="{FF2B5EF4-FFF2-40B4-BE49-F238E27FC236}">
-                <a16:creationId xmlns:a16="http://schemas.microsoft.com/office/drawing/2014/main" id="{FB19D1B5-AB3B-478D-9111-2D90E4BC43B5}"/>
+          <p:cNvPr id="8" name="text-103">
+            <a:extLst xmlns:a="http://schemas.openxmlformats.org/drawingml/2006/main">
+              <a:ext uri="{FF2B5EF4-FFF2-40B4-BE49-F238E27FC236}">
+                <a16:creationId xmlns:a16="http://schemas.microsoft.com/office/drawing/2014/main" id="{690671CB-A6D3-4774-A1F7-5C76F877461F}"/>
               </a:ext>
             </a:extLst>
           </p:cNvPr>
@@ -1983,10 +1983,10 @@
       </p:sp>
       <p:sp>
         <p:nvSpPr>
-          <p:cNvPr id="9" name="text-9">
-            <a:extLst xmlns:a="http://schemas.openxmlformats.org/drawingml/2006/main">
-              <a:ext uri="{FF2B5EF4-FFF2-40B4-BE49-F238E27FC236}">
-                <a16:creationId xmlns:a16="http://schemas.microsoft.com/office/drawing/2014/main" id="{ACFD9834-6112-4C81-9540-A316A5BBEF3D}"/>
+          <p:cNvPr id="9" name="text-104">
+            <a:extLst xmlns:a="http://schemas.openxmlformats.org/drawingml/2006/main">
+              <a:ext uri="{FF2B5EF4-FFF2-40B4-BE49-F238E27FC236}">
+                <a16:creationId xmlns:a16="http://schemas.microsoft.com/office/drawing/2014/main" id="{7C9D269E-C172-4588-895D-E8F61DFC9095}"/>
               </a:ext>
             </a:extLst>
           </p:cNvPr>
@@ -2039,10 +2039,10 @@
       </p:sp>
       <p:sp>
         <p:nvSpPr>
-          <p:cNvPr id="10" name="box-10">
-            <a:extLst xmlns:a="http://schemas.openxmlformats.org/drawingml/2006/main">
-              <a:ext uri="{FF2B5EF4-FFF2-40B4-BE49-F238E27FC236}">
-                <a16:creationId xmlns:a16="http://schemas.microsoft.com/office/drawing/2014/main" id="{CD190AE0-149C-4054-8F43-004C8C56A4A3}"/>
+          <p:cNvPr id="10" name="box-105">
+            <a:extLst xmlns:a="http://schemas.openxmlformats.org/drawingml/2006/main">
+              <a:ext uri="{FF2B5EF4-FFF2-40B4-BE49-F238E27FC236}">
+                <a16:creationId xmlns:a16="http://schemas.microsoft.com/office/drawing/2014/main" id="{5B26C8B8-C4FE-4042-A49D-1B1083CB955A}"/>
               </a:ext>
             </a:extLst>
           </p:cNvPr>
@@ -2079,7 +2079,7 @@
           <p:nvPr/>
         </p:nvPicPr>
         <p:blipFill>
-          <a:blip xmlns:r="http://schemas.openxmlformats.org/officeDocument/2006/relationships" xmlns:a="http://schemas.openxmlformats.org/drawingml/2006/main" r:embed="Re722dcd3292b4497"/>
+          <a:blip xmlns:r="http://schemas.openxmlformats.org/officeDocument/2006/relationships" xmlns:a="http://schemas.openxmlformats.org/drawingml/2006/main" r:embed="Re68cfc80f6d941d2"/>
           <a:stretch xmlns:a="http://schemas.openxmlformats.org/drawingml/2006/main"/>
         </p:blipFill>
         <p:spPr>
@@ -2094,10 +2094,10 @@
       </p:pic>
       <p:sp>
         <p:nvSpPr>
-          <p:cNvPr id="12" name="text-11">
-            <a:extLst xmlns:a="http://schemas.openxmlformats.org/drawingml/2006/main">
-              <a:ext uri="{FF2B5EF4-FFF2-40B4-BE49-F238E27FC236}">
-                <a16:creationId xmlns:a16="http://schemas.microsoft.com/office/drawing/2014/main" id="{8443A3E1-CEA5-4245-A42B-552CDF786F81}"/>
+          <p:cNvPr id="12" name="text-106">
+            <a:extLst xmlns:a="http://schemas.openxmlformats.org/drawingml/2006/main">
+              <a:ext uri="{FF2B5EF4-FFF2-40B4-BE49-F238E27FC236}">
+                <a16:creationId xmlns:a16="http://schemas.microsoft.com/office/drawing/2014/main" id="{0C126EFC-D9A8-4553-BBC3-A05A3B6B37FA}"/>
               </a:ext>
             </a:extLst>
           </p:cNvPr>
@@ -2151,7 +2151,7 @@
     </p:spTree>
     <p:extLst>
       <p:ext uri="{BB962C8B-B14F-4D97-AF65-F5344CB8AC3E}">
-        <p14:creationId xmlns:p14="http://schemas.microsoft.com/office/powerpoint/2010/main" val="73660144"/>
+        <p14:creationId xmlns:p14="http://schemas.microsoft.com/office/powerpoint/2010/main" val="155026677"/>
       </p:ext>
     </p:extLst>
   </p:cSld>
@@ -2179,10 +2179,10 @@
       </p:grpSpPr>
       <p:sp>
         <p:nvSpPr>
-          <p:cNvPr id="14" name="box-12">
-            <a:extLst xmlns:a="http://schemas.openxmlformats.org/drawingml/2006/main">
-              <a:ext uri="{FF2B5EF4-FFF2-40B4-BE49-F238E27FC236}">
-                <a16:creationId xmlns:a16="http://schemas.microsoft.com/office/drawing/2014/main" id="{D7DCD181-E2A5-4055-9422-BBD4094EBC74}"/>
+          <p:cNvPr id="14" name="box-107">
+            <a:extLst xmlns:a="http://schemas.openxmlformats.org/drawingml/2006/main">
+              <a:ext uri="{FF2B5EF4-FFF2-40B4-BE49-F238E27FC236}">
+                <a16:creationId xmlns:a16="http://schemas.microsoft.com/office/drawing/2014/main" id="{F6ABBFD8-CDAB-4E39-92AC-8D34197EF704}"/>
               </a:ext>
             </a:extLst>
           </p:cNvPr>
@@ -2212,10 +2212,10 @@
       </p:sp>
       <p:sp>
         <p:nvSpPr>
-          <p:cNvPr id="2" name="text-13">
-            <a:extLst xmlns:a="http://schemas.openxmlformats.org/drawingml/2006/main">
-              <a:ext uri="{FF2B5EF4-FFF2-40B4-BE49-F238E27FC236}">
-                <a16:creationId xmlns:a16="http://schemas.microsoft.com/office/drawing/2014/main" id="{AA6075EB-8A99-407D-9769-E436FEB4E090}"/>
+          <p:cNvPr id="2" name="text-108">
+            <a:extLst xmlns:a="http://schemas.openxmlformats.org/drawingml/2006/main">
+              <a:ext uri="{FF2B5EF4-FFF2-40B4-BE49-F238E27FC236}">
+                <a16:creationId xmlns:a16="http://schemas.microsoft.com/office/drawing/2014/main" id="{A8D8B22D-02F5-47D3-B55B-14F164C554EF}"/>
               </a:ext>
             </a:extLst>
           </p:cNvPr>
@@ -2268,10 +2268,10 @@
       </p:sp>
       <p:sp>
         <p:nvSpPr>
-          <p:cNvPr id="3" name="text-14">
-            <a:extLst xmlns:a="http://schemas.openxmlformats.org/drawingml/2006/main">
-              <a:ext uri="{FF2B5EF4-FFF2-40B4-BE49-F238E27FC236}">
-                <a16:creationId xmlns:a16="http://schemas.microsoft.com/office/drawing/2014/main" id="{448EBA4C-95EF-4751-948B-029DE3549769}"/>
+          <p:cNvPr id="3" name="text-109">
+            <a:extLst xmlns:a="http://schemas.openxmlformats.org/drawingml/2006/main">
+              <a:ext uri="{FF2B5EF4-FFF2-40B4-BE49-F238E27FC236}">
+                <a16:creationId xmlns:a16="http://schemas.microsoft.com/office/drawing/2014/main" id="{DBABC3FD-2CE4-4923-9D10-8F7E3DA19BCC}"/>
               </a:ext>
             </a:extLst>
           </p:cNvPr>
@@ -2324,10 +2324,10 @@
       </p:sp>
       <p:sp>
         <p:nvSpPr>
-          <p:cNvPr id="4" name="text-15">
-            <a:extLst xmlns:a="http://schemas.openxmlformats.org/drawingml/2006/main">
-              <a:ext uri="{FF2B5EF4-FFF2-40B4-BE49-F238E27FC236}">
-                <a16:creationId xmlns:a16="http://schemas.microsoft.com/office/drawing/2014/main" id="{BF347A30-1F5B-4A39-9C1D-BC092BD94AF1}"/>
+          <p:cNvPr id="4" name="text-110">
+            <a:extLst xmlns:a="http://schemas.openxmlformats.org/drawingml/2006/main">
+              <a:ext uri="{FF2B5EF4-FFF2-40B4-BE49-F238E27FC236}">
+                <a16:creationId xmlns:a16="http://schemas.microsoft.com/office/drawing/2014/main" id="{6376AA38-D118-40E6-ACFF-C79189035F97}"/>
               </a:ext>
             </a:extLst>
           </p:cNvPr>
@@ -2380,10 +2380,10 @@
       </p:sp>
       <p:sp>
         <p:nvSpPr>
-          <p:cNvPr id="5" name="text-16">
-            <a:extLst xmlns:a="http://schemas.openxmlformats.org/drawingml/2006/main">
-              <a:ext uri="{FF2B5EF4-FFF2-40B4-BE49-F238E27FC236}">
-                <a16:creationId xmlns:a16="http://schemas.microsoft.com/office/drawing/2014/main" id="{07AE1E89-2FC7-4AF2-85A3-06C4379D3704}"/>
+          <p:cNvPr id="5" name="text-111">
+            <a:extLst xmlns:a="http://schemas.openxmlformats.org/drawingml/2006/main">
+              <a:ext uri="{FF2B5EF4-FFF2-40B4-BE49-F238E27FC236}">
+                <a16:creationId xmlns:a16="http://schemas.microsoft.com/office/drawing/2014/main" id="{0B7F2EDF-7D8C-44D6-ADCD-5CBEF18D79D3}"/>
               </a:ext>
             </a:extLst>
           </p:cNvPr>
@@ -2436,10 +2436,10 @@
       </p:sp>
       <p:sp>
         <p:nvSpPr>
-          <p:cNvPr id="6" name="text-17">
-            <a:extLst xmlns:a="http://schemas.openxmlformats.org/drawingml/2006/main">
-              <a:ext uri="{FF2B5EF4-FFF2-40B4-BE49-F238E27FC236}">
-                <a16:creationId xmlns:a16="http://schemas.microsoft.com/office/drawing/2014/main" id="{ABFC7643-DC26-4153-A99E-00EEB088862F}"/>
+          <p:cNvPr id="6" name="text-112">
+            <a:extLst xmlns:a="http://schemas.openxmlformats.org/drawingml/2006/main">
+              <a:ext uri="{FF2B5EF4-FFF2-40B4-BE49-F238E27FC236}">
+                <a16:creationId xmlns:a16="http://schemas.microsoft.com/office/drawing/2014/main" id="{67DFFEA3-CBDF-4B8C-A3B5-58072E95E9BE}"/>
               </a:ext>
             </a:extLst>
           </p:cNvPr>
@@ -2492,10 +2492,10 @@
       </p:sp>
       <p:sp>
         <p:nvSpPr>
-          <p:cNvPr id="7" name="box-18">
-            <a:extLst xmlns:a="http://schemas.openxmlformats.org/drawingml/2006/main">
-              <a:ext uri="{FF2B5EF4-FFF2-40B4-BE49-F238E27FC236}">
-                <a16:creationId xmlns:a16="http://schemas.microsoft.com/office/drawing/2014/main" id="{EEBA3134-C90A-4D62-A69D-E817673AF22F}"/>
+          <p:cNvPr id="7" name="box-113">
+            <a:extLst xmlns:a="http://schemas.openxmlformats.org/drawingml/2006/main">
+              <a:ext uri="{FF2B5EF4-FFF2-40B4-BE49-F238E27FC236}">
+                <a16:creationId xmlns:a16="http://schemas.microsoft.com/office/drawing/2014/main" id="{98C85607-7E52-42BF-962D-AB50439E08B7}"/>
               </a:ext>
             </a:extLst>
           </p:cNvPr>
@@ -2525,10 +2525,10 @@
       </p:sp>
       <p:sp>
         <p:nvSpPr>
-          <p:cNvPr id="8" name="text-19">
-            <a:extLst xmlns:a="http://schemas.openxmlformats.org/drawingml/2006/main">
-              <a:ext uri="{FF2B5EF4-FFF2-40B4-BE49-F238E27FC236}">
-                <a16:creationId xmlns:a16="http://schemas.microsoft.com/office/drawing/2014/main" id="{0DD37BAE-8385-4CBD-9615-7CEDD4713500}"/>
+          <p:cNvPr id="8" name="text-114">
+            <a:extLst xmlns:a="http://schemas.openxmlformats.org/drawingml/2006/main">
+              <a:ext uri="{FF2B5EF4-FFF2-40B4-BE49-F238E27FC236}">
+                <a16:creationId xmlns:a16="http://schemas.microsoft.com/office/drawing/2014/main" id="{1C62B068-D172-4BB0-82B6-4CA22E9029C0}"/>
               </a:ext>
             </a:extLst>
           </p:cNvPr>
@@ -2574,17 +2574,17 @@
                 <a:ea typeface="Arial"/>
                 <a:cs typeface="Arial"/>
               </a:rPr>
-              <a:t>17 espaces relient révision, vocabulaire, examen, grammaire et pratique dans un atelier Windows cohérent.</a:t>
-            </a:r>
-          </a:p>
-        </p:txBody>
-      </p:sp>
-      <p:sp>
-        <p:nvSpPr>
-          <p:cNvPr id="9" name="text-20">
-            <a:extLst xmlns:a="http://schemas.openxmlformats.org/drawingml/2006/main">
-              <a:ext uri="{FF2B5EF4-FFF2-40B4-BE49-F238E27FC236}">
-                <a16:creationId xmlns:a16="http://schemas.microsoft.com/office/drawing/2014/main" id="{EA8E3825-E33A-425C-91F6-FE5D638E3517}"/>
+              <a:t>18 espaces relient révision, vocabulaire, dictionnaire bilingue FR-EN, examen, grammaire et pratique dans un atelier Windows cohérent.</a:t>
+            </a:r>
+          </a:p>
+        </p:txBody>
+      </p:sp>
+      <p:sp>
+        <p:nvSpPr>
+          <p:cNvPr id="9" name="text-115">
+            <a:extLst xmlns:a="http://schemas.openxmlformats.org/drawingml/2006/main">
+              <a:ext uri="{FF2B5EF4-FFF2-40B4-BE49-F238E27FC236}">
+                <a16:creationId xmlns:a16="http://schemas.microsoft.com/office/drawing/2014/main" id="{241056CC-3BC5-4BA0-B6AC-CD16E4A22F79}"/>
               </a:ext>
             </a:extLst>
           </p:cNvPr>
@@ -2637,10 +2637,10 @@
       </p:sp>
       <p:sp>
         <p:nvSpPr>
-          <p:cNvPr id="10" name="text-21">
-            <a:extLst xmlns:a="http://schemas.openxmlformats.org/drawingml/2006/main">
-              <a:ext uri="{FF2B5EF4-FFF2-40B4-BE49-F238E27FC236}">
-                <a16:creationId xmlns:a16="http://schemas.microsoft.com/office/drawing/2014/main" id="{841D04E4-79D8-4683-AE30-15C3AF1DBFD1}"/>
+          <p:cNvPr id="10" name="text-116">
+            <a:extLst xmlns:a="http://schemas.openxmlformats.org/drawingml/2006/main">
+              <a:ext uri="{FF2B5EF4-FFF2-40B4-BE49-F238E27FC236}">
+                <a16:creationId xmlns:a16="http://schemas.microsoft.com/office/drawing/2014/main" id="{4FE0560D-CAF8-4536-9C4F-90083D2EEEF3}"/>
               </a:ext>
             </a:extLst>
           </p:cNvPr>
@@ -2693,10 +2693,10 @@
       </p:sp>
       <p:sp>
         <p:nvSpPr>
-          <p:cNvPr id="11" name="box-22">
-            <a:extLst xmlns:a="http://schemas.openxmlformats.org/drawingml/2006/main">
-              <a:ext uri="{FF2B5EF4-FFF2-40B4-BE49-F238E27FC236}">
-                <a16:creationId xmlns:a16="http://schemas.microsoft.com/office/drawing/2014/main" id="{3C4F3CF1-3A18-45B2-B6C3-94D1007B4106}"/>
+          <p:cNvPr id="11" name="box-117">
+            <a:extLst xmlns:a="http://schemas.openxmlformats.org/drawingml/2006/main">
+              <a:ext uri="{FF2B5EF4-FFF2-40B4-BE49-F238E27FC236}">
+                <a16:creationId xmlns:a16="http://schemas.microsoft.com/office/drawing/2014/main" id="{03A06004-C8F4-4387-AB9D-CDC446BF2FB8}"/>
               </a:ext>
             </a:extLst>
           </p:cNvPr>
@@ -2733,7 +2733,7 @@
           <p:nvPr/>
         </p:nvPicPr>
         <p:blipFill>
-          <a:blip xmlns:r="http://schemas.openxmlformats.org/officeDocument/2006/relationships" xmlns:a="http://schemas.openxmlformats.org/drawingml/2006/main" r:embed="Rf6fe629e89eb4d73"/>
+          <a:blip xmlns:r="http://schemas.openxmlformats.org/officeDocument/2006/relationships" xmlns:a="http://schemas.openxmlformats.org/drawingml/2006/main" r:embed="R3c3c49f0bf784bea"/>
           <a:stretch xmlns:a="http://schemas.openxmlformats.org/drawingml/2006/main"/>
         </p:blipFill>
         <p:spPr>
@@ -2748,10 +2748,10 @@
       </p:pic>
       <p:sp>
         <p:nvSpPr>
-          <p:cNvPr id="13" name="text-23">
-            <a:extLst xmlns:a="http://schemas.openxmlformats.org/drawingml/2006/main">
-              <a:ext uri="{FF2B5EF4-FFF2-40B4-BE49-F238E27FC236}">
-                <a16:creationId xmlns:a16="http://schemas.microsoft.com/office/drawing/2014/main" id="{89421157-6C94-4446-864E-8531C9DA167C}"/>
+          <p:cNvPr id="13" name="text-118">
+            <a:extLst xmlns:a="http://schemas.openxmlformats.org/drawingml/2006/main">
+              <a:ext uri="{FF2B5EF4-FFF2-40B4-BE49-F238E27FC236}">
+                <a16:creationId xmlns:a16="http://schemas.microsoft.com/office/drawing/2014/main" id="{0F04BB1E-7A97-442C-BEE1-BCCD2A0D2D71}"/>
               </a:ext>
             </a:extLst>
           </p:cNvPr>
@@ -2805,7 +2805,7 @@
     </p:spTree>
     <p:extLst>
       <p:ext uri="{BB962C8B-B14F-4D97-AF65-F5344CB8AC3E}">
-        <p14:creationId xmlns:p14="http://schemas.microsoft.com/office/powerpoint/2010/main" val="2083834490"/>
+        <p14:creationId xmlns:p14="http://schemas.microsoft.com/office/powerpoint/2010/main" val="1191139925"/>
       </p:ext>
     </p:extLst>
   </p:cSld>
@@ -2833,10 +2833,10 @@
       </p:grpSpPr>
       <p:sp>
         <p:nvSpPr>
-          <p:cNvPr id="19" name="box-24">
-            <a:extLst xmlns:a="http://schemas.openxmlformats.org/drawingml/2006/main">
-              <a:ext uri="{FF2B5EF4-FFF2-40B4-BE49-F238E27FC236}">
-                <a16:creationId xmlns:a16="http://schemas.microsoft.com/office/drawing/2014/main" id="{68DCB4D9-A89C-41AD-BAA8-28BC3B8378EF}"/>
+          <p:cNvPr id="19" name="box-119">
+            <a:extLst xmlns:a="http://schemas.openxmlformats.org/drawingml/2006/main">
+              <a:ext uri="{FF2B5EF4-FFF2-40B4-BE49-F238E27FC236}">
+                <a16:creationId xmlns:a16="http://schemas.microsoft.com/office/drawing/2014/main" id="{4CFC0B2F-6513-444A-A093-4FD515FCB001}"/>
               </a:ext>
             </a:extLst>
           </p:cNvPr>
@@ -2866,10 +2866,10 @@
       </p:sp>
       <p:sp>
         <p:nvSpPr>
-          <p:cNvPr id="2" name="text-25">
-            <a:extLst xmlns:a="http://schemas.openxmlformats.org/drawingml/2006/main">
-              <a:ext uri="{FF2B5EF4-FFF2-40B4-BE49-F238E27FC236}">
-                <a16:creationId xmlns:a16="http://schemas.microsoft.com/office/drawing/2014/main" id="{31EA5935-7E6A-49C9-87C7-0FA51E773D37}"/>
+          <p:cNvPr id="2" name="text-120">
+            <a:extLst xmlns:a="http://schemas.openxmlformats.org/drawingml/2006/main">
+              <a:ext uri="{FF2B5EF4-FFF2-40B4-BE49-F238E27FC236}">
+                <a16:creationId xmlns:a16="http://schemas.microsoft.com/office/drawing/2014/main" id="{69ECC909-5123-45DF-862D-08A3B7215D0E}"/>
               </a:ext>
             </a:extLst>
           </p:cNvPr>
@@ -2922,10 +2922,10 @@
       </p:sp>
       <p:sp>
         <p:nvSpPr>
-          <p:cNvPr id="3" name="text-26">
-            <a:extLst xmlns:a="http://schemas.openxmlformats.org/drawingml/2006/main">
-              <a:ext uri="{FF2B5EF4-FFF2-40B4-BE49-F238E27FC236}">
-                <a16:creationId xmlns:a16="http://schemas.microsoft.com/office/drawing/2014/main" id="{E2F1C7C6-8427-48B2-8A62-FBA96E3B29EE}"/>
+          <p:cNvPr id="3" name="text-121">
+            <a:extLst xmlns:a="http://schemas.openxmlformats.org/drawingml/2006/main">
+              <a:ext uri="{FF2B5EF4-FFF2-40B4-BE49-F238E27FC236}">
+                <a16:creationId xmlns:a16="http://schemas.microsoft.com/office/drawing/2014/main" id="{13DEBDFE-BDAF-4FF0-8E2A-F8C63CA38881}"/>
               </a:ext>
             </a:extLst>
           </p:cNvPr>
@@ -2978,10 +2978,10 @@
       </p:sp>
       <p:sp>
         <p:nvSpPr>
-          <p:cNvPr id="4" name="text-27">
-            <a:extLst xmlns:a="http://schemas.openxmlformats.org/drawingml/2006/main">
-              <a:ext uri="{FF2B5EF4-FFF2-40B4-BE49-F238E27FC236}">
-                <a16:creationId xmlns:a16="http://schemas.microsoft.com/office/drawing/2014/main" id="{2FECA15F-6271-402C-83BD-8AD2B8033ADA}"/>
+          <p:cNvPr id="4" name="text-122">
+            <a:extLst xmlns:a="http://schemas.openxmlformats.org/drawingml/2006/main">
+              <a:ext uri="{FF2B5EF4-FFF2-40B4-BE49-F238E27FC236}">
+                <a16:creationId xmlns:a16="http://schemas.microsoft.com/office/drawing/2014/main" id="{BD09AFA0-84C3-4F4B-A226-760977EB54A7}"/>
               </a:ext>
             </a:extLst>
           </p:cNvPr>
@@ -3034,10 +3034,10 @@
       </p:sp>
       <p:sp>
         <p:nvSpPr>
-          <p:cNvPr id="5" name="text-28">
-            <a:extLst xmlns:a="http://schemas.openxmlformats.org/drawingml/2006/main">
-              <a:ext uri="{FF2B5EF4-FFF2-40B4-BE49-F238E27FC236}">
-                <a16:creationId xmlns:a16="http://schemas.microsoft.com/office/drawing/2014/main" id="{F346787F-8EDF-4073-8A7A-03979961ACE0}"/>
+          <p:cNvPr id="5" name="text-123">
+            <a:extLst xmlns:a="http://schemas.openxmlformats.org/drawingml/2006/main">
+              <a:ext uri="{FF2B5EF4-FFF2-40B4-BE49-F238E27FC236}">
+                <a16:creationId xmlns:a16="http://schemas.microsoft.com/office/drawing/2014/main" id="{12D889D8-C858-4353-B4E5-D914E5A87326}"/>
               </a:ext>
             </a:extLst>
           </p:cNvPr>
@@ -3090,10 +3090,10 @@
       </p:sp>
       <p:sp>
         <p:nvSpPr>
-          <p:cNvPr id="6" name="text-29">
-            <a:extLst xmlns:a="http://schemas.openxmlformats.org/drawingml/2006/main">
-              <a:ext uri="{FF2B5EF4-FFF2-40B4-BE49-F238E27FC236}">
-                <a16:creationId xmlns:a16="http://schemas.microsoft.com/office/drawing/2014/main" id="{F98FBCF8-F57B-4573-AFF8-0FE06FE1C636}"/>
+          <p:cNvPr id="6" name="text-124">
+            <a:extLst xmlns:a="http://schemas.openxmlformats.org/drawingml/2006/main">
+              <a:ext uri="{FF2B5EF4-FFF2-40B4-BE49-F238E27FC236}">
+                <a16:creationId xmlns:a16="http://schemas.microsoft.com/office/drawing/2014/main" id="{FFDE3905-826F-4CB5-BF18-ACA3DF41F560}"/>
               </a:ext>
             </a:extLst>
           </p:cNvPr>
@@ -3146,10 +3146,10 @@
       </p:sp>
       <p:sp>
         <p:nvSpPr>
-          <p:cNvPr id="7" name="box-30">
-            <a:extLst xmlns:a="http://schemas.openxmlformats.org/drawingml/2006/main">
-              <a:ext uri="{FF2B5EF4-FFF2-40B4-BE49-F238E27FC236}">
-                <a16:creationId xmlns:a16="http://schemas.microsoft.com/office/drawing/2014/main" id="{896C0623-4C47-4C5B-B345-E0574820F6CE}"/>
+          <p:cNvPr id="7" name="box-125">
+            <a:extLst xmlns:a="http://schemas.openxmlformats.org/drawingml/2006/main">
+              <a:ext uri="{FF2B5EF4-FFF2-40B4-BE49-F238E27FC236}">
+                <a16:creationId xmlns:a16="http://schemas.microsoft.com/office/drawing/2014/main" id="{92AE0CE7-0776-4306-B035-9118C185E9CE}"/>
               </a:ext>
             </a:extLst>
           </p:cNvPr>
@@ -3179,10 +3179,10 @@
       </p:sp>
       <p:sp>
         <p:nvSpPr>
-          <p:cNvPr id="8" name="text-31">
-            <a:extLst xmlns:a="http://schemas.openxmlformats.org/drawingml/2006/main">
-              <a:ext uri="{FF2B5EF4-FFF2-40B4-BE49-F238E27FC236}">
-                <a16:creationId xmlns:a16="http://schemas.microsoft.com/office/drawing/2014/main" id="{FAB4FB8E-A44D-41EE-8D92-A33675A94A25}"/>
+          <p:cNvPr id="8" name="text-126">
+            <a:extLst xmlns:a="http://schemas.openxmlformats.org/drawingml/2006/main">
+              <a:ext uri="{FF2B5EF4-FFF2-40B4-BE49-F238E27FC236}">
+                <a16:creationId xmlns:a16="http://schemas.microsoft.com/office/drawing/2014/main" id="{DBFA17C4-1F4C-4A0C-844E-A6BC9FB13D0D}"/>
               </a:ext>
             </a:extLst>
           </p:cNvPr>
@@ -3235,10 +3235,10 @@
       </p:sp>
       <p:sp>
         <p:nvSpPr>
-          <p:cNvPr id="9" name="text-32">
-            <a:extLst xmlns:a="http://schemas.openxmlformats.org/drawingml/2006/main">
-              <a:ext uri="{FF2B5EF4-FFF2-40B4-BE49-F238E27FC236}">
-                <a16:creationId xmlns:a16="http://schemas.microsoft.com/office/drawing/2014/main" id="{D76DFC98-0662-4CE2-82E5-FA3FE3465D5D}"/>
+          <p:cNvPr id="9" name="text-127">
+            <a:extLst xmlns:a="http://schemas.openxmlformats.org/drawingml/2006/main">
+              <a:ext uri="{FF2B5EF4-FFF2-40B4-BE49-F238E27FC236}">
+                <a16:creationId xmlns:a16="http://schemas.microsoft.com/office/drawing/2014/main" id="{05E9953B-220D-44C6-883F-E3927A8D3A7C}"/>
               </a:ext>
             </a:extLst>
           </p:cNvPr>
@@ -3291,10 +3291,10 @@
       </p:sp>
       <p:sp>
         <p:nvSpPr>
-          <p:cNvPr id="10" name="text-33">
-            <a:extLst xmlns:a="http://schemas.openxmlformats.org/drawingml/2006/main">
-              <a:ext uri="{FF2B5EF4-FFF2-40B4-BE49-F238E27FC236}">
-                <a16:creationId xmlns:a16="http://schemas.microsoft.com/office/drawing/2014/main" id="{8362E324-E4B3-472C-96CB-F9C357A82B6A}"/>
+          <p:cNvPr id="10" name="text-128">
+            <a:extLst xmlns:a="http://schemas.openxmlformats.org/drawingml/2006/main">
+              <a:ext uri="{FF2B5EF4-FFF2-40B4-BE49-F238E27FC236}">
+                <a16:creationId xmlns:a16="http://schemas.microsoft.com/office/drawing/2014/main" id="{377CC8A3-76C0-404F-AF45-02C215383139}"/>
               </a:ext>
             </a:extLst>
           </p:cNvPr>
@@ -3347,10 +3347,10 @@
       </p:sp>
       <p:sp>
         <p:nvSpPr>
-          <p:cNvPr id="11" name="box-34">
-            <a:extLst xmlns:a="http://schemas.openxmlformats.org/drawingml/2006/main">
-              <a:ext uri="{FF2B5EF4-FFF2-40B4-BE49-F238E27FC236}">
-                <a16:creationId xmlns:a16="http://schemas.microsoft.com/office/drawing/2014/main" id="{F4E6576F-E7F2-4591-BF77-2E0A3F3E1FEB}"/>
+          <p:cNvPr id="11" name="box-129">
+            <a:extLst xmlns:a="http://schemas.openxmlformats.org/drawingml/2006/main">
+              <a:ext uri="{FF2B5EF4-FFF2-40B4-BE49-F238E27FC236}">
+                <a16:creationId xmlns:a16="http://schemas.microsoft.com/office/drawing/2014/main" id="{EB9D318E-E6C2-4264-A1C5-389C279C5160}"/>
               </a:ext>
             </a:extLst>
           </p:cNvPr>
@@ -3380,10 +3380,10 @@
       </p:sp>
       <p:sp>
         <p:nvSpPr>
-          <p:cNvPr id="12" name="text-35">
-            <a:extLst xmlns:a="http://schemas.openxmlformats.org/drawingml/2006/main">
-              <a:ext uri="{FF2B5EF4-FFF2-40B4-BE49-F238E27FC236}">
-                <a16:creationId xmlns:a16="http://schemas.microsoft.com/office/drawing/2014/main" id="{F9842881-6F97-4EE7-8EB6-81BFCF1C62E1}"/>
+          <p:cNvPr id="12" name="text-130">
+            <a:extLst xmlns:a="http://schemas.openxmlformats.org/drawingml/2006/main">
+              <a:ext uri="{FF2B5EF4-FFF2-40B4-BE49-F238E27FC236}">
+                <a16:creationId xmlns:a16="http://schemas.microsoft.com/office/drawing/2014/main" id="{68F0F7CF-C7C5-4032-9CED-85C83ADD36AF}"/>
               </a:ext>
             </a:extLst>
           </p:cNvPr>
@@ -3436,10 +3436,10 @@
       </p:sp>
       <p:sp>
         <p:nvSpPr>
-          <p:cNvPr id="13" name="text-36">
-            <a:extLst xmlns:a="http://schemas.openxmlformats.org/drawingml/2006/main">
-              <a:ext uri="{FF2B5EF4-FFF2-40B4-BE49-F238E27FC236}">
-                <a16:creationId xmlns:a16="http://schemas.microsoft.com/office/drawing/2014/main" id="{B3F649D4-2DF4-4FBD-959D-F7360E7100AA}"/>
+          <p:cNvPr id="13" name="text-131">
+            <a:extLst xmlns:a="http://schemas.openxmlformats.org/drawingml/2006/main">
+              <a:ext uri="{FF2B5EF4-FFF2-40B4-BE49-F238E27FC236}">
+                <a16:creationId xmlns:a16="http://schemas.microsoft.com/office/drawing/2014/main" id="{E27AF4BA-1543-4E4A-B4B6-EAB5DAB38547}"/>
               </a:ext>
             </a:extLst>
           </p:cNvPr>
@@ -3485,17 +3485,17 @@
                 <a:ea typeface="Arial"/>
                 <a:cs typeface="Arial"/>
               </a:rPr>
-              <a:t>162 A1 entries, strict accented answers, exams, favorites and mistakes share one SQLite record.</a:t>
-            </a:r>
-          </a:p>
-        </p:txBody>
-      </p:sp>
-      <p:sp>
-        <p:nvSpPr>
-          <p:cNvPr id="14" name="text-37">
-            <a:extLst xmlns:a="http://schemas.openxmlformats.org/drawingml/2006/main">
-              <a:ext uri="{FF2B5EF4-FFF2-40B4-BE49-F238E27FC236}">
-                <a16:creationId xmlns:a16="http://schemas.microsoft.com/office/drawing/2014/main" id="{79240BBB-16CD-468D-814B-4BB9EF607138}"/>
+              <a:t>162 A1 entries, a 1,210-entry FR-EN dictionary, strict accented answers, exams, favorites and mistakes share one SQLite record.</a:t>
+            </a:r>
+          </a:p>
+        </p:txBody>
+      </p:sp>
+      <p:sp>
+        <p:nvSpPr>
+          <p:cNvPr id="14" name="text-132">
+            <a:extLst xmlns:a="http://schemas.openxmlformats.org/drawingml/2006/main">
+              <a:ext uri="{FF2B5EF4-FFF2-40B4-BE49-F238E27FC236}">
+                <a16:creationId xmlns:a16="http://schemas.microsoft.com/office/drawing/2014/main" id="{F82BE8F1-F3CE-4D6E-8262-1344950C63F9}"/>
               </a:ext>
             </a:extLst>
           </p:cNvPr>
@@ -3548,10 +3548,10 @@
       </p:sp>
       <p:sp>
         <p:nvSpPr>
-          <p:cNvPr id="15" name="box-38">
-            <a:extLst xmlns:a="http://schemas.openxmlformats.org/drawingml/2006/main">
-              <a:ext uri="{FF2B5EF4-FFF2-40B4-BE49-F238E27FC236}">
-                <a16:creationId xmlns:a16="http://schemas.microsoft.com/office/drawing/2014/main" id="{D055FB7A-3BAC-4ED5-AF8E-C8EE6F9601F4}"/>
+          <p:cNvPr id="15" name="box-133">
+            <a:extLst xmlns:a="http://schemas.openxmlformats.org/drawingml/2006/main">
+              <a:ext uri="{FF2B5EF4-FFF2-40B4-BE49-F238E27FC236}">
+                <a16:creationId xmlns:a16="http://schemas.microsoft.com/office/drawing/2014/main" id="{2D3126DB-4093-437C-A6DB-FA7880876E79}"/>
               </a:ext>
             </a:extLst>
           </p:cNvPr>
@@ -3581,10 +3581,10 @@
       </p:sp>
       <p:sp>
         <p:nvSpPr>
-          <p:cNvPr id="16" name="text-39">
-            <a:extLst xmlns:a="http://schemas.openxmlformats.org/drawingml/2006/main">
-              <a:ext uri="{FF2B5EF4-FFF2-40B4-BE49-F238E27FC236}">
-                <a16:creationId xmlns:a16="http://schemas.microsoft.com/office/drawing/2014/main" id="{0E07A2AC-0DB0-4A34-B07E-D9F9B90F3122}"/>
+          <p:cNvPr id="16" name="text-134">
+            <a:extLst xmlns:a="http://schemas.openxmlformats.org/drawingml/2006/main">
+              <a:ext uri="{FF2B5EF4-FFF2-40B4-BE49-F238E27FC236}">
+                <a16:creationId xmlns:a16="http://schemas.microsoft.com/office/drawing/2014/main" id="{A0ECF5FD-B37C-4B42-B7C0-70E59A097F87}"/>
               </a:ext>
             </a:extLst>
           </p:cNvPr>
@@ -3637,10 +3637,10 @@
       </p:sp>
       <p:sp>
         <p:nvSpPr>
-          <p:cNvPr id="17" name="text-40">
-            <a:extLst xmlns:a="http://schemas.openxmlformats.org/drawingml/2006/main">
-              <a:ext uri="{FF2B5EF4-FFF2-40B4-BE49-F238E27FC236}">
-                <a16:creationId xmlns:a16="http://schemas.microsoft.com/office/drawing/2014/main" id="{56A693ED-1D2B-42C8-AB90-F5A04EA7216B}"/>
+          <p:cNvPr id="17" name="text-135">
+            <a:extLst xmlns:a="http://schemas.openxmlformats.org/drawingml/2006/main">
+              <a:ext uri="{FF2B5EF4-FFF2-40B4-BE49-F238E27FC236}">
+                <a16:creationId xmlns:a16="http://schemas.microsoft.com/office/drawing/2014/main" id="{7AEF533D-F7BC-4F60-9232-38CB088A19E3}"/>
               </a:ext>
             </a:extLst>
           </p:cNvPr>
@@ -3693,10 +3693,10 @@
       </p:sp>
       <p:sp>
         <p:nvSpPr>
-          <p:cNvPr id="18" name="text-41">
-            <a:extLst xmlns:a="http://schemas.openxmlformats.org/drawingml/2006/main">
-              <a:ext uri="{FF2B5EF4-FFF2-40B4-BE49-F238E27FC236}">
-                <a16:creationId xmlns:a16="http://schemas.microsoft.com/office/drawing/2014/main" id="{4DFB5966-8D34-4596-8468-11FA961AD94F}"/>
+          <p:cNvPr id="18" name="text-136">
+            <a:extLst xmlns:a="http://schemas.openxmlformats.org/drawingml/2006/main">
+              <a:ext uri="{FF2B5EF4-FFF2-40B4-BE49-F238E27FC236}">
+                <a16:creationId xmlns:a16="http://schemas.microsoft.com/office/drawing/2014/main" id="{41CF9FF7-E86D-4048-B0ED-D0FD2DA150D3}"/>
               </a:ext>
             </a:extLst>
           </p:cNvPr>
@@ -3750,7 +3750,7 @@
     </p:spTree>
     <p:extLst>
       <p:ext uri="{BB962C8B-B14F-4D97-AF65-F5344CB8AC3E}">
-        <p14:creationId xmlns:p14="http://schemas.microsoft.com/office/powerpoint/2010/main" val="368118747"/>
+        <p14:creationId xmlns:p14="http://schemas.microsoft.com/office/powerpoint/2010/main" val="658514384"/>
       </p:ext>
     </p:extLst>
   </p:cSld>
@@ -3778,10 +3778,10 @@
       </p:grpSpPr>
       <p:sp>
         <p:nvSpPr>
-          <p:cNvPr id="18" name="box-42">
-            <a:extLst xmlns:a="http://schemas.openxmlformats.org/drawingml/2006/main">
-              <a:ext uri="{FF2B5EF4-FFF2-40B4-BE49-F238E27FC236}">
-                <a16:creationId xmlns:a16="http://schemas.microsoft.com/office/drawing/2014/main" id="{885F7E30-FBF7-41CD-9B1B-F2B769B02F50}"/>
+          <p:cNvPr id="18" name="box-137">
+            <a:extLst xmlns:a="http://schemas.openxmlformats.org/drawingml/2006/main">
+              <a:ext uri="{FF2B5EF4-FFF2-40B4-BE49-F238E27FC236}">
+                <a16:creationId xmlns:a16="http://schemas.microsoft.com/office/drawing/2014/main" id="{6BAB9373-D91B-46E8-9A39-563B91DB9025}"/>
               </a:ext>
             </a:extLst>
           </p:cNvPr>
@@ -3811,10 +3811,10 @@
       </p:sp>
       <p:sp>
         <p:nvSpPr>
-          <p:cNvPr id="2" name="text-43">
-            <a:extLst xmlns:a="http://schemas.openxmlformats.org/drawingml/2006/main">
-              <a:ext uri="{FF2B5EF4-FFF2-40B4-BE49-F238E27FC236}">
-                <a16:creationId xmlns:a16="http://schemas.microsoft.com/office/drawing/2014/main" id="{B683918C-80A5-4F31-9933-FF9BD676C304}"/>
+          <p:cNvPr id="2" name="text-138">
+            <a:extLst xmlns:a="http://schemas.openxmlformats.org/drawingml/2006/main">
+              <a:ext uri="{FF2B5EF4-FFF2-40B4-BE49-F238E27FC236}">
+                <a16:creationId xmlns:a16="http://schemas.microsoft.com/office/drawing/2014/main" id="{ECF761DB-43F4-4506-BB23-1C1417DF6C5F}"/>
               </a:ext>
             </a:extLst>
           </p:cNvPr>
@@ -3867,10 +3867,10 @@
       </p:sp>
       <p:sp>
         <p:nvSpPr>
-          <p:cNvPr id="3" name="text-44">
-            <a:extLst xmlns:a="http://schemas.openxmlformats.org/drawingml/2006/main">
-              <a:ext uri="{FF2B5EF4-FFF2-40B4-BE49-F238E27FC236}">
-                <a16:creationId xmlns:a16="http://schemas.microsoft.com/office/drawing/2014/main" id="{A28ED235-F240-45F3-BE94-BB9E52188031}"/>
+          <p:cNvPr id="3" name="text-139">
+            <a:extLst xmlns:a="http://schemas.openxmlformats.org/drawingml/2006/main">
+              <a:ext uri="{FF2B5EF4-FFF2-40B4-BE49-F238E27FC236}">
+                <a16:creationId xmlns:a16="http://schemas.microsoft.com/office/drawing/2014/main" id="{5BBC89C7-45C6-4978-8111-B9661948F425}"/>
               </a:ext>
             </a:extLst>
           </p:cNvPr>
@@ -3923,10 +3923,10 @@
       </p:sp>
       <p:sp>
         <p:nvSpPr>
-          <p:cNvPr id="4" name="text-45">
-            <a:extLst xmlns:a="http://schemas.openxmlformats.org/drawingml/2006/main">
-              <a:ext uri="{FF2B5EF4-FFF2-40B4-BE49-F238E27FC236}">
-                <a16:creationId xmlns:a16="http://schemas.microsoft.com/office/drawing/2014/main" id="{8DB93BFF-2764-4FC8-9D1B-7D72497AFD40}"/>
+          <p:cNvPr id="4" name="text-140">
+            <a:extLst xmlns:a="http://schemas.openxmlformats.org/drawingml/2006/main">
+              <a:ext uri="{FF2B5EF4-FFF2-40B4-BE49-F238E27FC236}">
+                <a16:creationId xmlns:a16="http://schemas.microsoft.com/office/drawing/2014/main" id="{C7BAEFC1-B8C9-40FB-8678-7CF72E406611}"/>
               </a:ext>
             </a:extLst>
           </p:cNvPr>
@@ -3979,10 +3979,10 @@
       </p:sp>
       <p:sp>
         <p:nvSpPr>
-          <p:cNvPr id="5" name="text-46">
-            <a:extLst xmlns:a="http://schemas.openxmlformats.org/drawingml/2006/main">
-              <a:ext uri="{FF2B5EF4-FFF2-40B4-BE49-F238E27FC236}">
-                <a16:creationId xmlns:a16="http://schemas.microsoft.com/office/drawing/2014/main" id="{A058A660-C360-4E62-B6D0-561D0347E10F}"/>
+          <p:cNvPr id="5" name="text-141">
+            <a:extLst xmlns:a="http://schemas.openxmlformats.org/drawingml/2006/main">
+              <a:ext uri="{FF2B5EF4-FFF2-40B4-BE49-F238E27FC236}">
+                <a16:creationId xmlns:a16="http://schemas.microsoft.com/office/drawing/2014/main" id="{B8C1975E-C418-4C6B-B5A7-38783DD4B21C}"/>
               </a:ext>
             </a:extLst>
           </p:cNvPr>
@@ -4035,10 +4035,10 @@
       </p:sp>
       <p:sp>
         <p:nvSpPr>
-          <p:cNvPr id="6" name="box-47">
-            <a:extLst xmlns:a="http://schemas.openxmlformats.org/drawingml/2006/main">
-              <a:ext uri="{FF2B5EF4-FFF2-40B4-BE49-F238E27FC236}">
-                <a16:creationId xmlns:a16="http://schemas.microsoft.com/office/drawing/2014/main" id="{E2B1E56B-0949-409C-9813-15B927B06AFA}"/>
+          <p:cNvPr id="6" name="box-142">
+            <a:extLst xmlns:a="http://schemas.openxmlformats.org/drawingml/2006/main">
+              <a:ext uri="{FF2B5EF4-FFF2-40B4-BE49-F238E27FC236}">
+                <a16:creationId xmlns:a16="http://schemas.microsoft.com/office/drawing/2014/main" id="{61DF5ABF-4AAD-4270-BB2A-80E0722B95EC}"/>
               </a:ext>
             </a:extLst>
           </p:cNvPr>
@@ -4068,10 +4068,10 @@
       </p:sp>
       <p:sp>
         <p:nvSpPr>
-          <p:cNvPr id="7" name="text-48">
-            <a:extLst xmlns:a="http://schemas.openxmlformats.org/drawingml/2006/main">
-              <a:ext uri="{FF2B5EF4-FFF2-40B4-BE49-F238E27FC236}">
-                <a16:creationId xmlns:a16="http://schemas.microsoft.com/office/drawing/2014/main" id="{807063C9-54A9-44AD-93B0-CDD163359DD1}"/>
+          <p:cNvPr id="7" name="text-143">
+            <a:extLst xmlns:a="http://schemas.openxmlformats.org/drawingml/2006/main">
+              <a:ext uri="{FF2B5EF4-FFF2-40B4-BE49-F238E27FC236}">
+                <a16:creationId xmlns:a16="http://schemas.microsoft.com/office/drawing/2014/main" id="{AC667315-DE7F-43F2-9F6A-1422E739A53E}"/>
               </a:ext>
             </a:extLst>
           </p:cNvPr>
@@ -4124,10 +4124,10 @@
       </p:sp>
       <p:sp>
         <p:nvSpPr>
-          <p:cNvPr id="8" name="text-49">
-            <a:extLst xmlns:a="http://schemas.openxmlformats.org/drawingml/2006/main">
-              <a:ext uri="{FF2B5EF4-FFF2-40B4-BE49-F238E27FC236}">
-                <a16:creationId xmlns:a16="http://schemas.microsoft.com/office/drawing/2014/main" id="{B599C11B-B2C2-4DF7-9C53-7A365F76EBFB}"/>
+          <p:cNvPr id="8" name="text-144">
+            <a:extLst xmlns:a="http://schemas.openxmlformats.org/drawingml/2006/main">
+              <a:ext uri="{FF2B5EF4-FFF2-40B4-BE49-F238E27FC236}">
+                <a16:creationId xmlns:a16="http://schemas.microsoft.com/office/drawing/2014/main" id="{C7167620-E0BF-4890-B574-80C877BC17E1}"/>
               </a:ext>
             </a:extLst>
           </p:cNvPr>
@@ -4180,10 +4180,10 @@
       </p:sp>
       <p:sp>
         <p:nvSpPr>
-          <p:cNvPr id="9" name="box-50">
-            <a:extLst xmlns:a="http://schemas.openxmlformats.org/drawingml/2006/main">
-              <a:ext uri="{FF2B5EF4-FFF2-40B4-BE49-F238E27FC236}">
-                <a16:creationId xmlns:a16="http://schemas.microsoft.com/office/drawing/2014/main" id="{CDC7D70A-616B-4A51-8C95-F4BBA62113D5}"/>
+          <p:cNvPr id="9" name="box-145">
+            <a:extLst xmlns:a="http://schemas.openxmlformats.org/drawingml/2006/main">
+              <a:ext uri="{FF2B5EF4-FFF2-40B4-BE49-F238E27FC236}">
+                <a16:creationId xmlns:a16="http://schemas.microsoft.com/office/drawing/2014/main" id="{915DE63D-312E-494D-B191-21454D08EE23}"/>
               </a:ext>
             </a:extLst>
           </p:cNvPr>
@@ -4213,10 +4213,10 @@
       </p:sp>
       <p:sp>
         <p:nvSpPr>
-          <p:cNvPr id="10" name="text-51">
-            <a:extLst xmlns:a="http://schemas.openxmlformats.org/drawingml/2006/main">
-              <a:ext uri="{FF2B5EF4-FFF2-40B4-BE49-F238E27FC236}">
-                <a16:creationId xmlns:a16="http://schemas.microsoft.com/office/drawing/2014/main" id="{D713DBA2-AD10-484E-955B-AC7A6756E53E}"/>
+          <p:cNvPr id="10" name="text-146">
+            <a:extLst xmlns:a="http://schemas.openxmlformats.org/drawingml/2006/main">
+              <a:ext uri="{FF2B5EF4-FFF2-40B4-BE49-F238E27FC236}">
+                <a16:creationId xmlns:a16="http://schemas.microsoft.com/office/drawing/2014/main" id="{3933C62D-7387-4BAE-B46A-0AD5331F1447}"/>
               </a:ext>
             </a:extLst>
           </p:cNvPr>
@@ -4269,10 +4269,10 @@
       </p:sp>
       <p:sp>
         <p:nvSpPr>
-          <p:cNvPr id="11" name="text-52">
-            <a:extLst xmlns:a="http://schemas.openxmlformats.org/drawingml/2006/main">
-              <a:ext uri="{FF2B5EF4-FFF2-40B4-BE49-F238E27FC236}">
-                <a16:creationId xmlns:a16="http://schemas.microsoft.com/office/drawing/2014/main" id="{BDFBC8F2-FE5B-4F08-8C21-01BDC72F567D}"/>
+          <p:cNvPr id="11" name="text-147">
+            <a:extLst xmlns:a="http://schemas.openxmlformats.org/drawingml/2006/main">
+              <a:ext uri="{FF2B5EF4-FFF2-40B4-BE49-F238E27FC236}">
+                <a16:creationId xmlns:a16="http://schemas.microsoft.com/office/drawing/2014/main" id="{C8FA4460-6DA8-4DE5-93C7-F732996DCA76}"/>
               </a:ext>
             </a:extLst>
           </p:cNvPr>
@@ -4325,10 +4325,10 @@
       </p:sp>
       <p:sp>
         <p:nvSpPr>
-          <p:cNvPr id="12" name="box-53">
-            <a:extLst xmlns:a="http://schemas.openxmlformats.org/drawingml/2006/main">
-              <a:ext uri="{FF2B5EF4-FFF2-40B4-BE49-F238E27FC236}">
-                <a16:creationId xmlns:a16="http://schemas.microsoft.com/office/drawing/2014/main" id="{8ED008B3-B33E-4389-B11F-28138A4D1282}"/>
+          <p:cNvPr id="12" name="box-148">
+            <a:extLst xmlns:a="http://schemas.openxmlformats.org/drawingml/2006/main">
+              <a:ext uri="{FF2B5EF4-FFF2-40B4-BE49-F238E27FC236}">
+                <a16:creationId xmlns:a16="http://schemas.microsoft.com/office/drawing/2014/main" id="{BF3DADDF-DC16-41F2-B63D-88B2FE2374D2}"/>
               </a:ext>
             </a:extLst>
           </p:cNvPr>
@@ -4358,10 +4358,10 @@
       </p:sp>
       <p:sp>
         <p:nvSpPr>
-          <p:cNvPr id="13" name="text-54">
-            <a:extLst xmlns:a="http://schemas.openxmlformats.org/drawingml/2006/main">
-              <a:ext uri="{FF2B5EF4-FFF2-40B4-BE49-F238E27FC236}">
-                <a16:creationId xmlns:a16="http://schemas.microsoft.com/office/drawing/2014/main" id="{A4748E45-0AA6-485A-980A-B74B932F7682}"/>
+          <p:cNvPr id="13" name="text-149">
+            <a:extLst xmlns:a="http://schemas.openxmlformats.org/drawingml/2006/main">
+              <a:ext uri="{FF2B5EF4-FFF2-40B4-BE49-F238E27FC236}">
+                <a16:creationId xmlns:a16="http://schemas.microsoft.com/office/drawing/2014/main" id="{10175C24-A31B-4D80-B2D1-C258710DB7E6}"/>
               </a:ext>
             </a:extLst>
           </p:cNvPr>
@@ -4414,10 +4414,10 @@
       </p:sp>
       <p:sp>
         <p:nvSpPr>
-          <p:cNvPr id="14" name="text-55">
-            <a:extLst xmlns:a="http://schemas.openxmlformats.org/drawingml/2006/main">
-              <a:ext uri="{FF2B5EF4-FFF2-40B4-BE49-F238E27FC236}">
-                <a16:creationId xmlns:a16="http://schemas.microsoft.com/office/drawing/2014/main" id="{B05A41B2-9F33-4F2C-B5B7-5CC9E88AB99E}"/>
+          <p:cNvPr id="14" name="text-150">
+            <a:extLst xmlns:a="http://schemas.openxmlformats.org/drawingml/2006/main">
+              <a:ext uri="{FF2B5EF4-FFF2-40B4-BE49-F238E27FC236}">
+                <a16:creationId xmlns:a16="http://schemas.microsoft.com/office/drawing/2014/main" id="{6E6B8E15-EF53-4CA2-A747-89C695B353C7}"/>
               </a:ext>
             </a:extLst>
           </p:cNvPr>
@@ -4470,10 +4470,10 @@
       </p:sp>
       <p:sp>
         <p:nvSpPr>
-          <p:cNvPr id="15" name="box-56">
-            <a:extLst xmlns:a="http://schemas.openxmlformats.org/drawingml/2006/main">
-              <a:ext uri="{FF2B5EF4-FFF2-40B4-BE49-F238E27FC236}">
-                <a16:creationId xmlns:a16="http://schemas.microsoft.com/office/drawing/2014/main" id="{C7A57353-27E6-49D2-8564-18F856026B74}"/>
+          <p:cNvPr id="15" name="box-151">
+            <a:extLst xmlns:a="http://schemas.openxmlformats.org/drawingml/2006/main">
+              <a:ext uri="{FF2B5EF4-FFF2-40B4-BE49-F238E27FC236}">
+                <a16:creationId xmlns:a16="http://schemas.microsoft.com/office/drawing/2014/main" id="{39CAE047-EEF7-41C6-BEF9-D03A2D6FC892}"/>
               </a:ext>
             </a:extLst>
           </p:cNvPr>
@@ -4503,10 +4503,10 @@
       </p:sp>
       <p:sp>
         <p:nvSpPr>
-          <p:cNvPr id="16" name="text-57">
-            <a:extLst xmlns:a="http://schemas.openxmlformats.org/drawingml/2006/main">
-              <a:ext uri="{FF2B5EF4-FFF2-40B4-BE49-F238E27FC236}">
-                <a16:creationId xmlns:a16="http://schemas.microsoft.com/office/drawing/2014/main" id="{244BA28B-5394-40FB-9F50-B2A3D2E2D7AF}"/>
+          <p:cNvPr id="16" name="text-152">
+            <a:extLst xmlns:a="http://schemas.openxmlformats.org/drawingml/2006/main">
+              <a:ext uri="{FF2B5EF4-FFF2-40B4-BE49-F238E27FC236}">
+                <a16:creationId xmlns:a16="http://schemas.microsoft.com/office/drawing/2014/main" id="{5E7DBBFE-7C18-474E-A9E0-058F18FC35E6}"/>
               </a:ext>
             </a:extLst>
           </p:cNvPr>
@@ -4552,17 +4552,17 @@
                 <a:ea typeface="Arial"/>
                 <a:cs typeface="Arial"/>
               </a:rPr>
-              <a:t>J’aime le français.</a:t>
-            </a:r>
-          </a:p>
-        </p:txBody>
-      </p:sp>
-      <p:sp>
-        <p:nvSpPr>
-          <p:cNvPr id="17" name="text-58">
-            <a:extLst xmlns:a="http://schemas.openxmlformats.org/drawingml/2006/main">
-              <a:ext uri="{FF2B5EF4-FFF2-40B4-BE49-F238E27FC236}">
-                <a16:creationId xmlns:a16="http://schemas.microsoft.com/office/drawing/2014/main" id="{8B79E647-EB9F-4B45-AFD0-26D187B61193}"/>
+              <a:t>yeux → l’œil (m)</a:t>
+            </a:r>
+          </a:p>
+        </p:txBody>
+      </p:sp>
+      <p:sp>
+        <p:nvSpPr>
+          <p:cNvPr id="17" name="text-153">
+            <a:extLst xmlns:a="http://schemas.openxmlformats.org/drawingml/2006/main">
+              <a:ext uri="{FF2B5EF4-FFF2-40B4-BE49-F238E27FC236}">
+                <a16:creationId xmlns:a16="http://schemas.microsoft.com/office/drawing/2014/main" id="{3D91DF67-D4A8-4F67-88D1-9000BE440B56}"/>
               </a:ext>
             </a:extLst>
           </p:cNvPr>
@@ -4608,7 +4608,7 @@
                 <a:ea typeface="Arial"/>
                 <a:cs typeface="Arial"/>
               </a:rPr>
-              <a:t>Kesme işareti anlamlıdır · apostrophes matter · l’apostrophe compte</a:t>
+              <a:t>Sözlük düzensiz çoğulu çözer · dictionary resolves irregular plurals · le dictionnaire retrouve le singulier</a:t>
             </a:r>
           </a:p>
         </p:txBody>
@@ -4616,7 +4616,7 @@
     </p:spTree>
     <p:extLst>
       <p:ext uri="{BB962C8B-B14F-4D97-AF65-F5344CB8AC3E}">
-        <p14:creationId xmlns:p14="http://schemas.microsoft.com/office/powerpoint/2010/main" val="1383582838"/>
+        <p14:creationId xmlns:p14="http://schemas.microsoft.com/office/powerpoint/2010/main" val="255765212"/>
       </p:ext>
     </p:extLst>
   </p:cSld>
@@ -4644,10 +4644,10 @@
       </p:grpSpPr>
       <p:sp>
         <p:nvSpPr>
-          <p:cNvPr id="21" name="box-59">
-            <a:extLst xmlns:a="http://schemas.openxmlformats.org/drawingml/2006/main">
-              <a:ext uri="{FF2B5EF4-FFF2-40B4-BE49-F238E27FC236}">
-                <a16:creationId xmlns:a16="http://schemas.microsoft.com/office/drawing/2014/main" id="{E8CA2E55-742A-4DDE-BFDD-BDDF49B3E492}"/>
+          <p:cNvPr id="21" name="box-154">
+            <a:extLst xmlns:a="http://schemas.openxmlformats.org/drawingml/2006/main">
+              <a:ext uri="{FF2B5EF4-FFF2-40B4-BE49-F238E27FC236}">
+                <a16:creationId xmlns:a16="http://schemas.microsoft.com/office/drawing/2014/main" id="{DF735055-437B-4E16-A73B-0969880F0977}"/>
               </a:ext>
             </a:extLst>
           </p:cNvPr>
@@ -4677,10 +4677,10 @@
       </p:sp>
       <p:sp>
         <p:nvSpPr>
-          <p:cNvPr id="2" name="text-60">
-            <a:extLst xmlns:a="http://schemas.openxmlformats.org/drawingml/2006/main">
-              <a:ext uri="{FF2B5EF4-FFF2-40B4-BE49-F238E27FC236}">
-                <a16:creationId xmlns:a16="http://schemas.microsoft.com/office/drawing/2014/main" id="{EAE0F16B-5A0C-44C9-AFCF-28D837DA076A}"/>
+          <p:cNvPr id="2" name="text-155">
+            <a:extLst xmlns:a="http://schemas.openxmlformats.org/drawingml/2006/main">
+              <a:ext uri="{FF2B5EF4-FFF2-40B4-BE49-F238E27FC236}">
+                <a16:creationId xmlns:a16="http://schemas.microsoft.com/office/drawing/2014/main" id="{B4F4797F-708D-4888-AFBC-FEB243087800}"/>
               </a:ext>
             </a:extLst>
           </p:cNvPr>
@@ -4733,10 +4733,10 @@
       </p:sp>
       <p:sp>
         <p:nvSpPr>
-          <p:cNvPr id="3" name="text-61">
-            <a:extLst xmlns:a="http://schemas.openxmlformats.org/drawingml/2006/main">
-              <a:ext uri="{FF2B5EF4-FFF2-40B4-BE49-F238E27FC236}">
-                <a16:creationId xmlns:a16="http://schemas.microsoft.com/office/drawing/2014/main" id="{348F0AE5-7630-4C1C-B3C5-11B61B082CB6}"/>
+          <p:cNvPr id="3" name="text-156">
+            <a:extLst xmlns:a="http://schemas.openxmlformats.org/drawingml/2006/main">
+              <a:ext uri="{FF2B5EF4-FFF2-40B4-BE49-F238E27FC236}">
+                <a16:creationId xmlns:a16="http://schemas.microsoft.com/office/drawing/2014/main" id="{CE92F4FE-4100-4DB6-BD57-4480A3508EFB}"/>
               </a:ext>
             </a:extLst>
           </p:cNvPr>
@@ -4789,10 +4789,10 @@
       </p:sp>
       <p:sp>
         <p:nvSpPr>
-          <p:cNvPr id="4" name="text-62">
-            <a:extLst xmlns:a="http://schemas.openxmlformats.org/drawingml/2006/main">
-              <a:ext uri="{FF2B5EF4-FFF2-40B4-BE49-F238E27FC236}">
-                <a16:creationId xmlns:a16="http://schemas.microsoft.com/office/drawing/2014/main" id="{5322831D-A0D0-4523-A243-AD8E4E44E0DA}"/>
+          <p:cNvPr id="4" name="text-157">
+            <a:extLst xmlns:a="http://schemas.openxmlformats.org/drawingml/2006/main">
+              <a:ext uri="{FF2B5EF4-FFF2-40B4-BE49-F238E27FC236}">
+                <a16:creationId xmlns:a16="http://schemas.microsoft.com/office/drawing/2014/main" id="{9A4BAF04-2976-4EEC-AA84-226F043003EC}"/>
               </a:ext>
             </a:extLst>
           </p:cNvPr>
@@ -4845,10 +4845,10 @@
       </p:sp>
       <p:sp>
         <p:nvSpPr>
-          <p:cNvPr id="5" name="text-63">
-            <a:extLst xmlns:a="http://schemas.openxmlformats.org/drawingml/2006/main">
-              <a:ext uri="{FF2B5EF4-FFF2-40B4-BE49-F238E27FC236}">
-                <a16:creationId xmlns:a16="http://schemas.microsoft.com/office/drawing/2014/main" id="{CD9C9608-1D34-410F-8817-47CF5C7CB081}"/>
+          <p:cNvPr id="5" name="text-158">
+            <a:extLst xmlns:a="http://schemas.openxmlformats.org/drawingml/2006/main">
+              <a:ext uri="{FF2B5EF4-FFF2-40B4-BE49-F238E27FC236}">
+                <a16:creationId xmlns:a16="http://schemas.microsoft.com/office/drawing/2014/main" id="{921916B6-4C01-4FB9-A1AD-A287D0E0CF5C}"/>
               </a:ext>
             </a:extLst>
           </p:cNvPr>
@@ -4901,10 +4901,10 @@
       </p:sp>
       <p:sp>
         <p:nvSpPr>
-          <p:cNvPr id="6" name="box-64">
-            <a:extLst xmlns:a="http://schemas.openxmlformats.org/drawingml/2006/main">
-              <a:ext uri="{FF2B5EF4-FFF2-40B4-BE49-F238E27FC236}">
-                <a16:creationId xmlns:a16="http://schemas.microsoft.com/office/drawing/2014/main" id="{BFB652B2-B0FA-4F1D-86AF-6F2F0D2934F8}"/>
+          <p:cNvPr id="6" name="box-159">
+            <a:extLst xmlns:a="http://schemas.openxmlformats.org/drawingml/2006/main">
+              <a:ext uri="{FF2B5EF4-FFF2-40B4-BE49-F238E27FC236}">
+                <a16:creationId xmlns:a16="http://schemas.microsoft.com/office/drawing/2014/main" id="{067B4F55-9E64-4383-AB4B-E6E599B95355}"/>
               </a:ext>
             </a:extLst>
           </p:cNvPr>
@@ -4934,10 +4934,10 @@
       </p:sp>
       <p:sp>
         <p:nvSpPr>
-          <p:cNvPr id="7" name="dot-65">
-            <a:extLst xmlns:a="http://schemas.openxmlformats.org/drawingml/2006/main">
-              <a:ext uri="{FF2B5EF4-FFF2-40B4-BE49-F238E27FC236}">
-                <a16:creationId xmlns:a16="http://schemas.microsoft.com/office/drawing/2014/main" id="{028109BC-55B0-4025-B174-E777F43CE858}"/>
+          <p:cNvPr id="7" name="dot-160">
+            <a:extLst xmlns:a="http://schemas.openxmlformats.org/drawingml/2006/main">
+              <a:ext uri="{FF2B5EF4-FFF2-40B4-BE49-F238E27FC236}">
+                <a16:creationId xmlns:a16="http://schemas.microsoft.com/office/drawing/2014/main" id="{6006D020-6A8E-4C75-BDC1-509FF19DC6C7}"/>
               </a:ext>
             </a:extLst>
           </p:cNvPr>
@@ -4965,10 +4965,10 @@
       </p:sp>
       <p:sp>
         <p:nvSpPr>
-          <p:cNvPr id="8" name="text-66">
-            <a:extLst xmlns:a="http://schemas.openxmlformats.org/drawingml/2006/main">
-              <a:ext uri="{FF2B5EF4-FFF2-40B4-BE49-F238E27FC236}">
-                <a16:creationId xmlns:a16="http://schemas.microsoft.com/office/drawing/2014/main" id="{E60AA736-9AB6-412C-9D98-3FE80D3900C1}"/>
+          <p:cNvPr id="8" name="text-161">
+            <a:extLst xmlns:a="http://schemas.openxmlformats.org/drawingml/2006/main">
+              <a:ext uri="{FF2B5EF4-FFF2-40B4-BE49-F238E27FC236}">
+                <a16:creationId xmlns:a16="http://schemas.microsoft.com/office/drawing/2014/main" id="{7CFC04E8-A2EF-4F17-BE35-7B481EC1CB96}"/>
               </a:ext>
             </a:extLst>
           </p:cNvPr>
@@ -5021,10 +5021,10 @@
       </p:sp>
       <p:sp>
         <p:nvSpPr>
-          <p:cNvPr id="9" name="text-67">
-            <a:extLst xmlns:a="http://schemas.openxmlformats.org/drawingml/2006/main">
-              <a:ext uri="{FF2B5EF4-FFF2-40B4-BE49-F238E27FC236}">
-                <a16:creationId xmlns:a16="http://schemas.microsoft.com/office/drawing/2014/main" id="{9ECB5AB1-EAD9-4E1A-B498-14CF0C2CB719}"/>
+          <p:cNvPr id="9" name="text-162">
+            <a:extLst xmlns:a="http://schemas.openxmlformats.org/drawingml/2006/main">
+              <a:ext uri="{FF2B5EF4-FFF2-40B4-BE49-F238E27FC236}">
+                <a16:creationId xmlns:a16="http://schemas.microsoft.com/office/drawing/2014/main" id="{EC6E338D-B4CC-4A6B-94D9-5025FFB48C03}"/>
               </a:ext>
             </a:extLst>
           </p:cNvPr>
@@ -5077,10 +5077,10 @@
       </p:sp>
       <p:sp>
         <p:nvSpPr>
-          <p:cNvPr id="10" name="text-68">
-            <a:extLst xmlns:a="http://schemas.openxmlformats.org/drawingml/2006/main">
-              <a:ext uri="{FF2B5EF4-FFF2-40B4-BE49-F238E27FC236}">
-                <a16:creationId xmlns:a16="http://schemas.microsoft.com/office/drawing/2014/main" id="{D4E1B850-1C6C-41B6-BA7B-E09632B594F7}"/>
+          <p:cNvPr id="10" name="text-163">
+            <a:extLst xmlns:a="http://schemas.openxmlformats.org/drawingml/2006/main">
+              <a:ext uri="{FF2B5EF4-FFF2-40B4-BE49-F238E27FC236}">
+                <a16:creationId xmlns:a16="http://schemas.microsoft.com/office/drawing/2014/main" id="{558BFEBD-1C97-4A5C-BDA7-0902D5EFB6FD}"/>
               </a:ext>
             </a:extLst>
           </p:cNvPr>
@@ -5133,10 +5133,10 @@
       </p:sp>
       <p:sp>
         <p:nvSpPr>
-          <p:cNvPr id="11" name="dot-69">
-            <a:extLst xmlns:a="http://schemas.openxmlformats.org/drawingml/2006/main">
-              <a:ext uri="{FF2B5EF4-FFF2-40B4-BE49-F238E27FC236}">
-                <a16:creationId xmlns:a16="http://schemas.microsoft.com/office/drawing/2014/main" id="{846E15A0-1CF5-456B-94A3-09EA76B5279A}"/>
+          <p:cNvPr id="11" name="dot-164">
+            <a:extLst xmlns:a="http://schemas.openxmlformats.org/drawingml/2006/main">
+              <a:ext uri="{FF2B5EF4-FFF2-40B4-BE49-F238E27FC236}">
+                <a16:creationId xmlns:a16="http://schemas.microsoft.com/office/drawing/2014/main" id="{E1FD1CCD-6725-4455-9FA6-48F6002F3DBB}"/>
               </a:ext>
             </a:extLst>
           </p:cNvPr>
@@ -5164,10 +5164,10 @@
       </p:sp>
       <p:sp>
         <p:nvSpPr>
-          <p:cNvPr id="12" name="text-70">
-            <a:extLst xmlns:a="http://schemas.openxmlformats.org/drawingml/2006/main">
-              <a:ext uri="{FF2B5EF4-FFF2-40B4-BE49-F238E27FC236}">
-                <a16:creationId xmlns:a16="http://schemas.microsoft.com/office/drawing/2014/main" id="{AED5EDC5-52D4-4728-8C12-801E5F02BE41}"/>
+          <p:cNvPr id="12" name="text-165">
+            <a:extLst xmlns:a="http://schemas.openxmlformats.org/drawingml/2006/main">
+              <a:ext uri="{FF2B5EF4-FFF2-40B4-BE49-F238E27FC236}">
+                <a16:creationId xmlns:a16="http://schemas.microsoft.com/office/drawing/2014/main" id="{6EA237C8-E1BA-4CA6-8C11-195120F8588A}"/>
               </a:ext>
             </a:extLst>
           </p:cNvPr>
@@ -5220,10 +5220,10 @@
       </p:sp>
       <p:sp>
         <p:nvSpPr>
-          <p:cNvPr id="13" name="text-71">
-            <a:extLst xmlns:a="http://schemas.openxmlformats.org/drawingml/2006/main">
-              <a:ext uri="{FF2B5EF4-FFF2-40B4-BE49-F238E27FC236}">
-                <a16:creationId xmlns:a16="http://schemas.microsoft.com/office/drawing/2014/main" id="{BF9A8BFC-12DC-4923-B789-F3949EF87038}"/>
+          <p:cNvPr id="13" name="text-166">
+            <a:extLst xmlns:a="http://schemas.openxmlformats.org/drawingml/2006/main">
+              <a:ext uri="{FF2B5EF4-FFF2-40B4-BE49-F238E27FC236}">
+                <a16:creationId xmlns:a16="http://schemas.microsoft.com/office/drawing/2014/main" id="{80C2EA4E-A394-4B2D-BDEE-F4D4C67B3B72}"/>
               </a:ext>
             </a:extLst>
           </p:cNvPr>
@@ -5276,10 +5276,10 @@
       </p:sp>
       <p:sp>
         <p:nvSpPr>
-          <p:cNvPr id="14" name="text-72">
-            <a:extLst xmlns:a="http://schemas.openxmlformats.org/drawingml/2006/main">
-              <a:ext uri="{FF2B5EF4-FFF2-40B4-BE49-F238E27FC236}">
-                <a16:creationId xmlns:a16="http://schemas.microsoft.com/office/drawing/2014/main" id="{59C15416-8384-4FC4-89E0-F1FA8EFC8FC3}"/>
+          <p:cNvPr id="14" name="text-167">
+            <a:extLst xmlns:a="http://schemas.openxmlformats.org/drawingml/2006/main">
+              <a:ext uri="{FF2B5EF4-FFF2-40B4-BE49-F238E27FC236}">
+                <a16:creationId xmlns:a16="http://schemas.microsoft.com/office/drawing/2014/main" id="{CE96F230-8CC9-477F-B65C-A73E92813419}"/>
               </a:ext>
             </a:extLst>
           </p:cNvPr>
@@ -5332,10 +5332,10 @@
       </p:sp>
       <p:sp>
         <p:nvSpPr>
-          <p:cNvPr id="15" name="dot-73">
-            <a:extLst xmlns:a="http://schemas.openxmlformats.org/drawingml/2006/main">
-              <a:ext uri="{FF2B5EF4-FFF2-40B4-BE49-F238E27FC236}">
-                <a16:creationId xmlns:a16="http://schemas.microsoft.com/office/drawing/2014/main" id="{C1F775BA-9F50-4576-B8B6-F62D52CA01E9}"/>
+          <p:cNvPr id="15" name="dot-168">
+            <a:extLst xmlns:a="http://schemas.openxmlformats.org/drawingml/2006/main">
+              <a:ext uri="{FF2B5EF4-FFF2-40B4-BE49-F238E27FC236}">
+                <a16:creationId xmlns:a16="http://schemas.microsoft.com/office/drawing/2014/main" id="{47E095DC-3C8E-4BA7-8640-573D3DB28731}"/>
               </a:ext>
             </a:extLst>
           </p:cNvPr>
@@ -5363,10 +5363,10 @@
       </p:sp>
       <p:sp>
         <p:nvSpPr>
-          <p:cNvPr id="16" name="text-74">
-            <a:extLst xmlns:a="http://schemas.openxmlformats.org/drawingml/2006/main">
-              <a:ext uri="{FF2B5EF4-FFF2-40B4-BE49-F238E27FC236}">
-                <a16:creationId xmlns:a16="http://schemas.microsoft.com/office/drawing/2014/main" id="{F6C3E64C-278E-4C27-A9EC-ECC9724D7895}"/>
+          <p:cNvPr id="16" name="text-169">
+            <a:extLst xmlns:a="http://schemas.openxmlformats.org/drawingml/2006/main">
+              <a:ext uri="{FF2B5EF4-FFF2-40B4-BE49-F238E27FC236}">
+                <a16:creationId xmlns:a16="http://schemas.microsoft.com/office/drawing/2014/main" id="{E7BEB6E4-E550-4A03-883D-F38F53212085}"/>
               </a:ext>
             </a:extLst>
           </p:cNvPr>
@@ -5419,10 +5419,10 @@
       </p:sp>
       <p:sp>
         <p:nvSpPr>
-          <p:cNvPr id="17" name="text-75">
-            <a:extLst xmlns:a="http://schemas.openxmlformats.org/drawingml/2006/main">
-              <a:ext uri="{FF2B5EF4-FFF2-40B4-BE49-F238E27FC236}">
-                <a16:creationId xmlns:a16="http://schemas.microsoft.com/office/drawing/2014/main" id="{2A6A63C0-07E0-40BC-B9E5-47AC479AB39B}"/>
+          <p:cNvPr id="17" name="text-170">
+            <a:extLst xmlns:a="http://schemas.openxmlformats.org/drawingml/2006/main">
+              <a:ext uri="{FF2B5EF4-FFF2-40B4-BE49-F238E27FC236}">
+                <a16:creationId xmlns:a16="http://schemas.microsoft.com/office/drawing/2014/main" id="{CE5B93CD-2485-4FA0-B2EA-31686D381C1E}"/>
               </a:ext>
             </a:extLst>
           </p:cNvPr>
@@ -5475,10 +5475,10 @@
       </p:sp>
       <p:sp>
         <p:nvSpPr>
-          <p:cNvPr id="18" name="text-76">
-            <a:extLst xmlns:a="http://schemas.openxmlformats.org/drawingml/2006/main">
-              <a:ext uri="{FF2B5EF4-FFF2-40B4-BE49-F238E27FC236}">
-                <a16:creationId xmlns:a16="http://schemas.microsoft.com/office/drawing/2014/main" id="{8E1B76D9-4BD0-42BF-8AFE-3736BD27A47D}"/>
+          <p:cNvPr id="18" name="text-171">
+            <a:extLst xmlns:a="http://schemas.openxmlformats.org/drawingml/2006/main">
+              <a:ext uri="{FF2B5EF4-FFF2-40B4-BE49-F238E27FC236}">
+                <a16:creationId xmlns:a16="http://schemas.microsoft.com/office/drawing/2014/main" id="{5856D05D-4902-48B5-91ED-242E44A77AAC}"/>
               </a:ext>
             </a:extLst>
           </p:cNvPr>
@@ -5531,10 +5531,10 @@
       </p:sp>
       <p:sp>
         <p:nvSpPr>
-          <p:cNvPr id="19" name="box-77">
-            <a:extLst xmlns:a="http://schemas.openxmlformats.org/drawingml/2006/main">
-              <a:ext uri="{FF2B5EF4-FFF2-40B4-BE49-F238E27FC236}">
-                <a16:creationId xmlns:a16="http://schemas.microsoft.com/office/drawing/2014/main" id="{6BF0A664-B7E4-4ABD-ABD8-0996CFC8C810}"/>
+          <p:cNvPr id="19" name="box-172">
+            <a:extLst xmlns:a="http://schemas.openxmlformats.org/drawingml/2006/main">
+              <a:ext uri="{FF2B5EF4-FFF2-40B4-BE49-F238E27FC236}">
+                <a16:creationId xmlns:a16="http://schemas.microsoft.com/office/drawing/2014/main" id="{F09108AC-EB69-4A4B-A8B9-277D1506004D}"/>
               </a:ext>
             </a:extLst>
           </p:cNvPr>
@@ -5564,10 +5564,10 @@
       </p:sp>
       <p:sp>
         <p:nvSpPr>
-          <p:cNvPr id="20" name="text-78">
-            <a:extLst xmlns:a="http://schemas.openxmlformats.org/drawingml/2006/main">
-              <a:ext uri="{FF2B5EF4-FFF2-40B4-BE49-F238E27FC236}">
-                <a16:creationId xmlns:a16="http://schemas.microsoft.com/office/drawing/2014/main" id="{19F1713F-AD26-4B0C-A402-F07E48FF3E66}"/>
+          <p:cNvPr id="20" name="text-173">
+            <a:extLst xmlns:a="http://schemas.openxmlformats.org/drawingml/2006/main">
+              <a:ext uri="{FF2B5EF4-FFF2-40B4-BE49-F238E27FC236}">
+                <a16:creationId xmlns:a16="http://schemas.microsoft.com/office/drawing/2014/main" id="{C9F4D3F1-C17C-4997-9762-CC186E20FB8E}"/>
               </a:ext>
             </a:extLst>
           </p:cNvPr>
@@ -5621,7 +5621,7 @@
     </p:spTree>
     <p:extLst>
       <p:ext uri="{BB962C8B-B14F-4D97-AF65-F5344CB8AC3E}">
-        <p14:creationId xmlns:p14="http://schemas.microsoft.com/office/powerpoint/2010/main" val="1873940815"/>
+        <p14:creationId xmlns:p14="http://schemas.microsoft.com/office/powerpoint/2010/main" val="172203844"/>
       </p:ext>
     </p:extLst>
   </p:cSld>
@@ -5649,10 +5649,10 @@
       </p:grpSpPr>
       <p:sp>
         <p:nvSpPr>
-          <p:cNvPr id="18" name="box-79">
-            <a:extLst xmlns:a="http://schemas.openxmlformats.org/drawingml/2006/main">
-              <a:ext uri="{FF2B5EF4-FFF2-40B4-BE49-F238E27FC236}">
-                <a16:creationId xmlns:a16="http://schemas.microsoft.com/office/drawing/2014/main" id="{39C02A3A-013D-40A7-92EB-E88070BF6E0C}"/>
+          <p:cNvPr id="18" name="box-174">
+            <a:extLst xmlns:a="http://schemas.openxmlformats.org/drawingml/2006/main">
+              <a:ext uri="{FF2B5EF4-FFF2-40B4-BE49-F238E27FC236}">
+                <a16:creationId xmlns:a16="http://schemas.microsoft.com/office/drawing/2014/main" id="{20256EEC-920D-40C0-B903-AA5C7AA831A2}"/>
               </a:ext>
             </a:extLst>
           </p:cNvPr>
@@ -5682,10 +5682,10 @@
       </p:sp>
       <p:sp>
         <p:nvSpPr>
-          <p:cNvPr id="2" name="text-80">
-            <a:extLst xmlns:a="http://schemas.openxmlformats.org/drawingml/2006/main">
-              <a:ext uri="{FF2B5EF4-FFF2-40B4-BE49-F238E27FC236}">
-                <a16:creationId xmlns:a16="http://schemas.microsoft.com/office/drawing/2014/main" id="{BC8B7B21-C99B-4523-BD8A-E90B66FA938E}"/>
+          <p:cNvPr id="2" name="text-175">
+            <a:extLst xmlns:a="http://schemas.openxmlformats.org/drawingml/2006/main">
+              <a:ext uri="{FF2B5EF4-FFF2-40B4-BE49-F238E27FC236}">
+                <a16:creationId xmlns:a16="http://schemas.microsoft.com/office/drawing/2014/main" id="{64A6C2CF-6056-4909-9FA0-4FF69A411EC4}"/>
               </a:ext>
             </a:extLst>
           </p:cNvPr>
@@ -5738,10 +5738,10 @@
       </p:sp>
       <p:sp>
         <p:nvSpPr>
-          <p:cNvPr id="3" name="text-81">
-            <a:extLst xmlns:a="http://schemas.openxmlformats.org/drawingml/2006/main">
-              <a:ext uri="{FF2B5EF4-FFF2-40B4-BE49-F238E27FC236}">
-                <a16:creationId xmlns:a16="http://schemas.microsoft.com/office/drawing/2014/main" id="{9D3B7AFF-E841-49D5-9CCD-98A5F98E8C85}"/>
+          <p:cNvPr id="3" name="text-176">
+            <a:extLst xmlns:a="http://schemas.openxmlformats.org/drawingml/2006/main">
+              <a:ext uri="{FF2B5EF4-FFF2-40B4-BE49-F238E27FC236}">
+                <a16:creationId xmlns:a16="http://schemas.microsoft.com/office/drawing/2014/main" id="{1B6AA55A-BA5A-4387-B373-243B0DA2440B}"/>
               </a:ext>
             </a:extLst>
           </p:cNvPr>
@@ -5794,10 +5794,10 @@
       </p:sp>
       <p:sp>
         <p:nvSpPr>
-          <p:cNvPr id="4" name="text-82">
-            <a:extLst xmlns:a="http://schemas.openxmlformats.org/drawingml/2006/main">
-              <a:ext uri="{FF2B5EF4-FFF2-40B4-BE49-F238E27FC236}">
-                <a16:creationId xmlns:a16="http://schemas.microsoft.com/office/drawing/2014/main" id="{272D765D-19F1-4D6A-A6B4-F35B19DD1299}"/>
+          <p:cNvPr id="4" name="text-177">
+            <a:extLst xmlns:a="http://schemas.openxmlformats.org/drawingml/2006/main">
+              <a:ext uri="{FF2B5EF4-FFF2-40B4-BE49-F238E27FC236}">
+                <a16:creationId xmlns:a16="http://schemas.microsoft.com/office/drawing/2014/main" id="{63A31BD9-1260-4C5D-BF06-C6E08D1F8B3F}"/>
               </a:ext>
             </a:extLst>
           </p:cNvPr>
@@ -5850,10 +5850,10 @@
       </p:sp>
       <p:sp>
         <p:nvSpPr>
-          <p:cNvPr id="5" name="text-83">
-            <a:extLst xmlns:a="http://schemas.openxmlformats.org/drawingml/2006/main">
-              <a:ext uri="{FF2B5EF4-FFF2-40B4-BE49-F238E27FC236}">
-                <a16:creationId xmlns:a16="http://schemas.microsoft.com/office/drawing/2014/main" id="{A9592D8F-3C46-4ED3-9BE5-AA7A0A762142}"/>
+          <p:cNvPr id="5" name="text-178">
+            <a:extLst xmlns:a="http://schemas.openxmlformats.org/drawingml/2006/main">
+              <a:ext uri="{FF2B5EF4-FFF2-40B4-BE49-F238E27FC236}">
+                <a16:creationId xmlns:a16="http://schemas.microsoft.com/office/drawing/2014/main" id="{E25F5FC5-9A05-441E-8ED7-85D0E2178034}"/>
               </a:ext>
             </a:extLst>
           </p:cNvPr>
@@ -5906,10 +5906,10 @@
       </p:sp>
       <p:sp>
         <p:nvSpPr>
-          <p:cNvPr id="6" name="text-84">
-            <a:extLst xmlns:a="http://schemas.openxmlformats.org/drawingml/2006/main">
-              <a:ext uri="{FF2B5EF4-FFF2-40B4-BE49-F238E27FC236}">
-                <a16:creationId xmlns:a16="http://schemas.microsoft.com/office/drawing/2014/main" id="{23006532-81B9-46C0-A6C1-A2ECBFDCED25}"/>
+          <p:cNvPr id="6" name="text-179">
+            <a:extLst xmlns:a="http://schemas.openxmlformats.org/drawingml/2006/main">
+              <a:ext uri="{FF2B5EF4-FFF2-40B4-BE49-F238E27FC236}">
+                <a16:creationId xmlns:a16="http://schemas.microsoft.com/office/drawing/2014/main" id="{06D4D28B-2F3E-4E4A-B0E9-DAC2667B3B3C}"/>
               </a:ext>
             </a:extLst>
           </p:cNvPr>
@@ -5962,10 +5962,10 @@
       </p:sp>
       <p:sp>
         <p:nvSpPr>
-          <p:cNvPr id="7" name="text-85">
-            <a:extLst xmlns:a="http://schemas.openxmlformats.org/drawingml/2006/main">
-              <a:ext uri="{FF2B5EF4-FFF2-40B4-BE49-F238E27FC236}">
-                <a16:creationId xmlns:a16="http://schemas.microsoft.com/office/drawing/2014/main" id="{A7139CDE-5220-4F96-84FE-3C4A2A51A007}"/>
+          <p:cNvPr id="7" name="text-180">
+            <a:extLst xmlns:a="http://schemas.openxmlformats.org/drawingml/2006/main">
+              <a:ext uri="{FF2B5EF4-FFF2-40B4-BE49-F238E27FC236}">
+                <a16:creationId xmlns:a16="http://schemas.microsoft.com/office/drawing/2014/main" id="{BB1452FE-4C1A-4D47-8AC6-1EB49831017D}"/>
               </a:ext>
             </a:extLst>
           </p:cNvPr>
@@ -6018,10 +6018,10 @@
       </p:sp>
       <p:sp>
         <p:nvSpPr>
-          <p:cNvPr id="8" name="text-86">
-            <a:extLst xmlns:a="http://schemas.openxmlformats.org/drawingml/2006/main">
-              <a:ext uri="{FF2B5EF4-FFF2-40B4-BE49-F238E27FC236}">
-                <a16:creationId xmlns:a16="http://schemas.microsoft.com/office/drawing/2014/main" id="{AF72BF6A-0183-4229-89C3-67CDC45767F0}"/>
+          <p:cNvPr id="8" name="text-181">
+            <a:extLst xmlns:a="http://schemas.openxmlformats.org/drawingml/2006/main">
+              <a:ext uri="{FF2B5EF4-FFF2-40B4-BE49-F238E27FC236}">
+                <a16:creationId xmlns:a16="http://schemas.microsoft.com/office/drawing/2014/main" id="{0F414EBF-1994-4D9B-A715-D4529C9727E7}"/>
               </a:ext>
             </a:extLst>
           </p:cNvPr>
@@ -6067,17 +6067,17 @@
                 <a:ea typeface="Arial"/>
                 <a:cs typeface="Arial"/>
               </a:rPr>
-              <a:t>29 / 29</a:t>
-            </a:r>
-          </a:p>
-        </p:txBody>
-      </p:sp>
-      <p:sp>
-        <p:nvSpPr>
-          <p:cNvPr id="9" name="text-87">
-            <a:extLst xmlns:a="http://schemas.openxmlformats.org/drawingml/2006/main">
-              <a:ext uri="{FF2B5EF4-FFF2-40B4-BE49-F238E27FC236}">
-                <a16:creationId xmlns:a16="http://schemas.microsoft.com/office/drawing/2014/main" id="{AF2AB590-0110-47F4-89DB-416CB4FEDA88}"/>
+              <a:t>37 / 37</a:t>
+            </a:r>
+          </a:p>
+        </p:txBody>
+      </p:sp>
+      <p:sp>
+        <p:nvSpPr>
+          <p:cNvPr id="9" name="text-182">
+            <a:extLst xmlns:a="http://schemas.openxmlformats.org/drawingml/2006/main">
+              <a:ext uri="{FF2B5EF4-FFF2-40B4-BE49-F238E27FC236}">
+                <a16:creationId xmlns:a16="http://schemas.microsoft.com/office/drawing/2014/main" id="{99A15766-1A2B-46B8-B151-AC87FA5B8C4B}"/>
               </a:ext>
             </a:extLst>
           </p:cNvPr>
@@ -6123,17 +6123,17 @@
                 <a:ea typeface="Arial"/>
                 <a:cs typeface="Arial"/>
               </a:rPr>
-              <a:t>17</a:t>
-            </a:r>
-          </a:p>
-        </p:txBody>
-      </p:sp>
-      <p:sp>
-        <p:nvSpPr>
-          <p:cNvPr id="10" name="text-88">
-            <a:extLst xmlns:a="http://schemas.openxmlformats.org/drawingml/2006/main">
-              <a:ext uri="{FF2B5EF4-FFF2-40B4-BE49-F238E27FC236}">
-                <a16:creationId xmlns:a16="http://schemas.microsoft.com/office/drawing/2014/main" id="{DA56E555-E322-4DDD-B149-5ED88E8FBE11}"/>
+              <a:t>18</a:t>
+            </a:r>
+          </a:p>
+        </p:txBody>
+      </p:sp>
+      <p:sp>
+        <p:nvSpPr>
+          <p:cNvPr id="10" name="text-183">
+            <a:extLst xmlns:a="http://schemas.openxmlformats.org/drawingml/2006/main">
+              <a:ext uri="{FF2B5EF4-FFF2-40B4-BE49-F238E27FC236}">
+                <a16:creationId xmlns:a16="http://schemas.microsoft.com/office/drawing/2014/main" id="{927D8A9B-6835-484E-BD14-8AD85A2F1250}"/>
               </a:ext>
             </a:extLst>
           </p:cNvPr>
@@ -6232,10 +6232,10 @@
       </p:sp>
       <p:sp>
         <p:nvSpPr>
-          <p:cNvPr id="11" name="text-89">
-            <a:extLst xmlns:a="http://schemas.openxmlformats.org/drawingml/2006/main">
-              <a:ext uri="{FF2B5EF4-FFF2-40B4-BE49-F238E27FC236}">
-                <a16:creationId xmlns:a16="http://schemas.microsoft.com/office/drawing/2014/main" id="{577A4B65-1699-4063-845C-A7FDA5F9BCFF}"/>
+          <p:cNvPr id="11" name="text-184">
+            <a:extLst xmlns:a="http://schemas.openxmlformats.org/drawingml/2006/main">
+              <a:ext uri="{FF2B5EF4-FFF2-40B4-BE49-F238E27FC236}">
+                <a16:creationId xmlns:a16="http://schemas.microsoft.com/office/drawing/2014/main" id="{47D41224-2F70-4FBA-89B2-DAAA3A97B657}"/>
               </a:ext>
             </a:extLst>
           </p:cNvPr>
@@ -6334,10 +6334,10 @@
       </p:sp>
       <p:sp>
         <p:nvSpPr>
-          <p:cNvPr id="12" name="text-90">
-            <a:extLst xmlns:a="http://schemas.openxmlformats.org/drawingml/2006/main">
-              <a:ext uri="{FF2B5EF4-FFF2-40B4-BE49-F238E27FC236}">
-                <a16:creationId xmlns:a16="http://schemas.microsoft.com/office/drawing/2014/main" id="{4D7DDF37-5CD9-40B0-A25B-CD2546EE88DF}"/>
+          <p:cNvPr id="12" name="text-185">
+            <a:extLst xmlns:a="http://schemas.openxmlformats.org/drawingml/2006/main">
+              <a:ext uri="{FF2B5EF4-FFF2-40B4-BE49-F238E27FC236}">
+                <a16:creationId xmlns:a16="http://schemas.microsoft.com/office/drawing/2014/main" id="{E29B2808-1DF6-469D-8B01-DF2DC2E4887C}"/>
               </a:ext>
             </a:extLst>
           </p:cNvPr>
@@ -6436,10 +6436,10 @@
       </p:sp>
       <p:sp>
         <p:nvSpPr>
-          <p:cNvPr id="13" name="box-91">
-            <a:extLst xmlns:a="http://schemas.openxmlformats.org/drawingml/2006/main">
-              <a:ext uri="{FF2B5EF4-FFF2-40B4-BE49-F238E27FC236}">
-                <a16:creationId xmlns:a16="http://schemas.microsoft.com/office/drawing/2014/main" id="{75EC0435-A2BE-4517-B492-F7A4EF70FE19}"/>
+          <p:cNvPr id="13" name="box-186">
+            <a:extLst xmlns:a="http://schemas.openxmlformats.org/drawingml/2006/main">
+              <a:ext uri="{FF2B5EF4-FFF2-40B4-BE49-F238E27FC236}">
+                <a16:creationId xmlns:a16="http://schemas.microsoft.com/office/drawing/2014/main" id="{E4B280F9-7F97-4FDE-A091-253EE14AE9BB}"/>
               </a:ext>
             </a:extLst>
           </p:cNvPr>
@@ -6469,10 +6469,10 @@
       </p:sp>
       <p:sp>
         <p:nvSpPr>
-          <p:cNvPr id="14" name="text-92">
-            <a:extLst xmlns:a="http://schemas.openxmlformats.org/drawingml/2006/main">
-              <a:ext uri="{FF2B5EF4-FFF2-40B4-BE49-F238E27FC236}">
-                <a16:creationId xmlns:a16="http://schemas.microsoft.com/office/drawing/2014/main" id="{26F9A253-6CD5-4205-91F9-8226A49F4C8D}"/>
+          <p:cNvPr id="14" name="text-187">
+            <a:extLst xmlns:a="http://schemas.openxmlformats.org/drawingml/2006/main">
+              <a:ext uri="{FF2B5EF4-FFF2-40B4-BE49-F238E27FC236}">
+                <a16:creationId xmlns:a16="http://schemas.microsoft.com/office/drawing/2014/main" id="{0EA0E6FB-5FEE-4576-90AC-ACC773AB3AE2}"/>
               </a:ext>
             </a:extLst>
           </p:cNvPr>
@@ -6525,10 +6525,10 @@
       </p:sp>
       <p:sp>
         <p:nvSpPr>
-          <p:cNvPr id="15" name="text-93">
-            <a:extLst xmlns:a="http://schemas.openxmlformats.org/drawingml/2006/main">
-              <a:ext uri="{FF2B5EF4-FFF2-40B4-BE49-F238E27FC236}">
-                <a16:creationId xmlns:a16="http://schemas.microsoft.com/office/drawing/2014/main" id="{DCB11C92-E7FC-4B64-92B3-D21DE908E482}"/>
+          <p:cNvPr id="15" name="text-188">
+            <a:extLst xmlns:a="http://schemas.openxmlformats.org/drawingml/2006/main">
+              <a:ext uri="{FF2B5EF4-FFF2-40B4-BE49-F238E27FC236}">
+                <a16:creationId xmlns:a16="http://schemas.microsoft.com/office/drawing/2014/main" id="{D460BC0C-0F16-4EC8-BB39-87DF0D14FBB9}"/>
               </a:ext>
             </a:extLst>
           </p:cNvPr>
@@ -6581,10 +6581,10 @@
       </p:sp>
       <p:sp>
         <p:nvSpPr>
-          <p:cNvPr id="16" name="text-94">
-            <a:extLst xmlns:a="http://schemas.openxmlformats.org/drawingml/2006/main">
-              <a:ext uri="{FF2B5EF4-FFF2-40B4-BE49-F238E27FC236}">
-                <a16:creationId xmlns:a16="http://schemas.microsoft.com/office/drawing/2014/main" id="{C82E9B58-B89D-4288-9403-21CA1E7DBA78}"/>
+          <p:cNvPr id="16" name="text-189">
+            <a:extLst xmlns:a="http://schemas.openxmlformats.org/drawingml/2006/main">
+              <a:ext uri="{FF2B5EF4-FFF2-40B4-BE49-F238E27FC236}">
+                <a16:creationId xmlns:a16="http://schemas.microsoft.com/office/drawing/2014/main" id="{B9A33E28-258F-49E4-94F7-07777D2620BE}"/>
               </a:ext>
             </a:extLst>
           </p:cNvPr>
@@ -6637,10 +6637,10 @@
       </p:sp>
       <p:sp>
         <p:nvSpPr>
-          <p:cNvPr id="17" name="text-95">
-            <a:extLst xmlns:a="http://schemas.openxmlformats.org/drawingml/2006/main">
-              <a:ext uri="{FF2B5EF4-FFF2-40B4-BE49-F238E27FC236}">
-                <a16:creationId xmlns:a16="http://schemas.microsoft.com/office/drawing/2014/main" id="{4ED96D4E-39F4-47E9-B866-62D21F542594}"/>
+          <p:cNvPr id="17" name="text-190">
+            <a:extLst xmlns:a="http://schemas.openxmlformats.org/drawingml/2006/main">
+              <a:ext uri="{FF2B5EF4-FFF2-40B4-BE49-F238E27FC236}">
+                <a16:creationId xmlns:a16="http://schemas.microsoft.com/office/drawing/2014/main" id="{32575B74-2724-41F0-B36C-016A9C631DAE}"/>
               </a:ext>
             </a:extLst>
           </p:cNvPr>
@@ -6694,7 +6694,7 @@
     </p:spTree>
     <p:extLst>
       <p:ext uri="{BB962C8B-B14F-4D97-AF65-F5344CB8AC3E}">
-        <p14:creationId xmlns:p14="http://schemas.microsoft.com/office/powerpoint/2010/main" val="178453102"/>
+        <p14:creationId xmlns:p14="http://schemas.microsoft.com/office/powerpoint/2010/main" val="833612905"/>
       </p:ext>
     </p:extLst>
   </p:cSld>

</xml_diff>

<commit_message>
Sunum: v1.1.0 indirme bağlantısı, 62 test, LM Studio / alternatif uç slaytı
Co-Authored-By: Claude Fable 5.1 <noreply@anthropic.com>
</commit_message>
<xml_diff>
--- a/docs/presentation/French-Course-AI-Trilingual.pptx
+++ b/docs/presentation/French-Course-AI-Trilingual.pptx
@@ -2,18 +2,18 @@
 <file path=ppt/presentation.xml><?xml version="1.0" encoding="utf-8"?>
 <p:presentation xmlns:p="http://schemas.openxmlformats.org/presentationml/2006/main">
   <p:sldMasterIdLst>
-    <p:sldMasterId xmlns:r="http://schemas.openxmlformats.org/officeDocument/2006/relationships" id="2147483648" r:id="R0aafaf07d7d54e61"/>
+    <p:sldMasterId xmlns:r="http://schemas.openxmlformats.org/officeDocument/2006/relationships" id="2147483648" r:id="R04246e0d762243b4"/>
   </p:sldMasterIdLst>
   <p:notesMasterIdLst>
-    <p:notesMasterId xmlns:r="http://schemas.openxmlformats.org/officeDocument/2006/relationships" r:id="R0e34adfa64ab47de"/>
+    <p:notesMasterId xmlns:r="http://schemas.openxmlformats.org/officeDocument/2006/relationships" r:id="R84b71e0b80b742a2"/>
   </p:notesMasterIdLst>
   <p:sldIdLst>
-    <p:sldId xmlns:r="http://schemas.openxmlformats.org/officeDocument/2006/relationships" id="256" r:id="Rbccd80f826694e52"/>
-    <p:sldId xmlns:r="http://schemas.openxmlformats.org/officeDocument/2006/relationships" id="257" r:id="Rfe81daac5efc4698"/>
-    <p:sldId xmlns:r="http://schemas.openxmlformats.org/officeDocument/2006/relationships" id="258" r:id="Rf7bd468dbfce4bf9"/>
-    <p:sldId xmlns:r="http://schemas.openxmlformats.org/officeDocument/2006/relationships" id="259" r:id="Ree57240259bc4489"/>
-    <p:sldId xmlns:r="http://schemas.openxmlformats.org/officeDocument/2006/relationships" id="260" r:id="Rb748d0cc1fed460b"/>
-    <p:sldId xmlns:r="http://schemas.openxmlformats.org/officeDocument/2006/relationships" id="261" r:id="R841f7fefdcc24d28"/>
+    <p:sldId xmlns:r="http://schemas.openxmlformats.org/officeDocument/2006/relationships" id="256" r:id="R3537739081a143b6"/>
+    <p:sldId xmlns:r="http://schemas.openxmlformats.org/officeDocument/2006/relationships" id="257" r:id="R3dc2dc7a9a234fe9"/>
+    <p:sldId xmlns:r="http://schemas.openxmlformats.org/officeDocument/2006/relationships" id="258" r:id="R68eb7dfea4564f24"/>
+    <p:sldId xmlns:r="http://schemas.openxmlformats.org/officeDocument/2006/relationships" id="259" r:id="R2d57ec27ef2c4ff9"/>
+    <p:sldId xmlns:r="http://schemas.openxmlformats.org/officeDocument/2006/relationships" id="260" r:id="R3d728462470048dd"/>
+    <p:sldId xmlns:r="http://schemas.openxmlformats.org/officeDocument/2006/relationships" id="261" r:id="Re6d28c063ce14968"/>
   </p:sldIdLst>
   <p:sldSz cx="12192000" cy="6858000"/>
   <p:notesSz cx="6858000" cy="9144000"/>
@@ -937,7 +937,7 @@
           </a:p>
           <a:p xmlns:a="http://schemas.openxmlformats.org/drawingml/2006/main">
             <a:r>
-              <a:t>- https://github.com/Azizsekerdil/FrenchCourseAI/releases/tag/v1.0.0</a:t>
+              <a:t>- https://github.com/Azizsekerdil/FrenchCourseAI/releases/tag/v1.1.0</a:t>
             </a:r>
           </a:p>
           <a:p xmlns:a="http://schemas.openxmlformats.org/drawingml/2006/main">
@@ -1010,7 +1010,7 @@
   </p:cSld>
   <p:clrMap bg1="lt1" tx1="dk1" bg2="lt2" tx2="dk2" accent1="accent1" accent2="accent2" accent3="accent3" accent4="accent4" accent5="accent5" accent6="accent6" hlink="hlink" folHlink="folHlink"/>
   <p:sldLayoutIdLst>
-    <p:sldLayoutId xmlns:r="http://schemas.openxmlformats.org/officeDocument/2006/relationships" id="2147483649" r:id="R1555e332b53044f7"/>
+    <p:sldLayoutId xmlns:r="http://schemas.openxmlformats.org/officeDocument/2006/relationships" id="2147483649" r:id="R63755a814d43430b"/>
   </p:sldLayoutIdLst>
   <p:txStyles>
     <p:titleStyle>
@@ -1561,7 +1561,7 @@
           <p:cNvPr id="13" name="box-96">
             <a:extLst xmlns:a="http://schemas.openxmlformats.org/drawingml/2006/main">
               <a:ext uri="{FF2B5EF4-FFF2-40B4-BE49-F238E27FC236}">
-                <a16:creationId xmlns:a16="http://schemas.microsoft.com/office/drawing/2014/main" id="{18F29EAB-4237-4C4D-9636-29185569263E}"/>
+                <a16:creationId xmlns:a16="http://schemas.microsoft.com/office/drawing/2014/main" id="{B568EEBB-CD44-4F94-B0A4-216557849A09}"/>
               </a:ext>
             </a:extLst>
           </p:cNvPr>
@@ -1594,7 +1594,7 @@
           <p:cNvPr id="2" name="text-97">
             <a:extLst xmlns:a="http://schemas.openxmlformats.org/drawingml/2006/main">
               <a:ext uri="{FF2B5EF4-FFF2-40B4-BE49-F238E27FC236}">
-                <a16:creationId xmlns:a16="http://schemas.microsoft.com/office/drawing/2014/main" id="{0BD50280-6787-419E-B3A6-D891E1130E7E}"/>
+                <a16:creationId xmlns:a16="http://schemas.microsoft.com/office/drawing/2014/main" id="{6390E38E-3789-493A-82C2-8BBB46EF76A2}"/>
               </a:ext>
             </a:extLst>
           </p:cNvPr>
@@ -1650,7 +1650,7 @@
           <p:cNvPr id="3" name="text-98">
             <a:extLst xmlns:a="http://schemas.openxmlformats.org/drawingml/2006/main">
               <a:ext uri="{FF2B5EF4-FFF2-40B4-BE49-F238E27FC236}">
-                <a16:creationId xmlns:a16="http://schemas.microsoft.com/office/drawing/2014/main" id="{5C1A09C7-B03C-49F0-8C85-D1103160DD36}"/>
+                <a16:creationId xmlns:a16="http://schemas.microsoft.com/office/drawing/2014/main" id="{7B487C0A-7D2B-48C7-8421-475EEACFF6B3}"/>
               </a:ext>
             </a:extLst>
           </p:cNvPr>
@@ -1706,7 +1706,7 @@
           <p:cNvPr id="4" name="text-99">
             <a:extLst xmlns:a="http://schemas.openxmlformats.org/drawingml/2006/main">
               <a:ext uri="{FF2B5EF4-FFF2-40B4-BE49-F238E27FC236}">
-                <a16:creationId xmlns:a16="http://schemas.microsoft.com/office/drawing/2014/main" id="{6A80C699-3C50-470F-BB57-4F444E1D6CED}"/>
+                <a16:creationId xmlns:a16="http://schemas.microsoft.com/office/drawing/2014/main" id="{6371B71C-D786-466F-A15B-8FEDF4E818E9}"/>
               </a:ext>
             </a:extLst>
           </p:cNvPr>
@@ -1762,7 +1762,7 @@
           <p:cNvPr id="5" name="text-100">
             <a:extLst xmlns:a="http://schemas.openxmlformats.org/drawingml/2006/main">
               <a:ext uri="{FF2B5EF4-FFF2-40B4-BE49-F238E27FC236}">
-                <a16:creationId xmlns:a16="http://schemas.microsoft.com/office/drawing/2014/main" id="{28E9F89A-F3C3-4C19-82DC-48F1139AB61F}"/>
+                <a16:creationId xmlns:a16="http://schemas.microsoft.com/office/drawing/2014/main" id="{433B53B6-4440-48A2-B36E-32A0ACD85D06}"/>
               </a:ext>
             </a:extLst>
           </p:cNvPr>
@@ -1818,7 +1818,7 @@
           <p:cNvPr id="6" name="text-101">
             <a:extLst xmlns:a="http://schemas.openxmlformats.org/drawingml/2006/main">
               <a:ext uri="{FF2B5EF4-FFF2-40B4-BE49-F238E27FC236}">
-                <a16:creationId xmlns:a16="http://schemas.microsoft.com/office/drawing/2014/main" id="{D54E8AF7-4E78-4D26-8A20-90C74A16F51E}"/>
+                <a16:creationId xmlns:a16="http://schemas.microsoft.com/office/drawing/2014/main" id="{8CB04D6D-F064-4113-A91D-6DE4BA02B416}"/>
               </a:ext>
             </a:extLst>
           </p:cNvPr>
@@ -1874,7 +1874,7 @@
           <p:cNvPr id="7" name="text-102">
             <a:extLst xmlns:a="http://schemas.openxmlformats.org/drawingml/2006/main">
               <a:ext uri="{FF2B5EF4-FFF2-40B4-BE49-F238E27FC236}">
-                <a16:creationId xmlns:a16="http://schemas.microsoft.com/office/drawing/2014/main" id="{AB4595D3-AAFE-4C41-8B31-C09F57456D1A}"/>
+                <a16:creationId xmlns:a16="http://schemas.microsoft.com/office/drawing/2014/main" id="{169ACB3A-F10B-4A1E-BB32-AA9CDB9BDAC4}"/>
               </a:ext>
             </a:extLst>
           </p:cNvPr>
@@ -1930,7 +1930,7 @@
           <p:cNvPr id="8" name="text-103">
             <a:extLst xmlns:a="http://schemas.openxmlformats.org/drawingml/2006/main">
               <a:ext uri="{FF2B5EF4-FFF2-40B4-BE49-F238E27FC236}">
-                <a16:creationId xmlns:a16="http://schemas.microsoft.com/office/drawing/2014/main" id="{690671CB-A6D3-4774-A1F7-5C76F877461F}"/>
+                <a16:creationId xmlns:a16="http://schemas.microsoft.com/office/drawing/2014/main" id="{9ABFC12C-6A66-4834-8789-8DFC6B26A719}"/>
               </a:ext>
             </a:extLst>
           </p:cNvPr>
@@ -1986,7 +1986,7 @@
           <p:cNvPr id="9" name="text-104">
             <a:extLst xmlns:a="http://schemas.openxmlformats.org/drawingml/2006/main">
               <a:ext uri="{FF2B5EF4-FFF2-40B4-BE49-F238E27FC236}">
-                <a16:creationId xmlns:a16="http://schemas.microsoft.com/office/drawing/2014/main" id="{7C9D269E-C172-4588-895D-E8F61DFC9095}"/>
+                <a16:creationId xmlns:a16="http://schemas.microsoft.com/office/drawing/2014/main" id="{E84D0AC2-1E9E-46ED-B6B2-E4AAA95B339B}"/>
               </a:ext>
             </a:extLst>
           </p:cNvPr>
@@ -2042,7 +2042,7 @@
           <p:cNvPr id="10" name="box-105">
             <a:extLst xmlns:a="http://schemas.openxmlformats.org/drawingml/2006/main">
               <a:ext uri="{FF2B5EF4-FFF2-40B4-BE49-F238E27FC236}">
-                <a16:creationId xmlns:a16="http://schemas.microsoft.com/office/drawing/2014/main" id="{5B26C8B8-C4FE-4042-A49D-1B1083CB955A}"/>
+                <a16:creationId xmlns:a16="http://schemas.microsoft.com/office/drawing/2014/main" id="{A95CFDF9-6D2A-479C-BC5D-594F4E38EC02}"/>
               </a:ext>
             </a:extLst>
           </p:cNvPr>
@@ -2079,7 +2079,7 @@
           <p:nvPr/>
         </p:nvPicPr>
         <p:blipFill>
-          <a:blip xmlns:r="http://schemas.openxmlformats.org/officeDocument/2006/relationships" xmlns:a="http://schemas.openxmlformats.org/drawingml/2006/main" r:embed="Re68cfc80f6d941d2"/>
+          <a:blip xmlns:r="http://schemas.openxmlformats.org/officeDocument/2006/relationships" xmlns:a="http://schemas.openxmlformats.org/drawingml/2006/main" r:embed="R0be58c9928da4e5d"/>
           <a:stretch xmlns:a="http://schemas.openxmlformats.org/drawingml/2006/main"/>
         </p:blipFill>
         <p:spPr>
@@ -2097,7 +2097,7 @@
           <p:cNvPr id="12" name="text-106">
             <a:extLst xmlns:a="http://schemas.openxmlformats.org/drawingml/2006/main">
               <a:ext uri="{FF2B5EF4-FFF2-40B4-BE49-F238E27FC236}">
-                <a16:creationId xmlns:a16="http://schemas.microsoft.com/office/drawing/2014/main" id="{0C126EFC-D9A8-4553-BBC3-A05A3B6B37FA}"/>
+                <a16:creationId xmlns:a16="http://schemas.microsoft.com/office/drawing/2014/main" id="{0CA07EFD-F8E4-4085-925B-7E4249B41C57}"/>
               </a:ext>
             </a:extLst>
           </p:cNvPr>
@@ -2151,7 +2151,7 @@
     </p:spTree>
     <p:extLst>
       <p:ext uri="{BB962C8B-B14F-4D97-AF65-F5344CB8AC3E}">
-        <p14:creationId xmlns:p14="http://schemas.microsoft.com/office/powerpoint/2010/main" val="155026677"/>
+        <p14:creationId xmlns:p14="http://schemas.microsoft.com/office/powerpoint/2010/main" val="1824151027"/>
       </p:ext>
     </p:extLst>
   </p:cSld>
@@ -2182,7 +2182,7 @@
           <p:cNvPr id="14" name="box-107">
             <a:extLst xmlns:a="http://schemas.openxmlformats.org/drawingml/2006/main">
               <a:ext uri="{FF2B5EF4-FFF2-40B4-BE49-F238E27FC236}">
-                <a16:creationId xmlns:a16="http://schemas.microsoft.com/office/drawing/2014/main" id="{F6ABBFD8-CDAB-4E39-92AC-8D34197EF704}"/>
+                <a16:creationId xmlns:a16="http://schemas.microsoft.com/office/drawing/2014/main" id="{52CA93C5-B4DC-4CFB-A934-ABBE7764D6B6}"/>
               </a:ext>
             </a:extLst>
           </p:cNvPr>
@@ -2215,7 +2215,7 @@
           <p:cNvPr id="2" name="text-108">
             <a:extLst xmlns:a="http://schemas.openxmlformats.org/drawingml/2006/main">
               <a:ext uri="{FF2B5EF4-FFF2-40B4-BE49-F238E27FC236}">
-                <a16:creationId xmlns:a16="http://schemas.microsoft.com/office/drawing/2014/main" id="{A8D8B22D-02F5-47D3-B55B-14F164C554EF}"/>
+                <a16:creationId xmlns:a16="http://schemas.microsoft.com/office/drawing/2014/main" id="{1D4420B2-4874-4400-B4DA-B6A87355773A}"/>
               </a:ext>
             </a:extLst>
           </p:cNvPr>
@@ -2271,7 +2271,7 @@
           <p:cNvPr id="3" name="text-109">
             <a:extLst xmlns:a="http://schemas.openxmlformats.org/drawingml/2006/main">
               <a:ext uri="{FF2B5EF4-FFF2-40B4-BE49-F238E27FC236}">
-                <a16:creationId xmlns:a16="http://schemas.microsoft.com/office/drawing/2014/main" id="{DBABC3FD-2CE4-4923-9D10-8F7E3DA19BCC}"/>
+                <a16:creationId xmlns:a16="http://schemas.microsoft.com/office/drawing/2014/main" id="{1081530D-EACE-4E12-9497-0969C3D0F78C}"/>
               </a:ext>
             </a:extLst>
           </p:cNvPr>
@@ -2327,7 +2327,7 @@
           <p:cNvPr id="4" name="text-110">
             <a:extLst xmlns:a="http://schemas.openxmlformats.org/drawingml/2006/main">
               <a:ext uri="{FF2B5EF4-FFF2-40B4-BE49-F238E27FC236}">
-                <a16:creationId xmlns:a16="http://schemas.microsoft.com/office/drawing/2014/main" id="{6376AA38-D118-40E6-ACFF-C79189035F97}"/>
+                <a16:creationId xmlns:a16="http://schemas.microsoft.com/office/drawing/2014/main" id="{199A8809-8D3A-41F9-974E-FF54D51FBB13}"/>
               </a:ext>
             </a:extLst>
           </p:cNvPr>
@@ -2383,7 +2383,7 @@
           <p:cNvPr id="5" name="text-111">
             <a:extLst xmlns:a="http://schemas.openxmlformats.org/drawingml/2006/main">
               <a:ext uri="{FF2B5EF4-FFF2-40B4-BE49-F238E27FC236}">
-                <a16:creationId xmlns:a16="http://schemas.microsoft.com/office/drawing/2014/main" id="{0B7F2EDF-7D8C-44D6-ADCD-5CBEF18D79D3}"/>
+                <a16:creationId xmlns:a16="http://schemas.microsoft.com/office/drawing/2014/main" id="{F035FAA0-095E-4792-B238-1768A9A2C140}"/>
               </a:ext>
             </a:extLst>
           </p:cNvPr>
@@ -2439,7 +2439,7 @@
           <p:cNvPr id="6" name="text-112">
             <a:extLst xmlns:a="http://schemas.openxmlformats.org/drawingml/2006/main">
               <a:ext uri="{FF2B5EF4-FFF2-40B4-BE49-F238E27FC236}">
-                <a16:creationId xmlns:a16="http://schemas.microsoft.com/office/drawing/2014/main" id="{67DFFEA3-CBDF-4B8C-A3B5-58072E95E9BE}"/>
+                <a16:creationId xmlns:a16="http://schemas.microsoft.com/office/drawing/2014/main" id="{D9240692-C966-4868-B4E3-115880B0D031}"/>
               </a:ext>
             </a:extLst>
           </p:cNvPr>
@@ -2495,7 +2495,7 @@
           <p:cNvPr id="7" name="box-113">
             <a:extLst xmlns:a="http://schemas.openxmlformats.org/drawingml/2006/main">
               <a:ext uri="{FF2B5EF4-FFF2-40B4-BE49-F238E27FC236}">
-                <a16:creationId xmlns:a16="http://schemas.microsoft.com/office/drawing/2014/main" id="{98C85607-7E52-42BF-962D-AB50439E08B7}"/>
+                <a16:creationId xmlns:a16="http://schemas.microsoft.com/office/drawing/2014/main" id="{832E56A6-8058-4D00-BF1E-ACF45C1F0675}"/>
               </a:ext>
             </a:extLst>
           </p:cNvPr>
@@ -2528,7 +2528,7 @@
           <p:cNvPr id="8" name="text-114">
             <a:extLst xmlns:a="http://schemas.openxmlformats.org/drawingml/2006/main">
               <a:ext uri="{FF2B5EF4-FFF2-40B4-BE49-F238E27FC236}">
-                <a16:creationId xmlns:a16="http://schemas.microsoft.com/office/drawing/2014/main" id="{1C62B068-D172-4BB0-82B6-4CA22E9029C0}"/>
+                <a16:creationId xmlns:a16="http://schemas.microsoft.com/office/drawing/2014/main" id="{655D3E42-1462-4F2C-B352-79FEC0C4AB0D}"/>
               </a:ext>
             </a:extLst>
           </p:cNvPr>
@@ -2584,7 +2584,7 @@
           <p:cNvPr id="9" name="text-115">
             <a:extLst xmlns:a="http://schemas.openxmlformats.org/drawingml/2006/main">
               <a:ext uri="{FF2B5EF4-FFF2-40B4-BE49-F238E27FC236}">
-                <a16:creationId xmlns:a16="http://schemas.microsoft.com/office/drawing/2014/main" id="{241056CC-3BC5-4BA0-B6AC-CD16E4A22F79}"/>
+                <a16:creationId xmlns:a16="http://schemas.microsoft.com/office/drawing/2014/main" id="{497B82BB-12CB-4EF0-BD33-D4D17E160930}"/>
               </a:ext>
             </a:extLst>
           </p:cNvPr>
@@ -2640,7 +2640,7 @@
           <p:cNvPr id="10" name="text-116">
             <a:extLst xmlns:a="http://schemas.openxmlformats.org/drawingml/2006/main">
               <a:ext uri="{FF2B5EF4-FFF2-40B4-BE49-F238E27FC236}">
-                <a16:creationId xmlns:a16="http://schemas.microsoft.com/office/drawing/2014/main" id="{4FE0560D-CAF8-4536-9C4F-90083D2EEEF3}"/>
+                <a16:creationId xmlns:a16="http://schemas.microsoft.com/office/drawing/2014/main" id="{B21E8043-DF0D-42C7-9ACC-36FB10CD7C12}"/>
               </a:ext>
             </a:extLst>
           </p:cNvPr>
@@ -2696,7 +2696,7 @@
           <p:cNvPr id="11" name="box-117">
             <a:extLst xmlns:a="http://schemas.openxmlformats.org/drawingml/2006/main">
               <a:ext uri="{FF2B5EF4-FFF2-40B4-BE49-F238E27FC236}">
-                <a16:creationId xmlns:a16="http://schemas.microsoft.com/office/drawing/2014/main" id="{03A06004-C8F4-4387-AB9D-CDC446BF2FB8}"/>
+                <a16:creationId xmlns:a16="http://schemas.microsoft.com/office/drawing/2014/main" id="{EC20DCBA-5FCB-4A9B-AD2E-D5C652C15C5D}"/>
               </a:ext>
             </a:extLst>
           </p:cNvPr>
@@ -2733,7 +2733,7 @@
           <p:nvPr/>
         </p:nvPicPr>
         <p:blipFill>
-          <a:blip xmlns:r="http://schemas.openxmlformats.org/officeDocument/2006/relationships" xmlns:a="http://schemas.openxmlformats.org/drawingml/2006/main" r:embed="R3c3c49f0bf784bea"/>
+          <a:blip xmlns:r="http://schemas.openxmlformats.org/officeDocument/2006/relationships" xmlns:a="http://schemas.openxmlformats.org/drawingml/2006/main" r:embed="R4c04723e8677416a"/>
           <a:stretch xmlns:a="http://schemas.openxmlformats.org/drawingml/2006/main"/>
         </p:blipFill>
         <p:spPr>
@@ -2751,7 +2751,7 @@
           <p:cNvPr id="13" name="text-118">
             <a:extLst xmlns:a="http://schemas.openxmlformats.org/drawingml/2006/main">
               <a:ext uri="{FF2B5EF4-FFF2-40B4-BE49-F238E27FC236}">
-                <a16:creationId xmlns:a16="http://schemas.microsoft.com/office/drawing/2014/main" id="{0F04BB1E-7A97-442C-BEE1-BCCD2A0D2D71}"/>
+                <a16:creationId xmlns:a16="http://schemas.microsoft.com/office/drawing/2014/main" id="{95E9C48F-5B04-4319-A7A9-A6AB165A6925}"/>
               </a:ext>
             </a:extLst>
           </p:cNvPr>
@@ -2805,7 +2805,7 @@
     </p:spTree>
     <p:extLst>
       <p:ext uri="{BB962C8B-B14F-4D97-AF65-F5344CB8AC3E}">
-        <p14:creationId xmlns:p14="http://schemas.microsoft.com/office/powerpoint/2010/main" val="1191139925"/>
+        <p14:creationId xmlns:p14="http://schemas.microsoft.com/office/powerpoint/2010/main" val="1796053792"/>
       </p:ext>
     </p:extLst>
   </p:cSld>
@@ -2836,7 +2836,7 @@
           <p:cNvPr id="19" name="box-119">
             <a:extLst xmlns:a="http://schemas.openxmlformats.org/drawingml/2006/main">
               <a:ext uri="{FF2B5EF4-FFF2-40B4-BE49-F238E27FC236}">
-                <a16:creationId xmlns:a16="http://schemas.microsoft.com/office/drawing/2014/main" id="{4CFC0B2F-6513-444A-A093-4FD515FCB001}"/>
+                <a16:creationId xmlns:a16="http://schemas.microsoft.com/office/drawing/2014/main" id="{20B733C7-0BF7-4DA8-85C5-998A407E58CE}"/>
               </a:ext>
             </a:extLst>
           </p:cNvPr>
@@ -2869,7 +2869,7 @@
           <p:cNvPr id="2" name="text-120">
             <a:extLst xmlns:a="http://schemas.openxmlformats.org/drawingml/2006/main">
               <a:ext uri="{FF2B5EF4-FFF2-40B4-BE49-F238E27FC236}">
-                <a16:creationId xmlns:a16="http://schemas.microsoft.com/office/drawing/2014/main" id="{69ECC909-5123-45DF-862D-08A3B7215D0E}"/>
+                <a16:creationId xmlns:a16="http://schemas.microsoft.com/office/drawing/2014/main" id="{A81DF5AA-BFD7-4C5B-BDA2-0A78B6CB4FB7}"/>
               </a:ext>
             </a:extLst>
           </p:cNvPr>
@@ -2925,7 +2925,7 @@
           <p:cNvPr id="3" name="text-121">
             <a:extLst xmlns:a="http://schemas.openxmlformats.org/drawingml/2006/main">
               <a:ext uri="{FF2B5EF4-FFF2-40B4-BE49-F238E27FC236}">
-                <a16:creationId xmlns:a16="http://schemas.microsoft.com/office/drawing/2014/main" id="{13DEBDFE-BDAF-4FF0-8E2A-F8C63CA38881}"/>
+                <a16:creationId xmlns:a16="http://schemas.microsoft.com/office/drawing/2014/main" id="{B7490012-3118-4951-9765-93046DCBC706}"/>
               </a:ext>
             </a:extLst>
           </p:cNvPr>
@@ -2981,7 +2981,7 @@
           <p:cNvPr id="4" name="text-122">
             <a:extLst xmlns:a="http://schemas.openxmlformats.org/drawingml/2006/main">
               <a:ext uri="{FF2B5EF4-FFF2-40B4-BE49-F238E27FC236}">
-                <a16:creationId xmlns:a16="http://schemas.microsoft.com/office/drawing/2014/main" id="{BD09AFA0-84C3-4F4B-A226-760977EB54A7}"/>
+                <a16:creationId xmlns:a16="http://schemas.microsoft.com/office/drawing/2014/main" id="{62F08ED5-23CB-427E-9406-9C04056237F4}"/>
               </a:ext>
             </a:extLst>
           </p:cNvPr>
@@ -3037,7 +3037,7 @@
           <p:cNvPr id="5" name="text-123">
             <a:extLst xmlns:a="http://schemas.openxmlformats.org/drawingml/2006/main">
               <a:ext uri="{FF2B5EF4-FFF2-40B4-BE49-F238E27FC236}">
-                <a16:creationId xmlns:a16="http://schemas.microsoft.com/office/drawing/2014/main" id="{12D889D8-C858-4353-B4E5-D914E5A87326}"/>
+                <a16:creationId xmlns:a16="http://schemas.microsoft.com/office/drawing/2014/main" id="{38618340-DC6B-4546-87EC-AAA05459603B}"/>
               </a:ext>
             </a:extLst>
           </p:cNvPr>
@@ -3093,7 +3093,7 @@
           <p:cNvPr id="6" name="text-124">
             <a:extLst xmlns:a="http://schemas.openxmlformats.org/drawingml/2006/main">
               <a:ext uri="{FF2B5EF4-FFF2-40B4-BE49-F238E27FC236}">
-                <a16:creationId xmlns:a16="http://schemas.microsoft.com/office/drawing/2014/main" id="{FFDE3905-826F-4CB5-BF18-ACA3DF41F560}"/>
+                <a16:creationId xmlns:a16="http://schemas.microsoft.com/office/drawing/2014/main" id="{8DC77991-41A0-4103-8E25-658D120E1AB6}"/>
               </a:ext>
             </a:extLst>
           </p:cNvPr>
@@ -3149,7 +3149,7 @@
           <p:cNvPr id="7" name="box-125">
             <a:extLst xmlns:a="http://schemas.openxmlformats.org/drawingml/2006/main">
               <a:ext uri="{FF2B5EF4-FFF2-40B4-BE49-F238E27FC236}">
-                <a16:creationId xmlns:a16="http://schemas.microsoft.com/office/drawing/2014/main" id="{92AE0CE7-0776-4306-B035-9118C185E9CE}"/>
+                <a16:creationId xmlns:a16="http://schemas.microsoft.com/office/drawing/2014/main" id="{FCB59E1D-CA09-4418-B6EE-7D6D2D5C1CA7}"/>
               </a:ext>
             </a:extLst>
           </p:cNvPr>
@@ -3182,7 +3182,7 @@
           <p:cNvPr id="8" name="text-126">
             <a:extLst xmlns:a="http://schemas.openxmlformats.org/drawingml/2006/main">
               <a:ext uri="{FF2B5EF4-FFF2-40B4-BE49-F238E27FC236}">
-                <a16:creationId xmlns:a16="http://schemas.microsoft.com/office/drawing/2014/main" id="{DBFA17C4-1F4C-4A0C-844E-A6BC9FB13D0D}"/>
+                <a16:creationId xmlns:a16="http://schemas.microsoft.com/office/drawing/2014/main" id="{7242AF45-8C80-4819-A5D5-D361D92D758B}"/>
               </a:ext>
             </a:extLst>
           </p:cNvPr>
@@ -3238,7 +3238,7 @@
           <p:cNvPr id="9" name="text-127">
             <a:extLst xmlns:a="http://schemas.openxmlformats.org/drawingml/2006/main">
               <a:ext uri="{FF2B5EF4-FFF2-40B4-BE49-F238E27FC236}">
-                <a16:creationId xmlns:a16="http://schemas.microsoft.com/office/drawing/2014/main" id="{05E9953B-220D-44C6-883F-E3927A8D3A7C}"/>
+                <a16:creationId xmlns:a16="http://schemas.microsoft.com/office/drawing/2014/main" id="{D14E668E-4A03-4145-BB4D-A767E4DAEBD3}"/>
               </a:ext>
             </a:extLst>
           </p:cNvPr>
@@ -3294,7 +3294,7 @@
           <p:cNvPr id="10" name="text-128">
             <a:extLst xmlns:a="http://schemas.openxmlformats.org/drawingml/2006/main">
               <a:ext uri="{FF2B5EF4-FFF2-40B4-BE49-F238E27FC236}">
-                <a16:creationId xmlns:a16="http://schemas.microsoft.com/office/drawing/2014/main" id="{377CC8A3-76C0-404F-AF45-02C215383139}"/>
+                <a16:creationId xmlns:a16="http://schemas.microsoft.com/office/drawing/2014/main" id="{57EE3C46-8CAC-44CF-8EFA-05A9AB665A04}"/>
               </a:ext>
             </a:extLst>
           </p:cNvPr>
@@ -3350,7 +3350,7 @@
           <p:cNvPr id="11" name="box-129">
             <a:extLst xmlns:a="http://schemas.openxmlformats.org/drawingml/2006/main">
               <a:ext uri="{FF2B5EF4-FFF2-40B4-BE49-F238E27FC236}">
-                <a16:creationId xmlns:a16="http://schemas.microsoft.com/office/drawing/2014/main" id="{EB9D318E-E6C2-4264-A1C5-389C279C5160}"/>
+                <a16:creationId xmlns:a16="http://schemas.microsoft.com/office/drawing/2014/main" id="{D451FAB5-DF49-4A4E-9F32-C2410997C990}"/>
               </a:ext>
             </a:extLst>
           </p:cNvPr>
@@ -3383,7 +3383,7 @@
           <p:cNvPr id="12" name="text-130">
             <a:extLst xmlns:a="http://schemas.openxmlformats.org/drawingml/2006/main">
               <a:ext uri="{FF2B5EF4-FFF2-40B4-BE49-F238E27FC236}">
-                <a16:creationId xmlns:a16="http://schemas.microsoft.com/office/drawing/2014/main" id="{68F0F7CF-C7C5-4032-9CED-85C83ADD36AF}"/>
+                <a16:creationId xmlns:a16="http://schemas.microsoft.com/office/drawing/2014/main" id="{70C50154-897E-4B65-A8E0-DD9B6F81DF47}"/>
               </a:ext>
             </a:extLst>
           </p:cNvPr>
@@ -3439,7 +3439,7 @@
           <p:cNvPr id="13" name="text-131">
             <a:extLst xmlns:a="http://schemas.openxmlformats.org/drawingml/2006/main">
               <a:ext uri="{FF2B5EF4-FFF2-40B4-BE49-F238E27FC236}">
-                <a16:creationId xmlns:a16="http://schemas.microsoft.com/office/drawing/2014/main" id="{E27AF4BA-1543-4E4A-B4B6-EAB5DAB38547}"/>
+                <a16:creationId xmlns:a16="http://schemas.microsoft.com/office/drawing/2014/main" id="{B4E2AA88-6DD5-4939-A1D4-A31195B1187C}"/>
               </a:ext>
             </a:extLst>
           </p:cNvPr>
@@ -3495,7 +3495,7 @@
           <p:cNvPr id="14" name="text-132">
             <a:extLst xmlns:a="http://schemas.openxmlformats.org/drawingml/2006/main">
               <a:ext uri="{FF2B5EF4-FFF2-40B4-BE49-F238E27FC236}">
-                <a16:creationId xmlns:a16="http://schemas.microsoft.com/office/drawing/2014/main" id="{F82BE8F1-F3CE-4D6E-8262-1344950C63F9}"/>
+                <a16:creationId xmlns:a16="http://schemas.microsoft.com/office/drawing/2014/main" id="{DF528D05-686C-4E70-BA33-ED9472369E4B}"/>
               </a:ext>
             </a:extLst>
           </p:cNvPr>
@@ -3551,7 +3551,7 @@
           <p:cNvPr id="15" name="box-133">
             <a:extLst xmlns:a="http://schemas.openxmlformats.org/drawingml/2006/main">
               <a:ext uri="{FF2B5EF4-FFF2-40B4-BE49-F238E27FC236}">
-                <a16:creationId xmlns:a16="http://schemas.microsoft.com/office/drawing/2014/main" id="{2D3126DB-4093-437C-A6DB-FA7880876E79}"/>
+                <a16:creationId xmlns:a16="http://schemas.microsoft.com/office/drawing/2014/main" id="{343AEB72-04C4-4909-B8E7-708B2BC1AEBF}"/>
               </a:ext>
             </a:extLst>
           </p:cNvPr>
@@ -3584,7 +3584,7 @@
           <p:cNvPr id="16" name="text-134">
             <a:extLst xmlns:a="http://schemas.openxmlformats.org/drawingml/2006/main">
               <a:ext uri="{FF2B5EF4-FFF2-40B4-BE49-F238E27FC236}">
-                <a16:creationId xmlns:a16="http://schemas.microsoft.com/office/drawing/2014/main" id="{A0ECF5FD-B37C-4B42-B7C0-70E59A097F87}"/>
+                <a16:creationId xmlns:a16="http://schemas.microsoft.com/office/drawing/2014/main" id="{8FDF7669-51DB-4EBE-ADCC-0CE2DDF0103A}"/>
               </a:ext>
             </a:extLst>
           </p:cNvPr>
@@ -3640,7 +3640,7 @@
           <p:cNvPr id="17" name="text-135">
             <a:extLst xmlns:a="http://schemas.openxmlformats.org/drawingml/2006/main">
               <a:ext uri="{FF2B5EF4-FFF2-40B4-BE49-F238E27FC236}">
-                <a16:creationId xmlns:a16="http://schemas.microsoft.com/office/drawing/2014/main" id="{7AEF533D-F7BC-4F60-9232-38CB088A19E3}"/>
+                <a16:creationId xmlns:a16="http://schemas.microsoft.com/office/drawing/2014/main" id="{94E3CBBE-7234-4257-820C-B4D988D5AF2D}"/>
               </a:ext>
             </a:extLst>
           </p:cNvPr>
@@ -3696,7 +3696,7 @@
           <p:cNvPr id="18" name="text-136">
             <a:extLst xmlns:a="http://schemas.openxmlformats.org/drawingml/2006/main">
               <a:ext uri="{FF2B5EF4-FFF2-40B4-BE49-F238E27FC236}">
-                <a16:creationId xmlns:a16="http://schemas.microsoft.com/office/drawing/2014/main" id="{41CF9FF7-E86D-4048-B0ED-D0FD2DA150D3}"/>
+                <a16:creationId xmlns:a16="http://schemas.microsoft.com/office/drawing/2014/main" id="{5B4B88B6-8EBB-4417-AA7B-39A25EBED6BD}"/>
               </a:ext>
             </a:extLst>
           </p:cNvPr>
@@ -3750,7 +3750,7 @@
     </p:spTree>
     <p:extLst>
       <p:ext uri="{BB962C8B-B14F-4D97-AF65-F5344CB8AC3E}">
-        <p14:creationId xmlns:p14="http://schemas.microsoft.com/office/powerpoint/2010/main" val="658514384"/>
+        <p14:creationId xmlns:p14="http://schemas.microsoft.com/office/powerpoint/2010/main" val="405408063"/>
       </p:ext>
     </p:extLst>
   </p:cSld>
@@ -3781,7 +3781,7 @@
           <p:cNvPr id="18" name="box-137">
             <a:extLst xmlns:a="http://schemas.openxmlformats.org/drawingml/2006/main">
               <a:ext uri="{FF2B5EF4-FFF2-40B4-BE49-F238E27FC236}">
-                <a16:creationId xmlns:a16="http://schemas.microsoft.com/office/drawing/2014/main" id="{6BAB9373-D91B-46E8-9A39-563B91DB9025}"/>
+                <a16:creationId xmlns:a16="http://schemas.microsoft.com/office/drawing/2014/main" id="{772E8448-2C95-4E55-86BE-BE96ABE232A4}"/>
               </a:ext>
             </a:extLst>
           </p:cNvPr>
@@ -3814,7 +3814,7 @@
           <p:cNvPr id="2" name="text-138">
             <a:extLst xmlns:a="http://schemas.openxmlformats.org/drawingml/2006/main">
               <a:ext uri="{FF2B5EF4-FFF2-40B4-BE49-F238E27FC236}">
-                <a16:creationId xmlns:a16="http://schemas.microsoft.com/office/drawing/2014/main" id="{ECF761DB-43F4-4506-BB23-1C1417DF6C5F}"/>
+                <a16:creationId xmlns:a16="http://schemas.microsoft.com/office/drawing/2014/main" id="{BC3A6C47-1F26-4A3A-B9D9-107EE82425E0}"/>
               </a:ext>
             </a:extLst>
           </p:cNvPr>
@@ -3870,7 +3870,7 @@
           <p:cNvPr id="3" name="text-139">
             <a:extLst xmlns:a="http://schemas.openxmlformats.org/drawingml/2006/main">
               <a:ext uri="{FF2B5EF4-FFF2-40B4-BE49-F238E27FC236}">
-                <a16:creationId xmlns:a16="http://schemas.microsoft.com/office/drawing/2014/main" id="{5BBC89C7-45C6-4978-8111-B9661948F425}"/>
+                <a16:creationId xmlns:a16="http://schemas.microsoft.com/office/drawing/2014/main" id="{E99F283A-98C1-4F3C-8D30-6344D0134A36}"/>
               </a:ext>
             </a:extLst>
           </p:cNvPr>
@@ -3926,7 +3926,7 @@
           <p:cNvPr id="4" name="text-140">
             <a:extLst xmlns:a="http://schemas.openxmlformats.org/drawingml/2006/main">
               <a:ext uri="{FF2B5EF4-FFF2-40B4-BE49-F238E27FC236}">
-                <a16:creationId xmlns:a16="http://schemas.microsoft.com/office/drawing/2014/main" id="{C7BAEFC1-B8C9-40FB-8678-7CF72E406611}"/>
+                <a16:creationId xmlns:a16="http://schemas.microsoft.com/office/drawing/2014/main" id="{DC2BBBA5-D5F4-4476-B8D3-76C89A2538BF}"/>
               </a:ext>
             </a:extLst>
           </p:cNvPr>
@@ -3982,7 +3982,7 @@
           <p:cNvPr id="5" name="text-141">
             <a:extLst xmlns:a="http://schemas.openxmlformats.org/drawingml/2006/main">
               <a:ext uri="{FF2B5EF4-FFF2-40B4-BE49-F238E27FC236}">
-                <a16:creationId xmlns:a16="http://schemas.microsoft.com/office/drawing/2014/main" id="{B8C1975E-C418-4C6B-B5A7-38783DD4B21C}"/>
+                <a16:creationId xmlns:a16="http://schemas.microsoft.com/office/drawing/2014/main" id="{00E5BBEE-9BBC-43EA-A14A-ADDF1126AA76}"/>
               </a:ext>
             </a:extLst>
           </p:cNvPr>
@@ -4038,7 +4038,7 @@
           <p:cNvPr id="6" name="box-142">
             <a:extLst xmlns:a="http://schemas.openxmlformats.org/drawingml/2006/main">
               <a:ext uri="{FF2B5EF4-FFF2-40B4-BE49-F238E27FC236}">
-                <a16:creationId xmlns:a16="http://schemas.microsoft.com/office/drawing/2014/main" id="{61DF5ABF-4AAD-4270-BB2A-80E0722B95EC}"/>
+                <a16:creationId xmlns:a16="http://schemas.microsoft.com/office/drawing/2014/main" id="{63C443C3-0970-47C6-AD32-CDB75D788770}"/>
               </a:ext>
             </a:extLst>
           </p:cNvPr>
@@ -4071,7 +4071,7 @@
           <p:cNvPr id="7" name="text-143">
             <a:extLst xmlns:a="http://schemas.openxmlformats.org/drawingml/2006/main">
               <a:ext uri="{FF2B5EF4-FFF2-40B4-BE49-F238E27FC236}">
-                <a16:creationId xmlns:a16="http://schemas.microsoft.com/office/drawing/2014/main" id="{AC667315-DE7F-43F2-9F6A-1422E739A53E}"/>
+                <a16:creationId xmlns:a16="http://schemas.microsoft.com/office/drawing/2014/main" id="{DD6CC093-5DB8-409B-A27A-D743E531789A}"/>
               </a:ext>
             </a:extLst>
           </p:cNvPr>
@@ -4127,7 +4127,7 @@
           <p:cNvPr id="8" name="text-144">
             <a:extLst xmlns:a="http://schemas.openxmlformats.org/drawingml/2006/main">
               <a:ext uri="{FF2B5EF4-FFF2-40B4-BE49-F238E27FC236}">
-                <a16:creationId xmlns:a16="http://schemas.microsoft.com/office/drawing/2014/main" id="{C7167620-E0BF-4890-B574-80C877BC17E1}"/>
+                <a16:creationId xmlns:a16="http://schemas.microsoft.com/office/drawing/2014/main" id="{A2BFC618-44EA-47E6-88D0-D1F73904D232}"/>
               </a:ext>
             </a:extLst>
           </p:cNvPr>
@@ -4183,7 +4183,7 @@
           <p:cNvPr id="9" name="box-145">
             <a:extLst xmlns:a="http://schemas.openxmlformats.org/drawingml/2006/main">
               <a:ext uri="{FF2B5EF4-FFF2-40B4-BE49-F238E27FC236}">
-                <a16:creationId xmlns:a16="http://schemas.microsoft.com/office/drawing/2014/main" id="{915DE63D-312E-494D-B191-21454D08EE23}"/>
+                <a16:creationId xmlns:a16="http://schemas.microsoft.com/office/drawing/2014/main" id="{63E137E8-EF00-405F-91D4-31986B6DA0FE}"/>
               </a:ext>
             </a:extLst>
           </p:cNvPr>
@@ -4216,7 +4216,7 @@
           <p:cNvPr id="10" name="text-146">
             <a:extLst xmlns:a="http://schemas.openxmlformats.org/drawingml/2006/main">
               <a:ext uri="{FF2B5EF4-FFF2-40B4-BE49-F238E27FC236}">
-                <a16:creationId xmlns:a16="http://schemas.microsoft.com/office/drawing/2014/main" id="{3933C62D-7387-4BAE-B46A-0AD5331F1447}"/>
+                <a16:creationId xmlns:a16="http://schemas.microsoft.com/office/drawing/2014/main" id="{7263430B-DFE2-4F63-AE99-E9B62B026FCA}"/>
               </a:ext>
             </a:extLst>
           </p:cNvPr>
@@ -4272,7 +4272,7 @@
           <p:cNvPr id="11" name="text-147">
             <a:extLst xmlns:a="http://schemas.openxmlformats.org/drawingml/2006/main">
               <a:ext uri="{FF2B5EF4-FFF2-40B4-BE49-F238E27FC236}">
-                <a16:creationId xmlns:a16="http://schemas.microsoft.com/office/drawing/2014/main" id="{C8FA4460-6DA8-4DE5-93C7-F732996DCA76}"/>
+                <a16:creationId xmlns:a16="http://schemas.microsoft.com/office/drawing/2014/main" id="{0AF1B2E8-8838-40B9-95A1-D29A69DC1956}"/>
               </a:ext>
             </a:extLst>
           </p:cNvPr>
@@ -4328,7 +4328,7 @@
           <p:cNvPr id="12" name="box-148">
             <a:extLst xmlns:a="http://schemas.openxmlformats.org/drawingml/2006/main">
               <a:ext uri="{FF2B5EF4-FFF2-40B4-BE49-F238E27FC236}">
-                <a16:creationId xmlns:a16="http://schemas.microsoft.com/office/drawing/2014/main" id="{BF3DADDF-DC16-41F2-B63D-88B2FE2374D2}"/>
+                <a16:creationId xmlns:a16="http://schemas.microsoft.com/office/drawing/2014/main" id="{D9B133E7-5E0C-4B52-B6E1-1949D708AB39}"/>
               </a:ext>
             </a:extLst>
           </p:cNvPr>
@@ -4361,7 +4361,7 @@
           <p:cNvPr id="13" name="text-149">
             <a:extLst xmlns:a="http://schemas.openxmlformats.org/drawingml/2006/main">
               <a:ext uri="{FF2B5EF4-FFF2-40B4-BE49-F238E27FC236}">
-                <a16:creationId xmlns:a16="http://schemas.microsoft.com/office/drawing/2014/main" id="{10175C24-A31B-4D80-B2D1-C258710DB7E6}"/>
+                <a16:creationId xmlns:a16="http://schemas.microsoft.com/office/drawing/2014/main" id="{A79D07B5-1D46-4E78-8D9E-483815EB107F}"/>
               </a:ext>
             </a:extLst>
           </p:cNvPr>
@@ -4417,7 +4417,7 @@
           <p:cNvPr id="14" name="text-150">
             <a:extLst xmlns:a="http://schemas.openxmlformats.org/drawingml/2006/main">
               <a:ext uri="{FF2B5EF4-FFF2-40B4-BE49-F238E27FC236}">
-                <a16:creationId xmlns:a16="http://schemas.microsoft.com/office/drawing/2014/main" id="{6E6B8E15-EF53-4CA2-A747-89C695B353C7}"/>
+                <a16:creationId xmlns:a16="http://schemas.microsoft.com/office/drawing/2014/main" id="{E258D1EC-7EDB-4D0B-9AF0-69D0105B4C29}"/>
               </a:ext>
             </a:extLst>
           </p:cNvPr>
@@ -4473,7 +4473,7 @@
           <p:cNvPr id="15" name="box-151">
             <a:extLst xmlns:a="http://schemas.openxmlformats.org/drawingml/2006/main">
               <a:ext uri="{FF2B5EF4-FFF2-40B4-BE49-F238E27FC236}">
-                <a16:creationId xmlns:a16="http://schemas.microsoft.com/office/drawing/2014/main" id="{39CAE047-EEF7-41C6-BEF9-D03A2D6FC892}"/>
+                <a16:creationId xmlns:a16="http://schemas.microsoft.com/office/drawing/2014/main" id="{3D98830C-B4F4-4705-A20A-EC87E8FE6254}"/>
               </a:ext>
             </a:extLst>
           </p:cNvPr>
@@ -4506,7 +4506,7 @@
           <p:cNvPr id="16" name="text-152">
             <a:extLst xmlns:a="http://schemas.openxmlformats.org/drawingml/2006/main">
               <a:ext uri="{FF2B5EF4-FFF2-40B4-BE49-F238E27FC236}">
-                <a16:creationId xmlns:a16="http://schemas.microsoft.com/office/drawing/2014/main" id="{5E7DBBFE-7C18-474E-A9E0-058F18FC35E6}"/>
+                <a16:creationId xmlns:a16="http://schemas.microsoft.com/office/drawing/2014/main" id="{0EDB767C-7D58-4D7D-B15B-683F90159B55}"/>
               </a:ext>
             </a:extLst>
           </p:cNvPr>
@@ -4562,7 +4562,7 @@
           <p:cNvPr id="17" name="text-153">
             <a:extLst xmlns:a="http://schemas.openxmlformats.org/drawingml/2006/main">
               <a:ext uri="{FF2B5EF4-FFF2-40B4-BE49-F238E27FC236}">
-                <a16:creationId xmlns:a16="http://schemas.microsoft.com/office/drawing/2014/main" id="{3D91DF67-D4A8-4F67-88D1-9000BE440B56}"/>
+                <a16:creationId xmlns:a16="http://schemas.microsoft.com/office/drawing/2014/main" id="{26B94BD2-FC29-40DF-AE55-C5A8580AFDD0}"/>
               </a:ext>
             </a:extLst>
           </p:cNvPr>
@@ -4616,7 +4616,7 @@
     </p:spTree>
     <p:extLst>
       <p:ext uri="{BB962C8B-B14F-4D97-AF65-F5344CB8AC3E}">
-        <p14:creationId xmlns:p14="http://schemas.microsoft.com/office/powerpoint/2010/main" val="255765212"/>
+        <p14:creationId xmlns:p14="http://schemas.microsoft.com/office/powerpoint/2010/main" val="178546162"/>
       </p:ext>
     </p:extLst>
   </p:cSld>
@@ -4647,7 +4647,7 @@
           <p:cNvPr id="21" name="box-154">
             <a:extLst xmlns:a="http://schemas.openxmlformats.org/drawingml/2006/main">
               <a:ext uri="{FF2B5EF4-FFF2-40B4-BE49-F238E27FC236}">
-                <a16:creationId xmlns:a16="http://schemas.microsoft.com/office/drawing/2014/main" id="{DF735055-437B-4E16-A73B-0969880F0977}"/>
+                <a16:creationId xmlns:a16="http://schemas.microsoft.com/office/drawing/2014/main" id="{FAD64A88-EF53-421E-AA51-982028D55660}"/>
               </a:ext>
             </a:extLst>
           </p:cNvPr>
@@ -4680,7 +4680,7 @@
           <p:cNvPr id="2" name="text-155">
             <a:extLst xmlns:a="http://schemas.openxmlformats.org/drawingml/2006/main">
               <a:ext uri="{FF2B5EF4-FFF2-40B4-BE49-F238E27FC236}">
-                <a16:creationId xmlns:a16="http://schemas.microsoft.com/office/drawing/2014/main" id="{B4F4797F-708D-4888-AFBC-FEB243087800}"/>
+                <a16:creationId xmlns:a16="http://schemas.microsoft.com/office/drawing/2014/main" id="{8AE2E265-3DEE-4198-A0BB-2B648E46DB55}"/>
               </a:ext>
             </a:extLst>
           </p:cNvPr>
@@ -4736,7 +4736,7 @@
           <p:cNvPr id="3" name="text-156">
             <a:extLst xmlns:a="http://schemas.openxmlformats.org/drawingml/2006/main">
               <a:ext uri="{FF2B5EF4-FFF2-40B4-BE49-F238E27FC236}">
-                <a16:creationId xmlns:a16="http://schemas.microsoft.com/office/drawing/2014/main" id="{CE92F4FE-4100-4DB6-BD57-4480A3508EFB}"/>
+                <a16:creationId xmlns:a16="http://schemas.microsoft.com/office/drawing/2014/main" id="{B7838C0D-94F9-4B5F-8428-CD1F927D14BD}"/>
               </a:ext>
             </a:extLst>
           </p:cNvPr>
@@ -4792,7 +4792,7 @@
           <p:cNvPr id="4" name="text-157">
             <a:extLst xmlns:a="http://schemas.openxmlformats.org/drawingml/2006/main">
               <a:ext uri="{FF2B5EF4-FFF2-40B4-BE49-F238E27FC236}">
-                <a16:creationId xmlns:a16="http://schemas.microsoft.com/office/drawing/2014/main" id="{9A4BAF04-2976-4EEC-AA84-226F043003EC}"/>
+                <a16:creationId xmlns:a16="http://schemas.microsoft.com/office/drawing/2014/main" id="{85C16B06-0C9B-4B10-8D25-081CF832DD0F}"/>
               </a:ext>
             </a:extLst>
           </p:cNvPr>
@@ -4848,7 +4848,7 @@
           <p:cNvPr id="5" name="text-158">
             <a:extLst xmlns:a="http://schemas.openxmlformats.org/drawingml/2006/main">
               <a:ext uri="{FF2B5EF4-FFF2-40B4-BE49-F238E27FC236}">
-                <a16:creationId xmlns:a16="http://schemas.microsoft.com/office/drawing/2014/main" id="{921916B6-4C01-4FB9-A1AD-A287D0E0CF5C}"/>
+                <a16:creationId xmlns:a16="http://schemas.microsoft.com/office/drawing/2014/main" id="{CC52C43F-0C87-487E-8C84-3B8AE8314386}"/>
               </a:ext>
             </a:extLst>
           </p:cNvPr>
@@ -4904,7 +4904,7 @@
           <p:cNvPr id="6" name="box-159">
             <a:extLst xmlns:a="http://schemas.openxmlformats.org/drawingml/2006/main">
               <a:ext uri="{FF2B5EF4-FFF2-40B4-BE49-F238E27FC236}">
-                <a16:creationId xmlns:a16="http://schemas.microsoft.com/office/drawing/2014/main" id="{067B4F55-9E64-4383-AB4B-E6E599B95355}"/>
+                <a16:creationId xmlns:a16="http://schemas.microsoft.com/office/drawing/2014/main" id="{35CE7BF3-71FB-4A50-A430-143FD7ADD60B}"/>
               </a:ext>
             </a:extLst>
           </p:cNvPr>
@@ -4937,7 +4937,7 @@
           <p:cNvPr id="7" name="dot-160">
             <a:extLst xmlns:a="http://schemas.openxmlformats.org/drawingml/2006/main">
               <a:ext uri="{FF2B5EF4-FFF2-40B4-BE49-F238E27FC236}">
-                <a16:creationId xmlns:a16="http://schemas.microsoft.com/office/drawing/2014/main" id="{6006D020-6A8E-4C75-BDC1-509FF19DC6C7}"/>
+                <a16:creationId xmlns:a16="http://schemas.microsoft.com/office/drawing/2014/main" id="{B3A794AC-AE50-4509-BC75-19EE0A8C167F}"/>
               </a:ext>
             </a:extLst>
           </p:cNvPr>
@@ -4968,7 +4968,7 @@
           <p:cNvPr id="8" name="text-161">
             <a:extLst xmlns:a="http://schemas.openxmlformats.org/drawingml/2006/main">
               <a:ext uri="{FF2B5EF4-FFF2-40B4-BE49-F238E27FC236}">
-                <a16:creationId xmlns:a16="http://schemas.microsoft.com/office/drawing/2014/main" id="{7CFC04E8-A2EF-4F17-BE35-7B481EC1CB96}"/>
+                <a16:creationId xmlns:a16="http://schemas.microsoft.com/office/drawing/2014/main" id="{34E45892-369B-48E6-8EAD-8194C999A3E0}"/>
               </a:ext>
             </a:extLst>
           </p:cNvPr>
@@ -5024,7 +5024,7 @@
           <p:cNvPr id="9" name="text-162">
             <a:extLst xmlns:a="http://schemas.openxmlformats.org/drawingml/2006/main">
               <a:ext uri="{FF2B5EF4-FFF2-40B4-BE49-F238E27FC236}">
-                <a16:creationId xmlns:a16="http://schemas.microsoft.com/office/drawing/2014/main" id="{EC6E338D-B4CC-4A6B-94D9-5025FFB48C03}"/>
+                <a16:creationId xmlns:a16="http://schemas.microsoft.com/office/drawing/2014/main" id="{612DEE05-5560-4734-B17B-1A6AB193C730}"/>
               </a:ext>
             </a:extLst>
           </p:cNvPr>
@@ -5080,7 +5080,7 @@
           <p:cNvPr id="10" name="text-163">
             <a:extLst xmlns:a="http://schemas.openxmlformats.org/drawingml/2006/main">
               <a:ext uri="{FF2B5EF4-FFF2-40B4-BE49-F238E27FC236}">
-                <a16:creationId xmlns:a16="http://schemas.microsoft.com/office/drawing/2014/main" id="{558BFEBD-1C97-4A5C-BDA7-0902D5EFB6FD}"/>
+                <a16:creationId xmlns:a16="http://schemas.microsoft.com/office/drawing/2014/main" id="{40CC8121-7455-4815-924E-967E10EBA3DA}"/>
               </a:ext>
             </a:extLst>
           </p:cNvPr>
@@ -5136,7 +5136,7 @@
           <p:cNvPr id="11" name="dot-164">
             <a:extLst xmlns:a="http://schemas.openxmlformats.org/drawingml/2006/main">
               <a:ext uri="{FF2B5EF4-FFF2-40B4-BE49-F238E27FC236}">
-                <a16:creationId xmlns:a16="http://schemas.microsoft.com/office/drawing/2014/main" id="{E1FD1CCD-6725-4455-9FA6-48F6002F3DBB}"/>
+                <a16:creationId xmlns:a16="http://schemas.microsoft.com/office/drawing/2014/main" id="{B82E5388-2D1F-43EE-8004-C1A7BDE32A76}"/>
               </a:ext>
             </a:extLst>
           </p:cNvPr>
@@ -5167,7 +5167,7 @@
           <p:cNvPr id="12" name="text-165">
             <a:extLst xmlns:a="http://schemas.openxmlformats.org/drawingml/2006/main">
               <a:ext uri="{FF2B5EF4-FFF2-40B4-BE49-F238E27FC236}">
-                <a16:creationId xmlns:a16="http://schemas.microsoft.com/office/drawing/2014/main" id="{6EA237C8-E1BA-4CA6-8C11-195120F8588A}"/>
+                <a16:creationId xmlns:a16="http://schemas.microsoft.com/office/drawing/2014/main" id="{C8B64B5C-BF1C-4056-8ABD-83C73E6E6F11}"/>
               </a:ext>
             </a:extLst>
           </p:cNvPr>
@@ -5223,7 +5223,7 @@
           <p:cNvPr id="13" name="text-166">
             <a:extLst xmlns:a="http://schemas.openxmlformats.org/drawingml/2006/main">
               <a:ext uri="{FF2B5EF4-FFF2-40B4-BE49-F238E27FC236}">
-                <a16:creationId xmlns:a16="http://schemas.microsoft.com/office/drawing/2014/main" id="{80C2EA4E-A394-4B2D-BDEE-F4D4C67B3B72}"/>
+                <a16:creationId xmlns:a16="http://schemas.microsoft.com/office/drawing/2014/main" id="{EF332CEB-05C1-4916-96DE-B83BBE2639C8}"/>
               </a:ext>
             </a:extLst>
           </p:cNvPr>
@@ -5269,7 +5269,7 @@
                 <a:ea typeface="Arial"/>
                 <a:cs typeface="Arial"/>
               </a:rPr>
-              <a:t>LM Studio</a:t>
+              <a:t>LM Studio / alt. uç</a:t>
             </a:r>
           </a:p>
         </p:txBody>
@@ -5279,7 +5279,7 @@
           <p:cNvPr id="14" name="text-167">
             <a:extLst xmlns:a="http://schemas.openxmlformats.org/drawingml/2006/main">
               <a:ext uri="{FF2B5EF4-FFF2-40B4-BE49-F238E27FC236}">
-                <a16:creationId xmlns:a16="http://schemas.microsoft.com/office/drawing/2014/main" id="{CE96F230-8CC9-477F-B65C-A73E92813419}"/>
+                <a16:creationId xmlns:a16="http://schemas.microsoft.com/office/drawing/2014/main" id="{9EEF3A88-06FD-433D-8121-79FB9ED0B284}"/>
               </a:ext>
             </a:extLst>
           </p:cNvPr>
@@ -5325,7 +5325,7 @@
                 <a:ea typeface="Arial"/>
                 <a:cs typeface="Arial"/>
               </a:rPr>
-              <a:t>İstek yalnızca yerel uç noktaya gider; bağlantı yoksa akış güvenle kapanır.</a:t>
+              <a:t>Önce yerel LM Studio; isteğe bağlı NVIDIA NIM veya özel OpenAI uyumlu uç. API anahtarı diske yazılmaz.</a:t>
             </a:r>
           </a:p>
         </p:txBody>
@@ -5335,7 +5335,7 @@
           <p:cNvPr id="15" name="dot-168">
             <a:extLst xmlns:a="http://schemas.openxmlformats.org/drawingml/2006/main">
               <a:ext uri="{FF2B5EF4-FFF2-40B4-BE49-F238E27FC236}">
-                <a16:creationId xmlns:a16="http://schemas.microsoft.com/office/drawing/2014/main" id="{47E095DC-3C8E-4BA7-8640-573D3DB28731}"/>
+                <a16:creationId xmlns:a16="http://schemas.microsoft.com/office/drawing/2014/main" id="{8C549CD1-31C1-4A9B-A24C-CD0E4CFD1044}"/>
               </a:ext>
             </a:extLst>
           </p:cNvPr>
@@ -5366,7 +5366,7 @@
           <p:cNvPr id="16" name="text-169">
             <a:extLst xmlns:a="http://schemas.openxmlformats.org/drawingml/2006/main">
               <a:ext uri="{FF2B5EF4-FFF2-40B4-BE49-F238E27FC236}">
-                <a16:creationId xmlns:a16="http://schemas.microsoft.com/office/drawing/2014/main" id="{E7BEB6E4-E550-4A03-883D-F38F53212085}"/>
+                <a16:creationId xmlns:a16="http://schemas.microsoft.com/office/drawing/2014/main" id="{89F28C62-63B1-4DBB-8AD6-F37EABE8A82D}"/>
               </a:ext>
             </a:extLst>
           </p:cNvPr>
@@ -5422,7 +5422,7 @@
           <p:cNvPr id="17" name="text-170">
             <a:extLst xmlns:a="http://schemas.openxmlformats.org/drawingml/2006/main">
               <a:ext uri="{FF2B5EF4-FFF2-40B4-BE49-F238E27FC236}">
-                <a16:creationId xmlns:a16="http://schemas.microsoft.com/office/drawing/2014/main" id="{CE5B93CD-2485-4FA0-B2EA-31686D381C1E}"/>
+                <a16:creationId xmlns:a16="http://schemas.microsoft.com/office/drawing/2014/main" id="{2C9C04D9-5053-403D-B7A3-67C8AC4382FA}"/>
               </a:ext>
             </a:extLst>
           </p:cNvPr>
@@ -5478,7 +5478,7 @@
           <p:cNvPr id="18" name="text-171">
             <a:extLst xmlns:a="http://schemas.openxmlformats.org/drawingml/2006/main">
               <a:ext uri="{FF2B5EF4-FFF2-40B4-BE49-F238E27FC236}">
-                <a16:creationId xmlns:a16="http://schemas.microsoft.com/office/drawing/2014/main" id="{5856D05D-4902-48B5-91ED-242E44A77AAC}"/>
+                <a16:creationId xmlns:a16="http://schemas.microsoft.com/office/drawing/2014/main" id="{9E0BF4EF-5259-488C-8278-61FBCD604E4A}"/>
               </a:ext>
             </a:extLst>
           </p:cNvPr>
@@ -5534,7 +5534,7 @@
           <p:cNvPr id="19" name="box-172">
             <a:extLst xmlns:a="http://schemas.openxmlformats.org/drawingml/2006/main">
               <a:ext uri="{FF2B5EF4-FFF2-40B4-BE49-F238E27FC236}">
-                <a16:creationId xmlns:a16="http://schemas.microsoft.com/office/drawing/2014/main" id="{F09108AC-EB69-4A4B-A8B9-277D1506004D}"/>
+                <a16:creationId xmlns:a16="http://schemas.microsoft.com/office/drawing/2014/main" id="{F735ED2C-1FA0-4D50-AB90-92045F3F0FFA}"/>
               </a:ext>
             </a:extLst>
           </p:cNvPr>
@@ -5567,7 +5567,7 @@
           <p:cNvPr id="20" name="text-173">
             <a:extLst xmlns:a="http://schemas.openxmlformats.org/drawingml/2006/main">
               <a:ext uri="{FF2B5EF4-FFF2-40B4-BE49-F238E27FC236}">
-                <a16:creationId xmlns:a16="http://schemas.microsoft.com/office/drawing/2014/main" id="{C9F4D3F1-C17C-4997-9762-CC186E20FB8E}"/>
+                <a16:creationId xmlns:a16="http://schemas.microsoft.com/office/drawing/2014/main" id="{7FF74AAE-5F93-4D19-90C8-FC05526D0FFB}"/>
               </a:ext>
             </a:extLst>
           </p:cNvPr>
@@ -5621,7 +5621,7 @@
     </p:spTree>
     <p:extLst>
       <p:ext uri="{BB962C8B-B14F-4D97-AF65-F5344CB8AC3E}">
-        <p14:creationId xmlns:p14="http://schemas.microsoft.com/office/powerpoint/2010/main" val="172203844"/>
+        <p14:creationId xmlns:p14="http://schemas.microsoft.com/office/powerpoint/2010/main" val="342098189"/>
       </p:ext>
     </p:extLst>
   </p:cSld>
@@ -5652,7 +5652,7 @@
           <p:cNvPr id="18" name="box-174">
             <a:extLst xmlns:a="http://schemas.openxmlformats.org/drawingml/2006/main">
               <a:ext uri="{FF2B5EF4-FFF2-40B4-BE49-F238E27FC236}">
-                <a16:creationId xmlns:a16="http://schemas.microsoft.com/office/drawing/2014/main" id="{20256EEC-920D-40C0-B903-AA5C7AA831A2}"/>
+                <a16:creationId xmlns:a16="http://schemas.microsoft.com/office/drawing/2014/main" id="{7565604A-90F0-431E-BD69-003023C9DDB9}"/>
               </a:ext>
             </a:extLst>
           </p:cNvPr>
@@ -5685,7 +5685,7 @@
           <p:cNvPr id="2" name="text-175">
             <a:extLst xmlns:a="http://schemas.openxmlformats.org/drawingml/2006/main">
               <a:ext uri="{FF2B5EF4-FFF2-40B4-BE49-F238E27FC236}">
-                <a16:creationId xmlns:a16="http://schemas.microsoft.com/office/drawing/2014/main" id="{64A6C2CF-6056-4909-9FA0-4FF69A411EC4}"/>
+                <a16:creationId xmlns:a16="http://schemas.microsoft.com/office/drawing/2014/main" id="{5921C001-5EF5-4F57-9F9A-7387BE12E4C5}"/>
               </a:ext>
             </a:extLst>
           </p:cNvPr>
@@ -5741,7 +5741,7 @@
           <p:cNvPr id="3" name="text-176">
             <a:extLst xmlns:a="http://schemas.openxmlformats.org/drawingml/2006/main">
               <a:ext uri="{FF2B5EF4-FFF2-40B4-BE49-F238E27FC236}">
-                <a16:creationId xmlns:a16="http://schemas.microsoft.com/office/drawing/2014/main" id="{1B6AA55A-BA5A-4387-B373-243B0DA2440B}"/>
+                <a16:creationId xmlns:a16="http://schemas.microsoft.com/office/drawing/2014/main" id="{3015BD00-DD25-445B-8BC3-769AE97250D1}"/>
               </a:ext>
             </a:extLst>
           </p:cNvPr>
@@ -5797,7 +5797,7 @@
           <p:cNvPr id="4" name="text-177">
             <a:extLst xmlns:a="http://schemas.openxmlformats.org/drawingml/2006/main">
               <a:ext uri="{FF2B5EF4-FFF2-40B4-BE49-F238E27FC236}">
-                <a16:creationId xmlns:a16="http://schemas.microsoft.com/office/drawing/2014/main" id="{63A31BD9-1260-4C5D-BF06-C6E08D1F8B3F}"/>
+                <a16:creationId xmlns:a16="http://schemas.microsoft.com/office/drawing/2014/main" id="{14BC9C73-9CEF-4B23-AB09-ABE47F59475E}"/>
               </a:ext>
             </a:extLst>
           </p:cNvPr>
@@ -5853,7 +5853,7 @@
           <p:cNvPr id="5" name="text-178">
             <a:extLst xmlns:a="http://schemas.openxmlformats.org/drawingml/2006/main">
               <a:ext uri="{FF2B5EF4-FFF2-40B4-BE49-F238E27FC236}">
-                <a16:creationId xmlns:a16="http://schemas.microsoft.com/office/drawing/2014/main" id="{E25F5FC5-9A05-441E-8ED7-85D0E2178034}"/>
+                <a16:creationId xmlns:a16="http://schemas.microsoft.com/office/drawing/2014/main" id="{67A1C5CE-DDC2-4FA8-9D54-A550AE3419DE}"/>
               </a:ext>
             </a:extLst>
           </p:cNvPr>
@@ -5909,7 +5909,7 @@
           <p:cNvPr id="6" name="text-179">
             <a:extLst xmlns:a="http://schemas.openxmlformats.org/drawingml/2006/main">
               <a:ext uri="{FF2B5EF4-FFF2-40B4-BE49-F238E27FC236}">
-                <a16:creationId xmlns:a16="http://schemas.microsoft.com/office/drawing/2014/main" id="{06D4D28B-2F3E-4E4A-B0E9-DAC2667B3B3C}"/>
+                <a16:creationId xmlns:a16="http://schemas.microsoft.com/office/drawing/2014/main" id="{EBAFADC1-9957-4F9E-A1AE-580789900CBC}"/>
               </a:ext>
             </a:extLst>
           </p:cNvPr>
@@ -5965,7 +5965,7 @@
           <p:cNvPr id="7" name="text-180">
             <a:extLst xmlns:a="http://schemas.openxmlformats.org/drawingml/2006/main">
               <a:ext uri="{FF2B5EF4-FFF2-40B4-BE49-F238E27FC236}">
-                <a16:creationId xmlns:a16="http://schemas.microsoft.com/office/drawing/2014/main" id="{BB1452FE-4C1A-4D47-8AC6-1EB49831017D}"/>
+                <a16:creationId xmlns:a16="http://schemas.microsoft.com/office/drawing/2014/main" id="{40238631-3635-4AB1-80E6-CCF2FF848778}"/>
               </a:ext>
             </a:extLst>
           </p:cNvPr>
@@ -6021,7 +6021,7 @@
           <p:cNvPr id="8" name="text-181">
             <a:extLst xmlns:a="http://schemas.openxmlformats.org/drawingml/2006/main">
               <a:ext uri="{FF2B5EF4-FFF2-40B4-BE49-F238E27FC236}">
-                <a16:creationId xmlns:a16="http://schemas.microsoft.com/office/drawing/2014/main" id="{0F414EBF-1994-4D9B-A715-D4529C9727E7}"/>
+                <a16:creationId xmlns:a16="http://schemas.microsoft.com/office/drawing/2014/main" id="{FB2BEE98-785F-4AF0-A26B-ADFFE9605200}"/>
               </a:ext>
             </a:extLst>
           </p:cNvPr>
@@ -6067,7 +6067,7 @@
                 <a:ea typeface="Arial"/>
                 <a:cs typeface="Arial"/>
               </a:rPr>
-              <a:t>37 / 37</a:t>
+              <a:t>62 / 62</a:t>
             </a:r>
           </a:p>
         </p:txBody>
@@ -6077,7 +6077,7 @@
           <p:cNvPr id="9" name="text-182">
             <a:extLst xmlns:a="http://schemas.openxmlformats.org/drawingml/2006/main">
               <a:ext uri="{FF2B5EF4-FFF2-40B4-BE49-F238E27FC236}">
-                <a16:creationId xmlns:a16="http://schemas.microsoft.com/office/drawing/2014/main" id="{99A15766-1A2B-46B8-B151-AC87FA5B8C4B}"/>
+                <a16:creationId xmlns:a16="http://schemas.microsoft.com/office/drawing/2014/main" id="{31FF7CFC-D8E2-4B7E-BBFB-0DB06E280799}"/>
               </a:ext>
             </a:extLst>
           </p:cNvPr>
@@ -6133,7 +6133,7 @@
           <p:cNvPr id="10" name="text-183">
             <a:extLst xmlns:a="http://schemas.openxmlformats.org/drawingml/2006/main">
               <a:ext uri="{FF2B5EF4-FFF2-40B4-BE49-F238E27FC236}">
-                <a16:creationId xmlns:a16="http://schemas.microsoft.com/office/drawing/2014/main" id="{927D8A9B-6835-484E-BD14-8AD85A2F1250}"/>
+                <a16:creationId xmlns:a16="http://schemas.microsoft.com/office/drawing/2014/main" id="{1B42DCCB-504D-4C2D-A998-D1BCE3DB17CD}"/>
               </a:ext>
             </a:extLst>
           </p:cNvPr>
@@ -6235,7 +6235,7 @@
           <p:cNvPr id="11" name="text-184">
             <a:extLst xmlns:a="http://schemas.openxmlformats.org/drawingml/2006/main">
               <a:ext uri="{FF2B5EF4-FFF2-40B4-BE49-F238E27FC236}">
-                <a16:creationId xmlns:a16="http://schemas.microsoft.com/office/drawing/2014/main" id="{47D41224-2F70-4FBA-89B2-DAAA3A97B657}"/>
+                <a16:creationId xmlns:a16="http://schemas.microsoft.com/office/drawing/2014/main" id="{924E9802-D00A-486A-A04D-FC9F439E8016}"/>
               </a:ext>
             </a:extLst>
           </p:cNvPr>
@@ -6337,7 +6337,7 @@
           <p:cNvPr id="12" name="text-185">
             <a:extLst xmlns:a="http://schemas.openxmlformats.org/drawingml/2006/main">
               <a:ext uri="{FF2B5EF4-FFF2-40B4-BE49-F238E27FC236}">
-                <a16:creationId xmlns:a16="http://schemas.microsoft.com/office/drawing/2014/main" id="{E29B2808-1DF6-469D-8B01-DF2DC2E4887C}"/>
+                <a16:creationId xmlns:a16="http://schemas.microsoft.com/office/drawing/2014/main" id="{BE3AA4A2-C702-4D7E-956C-83B53AA45771}"/>
               </a:ext>
             </a:extLst>
           </p:cNvPr>
@@ -6439,7 +6439,7 @@
           <p:cNvPr id="13" name="box-186">
             <a:extLst xmlns:a="http://schemas.openxmlformats.org/drawingml/2006/main">
               <a:ext uri="{FF2B5EF4-FFF2-40B4-BE49-F238E27FC236}">
-                <a16:creationId xmlns:a16="http://schemas.microsoft.com/office/drawing/2014/main" id="{E4B280F9-7F97-4FDE-A091-253EE14AE9BB}"/>
+                <a16:creationId xmlns:a16="http://schemas.microsoft.com/office/drawing/2014/main" id="{CC80DDA1-3E8A-42BA-B9CC-04B9B3122F38}"/>
               </a:ext>
             </a:extLst>
           </p:cNvPr>
@@ -6472,7 +6472,7 @@
           <p:cNvPr id="14" name="text-187">
             <a:extLst xmlns:a="http://schemas.openxmlformats.org/drawingml/2006/main">
               <a:ext uri="{FF2B5EF4-FFF2-40B4-BE49-F238E27FC236}">
-                <a16:creationId xmlns:a16="http://schemas.microsoft.com/office/drawing/2014/main" id="{0EA0E6FB-5FEE-4576-90AC-ACC773AB3AE2}"/>
+                <a16:creationId xmlns:a16="http://schemas.microsoft.com/office/drawing/2014/main" id="{86D29E27-0120-47DE-B0EF-5EC5769DF10B}"/>
               </a:ext>
             </a:extLst>
           </p:cNvPr>
@@ -6528,7 +6528,7 @@
           <p:cNvPr id="15" name="text-188">
             <a:extLst xmlns:a="http://schemas.openxmlformats.org/drawingml/2006/main">
               <a:ext uri="{FF2B5EF4-FFF2-40B4-BE49-F238E27FC236}">
-                <a16:creationId xmlns:a16="http://schemas.microsoft.com/office/drawing/2014/main" id="{D460BC0C-0F16-4EC8-BB39-87DF0D14FBB9}"/>
+                <a16:creationId xmlns:a16="http://schemas.microsoft.com/office/drawing/2014/main" id="{2EFB9BE0-9289-4FD7-885E-47D014724534}"/>
               </a:ext>
             </a:extLst>
           </p:cNvPr>
@@ -6574,7 +6574,7 @@
                 <a:ea typeface="Arial"/>
                 <a:cs typeface="Arial"/>
               </a:rPr>
-              <a:t>Windows 10/11 (x64) + macOS (Apple Silicon) — İndirme: github.com/Azizsekerdil/FrenchCourseAI/releases (v1.0.0) · (özel repo)</a:t>
+              <a:t>Windows 10/11 (x64) + macOS (Apple Silicon) — İndirme: github.com/Azizsekerdil/FrenchCourseAI/releases (v1.1.0) · (özel repo)</a:t>
             </a:r>
           </a:p>
         </p:txBody>
@@ -6584,7 +6584,7 @@
           <p:cNvPr id="16" name="text-189">
             <a:extLst xmlns:a="http://schemas.openxmlformats.org/drawingml/2006/main">
               <a:ext uri="{FF2B5EF4-FFF2-40B4-BE49-F238E27FC236}">
-                <a16:creationId xmlns:a16="http://schemas.microsoft.com/office/drawing/2014/main" id="{B9A33E28-258F-49E4-94F7-07777D2620BE}"/>
+                <a16:creationId xmlns:a16="http://schemas.microsoft.com/office/drawing/2014/main" id="{FB1A4828-AD6F-43BA-BB20-CD9E9457998B}"/>
               </a:ext>
             </a:extLst>
           </p:cNvPr>
@@ -6630,7 +6630,7 @@
                 <a:ea typeface="Arial"/>
                 <a:cs typeface="Arial"/>
               </a:rPr>
-              <a:t>Windows 10/11 (x64) &amp; macOS (Apple Silicon) — Download: GitHub Releases (v1.0.0)</a:t>
+              <a:t>Windows 10/11 (x64) &amp; macOS (Apple Silicon) — Download: GitHub Releases (v1.1.0)</a:t>
             </a:r>
           </a:p>
         </p:txBody>
@@ -6640,7 +6640,7 @@
           <p:cNvPr id="17" name="text-190">
             <a:extLst xmlns:a="http://schemas.openxmlformats.org/drawingml/2006/main">
               <a:ext uri="{FF2B5EF4-FFF2-40B4-BE49-F238E27FC236}">
-                <a16:creationId xmlns:a16="http://schemas.microsoft.com/office/drawing/2014/main" id="{32575B74-2724-41F0-B36C-016A9C631DAE}"/>
+                <a16:creationId xmlns:a16="http://schemas.microsoft.com/office/drawing/2014/main" id="{33B379C1-D365-41AC-A606-7D149199193B}"/>
               </a:ext>
             </a:extLst>
           </p:cNvPr>
@@ -6694,7 +6694,7 @@
     </p:spTree>
     <p:extLst>
       <p:ext uri="{BB962C8B-B14F-4D97-AF65-F5344CB8AC3E}">
-        <p14:creationId xmlns:p14="http://schemas.microsoft.com/office/powerpoint/2010/main" val="833612905"/>
+        <p14:creationId xmlns:p14="http://schemas.microsoft.com/office/powerpoint/2010/main" val="1118332856"/>
       </p:ext>
     </p:extLst>
   </p:cSld>

</xml_diff>

<commit_message>
Sunum: v1.1.1 indirme bilgileri, 68 test
Co-Authored-By: Claude Fable 5.1 <noreply@anthropic.com>
</commit_message>
<xml_diff>
--- a/docs/presentation/French-Course-AI-Trilingual.pptx
+++ b/docs/presentation/French-Course-AI-Trilingual.pptx
@@ -2,18 +2,18 @@
 <file path=ppt/presentation.xml><?xml version="1.0" encoding="utf-8"?>
 <p:presentation xmlns:p="http://schemas.openxmlformats.org/presentationml/2006/main">
   <p:sldMasterIdLst>
-    <p:sldMasterId xmlns:r="http://schemas.openxmlformats.org/officeDocument/2006/relationships" id="2147483648" r:id="R04246e0d762243b4"/>
+    <p:sldMasterId xmlns:r="http://schemas.openxmlformats.org/officeDocument/2006/relationships" id="2147483648" r:id="R267d342cafaa4d19"/>
   </p:sldMasterIdLst>
   <p:notesMasterIdLst>
-    <p:notesMasterId xmlns:r="http://schemas.openxmlformats.org/officeDocument/2006/relationships" r:id="R84b71e0b80b742a2"/>
+    <p:notesMasterId xmlns:r="http://schemas.openxmlformats.org/officeDocument/2006/relationships" r:id="R935c4e6952ff410e"/>
   </p:notesMasterIdLst>
   <p:sldIdLst>
-    <p:sldId xmlns:r="http://schemas.openxmlformats.org/officeDocument/2006/relationships" id="256" r:id="R3537739081a143b6"/>
-    <p:sldId xmlns:r="http://schemas.openxmlformats.org/officeDocument/2006/relationships" id="257" r:id="R3dc2dc7a9a234fe9"/>
-    <p:sldId xmlns:r="http://schemas.openxmlformats.org/officeDocument/2006/relationships" id="258" r:id="R68eb7dfea4564f24"/>
-    <p:sldId xmlns:r="http://schemas.openxmlformats.org/officeDocument/2006/relationships" id="259" r:id="R2d57ec27ef2c4ff9"/>
-    <p:sldId xmlns:r="http://schemas.openxmlformats.org/officeDocument/2006/relationships" id="260" r:id="R3d728462470048dd"/>
-    <p:sldId xmlns:r="http://schemas.openxmlformats.org/officeDocument/2006/relationships" id="261" r:id="Re6d28c063ce14968"/>
+    <p:sldId xmlns:r="http://schemas.openxmlformats.org/officeDocument/2006/relationships" id="256" r:id="Rf6f81e9999144e57"/>
+    <p:sldId xmlns:r="http://schemas.openxmlformats.org/officeDocument/2006/relationships" id="257" r:id="R019dcd2818374a49"/>
+    <p:sldId xmlns:r="http://schemas.openxmlformats.org/officeDocument/2006/relationships" id="258" r:id="Rc279a97c82824023"/>
+    <p:sldId xmlns:r="http://schemas.openxmlformats.org/officeDocument/2006/relationships" id="259" r:id="Rd900bfa8f9df4d5c"/>
+    <p:sldId xmlns:r="http://schemas.openxmlformats.org/officeDocument/2006/relationships" id="260" r:id="R936b9016072c48d9"/>
+    <p:sldId xmlns:r="http://schemas.openxmlformats.org/officeDocument/2006/relationships" id="261" r:id="R7b57e506c3c74885"/>
   </p:sldIdLst>
   <p:sldSz cx="12192000" cy="6858000"/>
   <p:notesSz cx="6858000" cy="9144000"/>
@@ -937,7 +937,7 @@
           </a:p>
           <a:p xmlns:a="http://schemas.openxmlformats.org/drawingml/2006/main">
             <a:r>
-              <a:t>- https://github.com/Azizsekerdil/FrenchCourseAI/releases/tag/v1.1.0</a:t>
+              <a:t>- https://github.com/Azizsekerdil/FrenchCourseAI/releases/tag/v1.1.1</a:t>
             </a:r>
           </a:p>
           <a:p xmlns:a="http://schemas.openxmlformats.org/drawingml/2006/main">
@@ -1010,7 +1010,7 @@
   </p:cSld>
   <p:clrMap bg1="lt1" tx1="dk1" bg2="lt2" tx2="dk2" accent1="accent1" accent2="accent2" accent3="accent3" accent4="accent4" accent5="accent5" accent6="accent6" hlink="hlink" folHlink="folHlink"/>
   <p:sldLayoutIdLst>
-    <p:sldLayoutId xmlns:r="http://schemas.openxmlformats.org/officeDocument/2006/relationships" id="2147483649" r:id="R63755a814d43430b"/>
+    <p:sldLayoutId xmlns:r="http://schemas.openxmlformats.org/officeDocument/2006/relationships" id="2147483649" r:id="R03be0b00e6cd4eb1"/>
   </p:sldLayoutIdLst>
   <p:txStyles>
     <p:titleStyle>
@@ -1561,7 +1561,7 @@
           <p:cNvPr id="13" name="box-96">
             <a:extLst xmlns:a="http://schemas.openxmlformats.org/drawingml/2006/main">
               <a:ext uri="{FF2B5EF4-FFF2-40B4-BE49-F238E27FC236}">
-                <a16:creationId xmlns:a16="http://schemas.microsoft.com/office/drawing/2014/main" id="{B568EEBB-CD44-4F94-B0A4-216557849A09}"/>
+                <a16:creationId xmlns:a16="http://schemas.microsoft.com/office/drawing/2014/main" id="{6D5CE4F0-5AC0-41B0-9ECD-C43221673865}"/>
               </a:ext>
             </a:extLst>
           </p:cNvPr>
@@ -1594,7 +1594,7 @@
           <p:cNvPr id="2" name="text-97">
             <a:extLst xmlns:a="http://schemas.openxmlformats.org/drawingml/2006/main">
               <a:ext uri="{FF2B5EF4-FFF2-40B4-BE49-F238E27FC236}">
-                <a16:creationId xmlns:a16="http://schemas.microsoft.com/office/drawing/2014/main" id="{6390E38E-3789-493A-82C2-8BBB46EF76A2}"/>
+                <a16:creationId xmlns:a16="http://schemas.microsoft.com/office/drawing/2014/main" id="{3C33AF64-DCA5-42F0-B902-9C126EB2F231}"/>
               </a:ext>
             </a:extLst>
           </p:cNvPr>
@@ -1650,7 +1650,7 @@
           <p:cNvPr id="3" name="text-98">
             <a:extLst xmlns:a="http://schemas.openxmlformats.org/drawingml/2006/main">
               <a:ext uri="{FF2B5EF4-FFF2-40B4-BE49-F238E27FC236}">
-                <a16:creationId xmlns:a16="http://schemas.microsoft.com/office/drawing/2014/main" id="{7B487C0A-7D2B-48C7-8421-475EEACFF6B3}"/>
+                <a16:creationId xmlns:a16="http://schemas.microsoft.com/office/drawing/2014/main" id="{5207D1BF-7839-405E-BDDF-3DB6770C394A}"/>
               </a:ext>
             </a:extLst>
           </p:cNvPr>
@@ -1706,7 +1706,7 @@
           <p:cNvPr id="4" name="text-99">
             <a:extLst xmlns:a="http://schemas.openxmlformats.org/drawingml/2006/main">
               <a:ext uri="{FF2B5EF4-FFF2-40B4-BE49-F238E27FC236}">
-                <a16:creationId xmlns:a16="http://schemas.microsoft.com/office/drawing/2014/main" id="{6371B71C-D786-466F-A15B-8FEDF4E818E9}"/>
+                <a16:creationId xmlns:a16="http://schemas.microsoft.com/office/drawing/2014/main" id="{35187BB4-E2A4-429E-B3F8-EBD9385F703D}"/>
               </a:ext>
             </a:extLst>
           </p:cNvPr>
@@ -1762,7 +1762,7 @@
           <p:cNvPr id="5" name="text-100">
             <a:extLst xmlns:a="http://schemas.openxmlformats.org/drawingml/2006/main">
               <a:ext uri="{FF2B5EF4-FFF2-40B4-BE49-F238E27FC236}">
-                <a16:creationId xmlns:a16="http://schemas.microsoft.com/office/drawing/2014/main" id="{433B53B6-4440-48A2-B36E-32A0ACD85D06}"/>
+                <a16:creationId xmlns:a16="http://schemas.microsoft.com/office/drawing/2014/main" id="{8AE65BC9-56D1-4F82-A3FF-B9425BFCEF73}"/>
               </a:ext>
             </a:extLst>
           </p:cNvPr>
@@ -1818,7 +1818,7 @@
           <p:cNvPr id="6" name="text-101">
             <a:extLst xmlns:a="http://schemas.openxmlformats.org/drawingml/2006/main">
               <a:ext uri="{FF2B5EF4-FFF2-40B4-BE49-F238E27FC236}">
-                <a16:creationId xmlns:a16="http://schemas.microsoft.com/office/drawing/2014/main" id="{8CB04D6D-F064-4113-A91D-6DE4BA02B416}"/>
+                <a16:creationId xmlns:a16="http://schemas.microsoft.com/office/drawing/2014/main" id="{3419C497-7425-4FFC-A34E-488B994B4390}"/>
               </a:ext>
             </a:extLst>
           </p:cNvPr>
@@ -1874,7 +1874,7 @@
           <p:cNvPr id="7" name="text-102">
             <a:extLst xmlns:a="http://schemas.openxmlformats.org/drawingml/2006/main">
               <a:ext uri="{FF2B5EF4-FFF2-40B4-BE49-F238E27FC236}">
-                <a16:creationId xmlns:a16="http://schemas.microsoft.com/office/drawing/2014/main" id="{169ACB3A-F10B-4A1E-BB32-AA9CDB9BDAC4}"/>
+                <a16:creationId xmlns:a16="http://schemas.microsoft.com/office/drawing/2014/main" id="{23F43529-8645-4519-B62F-050D5CFB9EF1}"/>
               </a:ext>
             </a:extLst>
           </p:cNvPr>
@@ -1930,7 +1930,7 @@
           <p:cNvPr id="8" name="text-103">
             <a:extLst xmlns:a="http://schemas.openxmlformats.org/drawingml/2006/main">
               <a:ext uri="{FF2B5EF4-FFF2-40B4-BE49-F238E27FC236}">
-                <a16:creationId xmlns:a16="http://schemas.microsoft.com/office/drawing/2014/main" id="{9ABFC12C-6A66-4834-8789-8DFC6B26A719}"/>
+                <a16:creationId xmlns:a16="http://schemas.microsoft.com/office/drawing/2014/main" id="{54348D43-8ECE-451C-B62E-D7E5FE51A376}"/>
               </a:ext>
             </a:extLst>
           </p:cNvPr>
@@ -1986,7 +1986,7 @@
           <p:cNvPr id="9" name="text-104">
             <a:extLst xmlns:a="http://schemas.openxmlformats.org/drawingml/2006/main">
               <a:ext uri="{FF2B5EF4-FFF2-40B4-BE49-F238E27FC236}">
-                <a16:creationId xmlns:a16="http://schemas.microsoft.com/office/drawing/2014/main" id="{E84D0AC2-1E9E-46ED-B6B2-E4AAA95B339B}"/>
+                <a16:creationId xmlns:a16="http://schemas.microsoft.com/office/drawing/2014/main" id="{3E21F5EB-D106-4123-A19C-BA4CB12644DE}"/>
               </a:ext>
             </a:extLst>
           </p:cNvPr>
@@ -2042,7 +2042,7 @@
           <p:cNvPr id="10" name="box-105">
             <a:extLst xmlns:a="http://schemas.openxmlformats.org/drawingml/2006/main">
               <a:ext uri="{FF2B5EF4-FFF2-40B4-BE49-F238E27FC236}">
-                <a16:creationId xmlns:a16="http://schemas.microsoft.com/office/drawing/2014/main" id="{A95CFDF9-6D2A-479C-BC5D-594F4E38EC02}"/>
+                <a16:creationId xmlns:a16="http://schemas.microsoft.com/office/drawing/2014/main" id="{443116B5-340A-444F-8724-E2821E4701D0}"/>
               </a:ext>
             </a:extLst>
           </p:cNvPr>
@@ -2079,7 +2079,7 @@
           <p:nvPr/>
         </p:nvPicPr>
         <p:blipFill>
-          <a:blip xmlns:r="http://schemas.openxmlformats.org/officeDocument/2006/relationships" xmlns:a="http://schemas.openxmlformats.org/drawingml/2006/main" r:embed="R0be58c9928da4e5d"/>
+          <a:blip xmlns:r="http://schemas.openxmlformats.org/officeDocument/2006/relationships" xmlns:a="http://schemas.openxmlformats.org/drawingml/2006/main" r:embed="R0b9d273636204077"/>
           <a:stretch xmlns:a="http://schemas.openxmlformats.org/drawingml/2006/main"/>
         </p:blipFill>
         <p:spPr>
@@ -2097,7 +2097,7 @@
           <p:cNvPr id="12" name="text-106">
             <a:extLst xmlns:a="http://schemas.openxmlformats.org/drawingml/2006/main">
               <a:ext uri="{FF2B5EF4-FFF2-40B4-BE49-F238E27FC236}">
-                <a16:creationId xmlns:a16="http://schemas.microsoft.com/office/drawing/2014/main" id="{0CA07EFD-F8E4-4085-925B-7E4249B41C57}"/>
+                <a16:creationId xmlns:a16="http://schemas.microsoft.com/office/drawing/2014/main" id="{59DEDC90-6A31-4617-AD34-5C4C6D19F0DA}"/>
               </a:ext>
             </a:extLst>
           </p:cNvPr>
@@ -2151,7 +2151,7 @@
     </p:spTree>
     <p:extLst>
       <p:ext uri="{BB962C8B-B14F-4D97-AF65-F5344CB8AC3E}">
-        <p14:creationId xmlns:p14="http://schemas.microsoft.com/office/powerpoint/2010/main" val="1824151027"/>
+        <p14:creationId xmlns:p14="http://schemas.microsoft.com/office/powerpoint/2010/main" val="890854248"/>
       </p:ext>
     </p:extLst>
   </p:cSld>
@@ -2182,7 +2182,7 @@
           <p:cNvPr id="14" name="box-107">
             <a:extLst xmlns:a="http://schemas.openxmlformats.org/drawingml/2006/main">
               <a:ext uri="{FF2B5EF4-FFF2-40B4-BE49-F238E27FC236}">
-                <a16:creationId xmlns:a16="http://schemas.microsoft.com/office/drawing/2014/main" id="{52CA93C5-B4DC-4CFB-A934-ABBE7764D6B6}"/>
+                <a16:creationId xmlns:a16="http://schemas.microsoft.com/office/drawing/2014/main" id="{495A112D-0420-4CDA-89B5-62C0AC298D26}"/>
               </a:ext>
             </a:extLst>
           </p:cNvPr>
@@ -2215,7 +2215,7 @@
           <p:cNvPr id="2" name="text-108">
             <a:extLst xmlns:a="http://schemas.openxmlformats.org/drawingml/2006/main">
               <a:ext uri="{FF2B5EF4-FFF2-40B4-BE49-F238E27FC236}">
-                <a16:creationId xmlns:a16="http://schemas.microsoft.com/office/drawing/2014/main" id="{1D4420B2-4874-4400-B4DA-B6A87355773A}"/>
+                <a16:creationId xmlns:a16="http://schemas.microsoft.com/office/drawing/2014/main" id="{B3CF1A6C-EED9-4771-85DD-28FF516C61AD}"/>
               </a:ext>
             </a:extLst>
           </p:cNvPr>
@@ -2271,7 +2271,7 @@
           <p:cNvPr id="3" name="text-109">
             <a:extLst xmlns:a="http://schemas.openxmlformats.org/drawingml/2006/main">
               <a:ext uri="{FF2B5EF4-FFF2-40B4-BE49-F238E27FC236}">
-                <a16:creationId xmlns:a16="http://schemas.microsoft.com/office/drawing/2014/main" id="{1081530D-EACE-4E12-9497-0969C3D0F78C}"/>
+                <a16:creationId xmlns:a16="http://schemas.microsoft.com/office/drawing/2014/main" id="{FA3F81AB-CC4D-4557-9E58-4CCF768D0DEA}"/>
               </a:ext>
             </a:extLst>
           </p:cNvPr>
@@ -2327,7 +2327,7 @@
           <p:cNvPr id="4" name="text-110">
             <a:extLst xmlns:a="http://schemas.openxmlformats.org/drawingml/2006/main">
               <a:ext uri="{FF2B5EF4-FFF2-40B4-BE49-F238E27FC236}">
-                <a16:creationId xmlns:a16="http://schemas.microsoft.com/office/drawing/2014/main" id="{199A8809-8D3A-41F9-974E-FF54D51FBB13}"/>
+                <a16:creationId xmlns:a16="http://schemas.microsoft.com/office/drawing/2014/main" id="{43AED079-E87C-480F-8104-710216AA5844}"/>
               </a:ext>
             </a:extLst>
           </p:cNvPr>
@@ -2383,7 +2383,7 @@
           <p:cNvPr id="5" name="text-111">
             <a:extLst xmlns:a="http://schemas.openxmlformats.org/drawingml/2006/main">
               <a:ext uri="{FF2B5EF4-FFF2-40B4-BE49-F238E27FC236}">
-                <a16:creationId xmlns:a16="http://schemas.microsoft.com/office/drawing/2014/main" id="{F035FAA0-095E-4792-B238-1768A9A2C140}"/>
+                <a16:creationId xmlns:a16="http://schemas.microsoft.com/office/drawing/2014/main" id="{E5FDABC9-0809-4874-8585-DCF0C76113DD}"/>
               </a:ext>
             </a:extLst>
           </p:cNvPr>
@@ -2439,7 +2439,7 @@
           <p:cNvPr id="6" name="text-112">
             <a:extLst xmlns:a="http://schemas.openxmlformats.org/drawingml/2006/main">
               <a:ext uri="{FF2B5EF4-FFF2-40B4-BE49-F238E27FC236}">
-                <a16:creationId xmlns:a16="http://schemas.microsoft.com/office/drawing/2014/main" id="{D9240692-C966-4868-B4E3-115880B0D031}"/>
+                <a16:creationId xmlns:a16="http://schemas.microsoft.com/office/drawing/2014/main" id="{EDCA7B2E-7ABA-4051-9EDA-E2A8EFFA7800}"/>
               </a:ext>
             </a:extLst>
           </p:cNvPr>
@@ -2495,7 +2495,7 @@
           <p:cNvPr id="7" name="box-113">
             <a:extLst xmlns:a="http://schemas.openxmlformats.org/drawingml/2006/main">
               <a:ext uri="{FF2B5EF4-FFF2-40B4-BE49-F238E27FC236}">
-                <a16:creationId xmlns:a16="http://schemas.microsoft.com/office/drawing/2014/main" id="{832E56A6-8058-4D00-BF1E-ACF45C1F0675}"/>
+                <a16:creationId xmlns:a16="http://schemas.microsoft.com/office/drawing/2014/main" id="{1511EB5C-9FE4-47B6-88E3-3719A26F25FA}"/>
               </a:ext>
             </a:extLst>
           </p:cNvPr>
@@ -2528,7 +2528,7 @@
           <p:cNvPr id="8" name="text-114">
             <a:extLst xmlns:a="http://schemas.openxmlformats.org/drawingml/2006/main">
               <a:ext uri="{FF2B5EF4-FFF2-40B4-BE49-F238E27FC236}">
-                <a16:creationId xmlns:a16="http://schemas.microsoft.com/office/drawing/2014/main" id="{655D3E42-1462-4F2C-B352-79FEC0C4AB0D}"/>
+                <a16:creationId xmlns:a16="http://schemas.microsoft.com/office/drawing/2014/main" id="{276539D4-EE2B-4C9E-B5DA-E815AD2F828E}"/>
               </a:ext>
             </a:extLst>
           </p:cNvPr>
@@ -2584,7 +2584,7 @@
           <p:cNvPr id="9" name="text-115">
             <a:extLst xmlns:a="http://schemas.openxmlformats.org/drawingml/2006/main">
               <a:ext uri="{FF2B5EF4-FFF2-40B4-BE49-F238E27FC236}">
-                <a16:creationId xmlns:a16="http://schemas.microsoft.com/office/drawing/2014/main" id="{497B82BB-12CB-4EF0-BD33-D4D17E160930}"/>
+                <a16:creationId xmlns:a16="http://schemas.microsoft.com/office/drawing/2014/main" id="{36E7D4FD-F24D-4968-A7D5-197DA0722D61}"/>
               </a:ext>
             </a:extLst>
           </p:cNvPr>
@@ -2640,7 +2640,7 @@
           <p:cNvPr id="10" name="text-116">
             <a:extLst xmlns:a="http://schemas.openxmlformats.org/drawingml/2006/main">
               <a:ext uri="{FF2B5EF4-FFF2-40B4-BE49-F238E27FC236}">
-                <a16:creationId xmlns:a16="http://schemas.microsoft.com/office/drawing/2014/main" id="{B21E8043-DF0D-42C7-9ACC-36FB10CD7C12}"/>
+                <a16:creationId xmlns:a16="http://schemas.microsoft.com/office/drawing/2014/main" id="{F2EBFA4B-031B-4CDD-B1ED-B3023A22E496}"/>
               </a:ext>
             </a:extLst>
           </p:cNvPr>
@@ -2696,7 +2696,7 @@
           <p:cNvPr id="11" name="box-117">
             <a:extLst xmlns:a="http://schemas.openxmlformats.org/drawingml/2006/main">
               <a:ext uri="{FF2B5EF4-FFF2-40B4-BE49-F238E27FC236}">
-                <a16:creationId xmlns:a16="http://schemas.microsoft.com/office/drawing/2014/main" id="{EC20DCBA-5FCB-4A9B-AD2E-D5C652C15C5D}"/>
+                <a16:creationId xmlns:a16="http://schemas.microsoft.com/office/drawing/2014/main" id="{D290AB1D-97F2-4209-8840-F4C293E370A0}"/>
               </a:ext>
             </a:extLst>
           </p:cNvPr>
@@ -2733,7 +2733,7 @@
           <p:nvPr/>
         </p:nvPicPr>
         <p:blipFill>
-          <a:blip xmlns:r="http://schemas.openxmlformats.org/officeDocument/2006/relationships" xmlns:a="http://schemas.openxmlformats.org/drawingml/2006/main" r:embed="R4c04723e8677416a"/>
+          <a:blip xmlns:r="http://schemas.openxmlformats.org/officeDocument/2006/relationships" xmlns:a="http://schemas.openxmlformats.org/drawingml/2006/main" r:embed="R4c8c7e483e364b37"/>
           <a:stretch xmlns:a="http://schemas.openxmlformats.org/drawingml/2006/main"/>
         </p:blipFill>
         <p:spPr>
@@ -2751,7 +2751,7 @@
           <p:cNvPr id="13" name="text-118">
             <a:extLst xmlns:a="http://schemas.openxmlformats.org/drawingml/2006/main">
               <a:ext uri="{FF2B5EF4-FFF2-40B4-BE49-F238E27FC236}">
-                <a16:creationId xmlns:a16="http://schemas.microsoft.com/office/drawing/2014/main" id="{95E9C48F-5B04-4319-A7A9-A6AB165A6925}"/>
+                <a16:creationId xmlns:a16="http://schemas.microsoft.com/office/drawing/2014/main" id="{487155F7-6E4E-4392-8401-621A5488F6ED}"/>
               </a:ext>
             </a:extLst>
           </p:cNvPr>
@@ -2805,7 +2805,7 @@
     </p:spTree>
     <p:extLst>
       <p:ext uri="{BB962C8B-B14F-4D97-AF65-F5344CB8AC3E}">
-        <p14:creationId xmlns:p14="http://schemas.microsoft.com/office/powerpoint/2010/main" val="1796053792"/>
+        <p14:creationId xmlns:p14="http://schemas.microsoft.com/office/powerpoint/2010/main" val="85511578"/>
       </p:ext>
     </p:extLst>
   </p:cSld>
@@ -2836,7 +2836,7 @@
           <p:cNvPr id="19" name="box-119">
             <a:extLst xmlns:a="http://schemas.openxmlformats.org/drawingml/2006/main">
               <a:ext uri="{FF2B5EF4-FFF2-40B4-BE49-F238E27FC236}">
-                <a16:creationId xmlns:a16="http://schemas.microsoft.com/office/drawing/2014/main" id="{20B733C7-0BF7-4DA8-85C5-998A407E58CE}"/>
+                <a16:creationId xmlns:a16="http://schemas.microsoft.com/office/drawing/2014/main" id="{80F5DC22-6915-49C9-87AB-A5CDAC9828ED}"/>
               </a:ext>
             </a:extLst>
           </p:cNvPr>
@@ -2869,7 +2869,7 @@
           <p:cNvPr id="2" name="text-120">
             <a:extLst xmlns:a="http://schemas.openxmlformats.org/drawingml/2006/main">
               <a:ext uri="{FF2B5EF4-FFF2-40B4-BE49-F238E27FC236}">
-                <a16:creationId xmlns:a16="http://schemas.microsoft.com/office/drawing/2014/main" id="{A81DF5AA-BFD7-4C5B-BDA2-0A78B6CB4FB7}"/>
+                <a16:creationId xmlns:a16="http://schemas.microsoft.com/office/drawing/2014/main" id="{11FF9FB3-741D-44B0-8A2E-86EBAB4E090E}"/>
               </a:ext>
             </a:extLst>
           </p:cNvPr>
@@ -2925,7 +2925,7 @@
           <p:cNvPr id="3" name="text-121">
             <a:extLst xmlns:a="http://schemas.openxmlformats.org/drawingml/2006/main">
               <a:ext uri="{FF2B5EF4-FFF2-40B4-BE49-F238E27FC236}">
-                <a16:creationId xmlns:a16="http://schemas.microsoft.com/office/drawing/2014/main" id="{B7490012-3118-4951-9765-93046DCBC706}"/>
+                <a16:creationId xmlns:a16="http://schemas.microsoft.com/office/drawing/2014/main" id="{7A782BF5-EB0C-433F-862F-C8D965FDCAE2}"/>
               </a:ext>
             </a:extLst>
           </p:cNvPr>
@@ -2981,7 +2981,7 @@
           <p:cNvPr id="4" name="text-122">
             <a:extLst xmlns:a="http://schemas.openxmlformats.org/drawingml/2006/main">
               <a:ext uri="{FF2B5EF4-FFF2-40B4-BE49-F238E27FC236}">
-                <a16:creationId xmlns:a16="http://schemas.microsoft.com/office/drawing/2014/main" id="{62F08ED5-23CB-427E-9406-9C04056237F4}"/>
+                <a16:creationId xmlns:a16="http://schemas.microsoft.com/office/drawing/2014/main" id="{72923761-A1B5-4938-937A-84BB87DD2224}"/>
               </a:ext>
             </a:extLst>
           </p:cNvPr>
@@ -3037,7 +3037,7 @@
           <p:cNvPr id="5" name="text-123">
             <a:extLst xmlns:a="http://schemas.openxmlformats.org/drawingml/2006/main">
               <a:ext uri="{FF2B5EF4-FFF2-40B4-BE49-F238E27FC236}">
-                <a16:creationId xmlns:a16="http://schemas.microsoft.com/office/drawing/2014/main" id="{38618340-DC6B-4546-87EC-AAA05459603B}"/>
+                <a16:creationId xmlns:a16="http://schemas.microsoft.com/office/drawing/2014/main" id="{A9667ED5-B427-45A1-97CC-669CFD3C725C}"/>
               </a:ext>
             </a:extLst>
           </p:cNvPr>
@@ -3093,7 +3093,7 @@
           <p:cNvPr id="6" name="text-124">
             <a:extLst xmlns:a="http://schemas.openxmlformats.org/drawingml/2006/main">
               <a:ext uri="{FF2B5EF4-FFF2-40B4-BE49-F238E27FC236}">
-                <a16:creationId xmlns:a16="http://schemas.microsoft.com/office/drawing/2014/main" id="{8DC77991-41A0-4103-8E25-658D120E1AB6}"/>
+                <a16:creationId xmlns:a16="http://schemas.microsoft.com/office/drawing/2014/main" id="{5A90C5D6-A375-46C6-A0FD-E6A64615A975}"/>
               </a:ext>
             </a:extLst>
           </p:cNvPr>
@@ -3149,7 +3149,7 @@
           <p:cNvPr id="7" name="box-125">
             <a:extLst xmlns:a="http://schemas.openxmlformats.org/drawingml/2006/main">
               <a:ext uri="{FF2B5EF4-FFF2-40B4-BE49-F238E27FC236}">
-                <a16:creationId xmlns:a16="http://schemas.microsoft.com/office/drawing/2014/main" id="{FCB59E1D-CA09-4418-B6EE-7D6D2D5C1CA7}"/>
+                <a16:creationId xmlns:a16="http://schemas.microsoft.com/office/drawing/2014/main" id="{399BFACB-997D-43F8-A96B-9CE2E84B4153}"/>
               </a:ext>
             </a:extLst>
           </p:cNvPr>
@@ -3182,7 +3182,7 @@
           <p:cNvPr id="8" name="text-126">
             <a:extLst xmlns:a="http://schemas.openxmlformats.org/drawingml/2006/main">
               <a:ext uri="{FF2B5EF4-FFF2-40B4-BE49-F238E27FC236}">
-                <a16:creationId xmlns:a16="http://schemas.microsoft.com/office/drawing/2014/main" id="{7242AF45-8C80-4819-A5D5-D361D92D758B}"/>
+                <a16:creationId xmlns:a16="http://schemas.microsoft.com/office/drawing/2014/main" id="{E73A0767-F875-484D-A1D6-CC5417F3B8CA}"/>
               </a:ext>
             </a:extLst>
           </p:cNvPr>
@@ -3238,7 +3238,7 @@
           <p:cNvPr id="9" name="text-127">
             <a:extLst xmlns:a="http://schemas.openxmlformats.org/drawingml/2006/main">
               <a:ext uri="{FF2B5EF4-FFF2-40B4-BE49-F238E27FC236}">
-                <a16:creationId xmlns:a16="http://schemas.microsoft.com/office/drawing/2014/main" id="{D14E668E-4A03-4145-BB4D-A767E4DAEBD3}"/>
+                <a16:creationId xmlns:a16="http://schemas.microsoft.com/office/drawing/2014/main" id="{FFEAACFA-F8E2-4834-8CF2-675C7771DF91}"/>
               </a:ext>
             </a:extLst>
           </p:cNvPr>
@@ -3294,7 +3294,7 @@
           <p:cNvPr id="10" name="text-128">
             <a:extLst xmlns:a="http://schemas.openxmlformats.org/drawingml/2006/main">
               <a:ext uri="{FF2B5EF4-FFF2-40B4-BE49-F238E27FC236}">
-                <a16:creationId xmlns:a16="http://schemas.microsoft.com/office/drawing/2014/main" id="{57EE3C46-8CAC-44CF-8EFA-05A9AB665A04}"/>
+                <a16:creationId xmlns:a16="http://schemas.microsoft.com/office/drawing/2014/main" id="{84CAADAC-49E7-4E43-A603-367A60BFEF53}"/>
               </a:ext>
             </a:extLst>
           </p:cNvPr>
@@ -3350,7 +3350,7 @@
           <p:cNvPr id="11" name="box-129">
             <a:extLst xmlns:a="http://schemas.openxmlformats.org/drawingml/2006/main">
               <a:ext uri="{FF2B5EF4-FFF2-40B4-BE49-F238E27FC236}">
-                <a16:creationId xmlns:a16="http://schemas.microsoft.com/office/drawing/2014/main" id="{D451FAB5-DF49-4A4E-9F32-C2410997C990}"/>
+                <a16:creationId xmlns:a16="http://schemas.microsoft.com/office/drawing/2014/main" id="{0FD066ED-6CBF-4B1A-B046-27B0D4EC2577}"/>
               </a:ext>
             </a:extLst>
           </p:cNvPr>
@@ -3383,7 +3383,7 @@
           <p:cNvPr id="12" name="text-130">
             <a:extLst xmlns:a="http://schemas.openxmlformats.org/drawingml/2006/main">
               <a:ext uri="{FF2B5EF4-FFF2-40B4-BE49-F238E27FC236}">
-                <a16:creationId xmlns:a16="http://schemas.microsoft.com/office/drawing/2014/main" id="{70C50154-897E-4B65-A8E0-DD9B6F81DF47}"/>
+                <a16:creationId xmlns:a16="http://schemas.microsoft.com/office/drawing/2014/main" id="{5BEDDEA5-1548-467D-88FB-AFDE2F5BB769}"/>
               </a:ext>
             </a:extLst>
           </p:cNvPr>
@@ -3439,7 +3439,7 @@
           <p:cNvPr id="13" name="text-131">
             <a:extLst xmlns:a="http://schemas.openxmlformats.org/drawingml/2006/main">
               <a:ext uri="{FF2B5EF4-FFF2-40B4-BE49-F238E27FC236}">
-                <a16:creationId xmlns:a16="http://schemas.microsoft.com/office/drawing/2014/main" id="{B4E2AA88-6DD5-4939-A1D4-A31195B1187C}"/>
+                <a16:creationId xmlns:a16="http://schemas.microsoft.com/office/drawing/2014/main" id="{F607A1EE-2A07-4A30-870A-4702D16E8F9B}"/>
               </a:ext>
             </a:extLst>
           </p:cNvPr>
@@ -3495,7 +3495,7 @@
           <p:cNvPr id="14" name="text-132">
             <a:extLst xmlns:a="http://schemas.openxmlformats.org/drawingml/2006/main">
               <a:ext uri="{FF2B5EF4-FFF2-40B4-BE49-F238E27FC236}">
-                <a16:creationId xmlns:a16="http://schemas.microsoft.com/office/drawing/2014/main" id="{DF528D05-686C-4E70-BA33-ED9472369E4B}"/>
+                <a16:creationId xmlns:a16="http://schemas.microsoft.com/office/drawing/2014/main" id="{09955BC1-D1B4-43E4-A21C-CDCA4F5DF0F5}"/>
               </a:ext>
             </a:extLst>
           </p:cNvPr>
@@ -3551,7 +3551,7 @@
           <p:cNvPr id="15" name="box-133">
             <a:extLst xmlns:a="http://schemas.openxmlformats.org/drawingml/2006/main">
               <a:ext uri="{FF2B5EF4-FFF2-40B4-BE49-F238E27FC236}">
-                <a16:creationId xmlns:a16="http://schemas.microsoft.com/office/drawing/2014/main" id="{343AEB72-04C4-4909-B8E7-708B2BC1AEBF}"/>
+                <a16:creationId xmlns:a16="http://schemas.microsoft.com/office/drawing/2014/main" id="{BF5D0A72-1FBA-4BA2-B155-B0FDB20B72A3}"/>
               </a:ext>
             </a:extLst>
           </p:cNvPr>
@@ -3584,7 +3584,7 @@
           <p:cNvPr id="16" name="text-134">
             <a:extLst xmlns:a="http://schemas.openxmlformats.org/drawingml/2006/main">
               <a:ext uri="{FF2B5EF4-FFF2-40B4-BE49-F238E27FC236}">
-                <a16:creationId xmlns:a16="http://schemas.microsoft.com/office/drawing/2014/main" id="{8FDF7669-51DB-4EBE-ADCC-0CE2DDF0103A}"/>
+                <a16:creationId xmlns:a16="http://schemas.microsoft.com/office/drawing/2014/main" id="{FE08AE18-C63C-4D1C-A992-53F94EC74F15}"/>
               </a:ext>
             </a:extLst>
           </p:cNvPr>
@@ -3640,7 +3640,7 @@
           <p:cNvPr id="17" name="text-135">
             <a:extLst xmlns:a="http://schemas.openxmlformats.org/drawingml/2006/main">
               <a:ext uri="{FF2B5EF4-FFF2-40B4-BE49-F238E27FC236}">
-                <a16:creationId xmlns:a16="http://schemas.microsoft.com/office/drawing/2014/main" id="{94E3CBBE-7234-4257-820C-B4D988D5AF2D}"/>
+                <a16:creationId xmlns:a16="http://schemas.microsoft.com/office/drawing/2014/main" id="{A732AEFF-3BB4-4B1D-912A-477F4BEB81F4}"/>
               </a:ext>
             </a:extLst>
           </p:cNvPr>
@@ -3696,7 +3696,7 @@
           <p:cNvPr id="18" name="text-136">
             <a:extLst xmlns:a="http://schemas.openxmlformats.org/drawingml/2006/main">
               <a:ext uri="{FF2B5EF4-FFF2-40B4-BE49-F238E27FC236}">
-                <a16:creationId xmlns:a16="http://schemas.microsoft.com/office/drawing/2014/main" id="{5B4B88B6-8EBB-4417-AA7B-39A25EBED6BD}"/>
+                <a16:creationId xmlns:a16="http://schemas.microsoft.com/office/drawing/2014/main" id="{78B07E1A-B5B8-4117-8B62-3891DDD860AE}"/>
               </a:ext>
             </a:extLst>
           </p:cNvPr>
@@ -3750,7 +3750,7 @@
     </p:spTree>
     <p:extLst>
       <p:ext uri="{BB962C8B-B14F-4D97-AF65-F5344CB8AC3E}">
-        <p14:creationId xmlns:p14="http://schemas.microsoft.com/office/powerpoint/2010/main" val="405408063"/>
+        <p14:creationId xmlns:p14="http://schemas.microsoft.com/office/powerpoint/2010/main" val="58396262"/>
       </p:ext>
     </p:extLst>
   </p:cSld>
@@ -3781,7 +3781,7 @@
           <p:cNvPr id="18" name="box-137">
             <a:extLst xmlns:a="http://schemas.openxmlformats.org/drawingml/2006/main">
               <a:ext uri="{FF2B5EF4-FFF2-40B4-BE49-F238E27FC236}">
-                <a16:creationId xmlns:a16="http://schemas.microsoft.com/office/drawing/2014/main" id="{772E8448-2C95-4E55-86BE-BE96ABE232A4}"/>
+                <a16:creationId xmlns:a16="http://schemas.microsoft.com/office/drawing/2014/main" id="{7BC867AD-0C9C-4AAF-9DAB-CB668C131F7B}"/>
               </a:ext>
             </a:extLst>
           </p:cNvPr>
@@ -3814,7 +3814,7 @@
           <p:cNvPr id="2" name="text-138">
             <a:extLst xmlns:a="http://schemas.openxmlformats.org/drawingml/2006/main">
               <a:ext uri="{FF2B5EF4-FFF2-40B4-BE49-F238E27FC236}">
-                <a16:creationId xmlns:a16="http://schemas.microsoft.com/office/drawing/2014/main" id="{BC3A6C47-1F26-4A3A-B9D9-107EE82425E0}"/>
+                <a16:creationId xmlns:a16="http://schemas.microsoft.com/office/drawing/2014/main" id="{971E420E-117F-4290-8F80-387D57C742EE}"/>
               </a:ext>
             </a:extLst>
           </p:cNvPr>
@@ -3870,7 +3870,7 @@
           <p:cNvPr id="3" name="text-139">
             <a:extLst xmlns:a="http://schemas.openxmlformats.org/drawingml/2006/main">
               <a:ext uri="{FF2B5EF4-FFF2-40B4-BE49-F238E27FC236}">
-                <a16:creationId xmlns:a16="http://schemas.microsoft.com/office/drawing/2014/main" id="{E99F283A-98C1-4F3C-8D30-6344D0134A36}"/>
+                <a16:creationId xmlns:a16="http://schemas.microsoft.com/office/drawing/2014/main" id="{F94D1225-6047-4283-B855-6CFABBB10CE7}"/>
               </a:ext>
             </a:extLst>
           </p:cNvPr>
@@ -3926,7 +3926,7 @@
           <p:cNvPr id="4" name="text-140">
             <a:extLst xmlns:a="http://schemas.openxmlformats.org/drawingml/2006/main">
               <a:ext uri="{FF2B5EF4-FFF2-40B4-BE49-F238E27FC236}">
-                <a16:creationId xmlns:a16="http://schemas.microsoft.com/office/drawing/2014/main" id="{DC2BBBA5-D5F4-4476-B8D3-76C89A2538BF}"/>
+                <a16:creationId xmlns:a16="http://schemas.microsoft.com/office/drawing/2014/main" id="{B918996D-BC32-4299-8BDC-0DF384391FB8}"/>
               </a:ext>
             </a:extLst>
           </p:cNvPr>
@@ -3982,7 +3982,7 @@
           <p:cNvPr id="5" name="text-141">
             <a:extLst xmlns:a="http://schemas.openxmlformats.org/drawingml/2006/main">
               <a:ext uri="{FF2B5EF4-FFF2-40B4-BE49-F238E27FC236}">
-                <a16:creationId xmlns:a16="http://schemas.microsoft.com/office/drawing/2014/main" id="{00E5BBEE-9BBC-43EA-A14A-ADDF1126AA76}"/>
+                <a16:creationId xmlns:a16="http://schemas.microsoft.com/office/drawing/2014/main" id="{35C52C14-5019-4158-AF94-DC462052319B}"/>
               </a:ext>
             </a:extLst>
           </p:cNvPr>
@@ -4038,7 +4038,7 @@
           <p:cNvPr id="6" name="box-142">
             <a:extLst xmlns:a="http://schemas.openxmlformats.org/drawingml/2006/main">
               <a:ext uri="{FF2B5EF4-FFF2-40B4-BE49-F238E27FC236}">
-                <a16:creationId xmlns:a16="http://schemas.microsoft.com/office/drawing/2014/main" id="{63C443C3-0970-47C6-AD32-CDB75D788770}"/>
+                <a16:creationId xmlns:a16="http://schemas.microsoft.com/office/drawing/2014/main" id="{6D743BEA-945E-4F40-A5A9-560513A72D42}"/>
               </a:ext>
             </a:extLst>
           </p:cNvPr>
@@ -4071,7 +4071,7 @@
           <p:cNvPr id="7" name="text-143">
             <a:extLst xmlns:a="http://schemas.openxmlformats.org/drawingml/2006/main">
               <a:ext uri="{FF2B5EF4-FFF2-40B4-BE49-F238E27FC236}">
-                <a16:creationId xmlns:a16="http://schemas.microsoft.com/office/drawing/2014/main" id="{DD6CC093-5DB8-409B-A27A-D743E531789A}"/>
+                <a16:creationId xmlns:a16="http://schemas.microsoft.com/office/drawing/2014/main" id="{3D170E07-4423-45AB-B412-CBE1056716AA}"/>
               </a:ext>
             </a:extLst>
           </p:cNvPr>
@@ -4127,7 +4127,7 @@
           <p:cNvPr id="8" name="text-144">
             <a:extLst xmlns:a="http://schemas.openxmlformats.org/drawingml/2006/main">
               <a:ext uri="{FF2B5EF4-FFF2-40B4-BE49-F238E27FC236}">
-                <a16:creationId xmlns:a16="http://schemas.microsoft.com/office/drawing/2014/main" id="{A2BFC618-44EA-47E6-88D0-D1F73904D232}"/>
+                <a16:creationId xmlns:a16="http://schemas.microsoft.com/office/drawing/2014/main" id="{85D22619-1727-435A-BA6B-B6DFB95B1565}"/>
               </a:ext>
             </a:extLst>
           </p:cNvPr>
@@ -4183,7 +4183,7 @@
           <p:cNvPr id="9" name="box-145">
             <a:extLst xmlns:a="http://schemas.openxmlformats.org/drawingml/2006/main">
               <a:ext uri="{FF2B5EF4-FFF2-40B4-BE49-F238E27FC236}">
-                <a16:creationId xmlns:a16="http://schemas.microsoft.com/office/drawing/2014/main" id="{63E137E8-EF00-405F-91D4-31986B6DA0FE}"/>
+                <a16:creationId xmlns:a16="http://schemas.microsoft.com/office/drawing/2014/main" id="{2293B403-6F27-4F0D-A8E2-B856A57132A7}"/>
               </a:ext>
             </a:extLst>
           </p:cNvPr>
@@ -4216,7 +4216,7 @@
           <p:cNvPr id="10" name="text-146">
             <a:extLst xmlns:a="http://schemas.openxmlformats.org/drawingml/2006/main">
               <a:ext uri="{FF2B5EF4-FFF2-40B4-BE49-F238E27FC236}">
-                <a16:creationId xmlns:a16="http://schemas.microsoft.com/office/drawing/2014/main" id="{7263430B-DFE2-4F63-AE99-E9B62B026FCA}"/>
+                <a16:creationId xmlns:a16="http://schemas.microsoft.com/office/drawing/2014/main" id="{1FC9A800-57D1-480A-9CD3-C066D2C46C08}"/>
               </a:ext>
             </a:extLst>
           </p:cNvPr>
@@ -4272,7 +4272,7 @@
           <p:cNvPr id="11" name="text-147">
             <a:extLst xmlns:a="http://schemas.openxmlformats.org/drawingml/2006/main">
               <a:ext uri="{FF2B5EF4-FFF2-40B4-BE49-F238E27FC236}">
-                <a16:creationId xmlns:a16="http://schemas.microsoft.com/office/drawing/2014/main" id="{0AF1B2E8-8838-40B9-95A1-D29A69DC1956}"/>
+                <a16:creationId xmlns:a16="http://schemas.microsoft.com/office/drawing/2014/main" id="{D398264A-A3B0-42A9-9205-B792E77CDFB2}"/>
               </a:ext>
             </a:extLst>
           </p:cNvPr>
@@ -4328,7 +4328,7 @@
           <p:cNvPr id="12" name="box-148">
             <a:extLst xmlns:a="http://schemas.openxmlformats.org/drawingml/2006/main">
               <a:ext uri="{FF2B5EF4-FFF2-40B4-BE49-F238E27FC236}">
-                <a16:creationId xmlns:a16="http://schemas.microsoft.com/office/drawing/2014/main" id="{D9B133E7-5E0C-4B52-B6E1-1949D708AB39}"/>
+                <a16:creationId xmlns:a16="http://schemas.microsoft.com/office/drawing/2014/main" id="{94F5350D-27CB-460D-98B4-36DC87375B89}"/>
               </a:ext>
             </a:extLst>
           </p:cNvPr>
@@ -4361,7 +4361,7 @@
           <p:cNvPr id="13" name="text-149">
             <a:extLst xmlns:a="http://schemas.openxmlformats.org/drawingml/2006/main">
               <a:ext uri="{FF2B5EF4-FFF2-40B4-BE49-F238E27FC236}">
-                <a16:creationId xmlns:a16="http://schemas.microsoft.com/office/drawing/2014/main" id="{A79D07B5-1D46-4E78-8D9E-483815EB107F}"/>
+                <a16:creationId xmlns:a16="http://schemas.microsoft.com/office/drawing/2014/main" id="{BA5B28FC-7950-4865-8E49-B2CF78871064}"/>
               </a:ext>
             </a:extLst>
           </p:cNvPr>
@@ -4417,7 +4417,7 @@
           <p:cNvPr id="14" name="text-150">
             <a:extLst xmlns:a="http://schemas.openxmlformats.org/drawingml/2006/main">
               <a:ext uri="{FF2B5EF4-FFF2-40B4-BE49-F238E27FC236}">
-                <a16:creationId xmlns:a16="http://schemas.microsoft.com/office/drawing/2014/main" id="{E258D1EC-7EDB-4D0B-9AF0-69D0105B4C29}"/>
+                <a16:creationId xmlns:a16="http://schemas.microsoft.com/office/drawing/2014/main" id="{DEEB3A82-479A-433E-85E0-730B969C3B60}"/>
               </a:ext>
             </a:extLst>
           </p:cNvPr>
@@ -4473,7 +4473,7 @@
           <p:cNvPr id="15" name="box-151">
             <a:extLst xmlns:a="http://schemas.openxmlformats.org/drawingml/2006/main">
               <a:ext uri="{FF2B5EF4-FFF2-40B4-BE49-F238E27FC236}">
-                <a16:creationId xmlns:a16="http://schemas.microsoft.com/office/drawing/2014/main" id="{3D98830C-B4F4-4705-A20A-EC87E8FE6254}"/>
+                <a16:creationId xmlns:a16="http://schemas.microsoft.com/office/drawing/2014/main" id="{1B99466E-E765-4E46-8EDB-9A116C17CD16}"/>
               </a:ext>
             </a:extLst>
           </p:cNvPr>
@@ -4506,7 +4506,7 @@
           <p:cNvPr id="16" name="text-152">
             <a:extLst xmlns:a="http://schemas.openxmlformats.org/drawingml/2006/main">
               <a:ext uri="{FF2B5EF4-FFF2-40B4-BE49-F238E27FC236}">
-                <a16:creationId xmlns:a16="http://schemas.microsoft.com/office/drawing/2014/main" id="{0EDB767C-7D58-4D7D-B15B-683F90159B55}"/>
+                <a16:creationId xmlns:a16="http://schemas.microsoft.com/office/drawing/2014/main" id="{8E5C544F-92D6-4B67-A1BE-7CE4A5F4D4A6}"/>
               </a:ext>
             </a:extLst>
           </p:cNvPr>
@@ -4562,7 +4562,7 @@
           <p:cNvPr id="17" name="text-153">
             <a:extLst xmlns:a="http://schemas.openxmlformats.org/drawingml/2006/main">
               <a:ext uri="{FF2B5EF4-FFF2-40B4-BE49-F238E27FC236}">
-                <a16:creationId xmlns:a16="http://schemas.microsoft.com/office/drawing/2014/main" id="{26B94BD2-FC29-40DF-AE55-C5A8580AFDD0}"/>
+                <a16:creationId xmlns:a16="http://schemas.microsoft.com/office/drawing/2014/main" id="{00CD5CEC-614A-4214-B326-F4F548B523F7}"/>
               </a:ext>
             </a:extLst>
           </p:cNvPr>
@@ -4616,7 +4616,7 @@
     </p:spTree>
     <p:extLst>
       <p:ext uri="{BB962C8B-B14F-4D97-AF65-F5344CB8AC3E}">
-        <p14:creationId xmlns:p14="http://schemas.microsoft.com/office/powerpoint/2010/main" val="178546162"/>
+        <p14:creationId xmlns:p14="http://schemas.microsoft.com/office/powerpoint/2010/main" val="1101391503"/>
       </p:ext>
     </p:extLst>
   </p:cSld>
@@ -4647,7 +4647,7 @@
           <p:cNvPr id="21" name="box-154">
             <a:extLst xmlns:a="http://schemas.openxmlformats.org/drawingml/2006/main">
               <a:ext uri="{FF2B5EF4-FFF2-40B4-BE49-F238E27FC236}">
-                <a16:creationId xmlns:a16="http://schemas.microsoft.com/office/drawing/2014/main" id="{FAD64A88-EF53-421E-AA51-982028D55660}"/>
+                <a16:creationId xmlns:a16="http://schemas.microsoft.com/office/drawing/2014/main" id="{A2694C25-BF2A-4C7C-ABBB-D6659608A68F}"/>
               </a:ext>
             </a:extLst>
           </p:cNvPr>
@@ -4680,7 +4680,7 @@
           <p:cNvPr id="2" name="text-155">
             <a:extLst xmlns:a="http://schemas.openxmlformats.org/drawingml/2006/main">
               <a:ext uri="{FF2B5EF4-FFF2-40B4-BE49-F238E27FC236}">
-                <a16:creationId xmlns:a16="http://schemas.microsoft.com/office/drawing/2014/main" id="{8AE2E265-3DEE-4198-A0BB-2B648E46DB55}"/>
+                <a16:creationId xmlns:a16="http://schemas.microsoft.com/office/drawing/2014/main" id="{9D7BF190-ED76-4CAF-9D9F-799B3791589F}"/>
               </a:ext>
             </a:extLst>
           </p:cNvPr>
@@ -4736,7 +4736,7 @@
           <p:cNvPr id="3" name="text-156">
             <a:extLst xmlns:a="http://schemas.openxmlformats.org/drawingml/2006/main">
               <a:ext uri="{FF2B5EF4-FFF2-40B4-BE49-F238E27FC236}">
-                <a16:creationId xmlns:a16="http://schemas.microsoft.com/office/drawing/2014/main" id="{B7838C0D-94F9-4B5F-8428-CD1F927D14BD}"/>
+                <a16:creationId xmlns:a16="http://schemas.microsoft.com/office/drawing/2014/main" id="{033DE3FA-B32E-43A4-A577-648CCACE13D5}"/>
               </a:ext>
             </a:extLst>
           </p:cNvPr>
@@ -4792,7 +4792,7 @@
           <p:cNvPr id="4" name="text-157">
             <a:extLst xmlns:a="http://schemas.openxmlformats.org/drawingml/2006/main">
               <a:ext uri="{FF2B5EF4-FFF2-40B4-BE49-F238E27FC236}">
-                <a16:creationId xmlns:a16="http://schemas.microsoft.com/office/drawing/2014/main" id="{85C16B06-0C9B-4B10-8D25-081CF832DD0F}"/>
+                <a16:creationId xmlns:a16="http://schemas.microsoft.com/office/drawing/2014/main" id="{F89BD8C9-65A1-4ABA-9313-09856E559000}"/>
               </a:ext>
             </a:extLst>
           </p:cNvPr>
@@ -4848,7 +4848,7 @@
           <p:cNvPr id="5" name="text-158">
             <a:extLst xmlns:a="http://schemas.openxmlformats.org/drawingml/2006/main">
               <a:ext uri="{FF2B5EF4-FFF2-40B4-BE49-F238E27FC236}">
-                <a16:creationId xmlns:a16="http://schemas.microsoft.com/office/drawing/2014/main" id="{CC52C43F-0C87-487E-8C84-3B8AE8314386}"/>
+                <a16:creationId xmlns:a16="http://schemas.microsoft.com/office/drawing/2014/main" id="{989CCBB7-97B9-4880-8587-BD960C1F10B1}"/>
               </a:ext>
             </a:extLst>
           </p:cNvPr>
@@ -4904,7 +4904,7 @@
           <p:cNvPr id="6" name="box-159">
             <a:extLst xmlns:a="http://schemas.openxmlformats.org/drawingml/2006/main">
               <a:ext uri="{FF2B5EF4-FFF2-40B4-BE49-F238E27FC236}">
-                <a16:creationId xmlns:a16="http://schemas.microsoft.com/office/drawing/2014/main" id="{35CE7BF3-71FB-4A50-A430-143FD7ADD60B}"/>
+                <a16:creationId xmlns:a16="http://schemas.microsoft.com/office/drawing/2014/main" id="{38F3EDFE-6744-44AD-A8AD-2DAE0EBEACDF}"/>
               </a:ext>
             </a:extLst>
           </p:cNvPr>
@@ -4937,7 +4937,7 @@
           <p:cNvPr id="7" name="dot-160">
             <a:extLst xmlns:a="http://schemas.openxmlformats.org/drawingml/2006/main">
               <a:ext uri="{FF2B5EF4-FFF2-40B4-BE49-F238E27FC236}">
-                <a16:creationId xmlns:a16="http://schemas.microsoft.com/office/drawing/2014/main" id="{B3A794AC-AE50-4509-BC75-19EE0A8C167F}"/>
+                <a16:creationId xmlns:a16="http://schemas.microsoft.com/office/drawing/2014/main" id="{23A193E1-C1E4-426C-B1B4-F21F97322E9E}"/>
               </a:ext>
             </a:extLst>
           </p:cNvPr>
@@ -4968,7 +4968,7 @@
           <p:cNvPr id="8" name="text-161">
             <a:extLst xmlns:a="http://schemas.openxmlformats.org/drawingml/2006/main">
               <a:ext uri="{FF2B5EF4-FFF2-40B4-BE49-F238E27FC236}">
-                <a16:creationId xmlns:a16="http://schemas.microsoft.com/office/drawing/2014/main" id="{34E45892-369B-48E6-8EAD-8194C999A3E0}"/>
+                <a16:creationId xmlns:a16="http://schemas.microsoft.com/office/drawing/2014/main" id="{AD53C560-38C5-45F4-BB20-CC63B85E1653}"/>
               </a:ext>
             </a:extLst>
           </p:cNvPr>
@@ -5024,7 +5024,7 @@
           <p:cNvPr id="9" name="text-162">
             <a:extLst xmlns:a="http://schemas.openxmlformats.org/drawingml/2006/main">
               <a:ext uri="{FF2B5EF4-FFF2-40B4-BE49-F238E27FC236}">
-                <a16:creationId xmlns:a16="http://schemas.microsoft.com/office/drawing/2014/main" id="{612DEE05-5560-4734-B17B-1A6AB193C730}"/>
+                <a16:creationId xmlns:a16="http://schemas.microsoft.com/office/drawing/2014/main" id="{82B920FA-C8C9-4A7A-AF7C-FCF3F2699F66}"/>
               </a:ext>
             </a:extLst>
           </p:cNvPr>
@@ -5080,7 +5080,7 @@
           <p:cNvPr id="10" name="text-163">
             <a:extLst xmlns:a="http://schemas.openxmlformats.org/drawingml/2006/main">
               <a:ext uri="{FF2B5EF4-FFF2-40B4-BE49-F238E27FC236}">
-                <a16:creationId xmlns:a16="http://schemas.microsoft.com/office/drawing/2014/main" id="{40CC8121-7455-4815-924E-967E10EBA3DA}"/>
+                <a16:creationId xmlns:a16="http://schemas.microsoft.com/office/drawing/2014/main" id="{8CD6B89A-1EF0-458B-955C-28D1DD23DCFD}"/>
               </a:ext>
             </a:extLst>
           </p:cNvPr>
@@ -5136,7 +5136,7 @@
           <p:cNvPr id="11" name="dot-164">
             <a:extLst xmlns:a="http://schemas.openxmlformats.org/drawingml/2006/main">
               <a:ext uri="{FF2B5EF4-FFF2-40B4-BE49-F238E27FC236}">
-                <a16:creationId xmlns:a16="http://schemas.microsoft.com/office/drawing/2014/main" id="{B82E5388-2D1F-43EE-8004-C1A7BDE32A76}"/>
+                <a16:creationId xmlns:a16="http://schemas.microsoft.com/office/drawing/2014/main" id="{5D0F53A3-D562-4AD2-863E-E49CBFEC58F2}"/>
               </a:ext>
             </a:extLst>
           </p:cNvPr>
@@ -5167,7 +5167,7 @@
           <p:cNvPr id="12" name="text-165">
             <a:extLst xmlns:a="http://schemas.openxmlformats.org/drawingml/2006/main">
               <a:ext uri="{FF2B5EF4-FFF2-40B4-BE49-F238E27FC236}">
-                <a16:creationId xmlns:a16="http://schemas.microsoft.com/office/drawing/2014/main" id="{C8B64B5C-BF1C-4056-8ABD-83C73E6E6F11}"/>
+                <a16:creationId xmlns:a16="http://schemas.microsoft.com/office/drawing/2014/main" id="{FFDA49E4-B7FB-4074-99EC-E31A2BDEEAD2}"/>
               </a:ext>
             </a:extLst>
           </p:cNvPr>
@@ -5223,7 +5223,7 @@
           <p:cNvPr id="13" name="text-166">
             <a:extLst xmlns:a="http://schemas.openxmlformats.org/drawingml/2006/main">
               <a:ext uri="{FF2B5EF4-FFF2-40B4-BE49-F238E27FC236}">
-                <a16:creationId xmlns:a16="http://schemas.microsoft.com/office/drawing/2014/main" id="{EF332CEB-05C1-4916-96DE-B83BBE2639C8}"/>
+                <a16:creationId xmlns:a16="http://schemas.microsoft.com/office/drawing/2014/main" id="{2F9BE5B7-E307-484F-8AE0-AAC149D91940}"/>
               </a:ext>
             </a:extLst>
           </p:cNvPr>
@@ -5279,7 +5279,7 @@
           <p:cNvPr id="14" name="text-167">
             <a:extLst xmlns:a="http://schemas.openxmlformats.org/drawingml/2006/main">
               <a:ext uri="{FF2B5EF4-FFF2-40B4-BE49-F238E27FC236}">
-                <a16:creationId xmlns:a16="http://schemas.microsoft.com/office/drawing/2014/main" id="{9EEF3A88-06FD-433D-8121-79FB9ED0B284}"/>
+                <a16:creationId xmlns:a16="http://schemas.microsoft.com/office/drawing/2014/main" id="{2613D64D-57F0-4C43-B5AA-785D45289B09}"/>
               </a:ext>
             </a:extLst>
           </p:cNvPr>
@@ -5335,7 +5335,7 @@
           <p:cNvPr id="15" name="dot-168">
             <a:extLst xmlns:a="http://schemas.openxmlformats.org/drawingml/2006/main">
               <a:ext uri="{FF2B5EF4-FFF2-40B4-BE49-F238E27FC236}">
-                <a16:creationId xmlns:a16="http://schemas.microsoft.com/office/drawing/2014/main" id="{8C549CD1-31C1-4A9B-A24C-CD0E4CFD1044}"/>
+                <a16:creationId xmlns:a16="http://schemas.microsoft.com/office/drawing/2014/main" id="{52A90B35-29FE-4B6C-8BC8-2F22D641203E}"/>
               </a:ext>
             </a:extLst>
           </p:cNvPr>
@@ -5366,7 +5366,7 @@
           <p:cNvPr id="16" name="text-169">
             <a:extLst xmlns:a="http://schemas.openxmlformats.org/drawingml/2006/main">
               <a:ext uri="{FF2B5EF4-FFF2-40B4-BE49-F238E27FC236}">
-                <a16:creationId xmlns:a16="http://schemas.microsoft.com/office/drawing/2014/main" id="{89F28C62-63B1-4DBB-8AD6-F37EABE8A82D}"/>
+                <a16:creationId xmlns:a16="http://schemas.microsoft.com/office/drawing/2014/main" id="{C86A5D85-0820-4849-B820-F6046A3839CA}"/>
               </a:ext>
             </a:extLst>
           </p:cNvPr>
@@ -5422,7 +5422,7 @@
           <p:cNvPr id="17" name="text-170">
             <a:extLst xmlns:a="http://schemas.openxmlformats.org/drawingml/2006/main">
               <a:ext uri="{FF2B5EF4-FFF2-40B4-BE49-F238E27FC236}">
-                <a16:creationId xmlns:a16="http://schemas.microsoft.com/office/drawing/2014/main" id="{2C9C04D9-5053-403D-B7A3-67C8AC4382FA}"/>
+                <a16:creationId xmlns:a16="http://schemas.microsoft.com/office/drawing/2014/main" id="{F981E8E3-3B29-4F91-B969-835C469AF9E1}"/>
               </a:ext>
             </a:extLst>
           </p:cNvPr>
@@ -5478,7 +5478,7 @@
           <p:cNvPr id="18" name="text-171">
             <a:extLst xmlns:a="http://schemas.openxmlformats.org/drawingml/2006/main">
               <a:ext uri="{FF2B5EF4-FFF2-40B4-BE49-F238E27FC236}">
-                <a16:creationId xmlns:a16="http://schemas.microsoft.com/office/drawing/2014/main" id="{9E0BF4EF-5259-488C-8278-61FBCD604E4A}"/>
+                <a16:creationId xmlns:a16="http://schemas.microsoft.com/office/drawing/2014/main" id="{642BBC0B-9D09-4CDC-B449-EF4A410D85EA}"/>
               </a:ext>
             </a:extLst>
           </p:cNvPr>
@@ -5534,7 +5534,7 @@
           <p:cNvPr id="19" name="box-172">
             <a:extLst xmlns:a="http://schemas.openxmlformats.org/drawingml/2006/main">
               <a:ext uri="{FF2B5EF4-FFF2-40B4-BE49-F238E27FC236}">
-                <a16:creationId xmlns:a16="http://schemas.microsoft.com/office/drawing/2014/main" id="{F735ED2C-1FA0-4D50-AB90-92045F3F0FFA}"/>
+                <a16:creationId xmlns:a16="http://schemas.microsoft.com/office/drawing/2014/main" id="{47BEDF10-B5FA-4FD9-8C0E-3081995AA5E0}"/>
               </a:ext>
             </a:extLst>
           </p:cNvPr>
@@ -5567,7 +5567,7 @@
           <p:cNvPr id="20" name="text-173">
             <a:extLst xmlns:a="http://schemas.openxmlformats.org/drawingml/2006/main">
               <a:ext uri="{FF2B5EF4-FFF2-40B4-BE49-F238E27FC236}">
-                <a16:creationId xmlns:a16="http://schemas.microsoft.com/office/drawing/2014/main" id="{7FF74AAE-5F93-4D19-90C8-FC05526D0FFB}"/>
+                <a16:creationId xmlns:a16="http://schemas.microsoft.com/office/drawing/2014/main" id="{C0174AED-58FD-40B3-9C16-9758D2F34FBE}"/>
               </a:ext>
             </a:extLst>
           </p:cNvPr>
@@ -5621,7 +5621,7 @@
     </p:spTree>
     <p:extLst>
       <p:ext uri="{BB962C8B-B14F-4D97-AF65-F5344CB8AC3E}">
-        <p14:creationId xmlns:p14="http://schemas.microsoft.com/office/powerpoint/2010/main" val="342098189"/>
+        <p14:creationId xmlns:p14="http://schemas.microsoft.com/office/powerpoint/2010/main" val="1150506508"/>
       </p:ext>
     </p:extLst>
   </p:cSld>
@@ -5652,7 +5652,7 @@
           <p:cNvPr id="18" name="box-174">
             <a:extLst xmlns:a="http://schemas.openxmlformats.org/drawingml/2006/main">
               <a:ext uri="{FF2B5EF4-FFF2-40B4-BE49-F238E27FC236}">
-                <a16:creationId xmlns:a16="http://schemas.microsoft.com/office/drawing/2014/main" id="{7565604A-90F0-431E-BD69-003023C9DDB9}"/>
+                <a16:creationId xmlns:a16="http://schemas.microsoft.com/office/drawing/2014/main" id="{8884ED1E-2624-4FBD-8CF3-117D41F57DB2}"/>
               </a:ext>
             </a:extLst>
           </p:cNvPr>
@@ -5685,7 +5685,7 @@
           <p:cNvPr id="2" name="text-175">
             <a:extLst xmlns:a="http://schemas.openxmlformats.org/drawingml/2006/main">
               <a:ext uri="{FF2B5EF4-FFF2-40B4-BE49-F238E27FC236}">
-                <a16:creationId xmlns:a16="http://schemas.microsoft.com/office/drawing/2014/main" id="{5921C001-5EF5-4F57-9F9A-7387BE12E4C5}"/>
+                <a16:creationId xmlns:a16="http://schemas.microsoft.com/office/drawing/2014/main" id="{2C842D71-3E9E-444A-A09A-1948BDDA92A6}"/>
               </a:ext>
             </a:extLst>
           </p:cNvPr>
@@ -5741,7 +5741,7 @@
           <p:cNvPr id="3" name="text-176">
             <a:extLst xmlns:a="http://schemas.openxmlformats.org/drawingml/2006/main">
               <a:ext uri="{FF2B5EF4-FFF2-40B4-BE49-F238E27FC236}">
-                <a16:creationId xmlns:a16="http://schemas.microsoft.com/office/drawing/2014/main" id="{3015BD00-DD25-445B-8BC3-769AE97250D1}"/>
+                <a16:creationId xmlns:a16="http://schemas.microsoft.com/office/drawing/2014/main" id="{19AD03AB-9EC5-4B7A-82F6-8BD58AAC0558}"/>
               </a:ext>
             </a:extLst>
           </p:cNvPr>
@@ -5797,7 +5797,7 @@
           <p:cNvPr id="4" name="text-177">
             <a:extLst xmlns:a="http://schemas.openxmlformats.org/drawingml/2006/main">
               <a:ext uri="{FF2B5EF4-FFF2-40B4-BE49-F238E27FC236}">
-                <a16:creationId xmlns:a16="http://schemas.microsoft.com/office/drawing/2014/main" id="{14BC9C73-9CEF-4B23-AB09-ABE47F59475E}"/>
+                <a16:creationId xmlns:a16="http://schemas.microsoft.com/office/drawing/2014/main" id="{979EE7BF-3726-4738-9A47-989DBCBA7777}"/>
               </a:ext>
             </a:extLst>
           </p:cNvPr>
@@ -5853,7 +5853,7 @@
           <p:cNvPr id="5" name="text-178">
             <a:extLst xmlns:a="http://schemas.openxmlformats.org/drawingml/2006/main">
               <a:ext uri="{FF2B5EF4-FFF2-40B4-BE49-F238E27FC236}">
-                <a16:creationId xmlns:a16="http://schemas.microsoft.com/office/drawing/2014/main" id="{67A1C5CE-DDC2-4FA8-9D54-A550AE3419DE}"/>
+                <a16:creationId xmlns:a16="http://schemas.microsoft.com/office/drawing/2014/main" id="{FF04E97E-40BF-4A8B-BE18-ABC4D2C8D92B}"/>
               </a:ext>
             </a:extLst>
           </p:cNvPr>
@@ -5909,7 +5909,7 @@
           <p:cNvPr id="6" name="text-179">
             <a:extLst xmlns:a="http://schemas.openxmlformats.org/drawingml/2006/main">
               <a:ext uri="{FF2B5EF4-FFF2-40B4-BE49-F238E27FC236}">
-                <a16:creationId xmlns:a16="http://schemas.microsoft.com/office/drawing/2014/main" id="{EBAFADC1-9957-4F9E-A1AE-580789900CBC}"/>
+                <a16:creationId xmlns:a16="http://schemas.microsoft.com/office/drawing/2014/main" id="{0B52263F-53B9-4442-9390-09B62BA2919B}"/>
               </a:ext>
             </a:extLst>
           </p:cNvPr>
@@ -5965,7 +5965,7 @@
           <p:cNvPr id="7" name="text-180">
             <a:extLst xmlns:a="http://schemas.openxmlformats.org/drawingml/2006/main">
               <a:ext uri="{FF2B5EF4-FFF2-40B4-BE49-F238E27FC236}">
-                <a16:creationId xmlns:a16="http://schemas.microsoft.com/office/drawing/2014/main" id="{40238631-3635-4AB1-80E6-CCF2FF848778}"/>
+                <a16:creationId xmlns:a16="http://schemas.microsoft.com/office/drawing/2014/main" id="{67F18CE7-BA50-4EE2-909A-07EA765A66D9}"/>
               </a:ext>
             </a:extLst>
           </p:cNvPr>
@@ -6021,7 +6021,7 @@
           <p:cNvPr id="8" name="text-181">
             <a:extLst xmlns:a="http://schemas.openxmlformats.org/drawingml/2006/main">
               <a:ext uri="{FF2B5EF4-FFF2-40B4-BE49-F238E27FC236}">
-                <a16:creationId xmlns:a16="http://schemas.microsoft.com/office/drawing/2014/main" id="{FB2BEE98-785F-4AF0-A26B-ADFFE9605200}"/>
+                <a16:creationId xmlns:a16="http://schemas.microsoft.com/office/drawing/2014/main" id="{DAC236D4-EBC1-4944-97ED-E693F73A3BB9}"/>
               </a:ext>
             </a:extLst>
           </p:cNvPr>
@@ -6067,7 +6067,7 @@
                 <a:ea typeface="Arial"/>
                 <a:cs typeface="Arial"/>
               </a:rPr>
-              <a:t>62 / 62</a:t>
+              <a:t>68 / 68</a:t>
             </a:r>
           </a:p>
         </p:txBody>
@@ -6077,7 +6077,7 @@
           <p:cNvPr id="9" name="text-182">
             <a:extLst xmlns:a="http://schemas.openxmlformats.org/drawingml/2006/main">
               <a:ext uri="{FF2B5EF4-FFF2-40B4-BE49-F238E27FC236}">
-                <a16:creationId xmlns:a16="http://schemas.microsoft.com/office/drawing/2014/main" id="{31FF7CFC-D8E2-4B7E-BBFB-0DB06E280799}"/>
+                <a16:creationId xmlns:a16="http://schemas.microsoft.com/office/drawing/2014/main" id="{D7DE910B-FDF2-4463-8ADD-9D1ABE64E28A}"/>
               </a:ext>
             </a:extLst>
           </p:cNvPr>
@@ -6133,7 +6133,7 @@
           <p:cNvPr id="10" name="text-183">
             <a:extLst xmlns:a="http://schemas.openxmlformats.org/drawingml/2006/main">
               <a:ext uri="{FF2B5EF4-FFF2-40B4-BE49-F238E27FC236}">
-                <a16:creationId xmlns:a16="http://schemas.microsoft.com/office/drawing/2014/main" id="{1B42DCCB-504D-4C2D-A998-D1BCE3DB17CD}"/>
+                <a16:creationId xmlns:a16="http://schemas.microsoft.com/office/drawing/2014/main" id="{2CC183CA-DAD4-456D-8AC0-A8365F2267E5}"/>
               </a:ext>
             </a:extLst>
           </p:cNvPr>
@@ -6235,7 +6235,7 @@
           <p:cNvPr id="11" name="text-184">
             <a:extLst xmlns:a="http://schemas.openxmlformats.org/drawingml/2006/main">
               <a:ext uri="{FF2B5EF4-FFF2-40B4-BE49-F238E27FC236}">
-                <a16:creationId xmlns:a16="http://schemas.microsoft.com/office/drawing/2014/main" id="{924E9802-D00A-486A-A04D-FC9F439E8016}"/>
+                <a16:creationId xmlns:a16="http://schemas.microsoft.com/office/drawing/2014/main" id="{A0A536D7-FFBC-4B20-A013-D75D1F99AF2C}"/>
               </a:ext>
             </a:extLst>
           </p:cNvPr>
@@ -6337,7 +6337,7 @@
           <p:cNvPr id="12" name="text-185">
             <a:extLst xmlns:a="http://schemas.openxmlformats.org/drawingml/2006/main">
               <a:ext uri="{FF2B5EF4-FFF2-40B4-BE49-F238E27FC236}">
-                <a16:creationId xmlns:a16="http://schemas.microsoft.com/office/drawing/2014/main" id="{BE3AA4A2-C702-4D7E-956C-83B53AA45771}"/>
+                <a16:creationId xmlns:a16="http://schemas.microsoft.com/office/drawing/2014/main" id="{5D99C3F2-B67B-4981-B5CA-357A06D90F9E}"/>
               </a:ext>
             </a:extLst>
           </p:cNvPr>
@@ -6439,7 +6439,7 @@
           <p:cNvPr id="13" name="box-186">
             <a:extLst xmlns:a="http://schemas.openxmlformats.org/drawingml/2006/main">
               <a:ext uri="{FF2B5EF4-FFF2-40B4-BE49-F238E27FC236}">
-                <a16:creationId xmlns:a16="http://schemas.microsoft.com/office/drawing/2014/main" id="{CC80DDA1-3E8A-42BA-B9CC-04B9B3122F38}"/>
+                <a16:creationId xmlns:a16="http://schemas.microsoft.com/office/drawing/2014/main" id="{00FCDBB3-BEE0-4CE0-A8CF-5D1410B1B12F}"/>
               </a:ext>
             </a:extLst>
           </p:cNvPr>
@@ -6472,7 +6472,7 @@
           <p:cNvPr id="14" name="text-187">
             <a:extLst xmlns:a="http://schemas.openxmlformats.org/drawingml/2006/main">
               <a:ext uri="{FF2B5EF4-FFF2-40B4-BE49-F238E27FC236}">
-                <a16:creationId xmlns:a16="http://schemas.microsoft.com/office/drawing/2014/main" id="{86D29E27-0120-47DE-B0EF-5EC5769DF10B}"/>
+                <a16:creationId xmlns:a16="http://schemas.microsoft.com/office/drawing/2014/main" id="{B6F694B4-DFBA-41B9-9AD2-4576D064FE20}"/>
               </a:ext>
             </a:extLst>
           </p:cNvPr>
@@ -6528,7 +6528,7 @@
           <p:cNvPr id="15" name="text-188">
             <a:extLst xmlns:a="http://schemas.openxmlformats.org/drawingml/2006/main">
               <a:ext uri="{FF2B5EF4-FFF2-40B4-BE49-F238E27FC236}">
-                <a16:creationId xmlns:a16="http://schemas.microsoft.com/office/drawing/2014/main" id="{2EFB9BE0-9289-4FD7-885E-47D014724534}"/>
+                <a16:creationId xmlns:a16="http://schemas.microsoft.com/office/drawing/2014/main" id="{D6CEDB6C-55BF-4ECB-BB2B-D007E0B1EA2D}"/>
               </a:ext>
             </a:extLst>
           </p:cNvPr>
@@ -6574,7 +6574,7 @@
                 <a:ea typeface="Arial"/>
                 <a:cs typeface="Arial"/>
               </a:rPr>
-              <a:t>Windows 10/11 (x64) + macOS (Apple Silicon) — İndirme: github.com/Azizsekerdil/FrenchCourseAI/releases (v1.1.0) · (özel repo)</a:t>
+              <a:t>Windows 10/11 (x64) + macOS (Apple Silicon) — İndirme: github.com/Azizsekerdil/FrenchCourseAI/releases (v1.1.1) · (özel repo)</a:t>
             </a:r>
           </a:p>
         </p:txBody>
@@ -6584,7 +6584,7 @@
           <p:cNvPr id="16" name="text-189">
             <a:extLst xmlns:a="http://schemas.openxmlformats.org/drawingml/2006/main">
               <a:ext uri="{FF2B5EF4-FFF2-40B4-BE49-F238E27FC236}">
-                <a16:creationId xmlns:a16="http://schemas.microsoft.com/office/drawing/2014/main" id="{FB1A4828-AD6F-43BA-BB20-CD9E9457998B}"/>
+                <a16:creationId xmlns:a16="http://schemas.microsoft.com/office/drawing/2014/main" id="{90C595AD-C4B1-475F-A3F5-40F621552F6E}"/>
               </a:ext>
             </a:extLst>
           </p:cNvPr>
@@ -6630,7 +6630,7 @@
                 <a:ea typeface="Arial"/>
                 <a:cs typeface="Arial"/>
               </a:rPr>
-              <a:t>Windows 10/11 (x64) &amp; macOS (Apple Silicon) — Download: GitHub Releases (v1.1.0)</a:t>
+              <a:t>Windows 10/11 (x64) &amp; macOS (Apple Silicon) — Download: GitHub Releases (v1.1.1)</a:t>
             </a:r>
           </a:p>
         </p:txBody>
@@ -6640,7 +6640,7 @@
           <p:cNvPr id="17" name="text-190">
             <a:extLst xmlns:a="http://schemas.openxmlformats.org/drawingml/2006/main">
               <a:ext uri="{FF2B5EF4-FFF2-40B4-BE49-F238E27FC236}">
-                <a16:creationId xmlns:a16="http://schemas.microsoft.com/office/drawing/2014/main" id="{33B379C1-D365-41AC-A606-7D149199193B}"/>
+                <a16:creationId xmlns:a16="http://schemas.microsoft.com/office/drawing/2014/main" id="{329A84B0-4595-4686-AADA-B620AB1CE0EC}"/>
               </a:ext>
             </a:extLst>
           </p:cNvPr>
@@ -6694,7 +6694,7 @@
     </p:spTree>
     <p:extLst>
       <p:ext uri="{BB962C8B-B14F-4D97-AF65-F5344CB8AC3E}">
-        <p14:creationId xmlns:p14="http://schemas.microsoft.com/office/powerpoint/2010/main" val="1118332856"/>
+        <p14:creationId xmlns:p14="http://schemas.microsoft.com/office/powerpoint/2010/main" val="537961290"/>
       </p:ext>
     </p:extLst>
   </p:cSld>

</xml_diff>

<commit_message>
Sunum: v1.1.2 indirme bilgileri, 70 test
Co-Authored-By: Claude Fable 5.1 <noreply@anthropic.com>
</commit_message>
<xml_diff>
--- a/docs/presentation/French-Course-AI-Trilingual.pptx
+++ b/docs/presentation/French-Course-AI-Trilingual.pptx
@@ -2,18 +2,18 @@
 <file path=ppt/presentation.xml><?xml version="1.0" encoding="utf-8"?>
 <p:presentation xmlns:p="http://schemas.openxmlformats.org/presentationml/2006/main">
   <p:sldMasterIdLst>
-    <p:sldMasterId xmlns:r="http://schemas.openxmlformats.org/officeDocument/2006/relationships" id="2147483648" r:id="R267d342cafaa4d19"/>
+    <p:sldMasterId xmlns:r="http://schemas.openxmlformats.org/officeDocument/2006/relationships" id="2147483648" r:id="R858a7a852b0248f4"/>
   </p:sldMasterIdLst>
   <p:notesMasterIdLst>
-    <p:notesMasterId xmlns:r="http://schemas.openxmlformats.org/officeDocument/2006/relationships" r:id="R935c4e6952ff410e"/>
+    <p:notesMasterId xmlns:r="http://schemas.openxmlformats.org/officeDocument/2006/relationships" r:id="R52316acd1f3d4259"/>
   </p:notesMasterIdLst>
   <p:sldIdLst>
-    <p:sldId xmlns:r="http://schemas.openxmlformats.org/officeDocument/2006/relationships" id="256" r:id="Rf6f81e9999144e57"/>
-    <p:sldId xmlns:r="http://schemas.openxmlformats.org/officeDocument/2006/relationships" id="257" r:id="R019dcd2818374a49"/>
-    <p:sldId xmlns:r="http://schemas.openxmlformats.org/officeDocument/2006/relationships" id="258" r:id="Rc279a97c82824023"/>
-    <p:sldId xmlns:r="http://schemas.openxmlformats.org/officeDocument/2006/relationships" id="259" r:id="Rd900bfa8f9df4d5c"/>
-    <p:sldId xmlns:r="http://schemas.openxmlformats.org/officeDocument/2006/relationships" id="260" r:id="R936b9016072c48d9"/>
-    <p:sldId xmlns:r="http://schemas.openxmlformats.org/officeDocument/2006/relationships" id="261" r:id="R7b57e506c3c74885"/>
+    <p:sldId xmlns:r="http://schemas.openxmlformats.org/officeDocument/2006/relationships" id="256" r:id="R9a0e630ba4724386"/>
+    <p:sldId xmlns:r="http://schemas.openxmlformats.org/officeDocument/2006/relationships" id="257" r:id="R3f58a6c03f624fdc"/>
+    <p:sldId xmlns:r="http://schemas.openxmlformats.org/officeDocument/2006/relationships" id="258" r:id="Rbd541fd432e34552"/>
+    <p:sldId xmlns:r="http://schemas.openxmlformats.org/officeDocument/2006/relationships" id="259" r:id="R14bc54267b38482b"/>
+    <p:sldId xmlns:r="http://schemas.openxmlformats.org/officeDocument/2006/relationships" id="260" r:id="R976b6544eca749cb"/>
+    <p:sldId xmlns:r="http://schemas.openxmlformats.org/officeDocument/2006/relationships" id="261" r:id="R6ac2e06f3ace4f84"/>
   </p:sldIdLst>
   <p:sldSz cx="12192000" cy="6858000"/>
   <p:notesSz cx="6858000" cy="9144000"/>
@@ -937,7 +937,7 @@
           </a:p>
           <a:p xmlns:a="http://schemas.openxmlformats.org/drawingml/2006/main">
             <a:r>
-              <a:t>- https://github.com/Azizsekerdil/FrenchCourseAI/releases/tag/v1.1.1</a:t>
+              <a:t>- https://github.com/Azizsekerdil/FrenchCourseAI/releases/tag/v1.1.2</a:t>
             </a:r>
           </a:p>
           <a:p xmlns:a="http://schemas.openxmlformats.org/drawingml/2006/main">
@@ -1010,7 +1010,7 @@
   </p:cSld>
   <p:clrMap bg1="lt1" tx1="dk1" bg2="lt2" tx2="dk2" accent1="accent1" accent2="accent2" accent3="accent3" accent4="accent4" accent5="accent5" accent6="accent6" hlink="hlink" folHlink="folHlink"/>
   <p:sldLayoutIdLst>
-    <p:sldLayoutId xmlns:r="http://schemas.openxmlformats.org/officeDocument/2006/relationships" id="2147483649" r:id="R03be0b00e6cd4eb1"/>
+    <p:sldLayoutId xmlns:r="http://schemas.openxmlformats.org/officeDocument/2006/relationships" id="2147483649" r:id="Rd6304f18c6b44270"/>
   </p:sldLayoutIdLst>
   <p:txStyles>
     <p:titleStyle>
@@ -1561,7 +1561,7 @@
           <p:cNvPr id="13" name="box-96">
             <a:extLst xmlns:a="http://schemas.openxmlformats.org/drawingml/2006/main">
               <a:ext uri="{FF2B5EF4-FFF2-40B4-BE49-F238E27FC236}">
-                <a16:creationId xmlns:a16="http://schemas.microsoft.com/office/drawing/2014/main" id="{6D5CE4F0-5AC0-41B0-9ECD-C43221673865}"/>
+                <a16:creationId xmlns:a16="http://schemas.microsoft.com/office/drawing/2014/main" id="{659231FC-90EE-44F5-A438-8E9D1EC9F661}"/>
               </a:ext>
             </a:extLst>
           </p:cNvPr>
@@ -1594,7 +1594,7 @@
           <p:cNvPr id="2" name="text-97">
             <a:extLst xmlns:a="http://schemas.openxmlformats.org/drawingml/2006/main">
               <a:ext uri="{FF2B5EF4-FFF2-40B4-BE49-F238E27FC236}">
-                <a16:creationId xmlns:a16="http://schemas.microsoft.com/office/drawing/2014/main" id="{3C33AF64-DCA5-42F0-B902-9C126EB2F231}"/>
+                <a16:creationId xmlns:a16="http://schemas.microsoft.com/office/drawing/2014/main" id="{682CB357-B419-4104-A112-13F7549FF62A}"/>
               </a:ext>
             </a:extLst>
           </p:cNvPr>
@@ -1650,7 +1650,7 @@
           <p:cNvPr id="3" name="text-98">
             <a:extLst xmlns:a="http://schemas.openxmlformats.org/drawingml/2006/main">
               <a:ext uri="{FF2B5EF4-FFF2-40B4-BE49-F238E27FC236}">
-                <a16:creationId xmlns:a16="http://schemas.microsoft.com/office/drawing/2014/main" id="{5207D1BF-7839-405E-BDDF-3DB6770C394A}"/>
+                <a16:creationId xmlns:a16="http://schemas.microsoft.com/office/drawing/2014/main" id="{CCB917A1-41A0-411B-962B-BF200533DBC9}"/>
               </a:ext>
             </a:extLst>
           </p:cNvPr>
@@ -1706,7 +1706,7 @@
           <p:cNvPr id="4" name="text-99">
             <a:extLst xmlns:a="http://schemas.openxmlformats.org/drawingml/2006/main">
               <a:ext uri="{FF2B5EF4-FFF2-40B4-BE49-F238E27FC236}">
-                <a16:creationId xmlns:a16="http://schemas.microsoft.com/office/drawing/2014/main" id="{35187BB4-E2A4-429E-B3F8-EBD9385F703D}"/>
+                <a16:creationId xmlns:a16="http://schemas.microsoft.com/office/drawing/2014/main" id="{4EE4AC98-81EA-4FA3-A42D-8E32A659FF02}"/>
               </a:ext>
             </a:extLst>
           </p:cNvPr>
@@ -1762,7 +1762,7 @@
           <p:cNvPr id="5" name="text-100">
             <a:extLst xmlns:a="http://schemas.openxmlformats.org/drawingml/2006/main">
               <a:ext uri="{FF2B5EF4-FFF2-40B4-BE49-F238E27FC236}">
-                <a16:creationId xmlns:a16="http://schemas.microsoft.com/office/drawing/2014/main" id="{8AE65BC9-56D1-4F82-A3FF-B9425BFCEF73}"/>
+                <a16:creationId xmlns:a16="http://schemas.microsoft.com/office/drawing/2014/main" id="{52C4F760-6050-4BFB-A9D3-05C73A1F670A}"/>
               </a:ext>
             </a:extLst>
           </p:cNvPr>
@@ -1818,7 +1818,7 @@
           <p:cNvPr id="6" name="text-101">
             <a:extLst xmlns:a="http://schemas.openxmlformats.org/drawingml/2006/main">
               <a:ext uri="{FF2B5EF4-FFF2-40B4-BE49-F238E27FC236}">
-                <a16:creationId xmlns:a16="http://schemas.microsoft.com/office/drawing/2014/main" id="{3419C497-7425-4FFC-A34E-488B994B4390}"/>
+                <a16:creationId xmlns:a16="http://schemas.microsoft.com/office/drawing/2014/main" id="{3D14FD1F-3EE8-4FE0-BEB1-0F714379CFFE}"/>
               </a:ext>
             </a:extLst>
           </p:cNvPr>
@@ -1874,7 +1874,7 @@
           <p:cNvPr id="7" name="text-102">
             <a:extLst xmlns:a="http://schemas.openxmlformats.org/drawingml/2006/main">
               <a:ext uri="{FF2B5EF4-FFF2-40B4-BE49-F238E27FC236}">
-                <a16:creationId xmlns:a16="http://schemas.microsoft.com/office/drawing/2014/main" id="{23F43529-8645-4519-B62F-050D5CFB9EF1}"/>
+                <a16:creationId xmlns:a16="http://schemas.microsoft.com/office/drawing/2014/main" id="{F22EEA0E-A2D0-4CCB-A9DD-795F11C8DE63}"/>
               </a:ext>
             </a:extLst>
           </p:cNvPr>
@@ -1930,7 +1930,7 @@
           <p:cNvPr id="8" name="text-103">
             <a:extLst xmlns:a="http://schemas.openxmlformats.org/drawingml/2006/main">
               <a:ext uri="{FF2B5EF4-FFF2-40B4-BE49-F238E27FC236}">
-                <a16:creationId xmlns:a16="http://schemas.microsoft.com/office/drawing/2014/main" id="{54348D43-8ECE-451C-B62E-D7E5FE51A376}"/>
+                <a16:creationId xmlns:a16="http://schemas.microsoft.com/office/drawing/2014/main" id="{820147D4-6555-422A-8C46-C8FF5D778678}"/>
               </a:ext>
             </a:extLst>
           </p:cNvPr>
@@ -1986,7 +1986,7 @@
           <p:cNvPr id="9" name="text-104">
             <a:extLst xmlns:a="http://schemas.openxmlformats.org/drawingml/2006/main">
               <a:ext uri="{FF2B5EF4-FFF2-40B4-BE49-F238E27FC236}">
-                <a16:creationId xmlns:a16="http://schemas.microsoft.com/office/drawing/2014/main" id="{3E21F5EB-D106-4123-A19C-BA4CB12644DE}"/>
+                <a16:creationId xmlns:a16="http://schemas.microsoft.com/office/drawing/2014/main" id="{A42412D5-6ED9-47D9-852C-3C54FF6E0D72}"/>
               </a:ext>
             </a:extLst>
           </p:cNvPr>
@@ -2042,7 +2042,7 @@
           <p:cNvPr id="10" name="box-105">
             <a:extLst xmlns:a="http://schemas.openxmlformats.org/drawingml/2006/main">
               <a:ext uri="{FF2B5EF4-FFF2-40B4-BE49-F238E27FC236}">
-                <a16:creationId xmlns:a16="http://schemas.microsoft.com/office/drawing/2014/main" id="{443116B5-340A-444F-8724-E2821E4701D0}"/>
+                <a16:creationId xmlns:a16="http://schemas.microsoft.com/office/drawing/2014/main" id="{2D9635B5-30FB-4440-AA6B-0B982FADA348}"/>
               </a:ext>
             </a:extLst>
           </p:cNvPr>
@@ -2079,7 +2079,7 @@
           <p:nvPr/>
         </p:nvPicPr>
         <p:blipFill>
-          <a:blip xmlns:r="http://schemas.openxmlformats.org/officeDocument/2006/relationships" xmlns:a="http://schemas.openxmlformats.org/drawingml/2006/main" r:embed="R0b9d273636204077"/>
+          <a:blip xmlns:r="http://schemas.openxmlformats.org/officeDocument/2006/relationships" xmlns:a="http://schemas.openxmlformats.org/drawingml/2006/main" r:embed="Re56a210efca84873"/>
           <a:stretch xmlns:a="http://schemas.openxmlformats.org/drawingml/2006/main"/>
         </p:blipFill>
         <p:spPr>
@@ -2097,7 +2097,7 @@
           <p:cNvPr id="12" name="text-106">
             <a:extLst xmlns:a="http://schemas.openxmlformats.org/drawingml/2006/main">
               <a:ext uri="{FF2B5EF4-FFF2-40B4-BE49-F238E27FC236}">
-                <a16:creationId xmlns:a16="http://schemas.microsoft.com/office/drawing/2014/main" id="{59DEDC90-6A31-4617-AD34-5C4C6D19F0DA}"/>
+                <a16:creationId xmlns:a16="http://schemas.microsoft.com/office/drawing/2014/main" id="{A611FF8D-8B50-47FF-806A-2B861BB68645}"/>
               </a:ext>
             </a:extLst>
           </p:cNvPr>
@@ -2151,7 +2151,7 @@
     </p:spTree>
     <p:extLst>
       <p:ext uri="{BB962C8B-B14F-4D97-AF65-F5344CB8AC3E}">
-        <p14:creationId xmlns:p14="http://schemas.microsoft.com/office/powerpoint/2010/main" val="890854248"/>
+        <p14:creationId xmlns:p14="http://schemas.microsoft.com/office/powerpoint/2010/main" val="1153727311"/>
       </p:ext>
     </p:extLst>
   </p:cSld>
@@ -2182,7 +2182,7 @@
           <p:cNvPr id="14" name="box-107">
             <a:extLst xmlns:a="http://schemas.openxmlformats.org/drawingml/2006/main">
               <a:ext uri="{FF2B5EF4-FFF2-40B4-BE49-F238E27FC236}">
-                <a16:creationId xmlns:a16="http://schemas.microsoft.com/office/drawing/2014/main" id="{495A112D-0420-4CDA-89B5-62C0AC298D26}"/>
+                <a16:creationId xmlns:a16="http://schemas.microsoft.com/office/drawing/2014/main" id="{C9CCFE9D-6B2D-4B48-89E4-078453BC0D11}"/>
               </a:ext>
             </a:extLst>
           </p:cNvPr>
@@ -2215,7 +2215,7 @@
           <p:cNvPr id="2" name="text-108">
             <a:extLst xmlns:a="http://schemas.openxmlformats.org/drawingml/2006/main">
               <a:ext uri="{FF2B5EF4-FFF2-40B4-BE49-F238E27FC236}">
-                <a16:creationId xmlns:a16="http://schemas.microsoft.com/office/drawing/2014/main" id="{B3CF1A6C-EED9-4771-85DD-28FF516C61AD}"/>
+                <a16:creationId xmlns:a16="http://schemas.microsoft.com/office/drawing/2014/main" id="{463FA626-65C6-4ABE-AA6F-FC62B300D276}"/>
               </a:ext>
             </a:extLst>
           </p:cNvPr>
@@ -2271,7 +2271,7 @@
           <p:cNvPr id="3" name="text-109">
             <a:extLst xmlns:a="http://schemas.openxmlformats.org/drawingml/2006/main">
               <a:ext uri="{FF2B5EF4-FFF2-40B4-BE49-F238E27FC236}">
-                <a16:creationId xmlns:a16="http://schemas.microsoft.com/office/drawing/2014/main" id="{FA3F81AB-CC4D-4557-9E58-4CCF768D0DEA}"/>
+                <a16:creationId xmlns:a16="http://schemas.microsoft.com/office/drawing/2014/main" id="{F7F24C49-BBCB-4B07-892B-D053E8AD1878}"/>
               </a:ext>
             </a:extLst>
           </p:cNvPr>
@@ -2327,7 +2327,7 @@
           <p:cNvPr id="4" name="text-110">
             <a:extLst xmlns:a="http://schemas.openxmlformats.org/drawingml/2006/main">
               <a:ext uri="{FF2B5EF4-FFF2-40B4-BE49-F238E27FC236}">
-                <a16:creationId xmlns:a16="http://schemas.microsoft.com/office/drawing/2014/main" id="{43AED079-E87C-480F-8104-710216AA5844}"/>
+                <a16:creationId xmlns:a16="http://schemas.microsoft.com/office/drawing/2014/main" id="{921AC716-DD37-4B64-B7C9-F58FD103DBC6}"/>
               </a:ext>
             </a:extLst>
           </p:cNvPr>
@@ -2383,7 +2383,7 @@
           <p:cNvPr id="5" name="text-111">
             <a:extLst xmlns:a="http://schemas.openxmlformats.org/drawingml/2006/main">
               <a:ext uri="{FF2B5EF4-FFF2-40B4-BE49-F238E27FC236}">
-                <a16:creationId xmlns:a16="http://schemas.microsoft.com/office/drawing/2014/main" id="{E5FDABC9-0809-4874-8585-DCF0C76113DD}"/>
+                <a16:creationId xmlns:a16="http://schemas.microsoft.com/office/drawing/2014/main" id="{FDE4CC3D-C5C9-43E5-B4D9-11849E8AE005}"/>
               </a:ext>
             </a:extLst>
           </p:cNvPr>
@@ -2439,7 +2439,7 @@
           <p:cNvPr id="6" name="text-112">
             <a:extLst xmlns:a="http://schemas.openxmlformats.org/drawingml/2006/main">
               <a:ext uri="{FF2B5EF4-FFF2-40B4-BE49-F238E27FC236}">
-                <a16:creationId xmlns:a16="http://schemas.microsoft.com/office/drawing/2014/main" id="{EDCA7B2E-7ABA-4051-9EDA-E2A8EFFA7800}"/>
+                <a16:creationId xmlns:a16="http://schemas.microsoft.com/office/drawing/2014/main" id="{6EA1B16A-9BEB-4ADC-9C6F-57F14BADCB5E}"/>
               </a:ext>
             </a:extLst>
           </p:cNvPr>
@@ -2495,7 +2495,7 @@
           <p:cNvPr id="7" name="box-113">
             <a:extLst xmlns:a="http://schemas.openxmlformats.org/drawingml/2006/main">
               <a:ext uri="{FF2B5EF4-FFF2-40B4-BE49-F238E27FC236}">
-                <a16:creationId xmlns:a16="http://schemas.microsoft.com/office/drawing/2014/main" id="{1511EB5C-9FE4-47B6-88E3-3719A26F25FA}"/>
+                <a16:creationId xmlns:a16="http://schemas.microsoft.com/office/drawing/2014/main" id="{B95B1C3A-F21A-4DBF-BFBD-2B4E4747F0D6}"/>
               </a:ext>
             </a:extLst>
           </p:cNvPr>
@@ -2528,7 +2528,7 @@
           <p:cNvPr id="8" name="text-114">
             <a:extLst xmlns:a="http://schemas.openxmlformats.org/drawingml/2006/main">
               <a:ext uri="{FF2B5EF4-FFF2-40B4-BE49-F238E27FC236}">
-                <a16:creationId xmlns:a16="http://schemas.microsoft.com/office/drawing/2014/main" id="{276539D4-EE2B-4C9E-B5DA-E815AD2F828E}"/>
+                <a16:creationId xmlns:a16="http://schemas.microsoft.com/office/drawing/2014/main" id="{F855C02B-A0DE-4258-B49B-F97AF127C558}"/>
               </a:ext>
             </a:extLst>
           </p:cNvPr>
@@ -2584,7 +2584,7 @@
           <p:cNvPr id="9" name="text-115">
             <a:extLst xmlns:a="http://schemas.openxmlformats.org/drawingml/2006/main">
               <a:ext uri="{FF2B5EF4-FFF2-40B4-BE49-F238E27FC236}">
-                <a16:creationId xmlns:a16="http://schemas.microsoft.com/office/drawing/2014/main" id="{36E7D4FD-F24D-4968-A7D5-197DA0722D61}"/>
+                <a16:creationId xmlns:a16="http://schemas.microsoft.com/office/drawing/2014/main" id="{8361A773-13B0-4D9C-BA7A-CBC84F1280E2}"/>
               </a:ext>
             </a:extLst>
           </p:cNvPr>
@@ -2640,7 +2640,7 @@
           <p:cNvPr id="10" name="text-116">
             <a:extLst xmlns:a="http://schemas.openxmlformats.org/drawingml/2006/main">
               <a:ext uri="{FF2B5EF4-FFF2-40B4-BE49-F238E27FC236}">
-                <a16:creationId xmlns:a16="http://schemas.microsoft.com/office/drawing/2014/main" id="{F2EBFA4B-031B-4CDD-B1ED-B3023A22E496}"/>
+                <a16:creationId xmlns:a16="http://schemas.microsoft.com/office/drawing/2014/main" id="{27B5A3A9-705B-4BB5-A23D-F6601A072E4F}"/>
               </a:ext>
             </a:extLst>
           </p:cNvPr>
@@ -2696,7 +2696,7 @@
           <p:cNvPr id="11" name="box-117">
             <a:extLst xmlns:a="http://schemas.openxmlformats.org/drawingml/2006/main">
               <a:ext uri="{FF2B5EF4-FFF2-40B4-BE49-F238E27FC236}">
-                <a16:creationId xmlns:a16="http://schemas.microsoft.com/office/drawing/2014/main" id="{D290AB1D-97F2-4209-8840-F4C293E370A0}"/>
+                <a16:creationId xmlns:a16="http://schemas.microsoft.com/office/drawing/2014/main" id="{AEAE9C2C-F48B-40C9-A667-96AAB80D5978}"/>
               </a:ext>
             </a:extLst>
           </p:cNvPr>
@@ -2733,7 +2733,7 @@
           <p:nvPr/>
         </p:nvPicPr>
         <p:blipFill>
-          <a:blip xmlns:r="http://schemas.openxmlformats.org/officeDocument/2006/relationships" xmlns:a="http://schemas.openxmlformats.org/drawingml/2006/main" r:embed="R4c8c7e483e364b37"/>
+          <a:blip xmlns:r="http://schemas.openxmlformats.org/officeDocument/2006/relationships" xmlns:a="http://schemas.openxmlformats.org/drawingml/2006/main" r:embed="R3e306e966af14cbd"/>
           <a:stretch xmlns:a="http://schemas.openxmlformats.org/drawingml/2006/main"/>
         </p:blipFill>
         <p:spPr>
@@ -2751,7 +2751,7 @@
           <p:cNvPr id="13" name="text-118">
             <a:extLst xmlns:a="http://schemas.openxmlformats.org/drawingml/2006/main">
               <a:ext uri="{FF2B5EF4-FFF2-40B4-BE49-F238E27FC236}">
-                <a16:creationId xmlns:a16="http://schemas.microsoft.com/office/drawing/2014/main" id="{487155F7-6E4E-4392-8401-621A5488F6ED}"/>
+                <a16:creationId xmlns:a16="http://schemas.microsoft.com/office/drawing/2014/main" id="{52036F32-A3AB-4C8A-972F-CC19D6803B72}"/>
               </a:ext>
             </a:extLst>
           </p:cNvPr>
@@ -2805,7 +2805,7 @@
     </p:spTree>
     <p:extLst>
       <p:ext uri="{BB962C8B-B14F-4D97-AF65-F5344CB8AC3E}">
-        <p14:creationId xmlns:p14="http://schemas.microsoft.com/office/powerpoint/2010/main" val="85511578"/>
+        <p14:creationId xmlns:p14="http://schemas.microsoft.com/office/powerpoint/2010/main" val="266341911"/>
       </p:ext>
     </p:extLst>
   </p:cSld>
@@ -2836,7 +2836,7 @@
           <p:cNvPr id="19" name="box-119">
             <a:extLst xmlns:a="http://schemas.openxmlformats.org/drawingml/2006/main">
               <a:ext uri="{FF2B5EF4-FFF2-40B4-BE49-F238E27FC236}">
-                <a16:creationId xmlns:a16="http://schemas.microsoft.com/office/drawing/2014/main" id="{80F5DC22-6915-49C9-87AB-A5CDAC9828ED}"/>
+                <a16:creationId xmlns:a16="http://schemas.microsoft.com/office/drawing/2014/main" id="{DDFA347D-4FFA-4CAB-9862-0C5AE68B3E73}"/>
               </a:ext>
             </a:extLst>
           </p:cNvPr>
@@ -2869,7 +2869,7 @@
           <p:cNvPr id="2" name="text-120">
             <a:extLst xmlns:a="http://schemas.openxmlformats.org/drawingml/2006/main">
               <a:ext uri="{FF2B5EF4-FFF2-40B4-BE49-F238E27FC236}">
-                <a16:creationId xmlns:a16="http://schemas.microsoft.com/office/drawing/2014/main" id="{11FF9FB3-741D-44B0-8A2E-86EBAB4E090E}"/>
+                <a16:creationId xmlns:a16="http://schemas.microsoft.com/office/drawing/2014/main" id="{EF840281-A6B4-4015-BBDB-7C0F28988B72}"/>
               </a:ext>
             </a:extLst>
           </p:cNvPr>
@@ -2925,7 +2925,7 @@
           <p:cNvPr id="3" name="text-121">
             <a:extLst xmlns:a="http://schemas.openxmlformats.org/drawingml/2006/main">
               <a:ext uri="{FF2B5EF4-FFF2-40B4-BE49-F238E27FC236}">
-                <a16:creationId xmlns:a16="http://schemas.microsoft.com/office/drawing/2014/main" id="{7A782BF5-EB0C-433F-862F-C8D965FDCAE2}"/>
+                <a16:creationId xmlns:a16="http://schemas.microsoft.com/office/drawing/2014/main" id="{9608319E-A7D9-4876-9804-BD8D1F321A7E}"/>
               </a:ext>
             </a:extLst>
           </p:cNvPr>
@@ -2981,7 +2981,7 @@
           <p:cNvPr id="4" name="text-122">
             <a:extLst xmlns:a="http://schemas.openxmlformats.org/drawingml/2006/main">
               <a:ext uri="{FF2B5EF4-FFF2-40B4-BE49-F238E27FC236}">
-                <a16:creationId xmlns:a16="http://schemas.microsoft.com/office/drawing/2014/main" id="{72923761-A1B5-4938-937A-84BB87DD2224}"/>
+                <a16:creationId xmlns:a16="http://schemas.microsoft.com/office/drawing/2014/main" id="{AD4FA21A-2E0C-4012-B405-369AD870A577}"/>
               </a:ext>
             </a:extLst>
           </p:cNvPr>
@@ -3037,7 +3037,7 @@
           <p:cNvPr id="5" name="text-123">
             <a:extLst xmlns:a="http://schemas.openxmlformats.org/drawingml/2006/main">
               <a:ext uri="{FF2B5EF4-FFF2-40B4-BE49-F238E27FC236}">
-                <a16:creationId xmlns:a16="http://schemas.microsoft.com/office/drawing/2014/main" id="{A9667ED5-B427-45A1-97CC-669CFD3C725C}"/>
+                <a16:creationId xmlns:a16="http://schemas.microsoft.com/office/drawing/2014/main" id="{6E73251A-21E7-4DA4-8383-168B63803738}"/>
               </a:ext>
             </a:extLst>
           </p:cNvPr>
@@ -3093,7 +3093,7 @@
           <p:cNvPr id="6" name="text-124">
             <a:extLst xmlns:a="http://schemas.openxmlformats.org/drawingml/2006/main">
               <a:ext uri="{FF2B5EF4-FFF2-40B4-BE49-F238E27FC236}">
-                <a16:creationId xmlns:a16="http://schemas.microsoft.com/office/drawing/2014/main" id="{5A90C5D6-A375-46C6-A0FD-E6A64615A975}"/>
+                <a16:creationId xmlns:a16="http://schemas.microsoft.com/office/drawing/2014/main" id="{5968340F-F5CD-4BAA-9FC2-FB7E33BF5273}"/>
               </a:ext>
             </a:extLst>
           </p:cNvPr>
@@ -3149,7 +3149,7 @@
           <p:cNvPr id="7" name="box-125">
             <a:extLst xmlns:a="http://schemas.openxmlformats.org/drawingml/2006/main">
               <a:ext uri="{FF2B5EF4-FFF2-40B4-BE49-F238E27FC236}">
-                <a16:creationId xmlns:a16="http://schemas.microsoft.com/office/drawing/2014/main" id="{399BFACB-997D-43F8-A96B-9CE2E84B4153}"/>
+                <a16:creationId xmlns:a16="http://schemas.microsoft.com/office/drawing/2014/main" id="{8AB29EC7-E76D-4E78-9E13-A51251214AEE}"/>
               </a:ext>
             </a:extLst>
           </p:cNvPr>
@@ -3182,7 +3182,7 @@
           <p:cNvPr id="8" name="text-126">
             <a:extLst xmlns:a="http://schemas.openxmlformats.org/drawingml/2006/main">
               <a:ext uri="{FF2B5EF4-FFF2-40B4-BE49-F238E27FC236}">
-                <a16:creationId xmlns:a16="http://schemas.microsoft.com/office/drawing/2014/main" id="{E73A0767-F875-484D-A1D6-CC5417F3B8CA}"/>
+                <a16:creationId xmlns:a16="http://schemas.microsoft.com/office/drawing/2014/main" id="{B3DB7247-DFA3-45ED-9D6E-9E3395CAAF33}"/>
               </a:ext>
             </a:extLst>
           </p:cNvPr>
@@ -3238,7 +3238,7 @@
           <p:cNvPr id="9" name="text-127">
             <a:extLst xmlns:a="http://schemas.openxmlformats.org/drawingml/2006/main">
               <a:ext uri="{FF2B5EF4-FFF2-40B4-BE49-F238E27FC236}">
-                <a16:creationId xmlns:a16="http://schemas.microsoft.com/office/drawing/2014/main" id="{FFEAACFA-F8E2-4834-8CF2-675C7771DF91}"/>
+                <a16:creationId xmlns:a16="http://schemas.microsoft.com/office/drawing/2014/main" id="{1D684FC0-A22D-464C-AFF3-20035F0CBDAB}"/>
               </a:ext>
             </a:extLst>
           </p:cNvPr>
@@ -3294,7 +3294,7 @@
           <p:cNvPr id="10" name="text-128">
             <a:extLst xmlns:a="http://schemas.openxmlformats.org/drawingml/2006/main">
               <a:ext uri="{FF2B5EF4-FFF2-40B4-BE49-F238E27FC236}">
-                <a16:creationId xmlns:a16="http://schemas.microsoft.com/office/drawing/2014/main" id="{84CAADAC-49E7-4E43-A603-367A60BFEF53}"/>
+                <a16:creationId xmlns:a16="http://schemas.microsoft.com/office/drawing/2014/main" id="{C008757B-9E59-4512-A475-4CD900697E19}"/>
               </a:ext>
             </a:extLst>
           </p:cNvPr>
@@ -3350,7 +3350,7 @@
           <p:cNvPr id="11" name="box-129">
             <a:extLst xmlns:a="http://schemas.openxmlformats.org/drawingml/2006/main">
               <a:ext uri="{FF2B5EF4-FFF2-40B4-BE49-F238E27FC236}">
-                <a16:creationId xmlns:a16="http://schemas.microsoft.com/office/drawing/2014/main" id="{0FD066ED-6CBF-4B1A-B046-27B0D4EC2577}"/>
+                <a16:creationId xmlns:a16="http://schemas.microsoft.com/office/drawing/2014/main" id="{A2CF9BAC-632A-4E82-AD3C-A447BB57B070}"/>
               </a:ext>
             </a:extLst>
           </p:cNvPr>
@@ -3383,7 +3383,7 @@
           <p:cNvPr id="12" name="text-130">
             <a:extLst xmlns:a="http://schemas.openxmlformats.org/drawingml/2006/main">
               <a:ext uri="{FF2B5EF4-FFF2-40B4-BE49-F238E27FC236}">
-                <a16:creationId xmlns:a16="http://schemas.microsoft.com/office/drawing/2014/main" id="{5BEDDEA5-1548-467D-88FB-AFDE2F5BB769}"/>
+                <a16:creationId xmlns:a16="http://schemas.microsoft.com/office/drawing/2014/main" id="{E94B7CB2-FEA2-49D5-8E42-A18119970B74}"/>
               </a:ext>
             </a:extLst>
           </p:cNvPr>
@@ -3439,7 +3439,7 @@
           <p:cNvPr id="13" name="text-131">
             <a:extLst xmlns:a="http://schemas.openxmlformats.org/drawingml/2006/main">
               <a:ext uri="{FF2B5EF4-FFF2-40B4-BE49-F238E27FC236}">
-                <a16:creationId xmlns:a16="http://schemas.microsoft.com/office/drawing/2014/main" id="{F607A1EE-2A07-4A30-870A-4702D16E8F9B}"/>
+                <a16:creationId xmlns:a16="http://schemas.microsoft.com/office/drawing/2014/main" id="{973F7E6B-5516-4B03-BD2D-BE09AC0E897E}"/>
               </a:ext>
             </a:extLst>
           </p:cNvPr>
@@ -3495,7 +3495,7 @@
           <p:cNvPr id="14" name="text-132">
             <a:extLst xmlns:a="http://schemas.openxmlformats.org/drawingml/2006/main">
               <a:ext uri="{FF2B5EF4-FFF2-40B4-BE49-F238E27FC236}">
-                <a16:creationId xmlns:a16="http://schemas.microsoft.com/office/drawing/2014/main" id="{09955BC1-D1B4-43E4-A21C-CDCA4F5DF0F5}"/>
+                <a16:creationId xmlns:a16="http://schemas.microsoft.com/office/drawing/2014/main" id="{AAB00184-D789-4860-877E-B5F3B72F4AF6}"/>
               </a:ext>
             </a:extLst>
           </p:cNvPr>
@@ -3551,7 +3551,7 @@
           <p:cNvPr id="15" name="box-133">
             <a:extLst xmlns:a="http://schemas.openxmlformats.org/drawingml/2006/main">
               <a:ext uri="{FF2B5EF4-FFF2-40B4-BE49-F238E27FC236}">
-                <a16:creationId xmlns:a16="http://schemas.microsoft.com/office/drawing/2014/main" id="{BF5D0A72-1FBA-4BA2-B155-B0FDB20B72A3}"/>
+                <a16:creationId xmlns:a16="http://schemas.microsoft.com/office/drawing/2014/main" id="{E22EB908-294A-4E19-AE30-79BC46F639D8}"/>
               </a:ext>
             </a:extLst>
           </p:cNvPr>
@@ -3584,7 +3584,7 @@
           <p:cNvPr id="16" name="text-134">
             <a:extLst xmlns:a="http://schemas.openxmlformats.org/drawingml/2006/main">
               <a:ext uri="{FF2B5EF4-FFF2-40B4-BE49-F238E27FC236}">
-                <a16:creationId xmlns:a16="http://schemas.microsoft.com/office/drawing/2014/main" id="{FE08AE18-C63C-4D1C-A992-53F94EC74F15}"/>
+                <a16:creationId xmlns:a16="http://schemas.microsoft.com/office/drawing/2014/main" id="{96777C01-9A62-4A55-9DC5-84D3E262B096}"/>
               </a:ext>
             </a:extLst>
           </p:cNvPr>
@@ -3640,7 +3640,7 @@
           <p:cNvPr id="17" name="text-135">
             <a:extLst xmlns:a="http://schemas.openxmlformats.org/drawingml/2006/main">
               <a:ext uri="{FF2B5EF4-FFF2-40B4-BE49-F238E27FC236}">
-                <a16:creationId xmlns:a16="http://schemas.microsoft.com/office/drawing/2014/main" id="{A732AEFF-3BB4-4B1D-912A-477F4BEB81F4}"/>
+                <a16:creationId xmlns:a16="http://schemas.microsoft.com/office/drawing/2014/main" id="{C7545CC8-8673-469E-91E3-B9546E62906B}"/>
               </a:ext>
             </a:extLst>
           </p:cNvPr>
@@ -3696,7 +3696,7 @@
           <p:cNvPr id="18" name="text-136">
             <a:extLst xmlns:a="http://schemas.openxmlformats.org/drawingml/2006/main">
               <a:ext uri="{FF2B5EF4-FFF2-40B4-BE49-F238E27FC236}">
-                <a16:creationId xmlns:a16="http://schemas.microsoft.com/office/drawing/2014/main" id="{78B07E1A-B5B8-4117-8B62-3891DDD860AE}"/>
+                <a16:creationId xmlns:a16="http://schemas.microsoft.com/office/drawing/2014/main" id="{4D216BBC-5D01-43F9-BCB3-9BCA45782154}"/>
               </a:ext>
             </a:extLst>
           </p:cNvPr>
@@ -3750,7 +3750,7 @@
     </p:spTree>
     <p:extLst>
       <p:ext uri="{BB962C8B-B14F-4D97-AF65-F5344CB8AC3E}">
-        <p14:creationId xmlns:p14="http://schemas.microsoft.com/office/powerpoint/2010/main" val="58396262"/>
+        <p14:creationId xmlns:p14="http://schemas.microsoft.com/office/powerpoint/2010/main" val="436792226"/>
       </p:ext>
     </p:extLst>
   </p:cSld>
@@ -3781,7 +3781,7 @@
           <p:cNvPr id="18" name="box-137">
             <a:extLst xmlns:a="http://schemas.openxmlformats.org/drawingml/2006/main">
               <a:ext uri="{FF2B5EF4-FFF2-40B4-BE49-F238E27FC236}">
-                <a16:creationId xmlns:a16="http://schemas.microsoft.com/office/drawing/2014/main" id="{7BC867AD-0C9C-4AAF-9DAB-CB668C131F7B}"/>
+                <a16:creationId xmlns:a16="http://schemas.microsoft.com/office/drawing/2014/main" id="{7E422107-8DAC-49F8-A70D-451A310EF9CE}"/>
               </a:ext>
             </a:extLst>
           </p:cNvPr>
@@ -3814,7 +3814,7 @@
           <p:cNvPr id="2" name="text-138">
             <a:extLst xmlns:a="http://schemas.openxmlformats.org/drawingml/2006/main">
               <a:ext uri="{FF2B5EF4-FFF2-40B4-BE49-F238E27FC236}">
-                <a16:creationId xmlns:a16="http://schemas.microsoft.com/office/drawing/2014/main" id="{971E420E-117F-4290-8F80-387D57C742EE}"/>
+                <a16:creationId xmlns:a16="http://schemas.microsoft.com/office/drawing/2014/main" id="{7BE6EDBD-FCF1-4807-A3B2-37C589A1A969}"/>
               </a:ext>
             </a:extLst>
           </p:cNvPr>
@@ -3870,7 +3870,7 @@
           <p:cNvPr id="3" name="text-139">
             <a:extLst xmlns:a="http://schemas.openxmlformats.org/drawingml/2006/main">
               <a:ext uri="{FF2B5EF4-FFF2-40B4-BE49-F238E27FC236}">
-                <a16:creationId xmlns:a16="http://schemas.microsoft.com/office/drawing/2014/main" id="{F94D1225-6047-4283-B855-6CFABBB10CE7}"/>
+                <a16:creationId xmlns:a16="http://schemas.microsoft.com/office/drawing/2014/main" id="{0FAD770B-D91F-4705-ABB6-4A0C9773F0A4}"/>
               </a:ext>
             </a:extLst>
           </p:cNvPr>
@@ -3926,7 +3926,7 @@
           <p:cNvPr id="4" name="text-140">
             <a:extLst xmlns:a="http://schemas.openxmlformats.org/drawingml/2006/main">
               <a:ext uri="{FF2B5EF4-FFF2-40B4-BE49-F238E27FC236}">
-                <a16:creationId xmlns:a16="http://schemas.microsoft.com/office/drawing/2014/main" id="{B918996D-BC32-4299-8BDC-0DF384391FB8}"/>
+                <a16:creationId xmlns:a16="http://schemas.microsoft.com/office/drawing/2014/main" id="{36B9326B-A3D6-4E9D-8279-5F931476D4EB}"/>
               </a:ext>
             </a:extLst>
           </p:cNvPr>
@@ -3982,7 +3982,7 @@
           <p:cNvPr id="5" name="text-141">
             <a:extLst xmlns:a="http://schemas.openxmlformats.org/drawingml/2006/main">
               <a:ext uri="{FF2B5EF4-FFF2-40B4-BE49-F238E27FC236}">
-                <a16:creationId xmlns:a16="http://schemas.microsoft.com/office/drawing/2014/main" id="{35C52C14-5019-4158-AF94-DC462052319B}"/>
+                <a16:creationId xmlns:a16="http://schemas.microsoft.com/office/drawing/2014/main" id="{6E8A3FEF-EBF5-4E82-971F-3F326E849435}"/>
               </a:ext>
             </a:extLst>
           </p:cNvPr>
@@ -4038,7 +4038,7 @@
           <p:cNvPr id="6" name="box-142">
             <a:extLst xmlns:a="http://schemas.openxmlformats.org/drawingml/2006/main">
               <a:ext uri="{FF2B5EF4-FFF2-40B4-BE49-F238E27FC236}">
-                <a16:creationId xmlns:a16="http://schemas.microsoft.com/office/drawing/2014/main" id="{6D743BEA-945E-4F40-A5A9-560513A72D42}"/>
+                <a16:creationId xmlns:a16="http://schemas.microsoft.com/office/drawing/2014/main" id="{FCDA89D6-B8E5-41F7-8003-743C9D933F3C}"/>
               </a:ext>
             </a:extLst>
           </p:cNvPr>
@@ -4071,7 +4071,7 @@
           <p:cNvPr id="7" name="text-143">
             <a:extLst xmlns:a="http://schemas.openxmlformats.org/drawingml/2006/main">
               <a:ext uri="{FF2B5EF4-FFF2-40B4-BE49-F238E27FC236}">
-                <a16:creationId xmlns:a16="http://schemas.microsoft.com/office/drawing/2014/main" id="{3D170E07-4423-45AB-B412-CBE1056716AA}"/>
+                <a16:creationId xmlns:a16="http://schemas.microsoft.com/office/drawing/2014/main" id="{6DFDD8E5-3BF6-43F0-ABEB-A9DF0EB81F57}"/>
               </a:ext>
             </a:extLst>
           </p:cNvPr>
@@ -4127,7 +4127,7 @@
           <p:cNvPr id="8" name="text-144">
             <a:extLst xmlns:a="http://schemas.openxmlformats.org/drawingml/2006/main">
               <a:ext uri="{FF2B5EF4-FFF2-40B4-BE49-F238E27FC236}">
-                <a16:creationId xmlns:a16="http://schemas.microsoft.com/office/drawing/2014/main" id="{85D22619-1727-435A-BA6B-B6DFB95B1565}"/>
+                <a16:creationId xmlns:a16="http://schemas.microsoft.com/office/drawing/2014/main" id="{5BBF735A-53D4-4961-A2CA-EDDF2D9BF586}"/>
               </a:ext>
             </a:extLst>
           </p:cNvPr>
@@ -4183,7 +4183,7 @@
           <p:cNvPr id="9" name="box-145">
             <a:extLst xmlns:a="http://schemas.openxmlformats.org/drawingml/2006/main">
               <a:ext uri="{FF2B5EF4-FFF2-40B4-BE49-F238E27FC236}">
-                <a16:creationId xmlns:a16="http://schemas.microsoft.com/office/drawing/2014/main" id="{2293B403-6F27-4F0D-A8E2-B856A57132A7}"/>
+                <a16:creationId xmlns:a16="http://schemas.microsoft.com/office/drawing/2014/main" id="{AD567E44-478B-4C83-8BD6-E6541E4FA450}"/>
               </a:ext>
             </a:extLst>
           </p:cNvPr>
@@ -4216,7 +4216,7 @@
           <p:cNvPr id="10" name="text-146">
             <a:extLst xmlns:a="http://schemas.openxmlformats.org/drawingml/2006/main">
               <a:ext uri="{FF2B5EF4-FFF2-40B4-BE49-F238E27FC236}">
-                <a16:creationId xmlns:a16="http://schemas.microsoft.com/office/drawing/2014/main" id="{1FC9A800-57D1-480A-9CD3-C066D2C46C08}"/>
+                <a16:creationId xmlns:a16="http://schemas.microsoft.com/office/drawing/2014/main" id="{D1CBDC21-8EF1-485F-9CE8-CDE6CA51A3AA}"/>
               </a:ext>
             </a:extLst>
           </p:cNvPr>
@@ -4272,7 +4272,7 @@
           <p:cNvPr id="11" name="text-147">
             <a:extLst xmlns:a="http://schemas.openxmlformats.org/drawingml/2006/main">
               <a:ext uri="{FF2B5EF4-FFF2-40B4-BE49-F238E27FC236}">
-                <a16:creationId xmlns:a16="http://schemas.microsoft.com/office/drawing/2014/main" id="{D398264A-A3B0-42A9-9205-B792E77CDFB2}"/>
+                <a16:creationId xmlns:a16="http://schemas.microsoft.com/office/drawing/2014/main" id="{2245C38D-0754-43E9-88DE-B2A95999C903}"/>
               </a:ext>
             </a:extLst>
           </p:cNvPr>
@@ -4328,7 +4328,7 @@
           <p:cNvPr id="12" name="box-148">
             <a:extLst xmlns:a="http://schemas.openxmlformats.org/drawingml/2006/main">
               <a:ext uri="{FF2B5EF4-FFF2-40B4-BE49-F238E27FC236}">
-                <a16:creationId xmlns:a16="http://schemas.microsoft.com/office/drawing/2014/main" id="{94F5350D-27CB-460D-98B4-36DC87375B89}"/>
+                <a16:creationId xmlns:a16="http://schemas.microsoft.com/office/drawing/2014/main" id="{B2708276-3B11-446F-8298-06C2986B573F}"/>
               </a:ext>
             </a:extLst>
           </p:cNvPr>
@@ -4361,7 +4361,7 @@
           <p:cNvPr id="13" name="text-149">
             <a:extLst xmlns:a="http://schemas.openxmlformats.org/drawingml/2006/main">
               <a:ext uri="{FF2B5EF4-FFF2-40B4-BE49-F238E27FC236}">
-                <a16:creationId xmlns:a16="http://schemas.microsoft.com/office/drawing/2014/main" id="{BA5B28FC-7950-4865-8E49-B2CF78871064}"/>
+                <a16:creationId xmlns:a16="http://schemas.microsoft.com/office/drawing/2014/main" id="{B2160CB6-1BAC-4136-A789-0DEF60E7D076}"/>
               </a:ext>
             </a:extLst>
           </p:cNvPr>
@@ -4417,7 +4417,7 @@
           <p:cNvPr id="14" name="text-150">
             <a:extLst xmlns:a="http://schemas.openxmlformats.org/drawingml/2006/main">
               <a:ext uri="{FF2B5EF4-FFF2-40B4-BE49-F238E27FC236}">
-                <a16:creationId xmlns:a16="http://schemas.microsoft.com/office/drawing/2014/main" id="{DEEB3A82-479A-433E-85E0-730B969C3B60}"/>
+                <a16:creationId xmlns:a16="http://schemas.microsoft.com/office/drawing/2014/main" id="{4530D738-F158-4697-829A-17CC8B93FADC}"/>
               </a:ext>
             </a:extLst>
           </p:cNvPr>
@@ -4473,7 +4473,7 @@
           <p:cNvPr id="15" name="box-151">
             <a:extLst xmlns:a="http://schemas.openxmlformats.org/drawingml/2006/main">
               <a:ext uri="{FF2B5EF4-FFF2-40B4-BE49-F238E27FC236}">
-                <a16:creationId xmlns:a16="http://schemas.microsoft.com/office/drawing/2014/main" id="{1B99466E-E765-4E46-8EDB-9A116C17CD16}"/>
+                <a16:creationId xmlns:a16="http://schemas.microsoft.com/office/drawing/2014/main" id="{D2CC9005-D12F-4426-9D17-0E7376B338A4}"/>
               </a:ext>
             </a:extLst>
           </p:cNvPr>
@@ -4506,7 +4506,7 @@
           <p:cNvPr id="16" name="text-152">
             <a:extLst xmlns:a="http://schemas.openxmlformats.org/drawingml/2006/main">
               <a:ext uri="{FF2B5EF4-FFF2-40B4-BE49-F238E27FC236}">
-                <a16:creationId xmlns:a16="http://schemas.microsoft.com/office/drawing/2014/main" id="{8E5C544F-92D6-4B67-A1BE-7CE4A5F4D4A6}"/>
+                <a16:creationId xmlns:a16="http://schemas.microsoft.com/office/drawing/2014/main" id="{24DCF3FD-9514-4396-B053-36F8E90AA39A}"/>
               </a:ext>
             </a:extLst>
           </p:cNvPr>
@@ -4562,7 +4562,7 @@
           <p:cNvPr id="17" name="text-153">
             <a:extLst xmlns:a="http://schemas.openxmlformats.org/drawingml/2006/main">
               <a:ext uri="{FF2B5EF4-FFF2-40B4-BE49-F238E27FC236}">
-                <a16:creationId xmlns:a16="http://schemas.microsoft.com/office/drawing/2014/main" id="{00CD5CEC-614A-4214-B326-F4F548B523F7}"/>
+                <a16:creationId xmlns:a16="http://schemas.microsoft.com/office/drawing/2014/main" id="{F2A2D63B-6AAE-41B1-B0EB-E64A5053F1D8}"/>
               </a:ext>
             </a:extLst>
           </p:cNvPr>
@@ -4616,7 +4616,7 @@
     </p:spTree>
     <p:extLst>
       <p:ext uri="{BB962C8B-B14F-4D97-AF65-F5344CB8AC3E}">
-        <p14:creationId xmlns:p14="http://schemas.microsoft.com/office/powerpoint/2010/main" val="1101391503"/>
+        <p14:creationId xmlns:p14="http://schemas.microsoft.com/office/powerpoint/2010/main" val="1951099586"/>
       </p:ext>
     </p:extLst>
   </p:cSld>
@@ -4647,7 +4647,7 @@
           <p:cNvPr id="21" name="box-154">
             <a:extLst xmlns:a="http://schemas.openxmlformats.org/drawingml/2006/main">
               <a:ext uri="{FF2B5EF4-FFF2-40B4-BE49-F238E27FC236}">
-                <a16:creationId xmlns:a16="http://schemas.microsoft.com/office/drawing/2014/main" id="{A2694C25-BF2A-4C7C-ABBB-D6659608A68F}"/>
+                <a16:creationId xmlns:a16="http://schemas.microsoft.com/office/drawing/2014/main" id="{8BF40BB5-DE86-4940-9695-B9043DA8DBB2}"/>
               </a:ext>
             </a:extLst>
           </p:cNvPr>
@@ -4680,7 +4680,7 @@
           <p:cNvPr id="2" name="text-155">
             <a:extLst xmlns:a="http://schemas.openxmlformats.org/drawingml/2006/main">
               <a:ext uri="{FF2B5EF4-FFF2-40B4-BE49-F238E27FC236}">
-                <a16:creationId xmlns:a16="http://schemas.microsoft.com/office/drawing/2014/main" id="{9D7BF190-ED76-4CAF-9D9F-799B3791589F}"/>
+                <a16:creationId xmlns:a16="http://schemas.microsoft.com/office/drawing/2014/main" id="{FB2DD79F-DE7A-4CA2-882C-EB6DB439BBBA}"/>
               </a:ext>
             </a:extLst>
           </p:cNvPr>
@@ -4736,7 +4736,7 @@
           <p:cNvPr id="3" name="text-156">
             <a:extLst xmlns:a="http://schemas.openxmlformats.org/drawingml/2006/main">
               <a:ext uri="{FF2B5EF4-FFF2-40B4-BE49-F238E27FC236}">
-                <a16:creationId xmlns:a16="http://schemas.microsoft.com/office/drawing/2014/main" id="{033DE3FA-B32E-43A4-A577-648CCACE13D5}"/>
+                <a16:creationId xmlns:a16="http://schemas.microsoft.com/office/drawing/2014/main" id="{CB3D4539-62ED-4BAC-AA4A-948297BECDB0}"/>
               </a:ext>
             </a:extLst>
           </p:cNvPr>
@@ -4792,7 +4792,7 @@
           <p:cNvPr id="4" name="text-157">
             <a:extLst xmlns:a="http://schemas.openxmlformats.org/drawingml/2006/main">
               <a:ext uri="{FF2B5EF4-FFF2-40B4-BE49-F238E27FC236}">
-                <a16:creationId xmlns:a16="http://schemas.microsoft.com/office/drawing/2014/main" id="{F89BD8C9-65A1-4ABA-9313-09856E559000}"/>
+                <a16:creationId xmlns:a16="http://schemas.microsoft.com/office/drawing/2014/main" id="{A958A5FE-FCE4-4D99-8B94-98ACEF8DBB44}"/>
               </a:ext>
             </a:extLst>
           </p:cNvPr>
@@ -4848,7 +4848,7 @@
           <p:cNvPr id="5" name="text-158">
             <a:extLst xmlns:a="http://schemas.openxmlformats.org/drawingml/2006/main">
               <a:ext uri="{FF2B5EF4-FFF2-40B4-BE49-F238E27FC236}">
-                <a16:creationId xmlns:a16="http://schemas.microsoft.com/office/drawing/2014/main" id="{989CCBB7-97B9-4880-8587-BD960C1F10B1}"/>
+                <a16:creationId xmlns:a16="http://schemas.microsoft.com/office/drawing/2014/main" id="{6574DC0B-1EA7-4D70-9F78-D57E3CA55E21}"/>
               </a:ext>
             </a:extLst>
           </p:cNvPr>
@@ -4904,7 +4904,7 @@
           <p:cNvPr id="6" name="box-159">
             <a:extLst xmlns:a="http://schemas.openxmlformats.org/drawingml/2006/main">
               <a:ext uri="{FF2B5EF4-FFF2-40B4-BE49-F238E27FC236}">
-                <a16:creationId xmlns:a16="http://schemas.microsoft.com/office/drawing/2014/main" id="{38F3EDFE-6744-44AD-A8AD-2DAE0EBEACDF}"/>
+                <a16:creationId xmlns:a16="http://schemas.microsoft.com/office/drawing/2014/main" id="{8E2C3A11-98BD-456D-842C-B89206318422}"/>
               </a:ext>
             </a:extLst>
           </p:cNvPr>
@@ -4937,7 +4937,7 @@
           <p:cNvPr id="7" name="dot-160">
             <a:extLst xmlns:a="http://schemas.openxmlformats.org/drawingml/2006/main">
               <a:ext uri="{FF2B5EF4-FFF2-40B4-BE49-F238E27FC236}">
-                <a16:creationId xmlns:a16="http://schemas.microsoft.com/office/drawing/2014/main" id="{23A193E1-C1E4-426C-B1B4-F21F97322E9E}"/>
+                <a16:creationId xmlns:a16="http://schemas.microsoft.com/office/drawing/2014/main" id="{6193F77A-A4E8-41B2-9D84-780E6592A861}"/>
               </a:ext>
             </a:extLst>
           </p:cNvPr>
@@ -4968,7 +4968,7 @@
           <p:cNvPr id="8" name="text-161">
             <a:extLst xmlns:a="http://schemas.openxmlformats.org/drawingml/2006/main">
               <a:ext uri="{FF2B5EF4-FFF2-40B4-BE49-F238E27FC236}">
-                <a16:creationId xmlns:a16="http://schemas.microsoft.com/office/drawing/2014/main" id="{AD53C560-38C5-45F4-BB20-CC63B85E1653}"/>
+                <a16:creationId xmlns:a16="http://schemas.microsoft.com/office/drawing/2014/main" id="{3FD16786-A705-456D-8F1D-41D997B4679C}"/>
               </a:ext>
             </a:extLst>
           </p:cNvPr>
@@ -5024,7 +5024,7 @@
           <p:cNvPr id="9" name="text-162">
             <a:extLst xmlns:a="http://schemas.openxmlformats.org/drawingml/2006/main">
               <a:ext uri="{FF2B5EF4-FFF2-40B4-BE49-F238E27FC236}">
-                <a16:creationId xmlns:a16="http://schemas.microsoft.com/office/drawing/2014/main" id="{82B920FA-C8C9-4A7A-AF7C-FCF3F2699F66}"/>
+                <a16:creationId xmlns:a16="http://schemas.microsoft.com/office/drawing/2014/main" id="{6B62DA74-9EB3-475E-8907-FAF980ED2937}"/>
               </a:ext>
             </a:extLst>
           </p:cNvPr>
@@ -5080,7 +5080,7 @@
           <p:cNvPr id="10" name="text-163">
             <a:extLst xmlns:a="http://schemas.openxmlformats.org/drawingml/2006/main">
               <a:ext uri="{FF2B5EF4-FFF2-40B4-BE49-F238E27FC236}">
-                <a16:creationId xmlns:a16="http://schemas.microsoft.com/office/drawing/2014/main" id="{8CD6B89A-1EF0-458B-955C-28D1DD23DCFD}"/>
+                <a16:creationId xmlns:a16="http://schemas.microsoft.com/office/drawing/2014/main" id="{F3B551EC-E303-4487-839B-27E102C4014C}"/>
               </a:ext>
             </a:extLst>
           </p:cNvPr>
@@ -5136,7 +5136,7 @@
           <p:cNvPr id="11" name="dot-164">
             <a:extLst xmlns:a="http://schemas.openxmlformats.org/drawingml/2006/main">
               <a:ext uri="{FF2B5EF4-FFF2-40B4-BE49-F238E27FC236}">
-                <a16:creationId xmlns:a16="http://schemas.microsoft.com/office/drawing/2014/main" id="{5D0F53A3-D562-4AD2-863E-E49CBFEC58F2}"/>
+                <a16:creationId xmlns:a16="http://schemas.microsoft.com/office/drawing/2014/main" id="{202B3A8E-445B-4ED2-94CE-AC36F732ED7E}"/>
               </a:ext>
             </a:extLst>
           </p:cNvPr>
@@ -5167,7 +5167,7 @@
           <p:cNvPr id="12" name="text-165">
             <a:extLst xmlns:a="http://schemas.openxmlformats.org/drawingml/2006/main">
               <a:ext uri="{FF2B5EF4-FFF2-40B4-BE49-F238E27FC236}">
-                <a16:creationId xmlns:a16="http://schemas.microsoft.com/office/drawing/2014/main" id="{FFDA49E4-B7FB-4074-99EC-E31A2BDEEAD2}"/>
+                <a16:creationId xmlns:a16="http://schemas.microsoft.com/office/drawing/2014/main" id="{0CAEF847-94F6-41D8-A25F-CAAA7D5E1260}"/>
               </a:ext>
             </a:extLst>
           </p:cNvPr>
@@ -5223,7 +5223,7 @@
           <p:cNvPr id="13" name="text-166">
             <a:extLst xmlns:a="http://schemas.openxmlformats.org/drawingml/2006/main">
               <a:ext uri="{FF2B5EF4-FFF2-40B4-BE49-F238E27FC236}">
-                <a16:creationId xmlns:a16="http://schemas.microsoft.com/office/drawing/2014/main" id="{2F9BE5B7-E307-484F-8AE0-AAC149D91940}"/>
+                <a16:creationId xmlns:a16="http://schemas.microsoft.com/office/drawing/2014/main" id="{0A62A614-AF40-47CF-9DE9-64B9682AF689}"/>
               </a:ext>
             </a:extLst>
           </p:cNvPr>
@@ -5279,7 +5279,7 @@
           <p:cNvPr id="14" name="text-167">
             <a:extLst xmlns:a="http://schemas.openxmlformats.org/drawingml/2006/main">
               <a:ext uri="{FF2B5EF4-FFF2-40B4-BE49-F238E27FC236}">
-                <a16:creationId xmlns:a16="http://schemas.microsoft.com/office/drawing/2014/main" id="{2613D64D-57F0-4C43-B5AA-785D45289B09}"/>
+                <a16:creationId xmlns:a16="http://schemas.microsoft.com/office/drawing/2014/main" id="{DC1451FD-3C8C-4471-B819-7E37048AE732}"/>
               </a:ext>
             </a:extLst>
           </p:cNvPr>
@@ -5335,7 +5335,7 @@
           <p:cNvPr id="15" name="dot-168">
             <a:extLst xmlns:a="http://schemas.openxmlformats.org/drawingml/2006/main">
               <a:ext uri="{FF2B5EF4-FFF2-40B4-BE49-F238E27FC236}">
-                <a16:creationId xmlns:a16="http://schemas.microsoft.com/office/drawing/2014/main" id="{52A90B35-29FE-4B6C-8BC8-2F22D641203E}"/>
+                <a16:creationId xmlns:a16="http://schemas.microsoft.com/office/drawing/2014/main" id="{25F1BC0B-59E5-4CAB-A8E0-09019AA11A40}"/>
               </a:ext>
             </a:extLst>
           </p:cNvPr>
@@ -5366,7 +5366,7 @@
           <p:cNvPr id="16" name="text-169">
             <a:extLst xmlns:a="http://schemas.openxmlformats.org/drawingml/2006/main">
               <a:ext uri="{FF2B5EF4-FFF2-40B4-BE49-F238E27FC236}">
-                <a16:creationId xmlns:a16="http://schemas.microsoft.com/office/drawing/2014/main" id="{C86A5D85-0820-4849-B820-F6046A3839CA}"/>
+                <a16:creationId xmlns:a16="http://schemas.microsoft.com/office/drawing/2014/main" id="{60D54C5E-6312-4B21-9BA7-BCD06BA144AA}"/>
               </a:ext>
             </a:extLst>
           </p:cNvPr>
@@ -5422,7 +5422,7 @@
           <p:cNvPr id="17" name="text-170">
             <a:extLst xmlns:a="http://schemas.openxmlformats.org/drawingml/2006/main">
               <a:ext uri="{FF2B5EF4-FFF2-40B4-BE49-F238E27FC236}">
-                <a16:creationId xmlns:a16="http://schemas.microsoft.com/office/drawing/2014/main" id="{F981E8E3-3B29-4F91-B969-835C469AF9E1}"/>
+                <a16:creationId xmlns:a16="http://schemas.microsoft.com/office/drawing/2014/main" id="{07CEBB0C-7485-470A-8FFF-4DA29129C45D}"/>
               </a:ext>
             </a:extLst>
           </p:cNvPr>
@@ -5478,7 +5478,7 @@
           <p:cNvPr id="18" name="text-171">
             <a:extLst xmlns:a="http://schemas.openxmlformats.org/drawingml/2006/main">
               <a:ext uri="{FF2B5EF4-FFF2-40B4-BE49-F238E27FC236}">
-                <a16:creationId xmlns:a16="http://schemas.microsoft.com/office/drawing/2014/main" id="{642BBC0B-9D09-4CDC-B449-EF4A410D85EA}"/>
+                <a16:creationId xmlns:a16="http://schemas.microsoft.com/office/drawing/2014/main" id="{83F67FCA-B8E1-4E4A-AEFB-59787AE90BB6}"/>
               </a:ext>
             </a:extLst>
           </p:cNvPr>
@@ -5534,7 +5534,7 @@
           <p:cNvPr id="19" name="box-172">
             <a:extLst xmlns:a="http://schemas.openxmlformats.org/drawingml/2006/main">
               <a:ext uri="{FF2B5EF4-FFF2-40B4-BE49-F238E27FC236}">
-                <a16:creationId xmlns:a16="http://schemas.microsoft.com/office/drawing/2014/main" id="{47BEDF10-B5FA-4FD9-8C0E-3081995AA5E0}"/>
+                <a16:creationId xmlns:a16="http://schemas.microsoft.com/office/drawing/2014/main" id="{FD7C578F-D603-454D-B61C-B079378D2199}"/>
               </a:ext>
             </a:extLst>
           </p:cNvPr>
@@ -5567,7 +5567,7 @@
           <p:cNvPr id="20" name="text-173">
             <a:extLst xmlns:a="http://schemas.openxmlformats.org/drawingml/2006/main">
               <a:ext uri="{FF2B5EF4-FFF2-40B4-BE49-F238E27FC236}">
-                <a16:creationId xmlns:a16="http://schemas.microsoft.com/office/drawing/2014/main" id="{C0174AED-58FD-40B3-9C16-9758D2F34FBE}"/>
+                <a16:creationId xmlns:a16="http://schemas.microsoft.com/office/drawing/2014/main" id="{E6404CC0-370A-4913-AC68-187FBFCA2E42}"/>
               </a:ext>
             </a:extLst>
           </p:cNvPr>
@@ -5621,7 +5621,7 @@
     </p:spTree>
     <p:extLst>
       <p:ext uri="{BB962C8B-B14F-4D97-AF65-F5344CB8AC3E}">
-        <p14:creationId xmlns:p14="http://schemas.microsoft.com/office/powerpoint/2010/main" val="1150506508"/>
+        <p14:creationId xmlns:p14="http://schemas.microsoft.com/office/powerpoint/2010/main" val="776098431"/>
       </p:ext>
     </p:extLst>
   </p:cSld>
@@ -5652,7 +5652,7 @@
           <p:cNvPr id="18" name="box-174">
             <a:extLst xmlns:a="http://schemas.openxmlformats.org/drawingml/2006/main">
               <a:ext uri="{FF2B5EF4-FFF2-40B4-BE49-F238E27FC236}">
-                <a16:creationId xmlns:a16="http://schemas.microsoft.com/office/drawing/2014/main" id="{8884ED1E-2624-4FBD-8CF3-117D41F57DB2}"/>
+                <a16:creationId xmlns:a16="http://schemas.microsoft.com/office/drawing/2014/main" id="{A9A8A16A-8296-470B-8E3B-AA016F9B500F}"/>
               </a:ext>
             </a:extLst>
           </p:cNvPr>
@@ -5685,7 +5685,7 @@
           <p:cNvPr id="2" name="text-175">
             <a:extLst xmlns:a="http://schemas.openxmlformats.org/drawingml/2006/main">
               <a:ext uri="{FF2B5EF4-FFF2-40B4-BE49-F238E27FC236}">
-                <a16:creationId xmlns:a16="http://schemas.microsoft.com/office/drawing/2014/main" id="{2C842D71-3E9E-444A-A09A-1948BDDA92A6}"/>
+                <a16:creationId xmlns:a16="http://schemas.microsoft.com/office/drawing/2014/main" id="{7847F375-8EB7-4030-B55F-41A17B155552}"/>
               </a:ext>
             </a:extLst>
           </p:cNvPr>
@@ -5741,7 +5741,7 @@
           <p:cNvPr id="3" name="text-176">
             <a:extLst xmlns:a="http://schemas.openxmlformats.org/drawingml/2006/main">
               <a:ext uri="{FF2B5EF4-FFF2-40B4-BE49-F238E27FC236}">
-                <a16:creationId xmlns:a16="http://schemas.microsoft.com/office/drawing/2014/main" id="{19AD03AB-9EC5-4B7A-82F6-8BD58AAC0558}"/>
+                <a16:creationId xmlns:a16="http://schemas.microsoft.com/office/drawing/2014/main" id="{8C2DF656-B1B1-4324-8D65-79D7A2E73F07}"/>
               </a:ext>
             </a:extLst>
           </p:cNvPr>
@@ -5797,7 +5797,7 @@
           <p:cNvPr id="4" name="text-177">
             <a:extLst xmlns:a="http://schemas.openxmlformats.org/drawingml/2006/main">
               <a:ext uri="{FF2B5EF4-FFF2-40B4-BE49-F238E27FC236}">
-                <a16:creationId xmlns:a16="http://schemas.microsoft.com/office/drawing/2014/main" id="{979EE7BF-3726-4738-9A47-989DBCBA7777}"/>
+                <a16:creationId xmlns:a16="http://schemas.microsoft.com/office/drawing/2014/main" id="{28AAC1AD-4712-4CBA-8005-F9C1E401EC06}"/>
               </a:ext>
             </a:extLst>
           </p:cNvPr>
@@ -5853,7 +5853,7 @@
           <p:cNvPr id="5" name="text-178">
             <a:extLst xmlns:a="http://schemas.openxmlformats.org/drawingml/2006/main">
               <a:ext uri="{FF2B5EF4-FFF2-40B4-BE49-F238E27FC236}">
-                <a16:creationId xmlns:a16="http://schemas.microsoft.com/office/drawing/2014/main" id="{FF04E97E-40BF-4A8B-BE18-ABC4D2C8D92B}"/>
+                <a16:creationId xmlns:a16="http://schemas.microsoft.com/office/drawing/2014/main" id="{B560A07B-0A82-48A2-ABE7-D45D818C92E8}"/>
               </a:ext>
             </a:extLst>
           </p:cNvPr>
@@ -5909,7 +5909,7 @@
           <p:cNvPr id="6" name="text-179">
             <a:extLst xmlns:a="http://schemas.openxmlformats.org/drawingml/2006/main">
               <a:ext uri="{FF2B5EF4-FFF2-40B4-BE49-F238E27FC236}">
-                <a16:creationId xmlns:a16="http://schemas.microsoft.com/office/drawing/2014/main" id="{0B52263F-53B9-4442-9390-09B62BA2919B}"/>
+                <a16:creationId xmlns:a16="http://schemas.microsoft.com/office/drawing/2014/main" id="{79B57534-F160-4B87-A89E-19EF041DED90}"/>
               </a:ext>
             </a:extLst>
           </p:cNvPr>
@@ -5965,7 +5965,7 @@
           <p:cNvPr id="7" name="text-180">
             <a:extLst xmlns:a="http://schemas.openxmlformats.org/drawingml/2006/main">
               <a:ext uri="{FF2B5EF4-FFF2-40B4-BE49-F238E27FC236}">
-                <a16:creationId xmlns:a16="http://schemas.microsoft.com/office/drawing/2014/main" id="{67F18CE7-BA50-4EE2-909A-07EA765A66D9}"/>
+                <a16:creationId xmlns:a16="http://schemas.microsoft.com/office/drawing/2014/main" id="{DC131343-C0A3-4433-A74C-8FB1A4A81371}"/>
               </a:ext>
             </a:extLst>
           </p:cNvPr>
@@ -6021,7 +6021,7 @@
           <p:cNvPr id="8" name="text-181">
             <a:extLst xmlns:a="http://schemas.openxmlformats.org/drawingml/2006/main">
               <a:ext uri="{FF2B5EF4-FFF2-40B4-BE49-F238E27FC236}">
-                <a16:creationId xmlns:a16="http://schemas.microsoft.com/office/drawing/2014/main" id="{DAC236D4-EBC1-4944-97ED-E693F73A3BB9}"/>
+                <a16:creationId xmlns:a16="http://schemas.microsoft.com/office/drawing/2014/main" id="{2CD30DC3-82E0-4D5F-987B-45202FBC1A5B}"/>
               </a:ext>
             </a:extLst>
           </p:cNvPr>
@@ -6067,7 +6067,7 @@
                 <a:ea typeface="Arial"/>
                 <a:cs typeface="Arial"/>
               </a:rPr>
-              <a:t>68 / 68</a:t>
+              <a:t>70 / 70</a:t>
             </a:r>
           </a:p>
         </p:txBody>
@@ -6077,7 +6077,7 @@
           <p:cNvPr id="9" name="text-182">
             <a:extLst xmlns:a="http://schemas.openxmlformats.org/drawingml/2006/main">
               <a:ext uri="{FF2B5EF4-FFF2-40B4-BE49-F238E27FC236}">
-                <a16:creationId xmlns:a16="http://schemas.microsoft.com/office/drawing/2014/main" id="{D7DE910B-FDF2-4463-8ADD-9D1ABE64E28A}"/>
+                <a16:creationId xmlns:a16="http://schemas.microsoft.com/office/drawing/2014/main" id="{A16F41B5-5AD2-49C3-8642-8CDB1C444E8C}"/>
               </a:ext>
             </a:extLst>
           </p:cNvPr>
@@ -6133,7 +6133,7 @@
           <p:cNvPr id="10" name="text-183">
             <a:extLst xmlns:a="http://schemas.openxmlformats.org/drawingml/2006/main">
               <a:ext uri="{FF2B5EF4-FFF2-40B4-BE49-F238E27FC236}">
-                <a16:creationId xmlns:a16="http://schemas.microsoft.com/office/drawing/2014/main" id="{2CC183CA-DAD4-456D-8AC0-A8365F2267E5}"/>
+                <a16:creationId xmlns:a16="http://schemas.microsoft.com/office/drawing/2014/main" id="{07631BD0-22C9-4DBA-A6E9-A833E2C62495}"/>
               </a:ext>
             </a:extLst>
           </p:cNvPr>
@@ -6235,7 +6235,7 @@
           <p:cNvPr id="11" name="text-184">
             <a:extLst xmlns:a="http://schemas.openxmlformats.org/drawingml/2006/main">
               <a:ext uri="{FF2B5EF4-FFF2-40B4-BE49-F238E27FC236}">
-                <a16:creationId xmlns:a16="http://schemas.microsoft.com/office/drawing/2014/main" id="{A0A536D7-FFBC-4B20-A013-D75D1F99AF2C}"/>
+                <a16:creationId xmlns:a16="http://schemas.microsoft.com/office/drawing/2014/main" id="{404AD45C-D57A-401A-A74A-FFE18B408C89}"/>
               </a:ext>
             </a:extLst>
           </p:cNvPr>
@@ -6337,7 +6337,7 @@
           <p:cNvPr id="12" name="text-185">
             <a:extLst xmlns:a="http://schemas.openxmlformats.org/drawingml/2006/main">
               <a:ext uri="{FF2B5EF4-FFF2-40B4-BE49-F238E27FC236}">
-                <a16:creationId xmlns:a16="http://schemas.microsoft.com/office/drawing/2014/main" id="{5D99C3F2-B67B-4981-B5CA-357A06D90F9E}"/>
+                <a16:creationId xmlns:a16="http://schemas.microsoft.com/office/drawing/2014/main" id="{A0453307-939C-4994-B6A1-004EE8DFFA2E}"/>
               </a:ext>
             </a:extLst>
           </p:cNvPr>
@@ -6439,7 +6439,7 @@
           <p:cNvPr id="13" name="box-186">
             <a:extLst xmlns:a="http://schemas.openxmlformats.org/drawingml/2006/main">
               <a:ext uri="{FF2B5EF4-FFF2-40B4-BE49-F238E27FC236}">
-                <a16:creationId xmlns:a16="http://schemas.microsoft.com/office/drawing/2014/main" id="{00FCDBB3-BEE0-4CE0-A8CF-5D1410B1B12F}"/>
+                <a16:creationId xmlns:a16="http://schemas.microsoft.com/office/drawing/2014/main" id="{178D68AD-7D30-40E4-8512-1D53830BB151}"/>
               </a:ext>
             </a:extLst>
           </p:cNvPr>
@@ -6472,7 +6472,7 @@
           <p:cNvPr id="14" name="text-187">
             <a:extLst xmlns:a="http://schemas.openxmlformats.org/drawingml/2006/main">
               <a:ext uri="{FF2B5EF4-FFF2-40B4-BE49-F238E27FC236}">
-                <a16:creationId xmlns:a16="http://schemas.microsoft.com/office/drawing/2014/main" id="{B6F694B4-DFBA-41B9-9AD2-4576D064FE20}"/>
+                <a16:creationId xmlns:a16="http://schemas.microsoft.com/office/drawing/2014/main" id="{F17AE0AB-2B24-47D8-95BB-FD33F65A7FDF}"/>
               </a:ext>
             </a:extLst>
           </p:cNvPr>
@@ -6528,7 +6528,7 @@
           <p:cNvPr id="15" name="text-188">
             <a:extLst xmlns:a="http://schemas.openxmlformats.org/drawingml/2006/main">
               <a:ext uri="{FF2B5EF4-FFF2-40B4-BE49-F238E27FC236}">
-                <a16:creationId xmlns:a16="http://schemas.microsoft.com/office/drawing/2014/main" id="{D6CEDB6C-55BF-4ECB-BB2B-D007E0B1EA2D}"/>
+                <a16:creationId xmlns:a16="http://schemas.microsoft.com/office/drawing/2014/main" id="{517692C7-DA81-4651-870C-60817E84FC85}"/>
               </a:ext>
             </a:extLst>
           </p:cNvPr>
@@ -6574,7 +6574,7 @@
                 <a:ea typeface="Arial"/>
                 <a:cs typeface="Arial"/>
               </a:rPr>
-              <a:t>Windows 10/11 (x64) + macOS (Apple Silicon) — İndirme: github.com/Azizsekerdil/FrenchCourseAI/releases (v1.1.1) · (özel repo)</a:t>
+              <a:t>Windows 10/11 (x64) + macOS (Apple Silicon) — İndirme: github.com/Azizsekerdil/FrenchCourseAI/releases (v1.1.2) · (özel repo)</a:t>
             </a:r>
           </a:p>
         </p:txBody>
@@ -6584,7 +6584,7 @@
           <p:cNvPr id="16" name="text-189">
             <a:extLst xmlns:a="http://schemas.openxmlformats.org/drawingml/2006/main">
               <a:ext uri="{FF2B5EF4-FFF2-40B4-BE49-F238E27FC236}">
-                <a16:creationId xmlns:a16="http://schemas.microsoft.com/office/drawing/2014/main" id="{90C595AD-C4B1-475F-A3F5-40F621552F6E}"/>
+                <a16:creationId xmlns:a16="http://schemas.microsoft.com/office/drawing/2014/main" id="{FE5C6782-F7D4-4A1F-BED3-7F116C1FEA71}"/>
               </a:ext>
             </a:extLst>
           </p:cNvPr>
@@ -6630,7 +6630,7 @@
                 <a:ea typeface="Arial"/>
                 <a:cs typeface="Arial"/>
               </a:rPr>
-              <a:t>Windows 10/11 (x64) &amp; macOS (Apple Silicon) — Download: GitHub Releases (v1.1.1)</a:t>
+              <a:t>Windows 10/11 (x64) &amp; macOS (Apple Silicon) — Download: GitHub Releases (v1.1.2)</a:t>
             </a:r>
           </a:p>
         </p:txBody>
@@ -6640,7 +6640,7 @@
           <p:cNvPr id="17" name="text-190">
             <a:extLst xmlns:a="http://schemas.openxmlformats.org/drawingml/2006/main">
               <a:ext uri="{FF2B5EF4-FFF2-40B4-BE49-F238E27FC236}">
-                <a16:creationId xmlns:a16="http://schemas.microsoft.com/office/drawing/2014/main" id="{329A84B0-4595-4686-AADA-B620AB1CE0EC}"/>
+                <a16:creationId xmlns:a16="http://schemas.microsoft.com/office/drawing/2014/main" id="{55D019DB-5DA4-4816-9D35-A8C1B7D581D2}"/>
               </a:ext>
             </a:extLst>
           </p:cNvPr>
@@ -6694,7 +6694,7 @@
     </p:spTree>
     <p:extLst>
       <p:ext uri="{BB962C8B-B14F-4D97-AF65-F5344CB8AC3E}">
-        <p14:creationId xmlns:p14="http://schemas.microsoft.com/office/powerpoint/2010/main" val="537961290"/>
+        <p14:creationId xmlns:p14="http://schemas.microsoft.com/office/powerpoint/2010/main" val="1960873308"/>
       </p:ext>
     </p:extLst>
   </p:cSld>

</xml_diff>

<commit_message>
Sunum: v1.2.0 sözlük yön seçimi, FR-EN-TR ve 88 test
Co-Authored-By: Claude Opus 5 <noreply@anthropic.com>
</commit_message>
<xml_diff>
--- a/docs/presentation/French-Course-AI-Trilingual.pptx
+++ b/docs/presentation/French-Course-AI-Trilingual.pptx
@@ -2,18 +2,18 @@
 <file path=ppt/presentation.xml><?xml version="1.0" encoding="utf-8"?>
 <p:presentation xmlns:p="http://schemas.openxmlformats.org/presentationml/2006/main">
   <p:sldMasterIdLst>
-    <p:sldMasterId xmlns:r="http://schemas.openxmlformats.org/officeDocument/2006/relationships" id="2147483648" r:id="R858a7a852b0248f4"/>
+    <p:sldMasterId xmlns:r="http://schemas.openxmlformats.org/officeDocument/2006/relationships" id="2147483648" r:id="R777d85ec3db14f64"/>
   </p:sldMasterIdLst>
   <p:notesMasterIdLst>
-    <p:notesMasterId xmlns:r="http://schemas.openxmlformats.org/officeDocument/2006/relationships" r:id="R52316acd1f3d4259"/>
+    <p:notesMasterId xmlns:r="http://schemas.openxmlformats.org/officeDocument/2006/relationships" r:id="R91fc055a92494e02"/>
   </p:notesMasterIdLst>
   <p:sldIdLst>
-    <p:sldId xmlns:r="http://schemas.openxmlformats.org/officeDocument/2006/relationships" id="256" r:id="R9a0e630ba4724386"/>
-    <p:sldId xmlns:r="http://schemas.openxmlformats.org/officeDocument/2006/relationships" id="257" r:id="R3f58a6c03f624fdc"/>
-    <p:sldId xmlns:r="http://schemas.openxmlformats.org/officeDocument/2006/relationships" id="258" r:id="Rbd541fd432e34552"/>
-    <p:sldId xmlns:r="http://schemas.openxmlformats.org/officeDocument/2006/relationships" id="259" r:id="R14bc54267b38482b"/>
-    <p:sldId xmlns:r="http://schemas.openxmlformats.org/officeDocument/2006/relationships" id="260" r:id="R976b6544eca749cb"/>
-    <p:sldId xmlns:r="http://schemas.openxmlformats.org/officeDocument/2006/relationships" id="261" r:id="R6ac2e06f3ace4f84"/>
+    <p:sldId xmlns:r="http://schemas.openxmlformats.org/officeDocument/2006/relationships" id="256" r:id="R0b99dc44387846c8"/>
+    <p:sldId xmlns:r="http://schemas.openxmlformats.org/officeDocument/2006/relationships" id="257" r:id="Rec0a6e5ad7234b37"/>
+    <p:sldId xmlns:r="http://schemas.openxmlformats.org/officeDocument/2006/relationships" id="258" r:id="Raab98e2575594611"/>
+    <p:sldId xmlns:r="http://schemas.openxmlformats.org/officeDocument/2006/relationships" id="259" r:id="R10defa035f6748b7"/>
+    <p:sldId xmlns:r="http://schemas.openxmlformats.org/officeDocument/2006/relationships" id="260" r:id="Rdfd9660a46c4428f"/>
+    <p:sldId xmlns:r="http://schemas.openxmlformats.org/officeDocument/2006/relationships" id="261" r:id="R132700071c1845ec"/>
   </p:sldIdLst>
   <p:sldSz cx="12192000" cy="6858000"/>
   <p:notesSz cx="6858000" cy="9144000"/>
@@ -937,7 +937,7 @@
           </a:p>
           <a:p xmlns:a="http://schemas.openxmlformats.org/drawingml/2006/main">
             <a:r>
-              <a:t>- https://github.com/Azizsekerdil/FrenchCourseAI/releases/tag/v1.1.2</a:t>
+              <a:t>- https://github.com/Azizsekerdil/FrenchCourseAI/releases/tag/v1.2.0</a:t>
             </a:r>
           </a:p>
           <a:p xmlns:a="http://schemas.openxmlformats.org/drawingml/2006/main">
@@ -1010,7 +1010,7 @@
   </p:cSld>
   <p:clrMap bg1="lt1" tx1="dk1" bg2="lt2" tx2="dk2" accent1="accent1" accent2="accent2" accent3="accent3" accent4="accent4" accent5="accent5" accent6="accent6" hlink="hlink" folHlink="folHlink"/>
   <p:sldLayoutIdLst>
-    <p:sldLayoutId xmlns:r="http://schemas.openxmlformats.org/officeDocument/2006/relationships" id="2147483649" r:id="Rd6304f18c6b44270"/>
+    <p:sldLayoutId xmlns:r="http://schemas.openxmlformats.org/officeDocument/2006/relationships" id="2147483649" r:id="Rbca1c4b8cc944ff7"/>
   </p:sldLayoutIdLst>
   <p:txStyles>
     <p:titleStyle>
@@ -1561,7 +1561,7 @@
           <p:cNvPr id="13" name="box-96">
             <a:extLst xmlns:a="http://schemas.openxmlformats.org/drawingml/2006/main">
               <a:ext uri="{FF2B5EF4-FFF2-40B4-BE49-F238E27FC236}">
-                <a16:creationId xmlns:a16="http://schemas.microsoft.com/office/drawing/2014/main" id="{659231FC-90EE-44F5-A438-8E9D1EC9F661}"/>
+                <a16:creationId xmlns:a16="http://schemas.microsoft.com/office/drawing/2014/main" id="{CC0BF1FB-07D7-40BA-BCBC-552FC85C5355}"/>
               </a:ext>
             </a:extLst>
           </p:cNvPr>
@@ -1594,7 +1594,7 @@
           <p:cNvPr id="2" name="text-97">
             <a:extLst xmlns:a="http://schemas.openxmlformats.org/drawingml/2006/main">
               <a:ext uri="{FF2B5EF4-FFF2-40B4-BE49-F238E27FC236}">
-                <a16:creationId xmlns:a16="http://schemas.microsoft.com/office/drawing/2014/main" id="{682CB357-B419-4104-A112-13F7549FF62A}"/>
+                <a16:creationId xmlns:a16="http://schemas.microsoft.com/office/drawing/2014/main" id="{B23721B5-210A-4D17-AF1F-A5566226BCED}"/>
               </a:ext>
             </a:extLst>
           </p:cNvPr>
@@ -1650,7 +1650,7 @@
           <p:cNvPr id="3" name="text-98">
             <a:extLst xmlns:a="http://schemas.openxmlformats.org/drawingml/2006/main">
               <a:ext uri="{FF2B5EF4-FFF2-40B4-BE49-F238E27FC236}">
-                <a16:creationId xmlns:a16="http://schemas.microsoft.com/office/drawing/2014/main" id="{CCB917A1-41A0-411B-962B-BF200533DBC9}"/>
+                <a16:creationId xmlns:a16="http://schemas.microsoft.com/office/drawing/2014/main" id="{D824C073-C521-44E6-957A-A011BE3FE694}"/>
               </a:ext>
             </a:extLst>
           </p:cNvPr>
@@ -1706,7 +1706,7 @@
           <p:cNvPr id="4" name="text-99">
             <a:extLst xmlns:a="http://schemas.openxmlformats.org/drawingml/2006/main">
               <a:ext uri="{FF2B5EF4-FFF2-40B4-BE49-F238E27FC236}">
-                <a16:creationId xmlns:a16="http://schemas.microsoft.com/office/drawing/2014/main" id="{4EE4AC98-81EA-4FA3-A42D-8E32A659FF02}"/>
+                <a16:creationId xmlns:a16="http://schemas.microsoft.com/office/drawing/2014/main" id="{D03651C7-D89A-46C4-9EC1-B91E15460D73}"/>
               </a:ext>
             </a:extLst>
           </p:cNvPr>
@@ -1762,7 +1762,7 @@
           <p:cNvPr id="5" name="text-100">
             <a:extLst xmlns:a="http://schemas.openxmlformats.org/drawingml/2006/main">
               <a:ext uri="{FF2B5EF4-FFF2-40B4-BE49-F238E27FC236}">
-                <a16:creationId xmlns:a16="http://schemas.microsoft.com/office/drawing/2014/main" id="{52C4F760-6050-4BFB-A9D3-05C73A1F670A}"/>
+                <a16:creationId xmlns:a16="http://schemas.microsoft.com/office/drawing/2014/main" id="{C0C1C4E1-399D-4F92-A060-BA5578B53702}"/>
               </a:ext>
             </a:extLst>
           </p:cNvPr>
@@ -1818,7 +1818,7 @@
           <p:cNvPr id="6" name="text-101">
             <a:extLst xmlns:a="http://schemas.openxmlformats.org/drawingml/2006/main">
               <a:ext uri="{FF2B5EF4-FFF2-40B4-BE49-F238E27FC236}">
-                <a16:creationId xmlns:a16="http://schemas.microsoft.com/office/drawing/2014/main" id="{3D14FD1F-3EE8-4FE0-BEB1-0F714379CFFE}"/>
+                <a16:creationId xmlns:a16="http://schemas.microsoft.com/office/drawing/2014/main" id="{4774CDE8-FC31-4E74-A1CF-75D4FE21A2C1}"/>
               </a:ext>
             </a:extLst>
           </p:cNvPr>
@@ -1874,7 +1874,7 @@
           <p:cNvPr id="7" name="text-102">
             <a:extLst xmlns:a="http://schemas.openxmlformats.org/drawingml/2006/main">
               <a:ext uri="{FF2B5EF4-FFF2-40B4-BE49-F238E27FC236}">
-                <a16:creationId xmlns:a16="http://schemas.microsoft.com/office/drawing/2014/main" id="{F22EEA0E-A2D0-4CCB-A9DD-795F11C8DE63}"/>
+                <a16:creationId xmlns:a16="http://schemas.microsoft.com/office/drawing/2014/main" id="{C0DFD30B-E1AC-4B58-BE3E-0BBCB6CB7CC5}"/>
               </a:ext>
             </a:extLst>
           </p:cNvPr>
@@ -1930,7 +1930,7 @@
           <p:cNvPr id="8" name="text-103">
             <a:extLst xmlns:a="http://schemas.openxmlformats.org/drawingml/2006/main">
               <a:ext uri="{FF2B5EF4-FFF2-40B4-BE49-F238E27FC236}">
-                <a16:creationId xmlns:a16="http://schemas.microsoft.com/office/drawing/2014/main" id="{820147D4-6555-422A-8C46-C8FF5D778678}"/>
+                <a16:creationId xmlns:a16="http://schemas.microsoft.com/office/drawing/2014/main" id="{649F2FE8-E022-46CD-81B9-EC55DADF963F}"/>
               </a:ext>
             </a:extLst>
           </p:cNvPr>
@@ -1986,7 +1986,7 @@
           <p:cNvPr id="9" name="text-104">
             <a:extLst xmlns:a="http://schemas.openxmlformats.org/drawingml/2006/main">
               <a:ext uri="{FF2B5EF4-FFF2-40B4-BE49-F238E27FC236}">
-                <a16:creationId xmlns:a16="http://schemas.microsoft.com/office/drawing/2014/main" id="{A42412D5-6ED9-47D9-852C-3C54FF6E0D72}"/>
+                <a16:creationId xmlns:a16="http://schemas.microsoft.com/office/drawing/2014/main" id="{00195D0B-9D18-4F2A-AE0B-E8476F691817}"/>
               </a:ext>
             </a:extLst>
           </p:cNvPr>
@@ -2042,7 +2042,7 @@
           <p:cNvPr id="10" name="box-105">
             <a:extLst xmlns:a="http://schemas.openxmlformats.org/drawingml/2006/main">
               <a:ext uri="{FF2B5EF4-FFF2-40B4-BE49-F238E27FC236}">
-                <a16:creationId xmlns:a16="http://schemas.microsoft.com/office/drawing/2014/main" id="{2D9635B5-30FB-4440-AA6B-0B982FADA348}"/>
+                <a16:creationId xmlns:a16="http://schemas.microsoft.com/office/drawing/2014/main" id="{A5D8DF39-1309-4E4A-9663-C67BA8678562}"/>
               </a:ext>
             </a:extLst>
           </p:cNvPr>
@@ -2079,7 +2079,7 @@
           <p:nvPr/>
         </p:nvPicPr>
         <p:blipFill>
-          <a:blip xmlns:r="http://schemas.openxmlformats.org/officeDocument/2006/relationships" xmlns:a="http://schemas.openxmlformats.org/drawingml/2006/main" r:embed="Re56a210efca84873"/>
+          <a:blip xmlns:r="http://schemas.openxmlformats.org/officeDocument/2006/relationships" xmlns:a="http://schemas.openxmlformats.org/drawingml/2006/main" r:embed="Rbc8f959f8bed4518"/>
           <a:stretch xmlns:a="http://schemas.openxmlformats.org/drawingml/2006/main"/>
         </p:blipFill>
         <p:spPr>
@@ -2097,7 +2097,7 @@
           <p:cNvPr id="12" name="text-106">
             <a:extLst xmlns:a="http://schemas.openxmlformats.org/drawingml/2006/main">
               <a:ext uri="{FF2B5EF4-FFF2-40B4-BE49-F238E27FC236}">
-                <a16:creationId xmlns:a16="http://schemas.microsoft.com/office/drawing/2014/main" id="{A611FF8D-8B50-47FF-806A-2B861BB68645}"/>
+                <a16:creationId xmlns:a16="http://schemas.microsoft.com/office/drawing/2014/main" id="{6B822255-19ED-4BFA-9AA7-31C32A0089F5}"/>
               </a:ext>
             </a:extLst>
           </p:cNvPr>
@@ -2151,7 +2151,7 @@
     </p:spTree>
     <p:extLst>
       <p:ext uri="{BB962C8B-B14F-4D97-AF65-F5344CB8AC3E}">
-        <p14:creationId xmlns:p14="http://schemas.microsoft.com/office/powerpoint/2010/main" val="1153727311"/>
+        <p14:creationId xmlns:p14="http://schemas.microsoft.com/office/powerpoint/2010/main" val="227037160"/>
       </p:ext>
     </p:extLst>
   </p:cSld>
@@ -2182,7 +2182,7 @@
           <p:cNvPr id="14" name="box-107">
             <a:extLst xmlns:a="http://schemas.openxmlformats.org/drawingml/2006/main">
               <a:ext uri="{FF2B5EF4-FFF2-40B4-BE49-F238E27FC236}">
-                <a16:creationId xmlns:a16="http://schemas.microsoft.com/office/drawing/2014/main" id="{C9CCFE9D-6B2D-4B48-89E4-078453BC0D11}"/>
+                <a16:creationId xmlns:a16="http://schemas.microsoft.com/office/drawing/2014/main" id="{B269E1CB-373D-49D1-858B-D4DEB8C380A1}"/>
               </a:ext>
             </a:extLst>
           </p:cNvPr>
@@ -2215,7 +2215,7 @@
           <p:cNvPr id="2" name="text-108">
             <a:extLst xmlns:a="http://schemas.openxmlformats.org/drawingml/2006/main">
               <a:ext uri="{FF2B5EF4-FFF2-40B4-BE49-F238E27FC236}">
-                <a16:creationId xmlns:a16="http://schemas.microsoft.com/office/drawing/2014/main" id="{463FA626-65C6-4ABE-AA6F-FC62B300D276}"/>
+                <a16:creationId xmlns:a16="http://schemas.microsoft.com/office/drawing/2014/main" id="{5706F6B9-09F0-4DD9-863C-8F27792870E6}"/>
               </a:ext>
             </a:extLst>
           </p:cNvPr>
@@ -2271,7 +2271,7 @@
           <p:cNvPr id="3" name="text-109">
             <a:extLst xmlns:a="http://schemas.openxmlformats.org/drawingml/2006/main">
               <a:ext uri="{FF2B5EF4-FFF2-40B4-BE49-F238E27FC236}">
-                <a16:creationId xmlns:a16="http://schemas.microsoft.com/office/drawing/2014/main" id="{F7F24C49-BBCB-4B07-892B-D053E8AD1878}"/>
+                <a16:creationId xmlns:a16="http://schemas.microsoft.com/office/drawing/2014/main" id="{52BFCF78-AAEA-4251-BD27-2C26F12FFB1C}"/>
               </a:ext>
             </a:extLst>
           </p:cNvPr>
@@ -2327,7 +2327,7 @@
           <p:cNvPr id="4" name="text-110">
             <a:extLst xmlns:a="http://schemas.openxmlformats.org/drawingml/2006/main">
               <a:ext uri="{FF2B5EF4-FFF2-40B4-BE49-F238E27FC236}">
-                <a16:creationId xmlns:a16="http://schemas.microsoft.com/office/drawing/2014/main" id="{921AC716-DD37-4B64-B7C9-F58FD103DBC6}"/>
+                <a16:creationId xmlns:a16="http://schemas.microsoft.com/office/drawing/2014/main" id="{69A3F8AF-2BEC-4A6C-B224-BD44FEE4E3C0}"/>
               </a:ext>
             </a:extLst>
           </p:cNvPr>
@@ -2383,7 +2383,7 @@
           <p:cNvPr id="5" name="text-111">
             <a:extLst xmlns:a="http://schemas.openxmlformats.org/drawingml/2006/main">
               <a:ext uri="{FF2B5EF4-FFF2-40B4-BE49-F238E27FC236}">
-                <a16:creationId xmlns:a16="http://schemas.microsoft.com/office/drawing/2014/main" id="{FDE4CC3D-C5C9-43E5-B4D9-11849E8AE005}"/>
+                <a16:creationId xmlns:a16="http://schemas.microsoft.com/office/drawing/2014/main" id="{21A99CF0-2143-4EDA-9F02-5674A40AEA27}"/>
               </a:ext>
             </a:extLst>
           </p:cNvPr>
@@ -2439,7 +2439,7 @@
           <p:cNvPr id="6" name="text-112">
             <a:extLst xmlns:a="http://schemas.openxmlformats.org/drawingml/2006/main">
               <a:ext uri="{FF2B5EF4-FFF2-40B4-BE49-F238E27FC236}">
-                <a16:creationId xmlns:a16="http://schemas.microsoft.com/office/drawing/2014/main" id="{6EA1B16A-9BEB-4ADC-9C6F-57F14BADCB5E}"/>
+                <a16:creationId xmlns:a16="http://schemas.microsoft.com/office/drawing/2014/main" id="{7B0B5E00-6C93-4672-AB54-58805AD1B754}"/>
               </a:ext>
             </a:extLst>
           </p:cNvPr>
@@ -2495,7 +2495,7 @@
           <p:cNvPr id="7" name="box-113">
             <a:extLst xmlns:a="http://schemas.openxmlformats.org/drawingml/2006/main">
               <a:ext uri="{FF2B5EF4-FFF2-40B4-BE49-F238E27FC236}">
-                <a16:creationId xmlns:a16="http://schemas.microsoft.com/office/drawing/2014/main" id="{B95B1C3A-F21A-4DBF-BFBD-2B4E4747F0D6}"/>
+                <a16:creationId xmlns:a16="http://schemas.microsoft.com/office/drawing/2014/main" id="{8DA99D75-94EB-47A2-BC12-5012356D4641}"/>
               </a:ext>
             </a:extLst>
           </p:cNvPr>
@@ -2528,7 +2528,7 @@
           <p:cNvPr id="8" name="text-114">
             <a:extLst xmlns:a="http://schemas.openxmlformats.org/drawingml/2006/main">
               <a:ext uri="{FF2B5EF4-FFF2-40B4-BE49-F238E27FC236}">
-                <a16:creationId xmlns:a16="http://schemas.microsoft.com/office/drawing/2014/main" id="{F855C02B-A0DE-4258-B49B-F97AF127C558}"/>
+                <a16:creationId xmlns:a16="http://schemas.microsoft.com/office/drawing/2014/main" id="{44AFB38B-29E4-429E-BA37-45A525958D2D}"/>
               </a:ext>
             </a:extLst>
           </p:cNvPr>
@@ -2574,7 +2574,7 @@
                 <a:ea typeface="Arial"/>
                 <a:cs typeface="Arial"/>
               </a:rPr>
-              <a:t>18 espaces relient révision, vocabulaire, dictionnaire bilingue FR-EN, examen, grammaire et pratique dans un atelier Windows cohérent.</a:t>
+              <a:t>18 espaces relient révision, vocabulaire, dictionnaire trilingue FR-EN-TR, examen, grammaire et pratique dans un atelier Windows cohérent.</a:t>
             </a:r>
           </a:p>
         </p:txBody>
@@ -2584,7 +2584,7 @@
           <p:cNvPr id="9" name="text-115">
             <a:extLst xmlns:a="http://schemas.openxmlformats.org/drawingml/2006/main">
               <a:ext uri="{FF2B5EF4-FFF2-40B4-BE49-F238E27FC236}">
-                <a16:creationId xmlns:a16="http://schemas.microsoft.com/office/drawing/2014/main" id="{8361A773-13B0-4D9C-BA7A-CBC84F1280E2}"/>
+                <a16:creationId xmlns:a16="http://schemas.microsoft.com/office/drawing/2014/main" id="{7BDEF8E6-2EAC-4B18-A12A-4C7723455B8E}"/>
               </a:ext>
             </a:extLst>
           </p:cNvPr>
@@ -2640,7 +2640,7 @@
           <p:cNvPr id="10" name="text-116">
             <a:extLst xmlns:a="http://schemas.openxmlformats.org/drawingml/2006/main">
               <a:ext uri="{FF2B5EF4-FFF2-40B4-BE49-F238E27FC236}">
-                <a16:creationId xmlns:a16="http://schemas.microsoft.com/office/drawing/2014/main" id="{27B5A3A9-705B-4BB5-A23D-F6601A072E4F}"/>
+                <a16:creationId xmlns:a16="http://schemas.microsoft.com/office/drawing/2014/main" id="{FFD30B6D-CACA-4BF8-9DDA-C813C5747497}"/>
               </a:ext>
             </a:extLst>
           </p:cNvPr>
@@ -2696,7 +2696,7 @@
           <p:cNvPr id="11" name="box-117">
             <a:extLst xmlns:a="http://schemas.openxmlformats.org/drawingml/2006/main">
               <a:ext uri="{FF2B5EF4-FFF2-40B4-BE49-F238E27FC236}">
-                <a16:creationId xmlns:a16="http://schemas.microsoft.com/office/drawing/2014/main" id="{AEAE9C2C-F48B-40C9-A667-96AAB80D5978}"/>
+                <a16:creationId xmlns:a16="http://schemas.microsoft.com/office/drawing/2014/main" id="{6C3FBAB0-4799-40A7-8D40-4C954215F1A2}"/>
               </a:ext>
             </a:extLst>
           </p:cNvPr>
@@ -2733,7 +2733,7 @@
           <p:nvPr/>
         </p:nvPicPr>
         <p:blipFill>
-          <a:blip xmlns:r="http://schemas.openxmlformats.org/officeDocument/2006/relationships" xmlns:a="http://schemas.openxmlformats.org/drawingml/2006/main" r:embed="R3e306e966af14cbd"/>
+          <a:blip xmlns:r="http://schemas.openxmlformats.org/officeDocument/2006/relationships" xmlns:a="http://schemas.openxmlformats.org/drawingml/2006/main" r:embed="Ra3e48b2253524b27"/>
           <a:stretch xmlns:a="http://schemas.openxmlformats.org/drawingml/2006/main"/>
         </p:blipFill>
         <p:spPr>
@@ -2751,7 +2751,7 @@
           <p:cNvPr id="13" name="text-118">
             <a:extLst xmlns:a="http://schemas.openxmlformats.org/drawingml/2006/main">
               <a:ext uri="{FF2B5EF4-FFF2-40B4-BE49-F238E27FC236}">
-                <a16:creationId xmlns:a16="http://schemas.microsoft.com/office/drawing/2014/main" id="{52036F32-A3AB-4C8A-972F-CC19D6803B72}"/>
+                <a16:creationId xmlns:a16="http://schemas.microsoft.com/office/drawing/2014/main" id="{865017A2-6418-4025-8528-589A5ED2514C}"/>
               </a:ext>
             </a:extLst>
           </p:cNvPr>
@@ -2805,7 +2805,7 @@
     </p:spTree>
     <p:extLst>
       <p:ext uri="{BB962C8B-B14F-4D97-AF65-F5344CB8AC3E}">
-        <p14:creationId xmlns:p14="http://schemas.microsoft.com/office/powerpoint/2010/main" val="266341911"/>
+        <p14:creationId xmlns:p14="http://schemas.microsoft.com/office/powerpoint/2010/main" val="162567238"/>
       </p:ext>
     </p:extLst>
   </p:cSld>
@@ -2836,7 +2836,7 @@
           <p:cNvPr id="19" name="box-119">
             <a:extLst xmlns:a="http://schemas.openxmlformats.org/drawingml/2006/main">
               <a:ext uri="{FF2B5EF4-FFF2-40B4-BE49-F238E27FC236}">
-                <a16:creationId xmlns:a16="http://schemas.microsoft.com/office/drawing/2014/main" id="{DDFA347D-4FFA-4CAB-9862-0C5AE68B3E73}"/>
+                <a16:creationId xmlns:a16="http://schemas.microsoft.com/office/drawing/2014/main" id="{5430FB06-83C2-4ABD-A69E-4A9D69A64C21}"/>
               </a:ext>
             </a:extLst>
           </p:cNvPr>
@@ -2869,7 +2869,7 @@
           <p:cNvPr id="2" name="text-120">
             <a:extLst xmlns:a="http://schemas.openxmlformats.org/drawingml/2006/main">
               <a:ext uri="{FF2B5EF4-FFF2-40B4-BE49-F238E27FC236}">
-                <a16:creationId xmlns:a16="http://schemas.microsoft.com/office/drawing/2014/main" id="{EF840281-A6B4-4015-BBDB-7C0F28988B72}"/>
+                <a16:creationId xmlns:a16="http://schemas.microsoft.com/office/drawing/2014/main" id="{83230D2E-C8A0-40D6-9427-1AF692D2DCE9}"/>
               </a:ext>
             </a:extLst>
           </p:cNvPr>
@@ -2925,7 +2925,7 @@
           <p:cNvPr id="3" name="text-121">
             <a:extLst xmlns:a="http://schemas.openxmlformats.org/drawingml/2006/main">
               <a:ext uri="{FF2B5EF4-FFF2-40B4-BE49-F238E27FC236}">
-                <a16:creationId xmlns:a16="http://schemas.microsoft.com/office/drawing/2014/main" id="{9608319E-A7D9-4876-9804-BD8D1F321A7E}"/>
+                <a16:creationId xmlns:a16="http://schemas.microsoft.com/office/drawing/2014/main" id="{429073D4-2FB1-4699-B00F-305630224762}"/>
               </a:ext>
             </a:extLst>
           </p:cNvPr>
@@ -2981,7 +2981,7 @@
           <p:cNvPr id="4" name="text-122">
             <a:extLst xmlns:a="http://schemas.openxmlformats.org/drawingml/2006/main">
               <a:ext uri="{FF2B5EF4-FFF2-40B4-BE49-F238E27FC236}">
-                <a16:creationId xmlns:a16="http://schemas.microsoft.com/office/drawing/2014/main" id="{AD4FA21A-2E0C-4012-B405-369AD870A577}"/>
+                <a16:creationId xmlns:a16="http://schemas.microsoft.com/office/drawing/2014/main" id="{153B5A8F-83F5-42E8-8855-A2D56BFE9060}"/>
               </a:ext>
             </a:extLst>
           </p:cNvPr>
@@ -3037,7 +3037,7 @@
           <p:cNvPr id="5" name="text-123">
             <a:extLst xmlns:a="http://schemas.openxmlformats.org/drawingml/2006/main">
               <a:ext uri="{FF2B5EF4-FFF2-40B4-BE49-F238E27FC236}">
-                <a16:creationId xmlns:a16="http://schemas.microsoft.com/office/drawing/2014/main" id="{6E73251A-21E7-4DA4-8383-168B63803738}"/>
+                <a16:creationId xmlns:a16="http://schemas.microsoft.com/office/drawing/2014/main" id="{BE2B181E-E866-4C3F-BBCF-20B021D3FF99}"/>
               </a:ext>
             </a:extLst>
           </p:cNvPr>
@@ -3093,7 +3093,7 @@
           <p:cNvPr id="6" name="text-124">
             <a:extLst xmlns:a="http://schemas.openxmlformats.org/drawingml/2006/main">
               <a:ext uri="{FF2B5EF4-FFF2-40B4-BE49-F238E27FC236}">
-                <a16:creationId xmlns:a16="http://schemas.microsoft.com/office/drawing/2014/main" id="{5968340F-F5CD-4BAA-9FC2-FB7E33BF5273}"/>
+                <a16:creationId xmlns:a16="http://schemas.microsoft.com/office/drawing/2014/main" id="{C9DEDAD6-B025-4FBD-A285-27D5B0B7EC94}"/>
               </a:ext>
             </a:extLst>
           </p:cNvPr>
@@ -3149,7 +3149,7 @@
           <p:cNvPr id="7" name="box-125">
             <a:extLst xmlns:a="http://schemas.openxmlformats.org/drawingml/2006/main">
               <a:ext uri="{FF2B5EF4-FFF2-40B4-BE49-F238E27FC236}">
-                <a16:creationId xmlns:a16="http://schemas.microsoft.com/office/drawing/2014/main" id="{8AB29EC7-E76D-4E78-9E13-A51251214AEE}"/>
+                <a16:creationId xmlns:a16="http://schemas.microsoft.com/office/drawing/2014/main" id="{118A01AA-B81D-4527-9915-8A45167B0BB4}"/>
               </a:ext>
             </a:extLst>
           </p:cNvPr>
@@ -3182,7 +3182,7 @@
           <p:cNvPr id="8" name="text-126">
             <a:extLst xmlns:a="http://schemas.openxmlformats.org/drawingml/2006/main">
               <a:ext uri="{FF2B5EF4-FFF2-40B4-BE49-F238E27FC236}">
-                <a16:creationId xmlns:a16="http://schemas.microsoft.com/office/drawing/2014/main" id="{B3DB7247-DFA3-45ED-9D6E-9E3395CAAF33}"/>
+                <a16:creationId xmlns:a16="http://schemas.microsoft.com/office/drawing/2014/main" id="{D42E28CA-67BB-43B7-B1E3-977569CD3C7E}"/>
               </a:ext>
             </a:extLst>
           </p:cNvPr>
@@ -3238,7 +3238,7 @@
           <p:cNvPr id="9" name="text-127">
             <a:extLst xmlns:a="http://schemas.openxmlformats.org/drawingml/2006/main">
               <a:ext uri="{FF2B5EF4-FFF2-40B4-BE49-F238E27FC236}">
-                <a16:creationId xmlns:a16="http://schemas.microsoft.com/office/drawing/2014/main" id="{1D684FC0-A22D-464C-AFF3-20035F0CBDAB}"/>
+                <a16:creationId xmlns:a16="http://schemas.microsoft.com/office/drawing/2014/main" id="{7D030B3B-E708-452E-8C31-30EA12ADF34E}"/>
               </a:ext>
             </a:extLst>
           </p:cNvPr>
@@ -3294,7 +3294,7 @@
           <p:cNvPr id="10" name="text-128">
             <a:extLst xmlns:a="http://schemas.openxmlformats.org/drawingml/2006/main">
               <a:ext uri="{FF2B5EF4-FFF2-40B4-BE49-F238E27FC236}">
-                <a16:creationId xmlns:a16="http://schemas.microsoft.com/office/drawing/2014/main" id="{C008757B-9E59-4512-A475-4CD900697E19}"/>
+                <a16:creationId xmlns:a16="http://schemas.microsoft.com/office/drawing/2014/main" id="{E3F8E93C-C84E-489C-81C5-4CEFEF1E39EC}"/>
               </a:ext>
             </a:extLst>
           </p:cNvPr>
@@ -3350,7 +3350,7 @@
           <p:cNvPr id="11" name="box-129">
             <a:extLst xmlns:a="http://schemas.openxmlformats.org/drawingml/2006/main">
               <a:ext uri="{FF2B5EF4-FFF2-40B4-BE49-F238E27FC236}">
-                <a16:creationId xmlns:a16="http://schemas.microsoft.com/office/drawing/2014/main" id="{A2CF9BAC-632A-4E82-AD3C-A447BB57B070}"/>
+                <a16:creationId xmlns:a16="http://schemas.microsoft.com/office/drawing/2014/main" id="{C2174192-882D-4EEE-8C51-E840C6F575E2}"/>
               </a:ext>
             </a:extLst>
           </p:cNvPr>
@@ -3383,7 +3383,7 @@
           <p:cNvPr id="12" name="text-130">
             <a:extLst xmlns:a="http://schemas.openxmlformats.org/drawingml/2006/main">
               <a:ext uri="{FF2B5EF4-FFF2-40B4-BE49-F238E27FC236}">
-                <a16:creationId xmlns:a16="http://schemas.microsoft.com/office/drawing/2014/main" id="{E94B7CB2-FEA2-49D5-8E42-A18119970B74}"/>
+                <a16:creationId xmlns:a16="http://schemas.microsoft.com/office/drawing/2014/main" id="{EE1AEBDE-6BB1-4BB4-869B-45816DB6FDE6}"/>
               </a:ext>
             </a:extLst>
           </p:cNvPr>
@@ -3439,7 +3439,7 @@
           <p:cNvPr id="13" name="text-131">
             <a:extLst xmlns:a="http://schemas.openxmlformats.org/drawingml/2006/main">
               <a:ext uri="{FF2B5EF4-FFF2-40B4-BE49-F238E27FC236}">
-                <a16:creationId xmlns:a16="http://schemas.microsoft.com/office/drawing/2014/main" id="{973F7E6B-5516-4B03-BD2D-BE09AC0E897E}"/>
+                <a16:creationId xmlns:a16="http://schemas.microsoft.com/office/drawing/2014/main" id="{08398D45-358D-4ED2-9A3E-00B1594E9FAB}"/>
               </a:ext>
             </a:extLst>
           </p:cNvPr>
@@ -3485,7 +3485,7 @@
                 <a:ea typeface="Arial"/>
                 <a:cs typeface="Arial"/>
               </a:rPr>
-              <a:t>162 A1 entries, a 1,210-entry FR-EN dictionary, strict accented answers, exams, favorites and mistakes share one SQLite record.</a:t>
+              <a:t>162 A1 entries, a 1,210-entry FR-EN-TR dictionary with selectable direction, strict accented answers, exams, favorites and mistakes share one SQLite record.</a:t>
             </a:r>
           </a:p>
         </p:txBody>
@@ -3495,7 +3495,7 @@
           <p:cNvPr id="14" name="text-132">
             <a:extLst xmlns:a="http://schemas.openxmlformats.org/drawingml/2006/main">
               <a:ext uri="{FF2B5EF4-FFF2-40B4-BE49-F238E27FC236}">
-                <a16:creationId xmlns:a16="http://schemas.microsoft.com/office/drawing/2014/main" id="{AAB00184-D789-4860-877E-B5F3B72F4AF6}"/>
+                <a16:creationId xmlns:a16="http://schemas.microsoft.com/office/drawing/2014/main" id="{12D611CE-A6A5-43C3-9C8E-F8D716BA941C}"/>
               </a:ext>
             </a:extLst>
           </p:cNvPr>
@@ -3551,7 +3551,7 @@
           <p:cNvPr id="15" name="box-133">
             <a:extLst xmlns:a="http://schemas.openxmlformats.org/drawingml/2006/main">
               <a:ext uri="{FF2B5EF4-FFF2-40B4-BE49-F238E27FC236}">
-                <a16:creationId xmlns:a16="http://schemas.microsoft.com/office/drawing/2014/main" id="{E22EB908-294A-4E19-AE30-79BC46F639D8}"/>
+                <a16:creationId xmlns:a16="http://schemas.microsoft.com/office/drawing/2014/main" id="{AC87ADB6-681B-4C64-9AD5-50C7A020F9A8}"/>
               </a:ext>
             </a:extLst>
           </p:cNvPr>
@@ -3584,7 +3584,7 @@
           <p:cNvPr id="16" name="text-134">
             <a:extLst xmlns:a="http://schemas.openxmlformats.org/drawingml/2006/main">
               <a:ext uri="{FF2B5EF4-FFF2-40B4-BE49-F238E27FC236}">
-                <a16:creationId xmlns:a16="http://schemas.microsoft.com/office/drawing/2014/main" id="{96777C01-9A62-4A55-9DC5-84D3E262B096}"/>
+                <a16:creationId xmlns:a16="http://schemas.microsoft.com/office/drawing/2014/main" id="{20166F77-824B-4F41-BD37-4703A75A2D8F}"/>
               </a:ext>
             </a:extLst>
           </p:cNvPr>
@@ -3640,7 +3640,7 @@
           <p:cNvPr id="17" name="text-135">
             <a:extLst xmlns:a="http://schemas.openxmlformats.org/drawingml/2006/main">
               <a:ext uri="{FF2B5EF4-FFF2-40B4-BE49-F238E27FC236}">
-                <a16:creationId xmlns:a16="http://schemas.microsoft.com/office/drawing/2014/main" id="{C7545CC8-8673-469E-91E3-B9546E62906B}"/>
+                <a16:creationId xmlns:a16="http://schemas.microsoft.com/office/drawing/2014/main" id="{B0CBF7D2-DEDB-4537-9706-AD860A32B86A}"/>
               </a:ext>
             </a:extLst>
           </p:cNvPr>
@@ -3696,7 +3696,7 @@
           <p:cNvPr id="18" name="text-136">
             <a:extLst xmlns:a="http://schemas.openxmlformats.org/drawingml/2006/main">
               <a:ext uri="{FF2B5EF4-FFF2-40B4-BE49-F238E27FC236}">
-                <a16:creationId xmlns:a16="http://schemas.microsoft.com/office/drawing/2014/main" id="{4D216BBC-5D01-43F9-BCB3-9BCA45782154}"/>
+                <a16:creationId xmlns:a16="http://schemas.microsoft.com/office/drawing/2014/main" id="{B461667C-611E-46DE-B36F-5C9A8C99A58C}"/>
               </a:ext>
             </a:extLst>
           </p:cNvPr>
@@ -3750,7 +3750,7 @@
     </p:spTree>
     <p:extLst>
       <p:ext uri="{BB962C8B-B14F-4D97-AF65-F5344CB8AC3E}">
-        <p14:creationId xmlns:p14="http://schemas.microsoft.com/office/powerpoint/2010/main" val="436792226"/>
+        <p14:creationId xmlns:p14="http://schemas.microsoft.com/office/powerpoint/2010/main" val="1651305419"/>
       </p:ext>
     </p:extLst>
   </p:cSld>
@@ -3781,7 +3781,7 @@
           <p:cNvPr id="18" name="box-137">
             <a:extLst xmlns:a="http://schemas.openxmlformats.org/drawingml/2006/main">
               <a:ext uri="{FF2B5EF4-FFF2-40B4-BE49-F238E27FC236}">
-                <a16:creationId xmlns:a16="http://schemas.microsoft.com/office/drawing/2014/main" id="{7E422107-8DAC-49F8-A70D-451A310EF9CE}"/>
+                <a16:creationId xmlns:a16="http://schemas.microsoft.com/office/drawing/2014/main" id="{86098B13-3A3B-4803-A531-7C54E79ADEB7}"/>
               </a:ext>
             </a:extLst>
           </p:cNvPr>
@@ -3814,7 +3814,7 @@
           <p:cNvPr id="2" name="text-138">
             <a:extLst xmlns:a="http://schemas.openxmlformats.org/drawingml/2006/main">
               <a:ext uri="{FF2B5EF4-FFF2-40B4-BE49-F238E27FC236}">
-                <a16:creationId xmlns:a16="http://schemas.microsoft.com/office/drawing/2014/main" id="{7BE6EDBD-FCF1-4807-A3B2-37C589A1A969}"/>
+                <a16:creationId xmlns:a16="http://schemas.microsoft.com/office/drawing/2014/main" id="{8FFD2369-0BEF-4976-B665-F9DE5A182EC9}"/>
               </a:ext>
             </a:extLst>
           </p:cNvPr>
@@ -3870,7 +3870,7 @@
           <p:cNvPr id="3" name="text-139">
             <a:extLst xmlns:a="http://schemas.openxmlformats.org/drawingml/2006/main">
               <a:ext uri="{FF2B5EF4-FFF2-40B4-BE49-F238E27FC236}">
-                <a16:creationId xmlns:a16="http://schemas.microsoft.com/office/drawing/2014/main" id="{0FAD770B-D91F-4705-ABB6-4A0C9773F0A4}"/>
+                <a16:creationId xmlns:a16="http://schemas.microsoft.com/office/drawing/2014/main" id="{94F6305E-1B21-46DE-B457-E25CFE5C9883}"/>
               </a:ext>
             </a:extLst>
           </p:cNvPr>
@@ -3926,7 +3926,7 @@
           <p:cNvPr id="4" name="text-140">
             <a:extLst xmlns:a="http://schemas.openxmlformats.org/drawingml/2006/main">
               <a:ext uri="{FF2B5EF4-FFF2-40B4-BE49-F238E27FC236}">
-                <a16:creationId xmlns:a16="http://schemas.microsoft.com/office/drawing/2014/main" id="{36B9326B-A3D6-4E9D-8279-5F931476D4EB}"/>
+                <a16:creationId xmlns:a16="http://schemas.microsoft.com/office/drawing/2014/main" id="{D14E835F-DFEA-4C82-91FE-A4019CF7CD47}"/>
               </a:ext>
             </a:extLst>
           </p:cNvPr>
@@ -3982,7 +3982,7 @@
           <p:cNvPr id="5" name="text-141">
             <a:extLst xmlns:a="http://schemas.openxmlformats.org/drawingml/2006/main">
               <a:ext uri="{FF2B5EF4-FFF2-40B4-BE49-F238E27FC236}">
-                <a16:creationId xmlns:a16="http://schemas.microsoft.com/office/drawing/2014/main" id="{6E8A3FEF-EBF5-4E82-971F-3F326E849435}"/>
+                <a16:creationId xmlns:a16="http://schemas.microsoft.com/office/drawing/2014/main" id="{86665A2E-BAE6-4724-994C-8B21BE261E60}"/>
               </a:ext>
             </a:extLst>
           </p:cNvPr>
@@ -4038,7 +4038,7 @@
           <p:cNvPr id="6" name="box-142">
             <a:extLst xmlns:a="http://schemas.openxmlformats.org/drawingml/2006/main">
               <a:ext uri="{FF2B5EF4-FFF2-40B4-BE49-F238E27FC236}">
-                <a16:creationId xmlns:a16="http://schemas.microsoft.com/office/drawing/2014/main" id="{FCDA89D6-B8E5-41F7-8003-743C9D933F3C}"/>
+                <a16:creationId xmlns:a16="http://schemas.microsoft.com/office/drawing/2014/main" id="{8FC6C8C6-FB4D-4E6E-A677-E7C06D2D7562}"/>
               </a:ext>
             </a:extLst>
           </p:cNvPr>
@@ -4071,7 +4071,7 @@
           <p:cNvPr id="7" name="text-143">
             <a:extLst xmlns:a="http://schemas.openxmlformats.org/drawingml/2006/main">
               <a:ext uri="{FF2B5EF4-FFF2-40B4-BE49-F238E27FC236}">
-                <a16:creationId xmlns:a16="http://schemas.microsoft.com/office/drawing/2014/main" id="{6DFDD8E5-3BF6-43F0-ABEB-A9DF0EB81F57}"/>
+                <a16:creationId xmlns:a16="http://schemas.microsoft.com/office/drawing/2014/main" id="{EB5FAEB9-7E71-4315-AC64-83B711A21136}"/>
               </a:ext>
             </a:extLst>
           </p:cNvPr>
@@ -4127,7 +4127,7 @@
           <p:cNvPr id="8" name="text-144">
             <a:extLst xmlns:a="http://schemas.openxmlformats.org/drawingml/2006/main">
               <a:ext uri="{FF2B5EF4-FFF2-40B4-BE49-F238E27FC236}">
-                <a16:creationId xmlns:a16="http://schemas.microsoft.com/office/drawing/2014/main" id="{5BBF735A-53D4-4961-A2CA-EDDF2D9BF586}"/>
+                <a16:creationId xmlns:a16="http://schemas.microsoft.com/office/drawing/2014/main" id="{D771616E-9192-4FA9-B387-BC0592B27063}"/>
               </a:ext>
             </a:extLst>
           </p:cNvPr>
@@ -4183,7 +4183,7 @@
           <p:cNvPr id="9" name="box-145">
             <a:extLst xmlns:a="http://schemas.openxmlformats.org/drawingml/2006/main">
               <a:ext uri="{FF2B5EF4-FFF2-40B4-BE49-F238E27FC236}">
-                <a16:creationId xmlns:a16="http://schemas.microsoft.com/office/drawing/2014/main" id="{AD567E44-478B-4C83-8BD6-E6541E4FA450}"/>
+                <a16:creationId xmlns:a16="http://schemas.microsoft.com/office/drawing/2014/main" id="{8DDC41EB-389E-492F-897B-459F6CAA8E43}"/>
               </a:ext>
             </a:extLst>
           </p:cNvPr>
@@ -4216,7 +4216,7 @@
           <p:cNvPr id="10" name="text-146">
             <a:extLst xmlns:a="http://schemas.openxmlformats.org/drawingml/2006/main">
               <a:ext uri="{FF2B5EF4-FFF2-40B4-BE49-F238E27FC236}">
-                <a16:creationId xmlns:a16="http://schemas.microsoft.com/office/drawing/2014/main" id="{D1CBDC21-8EF1-485F-9CE8-CDE6CA51A3AA}"/>
+                <a16:creationId xmlns:a16="http://schemas.microsoft.com/office/drawing/2014/main" id="{916A457C-A0A8-4942-AA9B-8E8FDC935DD1}"/>
               </a:ext>
             </a:extLst>
           </p:cNvPr>
@@ -4272,7 +4272,7 @@
           <p:cNvPr id="11" name="text-147">
             <a:extLst xmlns:a="http://schemas.openxmlformats.org/drawingml/2006/main">
               <a:ext uri="{FF2B5EF4-FFF2-40B4-BE49-F238E27FC236}">
-                <a16:creationId xmlns:a16="http://schemas.microsoft.com/office/drawing/2014/main" id="{2245C38D-0754-43E9-88DE-B2A95999C903}"/>
+                <a16:creationId xmlns:a16="http://schemas.microsoft.com/office/drawing/2014/main" id="{38ACC870-69F3-4048-BB14-A692E7929683}"/>
               </a:ext>
             </a:extLst>
           </p:cNvPr>
@@ -4328,7 +4328,7 @@
           <p:cNvPr id="12" name="box-148">
             <a:extLst xmlns:a="http://schemas.openxmlformats.org/drawingml/2006/main">
               <a:ext uri="{FF2B5EF4-FFF2-40B4-BE49-F238E27FC236}">
-                <a16:creationId xmlns:a16="http://schemas.microsoft.com/office/drawing/2014/main" id="{B2708276-3B11-446F-8298-06C2986B573F}"/>
+                <a16:creationId xmlns:a16="http://schemas.microsoft.com/office/drawing/2014/main" id="{7DED6BC6-48E6-4E3A-9F5B-2F83EC0B1020}"/>
               </a:ext>
             </a:extLst>
           </p:cNvPr>
@@ -4361,7 +4361,7 @@
           <p:cNvPr id="13" name="text-149">
             <a:extLst xmlns:a="http://schemas.openxmlformats.org/drawingml/2006/main">
               <a:ext uri="{FF2B5EF4-FFF2-40B4-BE49-F238E27FC236}">
-                <a16:creationId xmlns:a16="http://schemas.microsoft.com/office/drawing/2014/main" id="{B2160CB6-1BAC-4136-A789-0DEF60E7D076}"/>
+                <a16:creationId xmlns:a16="http://schemas.microsoft.com/office/drawing/2014/main" id="{23AA377A-69BA-4AEA-8D38-3C190EF4AB7B}"/>
               </a:ext>
             </a:extLst>
           </p:cNvPr>
@@ -4417,7 +4417,7 @@
           <p:cNvPr id="14" name="text-150">
             <a:extLst xmlns:a="http://schemas.openxmlformats.org/drawingml/2006/main">
               <a:ext uri="{FF2B5EF4-FFF2-40B4-BE49-F238E27FC236}">
-                <a16:creationId xmlns:a16="http://schemas.microsoft.com/office/drawing/2014/main" id="{4530D738-F158-4697-829A-17CC8B93FADC}"/>
+                <a16:creationId xmlns:a16="http://schemas.microsoft.com/office/drawing/2014/main" id="{656DC3AD-1DB8-432C-AD56-58E7F206989B}"/>
               </a:ext>
             </a:extLst>
           </p:cNvPr>
@@ -4473,7 +4473,7 @@
           <p:cNvPr id="15" name="box-151">
             <a:extLst xmlns:a="http://schemas.openxmlformats.org/drawingml/2006/main">
               <a:ext uri="{FF2B5EF4-FFF2-40B4-BE49-F238E27FC236}">
-                <a16:creationId xmlns:a16="http://schemas.microsoft.com/office/drawing/2014/main" id="{D2CC9005-D12F-4426-9D17-0E7376B338A4}"/>
+                <a16:creationId xmlns:a16="http://schemas.microsoft.com/office/drawing/2014/main" id="{9666CDD5-81BF-457C-9F95-275E9106D2B2}"/>
               </a:ext>
             </a:extLst>
           </p:cNvPr>
@@ -4506,7 +4506,7 @@
           <p:cNvPr id="16" name="text-152">
             <a:extLst xmlns:a="http://schemas.openxmlformats.org/drawingml/2006/main">
               <a:ext uri="{FF2B5EF4-FFF2-40B4-BE49-F238E27FC236}">
-                <a16:creationId xmlns:a16="http://schemas.microsoft.com/office/drawing/2014/main" id="{24DCF3FD-9514-4396-B053-36F8E90AA39A}"/>
+                <a16:creationId xmlns:a16="http://schemas.microsoft.com/office/drawing/2014/main" id="{77E94200-0296-456F-AD91-20E047C1B656}"/>
               </a:ext>
             </a:extLst>
           </p:cNvPr>
@@ -4562,7 +4562,7 @@
           <p:cNvPr id="17" name="text-153">
             <a:extLst xmlns:a="http://schemas.openxmlformats.org/drawingml/2006/main">
               <a:ext uri="{FF2B5EF4-FFF2-40B4-BE49-F238E27FC236}">
-                <a16:creationId xmlns:a16="http://schemas.microsoft.com/office/drawing/2014/main" id="{F2A2D63B-6AAE-41B1-B0EB-E64A5053F1D8}"/>
+                <a16:creationId xmlns:a16="http://schemas.microsoft.com/office/drawing/2014/main" id="{03FFF9AD-07C2-4552-BBA5-138169D5D7FF}"/>
               </a:ext>
             </a:extLst>
           </p:cNvPr>
@@ -4608,7 +4608,7 @@
                 <a:ea typeface="Arial"/>
                 <a:cs typeface="Arial"/>
               </a:rPr>
-              <a:t>Sözlük düzensiz çoğulu çözer · dictionary resolves irregular plurals · le dictionnaire retrouve le singulier</a:t>
+              <a:t>Sözlük FR↔EN↔TR yön seçimli · dictionary FR/EN/TR with direction switch · dictionnaire FR/EN/TR à sens réglable</a:t>
             </a:r>
           </a:p>
         </p:txBody>
@@ -4616,7 +4616,7 @@
     </p:spTree>
     <p:extLst>
       <p:ext uri="{BB962C8B-B14F-4D97-AF65-F5344CB8AC3E}">
-        <p14:creationId xmlns:p14="http://schemas.microsoft.com/office/powerpoint/2010/main" val="1951099586"/>
+        <p14:creationId xmlns:p14="http://schemas.microsoft.com/office/powerpoint/2010/main" val="503049196"/>
       </p:ext>
     </p:extLst>
   </p:cSld>
@@ -4647,7 +4647,7 @@
           <p:cNvPr id="21" name="box-154">
             <a:extLst xmlns:a="http://schemas.openxmlformats.org/drawingml/2006/main">
               <a:ext uri="{FF2B5EF4-FFF2-40B4-BE49-F238E27FC236}">
-                <a16:creationId xmlns:a16="http://schemas.microsoft.com/office/drawing/2014/main" id="{8BF40BB5-DE86-4940-9695-B9043DA8DBB2}"/>
+                <a16:creationId xmlns:a16="http://schemas.microsoft.com/office/drawing/2014/main" id="{E8B3E0C1-99A0-4DD6-BF4A-610ED5286BA5}"/>
               </a:ext>
             </a:extLst>
           </p:cNvPr>
@@ -4680,7 +4680,7 @@
           <p:cNvPr id="2" name="text-155">
             <a:extLst xmlns:a="http://schemas.openxmlformats.org/drawingml/2006/main">
               <a:ext uri="{FF2B5EF4-FFF2-40B4-BE49-F238E27FC236}">
-                <a16:creationId xmlns:a16="http://schemas.microsoft.com/office/drawing/2014/main" id="{FB2DD79F-DE7A-4CA2-882C-EB6DB439BBBA}"/>
+                <a16:creationId xmlns:a16="http://schemas.microsoft.com/office/drawing/2014/main" id="{544939FD-5C8D-427E-9FD6-F260CDE8CA7C}"/>
               </a:ext>
             </a:extLst>
           </p:cNvPr>
@@ -4736,7 +4736,7 @@
           <p:cNvPr id="3" name="text-156">
             <a:extLst xmlns:a="http://schemas.openxmlformats.org/drawingml/2006/main">
               <a:ext uri="{FF2B5EF4-FFF2-40B4-BE49-F238E27FC236}">
-                <a16:creationId xmlns:a16="http://schemas.microsoft.com/office/drawing/2014/main" id="{CB3D4539-62ED-4BAC-AA4A-948297BECDB0}"/>
+                <a16:creationId xmlns:a16="http://schemas.microsoft.com/office/drawing/2014/main" id="{97DD0386-7BAB-4036-9BE9-A5ADAE0DA3A9}"/>
               </a:ext>
             </a:extLst>
           </p:cNvPr>
@@ -4792,7 +4792,7 @@
           <p:cNvPr id="4" name="text-157">
             <a:extLst xmlns:a="http://schemas.openxmlformats.org/drawingml/2006/main">
               <a:ext uri="{FF2B5EF4-FFF2-40B4-BE49-F238E27FC236}">
-                <a16:creationId xmlns:a16="http://schemas.microsoft.com/office/drawing/2014/main" id="{A958A5FE-FCE4-4D99-8B94-98ACEF8DBB44}"/>
+                <a16:creationId xmlns:a16="http://schemas.microsoft.com/office/drawing/2014/main" id="{66B3F3E1-2341-4B96-8732-75824E9E1578}"/>
               </a:ext>
             </a:extLst>
           </p:cNvPr>
@@ -4848,7 +4848,7 @@
           <p:cNvPr id="5" name="text-158">
             <a:extLst xmlns:a="http://schemas.openxmlformats.org/drawingml/2006/main">
               <a:ext uri="{FF2B5EF4-FFF2-40B4-BE49-F238E27FC236}">
-                <a16:creationId xmlns:a16="http://schemas.microsoft.com/office/drawing/2014/main" id="{6574DC0B-1EA7-4D70-9F78-D57E3CA55E21}"/>
+                <a16:creationId xmlns:a16="http://schemas.microsoft.com/office/drawing/2014/main" id="{B2A9AD16-F81A-4947-A427-53CD779883F5}"/>
               </a:ext>
             </a:extLst>
           </p:cNvPr>
@@ -4904,7 +4904,7 @@
           <p:cNvPr id="6" name="box-159">
             <a:extLst xmlns:a="http://schemas.openxmlformats.org/drawingml/2006/main">
               <a:ext uri="{FF2B5EF4-FFF2-40B4-BE49-F238E27FC236}">
-                <a16:creationId xmlns:a16="http://schemas.microsoft.com/office/drawing/2014/main" id="{8E2C3A11-98BD-456D-842C-B89206318422}"/>
+                <a16:creationId xmlns:a16="http://schemas.microsoft.com/office/drawing/2014/main" id="{E5E11766-50FA-4DE5-BF4F-E6ED1A3C943C}"/>
               </a:ext>
             </a:extLst>
           </p:cNvPr>
@@ -4937,7 +4937,7 @@
           <p:cNvPr id="7" name="dot-160">
             <a:extLst xmlns:a="http://schemas.openxmlformats.org/drawingml/2006/main">
               <a:ext uri="{FF2B5EF4-FFF2-40B4-BE49-F238E27FC236}">
-                <a16:creationId xmlns:a16="http://schemas.microsoft.com/office/drawing/2014/main" id="{6193F77A-A4E8-41B2-9D84-780E6592A861}"/>
+                <a16:creationId xmlns:a16="http://schemas.microsoft.com/office/drawing/2014/main" id="{D7C61073-FE42-407B-B37C-E8655B0E01B4}"/>
               </a:ext>
             </a:extLst>
           </p:cNvPr>
@@ -4968,7 +4968,7 @@
           <p:cNvPr id="8" name="text-161">
             <a:extLst xmlns:a="http://schemas.openxmlformats.org/drawingml/2006/main">
               <a:ext uri="{FF2B5EF4-FFF2-40B4-BE49-F238E27FC236}">
-                <a16:creationId xmlns:a16="http://schemas.microsoft.com/office/drawing/2014/main" id="{3FD16786-A705-456D-8F1D-41D997B4679C}"/>
+                <a16:creationId xmlns:a16="http://schemas.microsoft.com/office/drawing/2014/main" id="{5AA26E4C-CFC5-42A9-8C08-E40CEC73C6BB}"/>
               </a:ext>
             </a:extLst>
           </p:cNvPr>
@@ -5024,7 +5024,7 @@
           <p:cNvPr id="9" name="text-162">
             <a:extLst xmlns:a="http://schemas.openxmlformats.org/drawingml/2006/main">
               <a:ext uri="{FF2B5EF4-FFF2-40B4-BE49-F238E27FC236}">
-                <a16:creationId xmlns:a16="http://schemas.microsoft.com/office/drawing/2014/main" id="{6B62DA74-9EB3-475E-8907-FAF980ED2937}"/>
+                <a16:creationId xmlns:a16="http://schemas.microsoft.com/office/drawing/2014/main" id="{9842C059-89C6-4248-A294-076AA430A7CC}"/>
               </a:ext>
             </a:extLst>
           </p:cNvPr>
@@ -5080,7 +5080,7 @@
           <p:cNvPr id="10" name="text-163">
             <a:extLst xmlns:a="http://schemas.openxmlformats.org/drawingml/2006/main">
               <a:ext uri="{FF2B5EF4-FFF2-40B4-BE49-F238E27FC236}">
-                <a16:creationId xmlns:a16="http://schemas.microsoft.com/office/drawing/2014/main" id="{F3B551EC-E303-4487-839B-27E102C4014C}"/>
+                <a16:creationId xmlns:a16="http://schemas.microsoft.com/office/drawing/2014/main" id="{8CD5D473-D123-43BF-AADD-630B146E0EB6}"/>
               </a:ext>
             </a:extLst>
           </p:cNvPr>
@@ -5136,7 +5136,7 @@
           <p:cNvPr id="11" name="dot-164">
             <a:extLst xmlns:a="http://schemas.openxmlformats.org/drawingml/2006/main">
               <a:ext uri="{FF2B5EF4-FFF2-40B4-BE49-F238E27FC236}">
-                <a16:creationId xmlns:a16="http://schemas.microsoft.com/office/drawing/2014/main" id="{202B3A8E-445B-4ED2-94CE-AC36F732ED7E}"/>
+                <a16:creationId xmlns:a16="http://schemas.microsoft.com/office/drawing/2014/main" id="{6F7148AA-C938-4AE6-AD8F-582702CC64DE}"/>
               </a:ext>
             </a:extLst>
           </p:cNvPr>
@@ -5167,7 +5167,7 @@
           <p:cNvPr id="12" name="text-165">
             <a:extLst xmlns:a="http://schemas.openxmlformats.org/drawingml/2006/main">
               <a:ext uri="{FF2B5EF4-FFF2-40B4-BE49-F238E27FC236}">
-                <a16:creationId xmlns:a16="http://schemas.microsoft.com/office/drawing/2014/main" id="{0CAEF847-94F6-41D8-A25F-CAAA7D5E1260}"/>
+                <a16:creationId xmlns:a16="http://schemas.microsoft.com/office/drawing/2014/main" id="{55CBB57F-CF66-4227-9A18-0085EC59B770}"/>
               </a:ext>
             </a:extLst>
           </p:cNvPr>
@@ -5223,7 +5223,7 @@
           <p:cNvPr id="13" name="text-166">
             <a:extLst xmlns:a="http://schemas.openxmlformats.org/drawingml/2006/main">
               <a:ext uri="{FF2B5EF4-FFF2-40B4-BE49-F238E27FC236}">
-                <a16:creationId xmlns:a16="http://schemas.microsoft.com/office/drawing/2014/main" id="{0A62A614-AF40-47CF-9DE9-64B9682AF689}"/>
+                <a16:creationId xmlns:a16="http://schemas.microsoft.com/office/drawing/2014/main" id="{B2B5D1B2-71FC-4E35-98DD-2CC737227D83}"/>
               </a:ext>
             </a:extLst>
           </p:cNvPr>
@@ -5279,7 +5279,7 @@
           <p:cNvPr id="14" name="text-167">
             <a:extLst xmlns:a="http://schemas.openxmlformats.org/drawingml/2006/main">
               <a:ext uri="{FF2B5EF4-FFF2-40B4-BE49-F238E27FC236}">
-                <a16:creationId xmlns:a16="http://schemas.microsoft.com/office/drawing/2014/main" id="{DC1451FD-3C8C-4471-B819-7E37048AE732}"/>
+                <a16:creationId xmlns:a16="http://schemas.microsoft.com/office/drawing/2014/main" id="{E7D45C78-F30C-433D-9921-CA3485B3D286}"/>
               </a:ext>
             </a:extLst>
           </p:cNvPr>
@@ -5335,7 +5335,7 @@
           <p:cNvPr id="15" name="dot-168">
             <a:extLst xmlns:a="http://schemas.openxmlformats.org/drawingml/2006/main">
               <a:ext uri="{FF2B5EF4-FFF2-40B4-BE49-F238E27FC236}">
-                <a16:creationId xmlns:a16="http://schemas.microsoft.com/office/drawing/2014/main" id="{25F1BC0B-59E5-4CAB-A8E0-09019AA11A40}"/>
+                <a16:creationId xmlns:a16="http://schemas.microsoft.com/office/drawing/2014/main" id="{73F1F820-B484-41E7-AC66-FB93EF5D42B4}"/>
               </a:ext>
             </a:extLst>
           </p:cNvPr>
@@ -5366,7 +5366,7 @@
           <p:cNvPr id="16" name="text-169">
             <a:extLst xmlns:a="http://schemas.openxmlformats.org/drawingml/2006/main">
               <a:ext uri="{FF2B5EF4-FFF2-40B4-BE49-F238E27FC236}">
-                <a16:creationId xmlns:a16="http://schemas.microsoft.com/office/drawing/2014/main" id="{60D54C5E-6312-4B21-9BA7-BCD06BA144AA}"/>
+                <a16:creationId xmlns:a16="http://schemas.microsoft.com/office/drawing/2014/main" id="{E85EF3E8-9384-471D-A6E1-FD791E77F1AF}"/>
               </a:ext>
             </a:extLst>
           </p:cNvPr>
@@ -5422,7 +5422,7 @@
           <p:cNvPr id="17" name="text-170">
             <a:extLst xmlns:a="http://schemas.openxmlformats.org/drawingml/2006/main">
               <a:ext uri="{FF2B5EF4-FFF2-40B4-BE49-F238E27FC236}">
-                <a16:creationId xmlns:a16="http://schemas.microsoft.com/office/drawing/2014/main" id="{07CEBB0C-7485-470A-8FFF-4DA29129C45D}"/>
+                <a16:creationId xmlns:a16="http://schemas.microsoft.com/office/drawing/2014/main" id="{F1F968F7-11F0-4B1C-9802-0FE9818DCD57}"/>
               </a:ext>
             </a:extLst>
           </p:cNvPr>
@@ -5478,7 +5478,7 @@
           <p:cNvPr id="18" name="text-171">
             <a:extLst xmlns:a="http://schemas.openxmlformats.org/drawingml/2006/main">
               <a:ext uri="{FF2B5EF4-FFF2-40B4-BE49-F238E27FC236}">
-                <a16:creationId xmlns:a16="http://schemas.microsoft.com/office/drawing/2014/main" id="{83F67FCA-B8E1-4E4A-AEFB-59787AE90BB6}"/>
+                <a16:creationId xmlns:a16="http://schemas.microsoft.com/office/drawing/2014/main" id="{75AA6205-06CB-4AB1-8085-A20BEE92808E}"/>
               </a:ext>
             </a:extLst>
           </p:cNvPr>
@@ -5534,7 +5534,7 @@
           <p:cNvPr id="19" name="box-172">
             <a:extLst xmlns:a="http://schemas.openxmlformats.org/drawingml/2006/main">
               <a:ext uri="{FF2B5EF4-FFF2-40B4-BE49-F238E27FC236}">
-                <a16:creationId xmlns:a16="http://schemas.microsoft.com/office/drawing/2014/main" id="{FD7C578F-D603-454D-B61C-B079378D2199}"/>
+                <a16:creationId xmlns:a16="http://schemas.microsoft.com/office/drawing/2014/main" id="{102B5049-1B23-493B-8412-83223564AF01}"/>
               </a:ext>
             </a:extLst>
           </p:cNvPr>
@@ -5567,7 +5567,7 @@
           <p:cNvPr id="20" name="text-173">
             <a:extLst xmlns:a="http://schemas.openxmlformats.org/drawingml/2006/main">
               <a:ext uri="{FF2B5EF4-FFF2-40B4-BE49-F238E27FC236}">
-                <a16:creationId xmlns:a16="http://schemas.microsoft.com/office/drawing/2014/main" id="{E6404CC0-370A-4913-AC68-187FBFCA2E42}"/>
+                <a16:creationId xmlns:a16="http://schemas.microsoft.com/office/drawing/2014/main" id="{545A0ABA-717F-4CB6-9A05-EF3C309C2E55}"/>
               </a:ext>
             </a:extLst>
           </p:cNvPr>
@@ -5621,7 +5621,7 @@
     </p:spTree>
     <p:extLst>
       <p:ext uri="{BB962C8B-B14F-4D97-AF65-F5344CB8AC3E}">
-        <p14:creationId xmlns:p14="http://schemas.microsoft.com/office/powerpoint/2010/main" val="776098431"/>
+        <p14:creationId xmlns:p14="http://schemas.microsoft.com/office/powerpoint/2010/main" val="1104120444"/>
       </p:ext>
     </p:extLst>
   </p:cSld>
@@ -5652,7 +5652,7 @@
           <p:cNvPr id="18" name="box-174">
             <a:extLst xmlns:a="http://schemas.openxmlformats.org/drawingml/2006/main">
               <a:ext uri="{FF2B5EF4-FFF2-40B4-BE49-F238E27FC236}">
-                <a16:creationId xmlns:a16="http://schemas.microsoft.com/office/drawing/2014/main" id="{A9A8A16A-8296-470B-8E3B-AA016F9B500F}"/>
+                <a16:creationId xmlns:a16="http://schemas.microsoft.com/office/drawing/2014/main" id="{A61AE751-C056-450D-8889-DD400F8BED1E}"/>
               </a:ext>
             </a:extLst>
           </p:cNvPr>
@@ -5685,7 +5685,7 @@
           <p:cNvPr id="2" name="text-175">
             <a:extLst xmlns:a="http://schemas.openxmlformats.org/drawingml/2006/main">
               <a:ext uri="{FF2B5EF4-FFF2-40B4-BE49-F238E27FC236}">
-                <a16:creationId xmlns:a16="http://schemas.microsoft.com/office/drawing/2014/main" id="{7847F375-8EB7-4030-B55F-41A17B155552}"/>
+                <a16:creationId xmlns:a16="http://schemas.microsoft.com/office/drawing/2014/main" id="{70B3CCE1-110B-4CAB-A443-C53FD97A485C}"/>
               </a:ext>
             </a:extLst>
           </p:cNvPr>
@@ -5741,7 +5741,7 @@
           <p:cNvPr id="3" name="text-176">
             <a:extLst xmlns:a="http://schemas.openxmlformats.org/drawingml/2006/main">
               <a:ext uri="{FF2B5EF4-FFF2-40B4-BE49-F238E27FC236}">
-                <a16:creationId xmlns:a16="http://schemas.microsoft.com/office/drawing/2014/main" id="{8C2DF656-B1B1-4324-8D65-79D7A2E73F07}"/>
+                <a16:creationId xmlns:a16="http://schemas.microsoft.com/office/drawing/2014/main" id="{06A6487A-E557-4502-8233-A17DC08D67A9}"/>
               </a:ext>
             </a:extLst>
           </p:cNvPr>
@@ -5797,7 +5797,7 @@
           <p:cNvPr id="4" name="text-177">
             <a:extLst xmlns:a="http://schemas.openxmlformats.org/drawingml/2006/main">
               <a:ext uri="{FF2B5EF4-FFF2-40B4-BE49-F238E27FC236}">
-                <a16:creationId xmlns:a16="http://schemas.microsoft.com/office/drawing/2014/main" id="{28AAC1AD-4712-4CBA-8005-F9C1E401EC06}"/>
+                <a16:creationId xmlns:a16="http://schemas.microsoft.com/office/drawing/2014/main" id="{A855B37F-28F7-407E-96C6-8C4B84E92757}"/>
               </a:ext>
             </a:extLst>
           </p:cNvPr>
@@ -5853,7 +5853,7 @@
           <p:cNvPr id="5" name="text-178">
             <a:extLst xmlns:a="http://schemas.openxmlformats.org/drawingml/2006/main">
               <a:ext uri="{FF2B5EF4-FFF2-40B4-BE49-F238E27FC236}">
-                <a16:creationId xmlns:a16="http://schemas.microsoft.com/office/drawing/2014/main" id="{B560A07B-0A82-48A2-ABE7-D45D818C92E8}"/>
+                <a16:creationId xmlns:a16="http://schemas.microsoft.com/office/drawing/2014/main" id="{FF85EF30-0130-4C7B-AC83-1688B6638FAA}"/>
               </a:ext>
             </a:extLst>
           </p:cNvPr>
@@ -5909,7 +5909,7 @@
           <p:cNvPr id="6" name="text-179">
             <a:extLst xmlns:a="http://schemas.openxmlformats.org/drawingml/2006/main">
               <a:ext uri="{FF2B5EF4-FFF2-40B4-BE49-F238E27FC236}">
-                <a16:creationId xmlns:a16="http://schemas.microsoft.com/office/drawing/2014/main" id="{79B57534-F160-4B87-A89E-19EF041DED90}"/>
+                <a16:creationId xmlns:a16="http://schemas.microsoft.com/office/drawing/2014/main" id="{748E5753-74A5-47F9-B8B5-A6CEF7ADC87B}"/>
               </a:ext>
             </a:extLst>
           </p:cNvPr>
@@ -5965,7 +5965,7 @@
           <p:cNvPr id="7" name="text-180">
             <a:extLst xmlns:a="http://schemas.openxmlformats.org/drawingml/2006/main">
               <a:ext uri="{FF2B5EF4-FFF2-40B4-BE49-F238E27FC236}">
-                <a16:creationId xmlns:a16="http://schemas.microsoft.com/office/drawing/2014/main" id="{DC131343-C0A3-4433-A74C-8FB1A4A81371}"/>
+                <a16:creationId xmlns:a16="http://schemas.microsoft.com/office/drawing/2014/main" id="{51F0F5F5-9835-4859-8140-07143DF0D046}"/>
               </a:ext>
             </a:extLst>
           </p:cNvPr>
@@ -6021,7 +6021,7 @@
           <p:cNvPr id="8" name="text-181">
             <a:extLst xmlns:a="http://schemas.openxmlformats.org/drawingml/2006/main">
               <a:ext uri="{FF2B5EF4-FFF2-40B4-BE49-F238E27FC236}">
-                <a16:creationId xmlns:a16="http://schemas.microsoft.com/office/drawing/2014/main" id="{2CD30DC3-82E0-4D5F-987B-45202FBC1A5B}"/>
+                <a16:creationId xmlns:a16="http://schemas.microsoft.com/office/drawing/2014/main" id="{D52E25F6-D6CF-4E1D-B6CB-98DA841AB8EB}"/>
               </a:ext>
             </a:extLst>
           </p:cNvPr>
@@ -6067,7 +6067,7 @@
                 <a:ea typeface="Arial"/>
                 <a:cs typeface="Arial"/>
               </a:rPr>
-              <a:t>70 / 70</a:t>
+              <a:t>88 / 88</a:t>
             </a:r>
           </a:p>
         </p:txBody>
@@ -6077,7 +6077,7 @@
           <p:cNvPr id="9" name="text-182">
             <a:extLst xmlns:a="http://schemas.openxmlformats.org/drawingml/2006/main">
               <a:ext uri="{FF2B5EF4-FFF2-40B4-BE49-F238E27FC236}">
-                <a16:creationId xmlns:a16="http://schemas.microsoft.com/office/drawing/2014/main" id="{A16F41B5-5AD2-49C3-8642-8CDB1C444E8C}"/>
+                <a16:creationId xmlns:a16="http://schemas.microsoft.com/office/drawing/2014/main" id="{7FB8E4F9-2306-4F28-A70D-DBC0C0C5B018}"/>
               </a:ext>
             </a:extLst>
           </p:cNvPr>
@@ -6133,7 +6133,7 @@
           <p:cNvPr id="10" name="text-183">
             <a:extLst xmlns:a="http://schemas.openxmlformats.org/drawingml/2006/main">
               <a:ext uri="{FF2B5EF4-FFF2-40B4-BE49-F238E27FC236}">
-                <a16:creationId xmlns:a16="http://schemas.microsoft.com/office/drawing/2014/main" id="{07631BD0-22C9-4DBA-A6E9-A833E2C62495}"/>
+                <a16:creationId xmlns:a16="http://schemas.microsoft.com/office/drawing/2014/main" id="{766BCBFE-9EE0-43D7-B3D1-B74B9AB8BE57}"/>
               </a:ext>
             </a:extLst>
           </p:cNvPr>
@@ -6235,7 +6235,7 @@
           <p:cNvPr id="11" name="text-184">
             <a:extLst xmlns:a="http://schemas.openxmlformats.org/drawingml/2006/main">
               <a:ext uri="{FF2B5EF4-FFF2-40B4-BE49-F238E27FC236}">
-                <a16:creationId xmlns:a16="http://schemas.microsoft.com/office/drawing/2014/main" id="{404AD45C-D57A-401A-A74A-FFE18B408C89}"/>
+                <a16:creationId xmlns:a16="http://schemas.microsoft.com/office/drawing/2014/main" id="{56DF93DE-0090-463E-B681-9D5D31309A46}"/>
               </a:ext>
             </a:extLst>
           </p:cNvPr>
@@ -6337,7 +6337,7 @@
           <p:cNvPr id="12" name="text-185">
             <a:extLst xmlns:a="http://schemas.openxmlformats.org/drawingml/2006/main">
               <a:ext uri="{FF2B5EF4-FFF2-40B4-BE49-F238E27FC236}">
-                <a16:creationId xmlns:a16="http://schemas.microsoft.com/office/drawing/2014/main" id="{A0453307-939C-4994-B6A1-004EE8DFFA2E}"/>
+                <a16:creationId xmlns:a16="http://schemas.microsoft.com/office/drawing/2014/main" id="{2D79842C-BE92-4FED-9900-C2AB9A54ADCC}"/>
               </a:ext>
             </a:extLst>
           </p:cNvPr>
@@ -6439,7 +6439,7 @@
           <p:cNvPr id="13" name="box-186">
             <a:extLst xmlns:a="http://schemas.openxmlformats.org/drawingml/2006/main">
               <a:ext uri="{FF2B5EF4-FFF2-40B4-BE49-F238E27FC236}">
-                <a16:creationId xmlns:a16="http://schemas.microsoft.com/office/drawing/2014/main" id="{178D68AD-7D30-40E4-8512-1D53830BB151}"/>
+                <a16:creationId xmlns:a16="http://schemas.microsoft.com/office/drawing/2014/main" id="{80701FEF-428A-4C39-AEA8-CD0D15DEEE6B}"/>
               </a:ext>
             </a:extLst>
           </p:cNvPr>
@@ -6472,7 +6472,7 @@
           <p:cNvPr id="14" name="text-187">
             <a:extLst xmlns:a="http://schemas.openxmlformats.org/drawingml/2006/main">
               <a:ext uri="{FF2B5EF4-FFF2-40B4-BE49-F238E27FC236}">
-                <a16:creationId xmlns:a16="http://schemas.microsoft.com/office/drawing/2014/main" id="{F17AE0AB-2B24-47D8-95BB-FD33F65A7FDF}"/>
+                <a16:creationId xmlns:a16="http://schemas.microsoft.com/office/drawing/2014/main" id="{C12BD690-241C-467D-9EDA-617A9D768A9D}"/>
               </a:ext>
             </a:extLst>
           </p:cNvPr>
@@ -6528,7 +6528,7 @@
           <p:cNvPr id="15" name="text-188">
             <a:extLst xmlns:a="http://schemas.openxmlformats.org/drawingml/2006/main">
               <a:ext uri="{FF2B5EF4-FFF2-40B4-BE49-F238E27FC236}">
-                <a16:creationId xmlns:a16="http://schemas.microsoft.com/office/drawing/2014/main" id="{517692C7-DA81-4651-870C-60817E84FC85}"/>
+                <a16:creationId xmlns:a16="http://schemas.microsoft.com/office/drawing/2014/main" id="{B1906F56-1EDB-4A28-A091-7EA6424E8723}"/>
               </a:ext>
             </a:extLst>
           </p:cNvPr>
@@ -6574,7 +6574,7 @@
                 <a:ea typeface="Arial"/>
                 <a:cs typeface="Arial"/>
               </a:rPr>
-              <a:t>Windows 10/11 (x64) + macOS (Apple Silicon) — İndirme: github.com/Azizsekerdil/FrenchCourseAI/releases (v1.1.2) · (özel repo)</a:t>
+              <a:t>Windows 10/11 (x64) + macOS (Apple Silicon) — İndirme: github.com/Azizsekerdil/FrenchCourseAI/releases (v1.2.0) · (özel repo)</a:t>
             </a:r>
           </a:p>
         </p:txBody>
@@ -6584,7 +6584,7 @@
           <p:cNvPr id="16" name="text-189">
             <a:extLst xmlns:a="http://schemas.openxmlformats.org/drawingml/2006/main">
               <a:ext uri="{FF2B5EF4-FFF2-40B4-BE49-F238E27FC236}">
-                <a16:creationId xmlns:a16="http://schemas.microsoft.com/office/drawing/2014/main" id="{FE5C6782-F7D4-4A1F-BED3-7F116C1FEA71}"/>
+                <a16:creationId xmlns:a16="http://schemas.microsoft.com/office/drawing/2014/main" id="{71948E03-0A22-4717-8462-4B7E8D01BB63}"/>
               </a:ext>
             </a:extLst>
           </p:cNvPr>
@@ -6630,7 +6630,7 @@
                 <a:ea typeface="Arial"/>
                 <a:cs typeface="Arial"/>
               </a:rPr>
-              <a:t>Windows 10/11 (x64) &amp; macOS (Apple Silicon) — Download: GitHub Releases (v1.1.2)</a:t>
+              <a:t>Windows 10/11 (x64) &amp; macOS (Apple Silicon) — Download: GitHub Releases (v1.2.0)</a:t>
             </a:r>
           </a:p>
         </p:txBody>
@@ -6640,7 +6640,7 @@
           <p:cNvPr id="17" name="text-190">
             <a:extLst xmlns:a="http://schemas.openxmlformats.org/drawingml/2006/main">
               <a:ext uri="{FF2B5EF4-FFF2-40B4-BE49-F238E27FC236}">
-                <a16:creationId xmlns:a16="http://schemas.microsoft.com/office/drawing/2014/main" id="{55D019DB-5DA4-4816-9D35-A8C1B7D581D2}"/>
+                <a16:creationId xmlns:a16="http://schemas.microsoft.com/office/drawing/2014/main" id="{A76AE6AE-237E-40C9-8BB4-DCB4B4BA4A18}"/>
               </a:ext>
             </a:extLst>
           </p:cNvPr>
@@ -6694,7 +6694,7 @@
     </p:spTree>
     <p:extLst>
       <p:ext uri="{BB962C8B-B14F-4D97-AF65-F5344CB8AC3E}">
-        <p14:creationId xmlns:p14="http://schemas.microsoft.com/office/powerpoint/2010/main" val="1960873308"/>
+        <p14:creationId xmlns:p14="http://schemas.microsoft.com/office/powerpoint/2010/main" val="1675832446"/>
       </p:ext>
     </p:extLst>
   </p:cSld>

</xml_diff>

<commit_message>
MIT lisansı: LICENSE, üçüncü taraf bildirimleri ve paket içine lisans metinleri
- LICENSE (MIT) + THIRD_PARTY_NOTICES.md: kullanılan/paketlenen her bileşen
  gerçek lisansıyla listelendi; hiçbir kopyasol kütüphane bağlı değil.
- README TR/EN ve kullanım kılavuzlarına lisans bölümü.
- build.bat / build_macos.sh / .spec: LICENSE ve bildirim dosyası dağıtıma eklenir.
- Sunum betiğinden kullanıcı adı ve mutlak yollar temizlendi.

Co-Authored-By: Claude Opus 5 <noreply@anthropic.com>
</commit_message>
<xml_diff>
--- a/docs/presentation/French-Course-AI-Trilingual.pptx
+++ b/docs/presentation/French-Course-AI-Trilingual.pptx
@@ -2,18 +2,18 @@
 <file path=ppt/presentation.xml><?xml version="1.0" encoding="utf-8"?>
 <p:presentation xmlns:p="http://schemas.openxmlformats.org/presentationml/2006/main">
   <p:sldMasterIdLst>
-    <p:sldMasterId xmlns:r="http://schemas.openxmlformats.org/officeDocument/2006/relationships" id="2147483648" r:id="Rf6fab69e473c4139"/>
+    <p:sldMasterId xmlns:r="http://schemas.openxmlformats.org/officeDocument/2006/relationships" id="2147483648" r:id="R8fe9b9aabdcc4cf8"/>
   </p:sldMasterIdLst>
   <p:notesMasterIdLst>
-    <p:notesMasterId xmlns:r="http://schemas.openxmlformats.org/officeDocument/2006/relationships" r:id="R5e42ea198bcd47d5"/>
+    <p:notesMasterId xmlns:r="http://schemas.openxmlformats.org/officeDocument/2006/relationships" r:id="Ra8e114cae6f64444"/>
   </p:notesMasterIdLst>
   <p:sldIdLst>
-    <p:sldId xmlns:r="http://schemas.openxmlformats.org/officeDocument/2006/relationships" id="256" r:id="R9d64ab56604744b3"/>
-    <p:sldId xmlns:r="http://schemas.openxmlformats.org/officeDocument/2006/relationships" id="257" r:id="R3cdeac128f8141a9"/>
-    <p:sldId xmlns:r="http://schemas.openxmlformats.org/officeDocument/2006/relationships" id="258" r:id="R61a5d33b0d2e4a0d"/>
-    <p:sldId xmlns:r="http://schemas.openxmlformats.org/officeDocument/2006/relationships" id="259" r:id="R98f7f82188df46eb"/>
-    <p:sldId xmlns:r="http://schemas.openxmlformats.org/officeDocument/2006/relationships" id="260" r:id="R6143ed2a8cc64727"/>
-    <p:sldId xmlns:r="http://schemas.openxmlformats.org/officeDocument/2006/relationships" id="261" r:id="R093bc2a489d94075"/>
+    <p:sldId xmlns:r="http://schemas.openxmlformats.org/officeDocument/2006/relationships" id="256" r:id="R84170468b6c84abe"/>
+    <p:sldId xmlns:r="http://schemas.openxmlformats.org/officeDocument/2006/relationships" id="257" r:id="R68af3acacc654393"/>
+    <p:sldId xmlns:r="http://schemas.openxmlformats.org/officeDocument/2006/relationships" id="258" r:id="R7e679a63ff584942"/>
+    <p:sldId xmlns:r="http://schemas.openxmlformats.org/officeDocument/2006/relationships" id="259" r:id="R164c92a6b4f046b9"/>
+    <p:sldId xmlns:r="http://schemas.openxmlformats.org/officeDocument/2006/relationships" id="260" r:id="Rb9e3eaabdfce4def"/>
+    <p:sldId xmlns:r="http://schemas.openxmlformats.org/officeDocument/2006/relationships" id="261" r:id="Rf1bcfd8a472541a8"/>
   </p:sldIdLst>
   <p:sldSz cx="12192000" cy="6858000"/>
   <p:notesSz cx="6858000" cy="9144000"/>
@@ -462,7 +462,7 @@
           </a:p>
           <a:p xmlns:a="http://schemas.openxmlformats.org/drawingml/2006/main">
             <a:r>
-              <a:t>- Original icon generated for this project: D:/GE_FR/FrenchCourseAI/assets/app-final.png</a:t>
+              <a:t>- Original icon generated for this project: D:\GE_FR\FrenchCourseAI\assets\app-final.png</a:t>
             </a:r>
           </a:p>
           <a:p xmlns:a="http://schemas.openxmlformats.org/drawingml/2006/main">
@@ -552,7 +552,7 @@
           </a:p>
           <a:p xmlns:a="http://schemas.openxmlformats.org/drawingml/2006/main">
             <a:r>
-              <a:t>- Product screenshot: D:/GE_FR/FrenchCourseAI/docs/presentation/assets/french-course-ai-screenshot.jpg</a:t>
+              <a:t>- Product screenshot: D:\GE_FR\FrenchCourseAI\docs\presentation\assets\french-course-ai-screenshot.jpg</a:t>
             </a:r>
           </a:p>
           <a:p xmlns:a="http://schemas.openxmlformats.org/drawingml/2006/main">
@@ -1010,7 +1010,7 @@
   </p:cSld>
   <p:clrMap bg1="lt1" tx1="dk1" bg2="lt2" tx2="dk2" accent1="accent1" accent2="accent2" accent3="accent3" accent4="accent4" accent5="accent5" accent6="accent6" hlink="hlink" folHlink="folHlink"/>
   <p:sldLayoutIdLst>
-    <p:sldLayoutId xmlns:r="http://schemas.openxmlformats.org/officeDocument/2006/relationships" id="2147483649" r:id="R09105308416c4510"/>
+    <p:sldLayoutId xmlns:r="http://schemas.openxmlformats.org/officeDocument/2006/relationships" id="2147483649" r:id="R95a3c3672be84528"/>
   </p:sldLayoutIdLst>
   <p:txStyles>
     <p:titleStyle>
@@ -1561,7 +1561,7 @@
           <p:cNvPr id="13" name="box-96">
             <a:extLst xmlns:a="http://schemas.openxmlformats.org/drawingml/2006/main">
               <a:ext uri="{FF2B5EF4-FFF2-40B4-BE49-F238E27FC236}">
-                <a16:creationId xmlns:a16="http://schemas.microsoft.com/office/drawing/2014/main" id="{69E57F4C-3AE7-441B-BABA-3671B5F29537}"/>
+                <a16:creationId xmlns:a16="http://schemas.microsoft.com/office/drawing/2014/main" id="{E223C60B-CAC2-4968-BC25-235EB988D6E1}"/>
               </a:ext>
             </a:extLst>
           </p:cNvPr>
@@ -1594,7 +1594,7 @@
           <p:cNvPr id="2" name="text-97">
             <a:extLst xmlns:a="http://schemas.openxmlformats.org/drawingml/2006/main">
               <a:ext uri="{FF2B5EF4-FFF2-40B4-BE49-F238E27FC236}">
-                <a16:creationId xmlns:a16="http://schemas.microsoft.com/office/drawing/2014/main" id="{6D4F4F97-C0DD-4407-9DDD-71E67AC283E4}"/>
+                <a16:creationId xmlns:a16="http://schemas.microsoft.com/office/drawing/2014/main" id="{1E42BC4A-002F-4CB2-A3C7-5D3D1BC27BE3}"/>
               </a:ext>
             </a:extLst>
           </p:cNvPr>
@@ -1650,7 +1650,7 @@
           <p:cNvPr id="3" name="text-98">
             <a:extLst xmlns:a="http://schemas.openxmlformats.org/drawingml/2006/main">
               <a:ext uri="{FF2B5EF4-FFF2-40B4-BE49-F238E27FC236}">
-                <a16:creationId xmlns:a16="http://schemas.microsoft.com/office/drawing/2014/main" id="{91D9E5E9-F5C7-4199-AD7F-F01B6DF47BFF}"/>
+                <a16:creationId xmlns:a16="http://schemas.microsoft.com/office/drawing/2014/main" id="{E49E40FF-E503-45EC-B4D1-12E8F0AF5D74}"/>
               </a:ext>
             </a:extLst>
           </p:cNvPr>
@@ -1706,7 +1706,7 @@
           <p:cNvPr id="4" name="text-99">
             <a:extLst xmlns:a="http://schemas.openxmlformats.org/drawingml/2006/main">
               <a:ext uri="{FF2B5EF4-FFF2-40B4-BE49-F238E27FC236}">
-                <a16:creationId xmlns:a16="http://schemas.microsoft.com/office/drawing/2014/main" id="{C06180DC-388F-4B5D-BC67-8480A8BBF55F}"/>
+                <a16:creationId xmlns:a16="http://schemas.microsoft.com/office/drawing/2014/main" id="{2FA721CE-71E9-421F-BDBC-B8B7DD9F0C4E}"/>
               </a:ext>
             </a:extLst>
           </p:cNvPr>
@@ -1762,7 +1762,7 @@
           <p:cNvPr id="5" name="text-100">
             <a:extLst xmlns:a="http://schemas.openxmlformats.org/drawingml/2006/main">
               <a:ext uri="{FF2B5EF4-FFF2-40B4-BE49-F238E27FC236}">
-                <a16:creationId xmlns:a16="http://schemas.microsoft.com/office/drawing/2014/main" id="{58EED0B4-7CB5-4CD1-8DD1-30D1E2D9F945}"/>
+                <a16:creationId xmlns:a16="http://schemas.microsoft.com/office/drawing/2014/main" id="{A733FA3C-9736-4D62-B531-048E087B1397}"/>
               </a:ext>
             </a:extLst>
           </p:cNvPr>
@@ -1818,7 +1818,7 @@
           <p:cNvPr id="6" name="text-101">
             <a:extLst xmlns:a="http://schemas.openxmlformats.org/drawingml/2006/main">
               <a:ext uri="{FF2B5EF4-FFF2-40B4-BE49-F238E27FC236}">
-                <a16:creationId xmlns:a16="http://schemas.microsoft.com/office/drawing/2014/main" id="{54DE1E15-E6F6-4059-B706-88934C7F6EFC}"/>
+                <a16:creationId xmlns:a16="http://schemas.microsoft.com/office/drawing/2014/main" id="{AE89DFDD-F261-4B9C-A630-431375AAFF3F}"/>
               </a:ext>
             </a:extLst>
           </p:cNvPr>
@@ -1874,7 +1874,7 @@
           <p:cNvPr id="7" name="text-102">
             <a:extLst xmlns:a="http://schemas.openxmlformats.org/drawingml/2006/main">
               <a:ext uri="{FF2B5EF4-FFF2-40B4-BE49-F238E27FC236}">
-                <a16:creationId xmlns:a16="http://schemas.microsoft.com/office/drawing/2014/main" id="{F3ED501B-766D-4DB1-8D95-FB2E72FEC3AA}"/>
+                <a16:creationId xmlns:a16="http://schemas.microsoft.com/office/drawing/2014/main" id="{A0CD3429-C0E4-410A-87A6-473340916AB4}"/>
               </a:ext>
             </a:extLst>
           </p:cNvPr>
@@ -1930,7 +1930,7 @@
           <p:cNvPr id="8" name="text-103">
             <a:extLst xmlns:a="http://schemas.openxmlformats.org/drawingml/2006/main">
               <a:ext uri="{FF2B5EF4-FFF2-40B4-BE49-F238E27FC236}">
-                <a16:creationId xmlns:a16="http://schemas.microsoft.com/office/drawing/2014/main" id="{2756FF15-B3EF-49B9-AF45-65CC6E5A87FA}"/>
+                <a16:creationId xmlns:a16="http://schemas.microsoft.com/office/drawing/2014/main" id="{7B533449-A15C-4788-B019-1D8E27C115EC}"/>
               </a:ext>
             </a:extLst>
           </p:cNvPr>
@@ -1986,7 +1986,7 @@
           <p:cNvPr id="9" name="text-104">
             <a:extLst xmlns:a="http://schemas.openxmlformats.org/drawingml/2006/main">
               <a:ext uri="{FF2B5EF4-FFF2-40B4-BE49-F238E27FC236}">
-                <a16:creationId xmlns:a16="http://schemas.microsoft.com/office/drawing/2014/main" id="{E09E021B-1360-4163-99F5-8F9D1C0990C4}"/>
+                <a16:creationId xmlns:a16="http://schemas.microsoft.com/office/drawing/2014/main" id="{B418E5D0-AEE0-4DB5-9699-C3391B616175}"/>
               </a:ext>
             </a:extLst>
           </p:cNvPr>
@@ -2042,7 +2042,7 @@
           <p:cNvPr id="10" name="box-105">
             <a:extLst xmlns:a="http://schemas.openxmlformats.org/drawingml/2006/main">
               <a:ext uri="{FF2B5EF4-FFF2-40B4-BE49-F238E27FC236}">
-                <a16:creationId xmlns:a16="http://schemas.microsoft.com/office/drawing/2014/main" id="{AF8020C4-D971-4CAA-B45D-4C2A709DDA73}"/>
+                <a16:creationId xmlns:a16="http://schemas.microsoft.com/office/drawing/2014/main" id="{2BEB662D-BD9F-471B-918B-A1D8E6565465}"/>
               </a:ext>
             </a:extLst>
           </p:cNvPr>
@@ -2079,7 +2079,7 @@
           <p:nvPr/>
         </p:nvPicPr>
         <p:blipFill>
-          <a:blip xmlns:r="http://schemas.openxmlformats.org/officeDocument/2006/relationships" xmlns:a="http://schemas.openxmlformats.org/drawingml/2006/main" r:embed="R1455b15016d64731"/>
+          <a:blip xmlns:r="http://schemas.openxmlformats.org/officeDocument/2006/relationships" xmlns:a="http://schemas.openxmlformats.org/drawingml/2006/main" r:embed="Rf7f67760445e4035"/>
           <a:stretch xmlns:a="http://schemas.openxmlformats.org/drawingml/2006/main"/>
         </p:blipFill>
         <p:spPr>
@@ -2097,7 +2097,7 @@
           <p:cNvPr id="12" name="text-106">
             <a:extLst xmlns:a="http://schemas.openxmlformats.org/drawingml/2006/main">
               <a:ext uri="{FF2B5EF4-FFF2-40B4-BE49-F238E27FC236}">
-                <a16:creationId xmlns:a16="http://schemas.microsoft.com/office/drawing/2014/main" id="{17490753-B28E-46B5-BEA0-B1F5CCA70C54}"/>
+                <a16:creationId xmlns:a16="http://schemas.microsoft.com/office/drawing/2014/main" id="{3432A8B7-D95B-4BA0-883C-C4A2E6769F77}"/>
               </a:ext>
             </a:extLst>
           </p:cNvPr>
@@ -2151,7 +2151,7 @@
     </p:spTree>
     <p:extLst>
       <p:ext uri="{BB962C8B-B14F-4D97-AF65-F5344CB8AC3E}">
-        <p14:creationId xmlns:p14="http://schemas.microsoft.com/office/powerpoint/2010/main" val="721596015"/>
+        <p14:creationId xmlns:p14="http://schemas.microsoft.com/office/powerpoint/2010/main" val="994433417"/>
       </p:ext>
     </p:extLst>
   </p:cSld>
@@ -2182,7 +2182,7 @@
           <p:cNvPr id="14" name="box-107">
             <a:extLst xmlns:a="http://schemas.openxmlformats.org/drawingml/2006/main">
               <a:ext uri="{FF2B5EF4-FFF2-40B4-BE49-F238E27FC236}">
-                <a16:creationId xmlns:a16="http://schemas.microsoft.com/office/drawing/2014/main" id="{547EB03F-FC73-4A84-8943-C429421EE562}"/>
+                <a16:creationId xmlns:a16="http://schemas.microsoft.com/office/drawing/2014/main" id="{CE04DA62-A428-4613-8DD9-061B53A5A599}"/>
               </a:ext>
             </a:extLst>
           </p:cNvPr>
@@ -2215,7 +2215,7 @@
           <p:cNvPr id="2" name="text-108">
             <a:extLst xmlns:a="http://schemas.openxmlformats.org/drawingml/2006/main">
               <a:ext uri="{FF2B5EF4-FFF2-40B4-BE49-F238E27FC236}">
-                <a16:creationId xmlns:a16="http://schemas.microsoft.com/office/drawing/2014/main" id="{B8F3A0C6-68BD-4A5E-AE96-E54107C10690}"/>
+                <a16:creationId xmlns:a16="http://schemas.microsoft.com/office/drawing/2014/main" id="{0A1D9E25-65C6-4C2A-B8F2-A714B492C8D8}"/>
               </a:ext>
             </a:extLst>
           </p:cNvPr>
@@ -2271,7 +2271,7 @@
           <p:cNvPr id="3" name="text-109">
             <a:extLst xmlns:a="http://schemas.openxmlformats.org/drawingml/2006/main">
               <a:ext uri="{FF2B5EF4-FFF2-40B4-BE49-F238E27FC236}">
-                <a16:creationId xmlns:a16="http://schemas.microsoft.com/office/drawing/2014/main" id="{A4C91E93-2C0C-40A4-B46A-4AF60D30EAEE}"/>
+                <a16:creationId xmlns:a16="http://schemas.microsoft.com/office/drawing/2014/main" id="{0F5206BB-3CC4-4983-A447-08D952EF38D0}"/>
               </a:ext>
             </a:extLst>
           </p:cNvPr>
@@ -2327,7 +2327,7 @@
           <p:cNvPr id="4" name="text-110">
             <a:extLst xmlns:a="http://schemas.openxmlformats.org/drawingml/2006/main">
               <a:ext uri="{FF2B5EF4-FFF2-40B4-BE49-F238E27FC236}">
-                <a16:creationId xmlns:a16="http://schemas.microsoft.com/office/drawing/2014/main" id="{6EE5FDF1-A067-4C77-A0A0-1FDF8B503541}"/>
+                <a16:creationId xmlns:a16="http://schemas.microsoft.com/office/drawing/2014/main" id="{DB6CE1F0-DFAF-42DC-8593-02722F96A76F}"/>
               </a:ext>
             </a:extLst>
           </p:cNvPr>
@@ -2383,7 +2383,7 @@
           <p:cNvPr id="5" name="text-111">
             <a:extLst xmlns:a="http://schemas.openxmlformats.org/drawingml/2006/main">
               <a:ext uri="{FF2B5EF4-FFF2-40B4-BE49-F238E27FC236}">
-                <a16:creationId xmlns:a16="http://schemas.microsoft.com/office/drawing/2014/main" id="{A04822AE-DC8E-4471-AB4D-063545051DEB}"/>
+                <a16:creationId xmlns:a16="http://schemas.microsoft.com/office/drawing/2014/main" id="{080E81FA-80B3-482A-AD9D-39DE2227CA87}"/>
               </a:ext>
             </a:extLst>
           </p:cNvPr>
@@ -2439,7 +2439,7 @@
           <p:cNvPr id="6" name="text-112">
             <a:extLst xmlns:a="http://schemas.openxmlformats.org/drawingml/2006/main">
               <a:ext uri="{FF2B5EF4-FFF2-40B4-BE49-F238E27FC236}">
-                <a16:creationId xmlns:a16="http://schemas.microsoft.com/office/drawing/2014/main" id="{50563FF1-FAAC-4A59-9A5D-BDBCEEB1CDFF}"/>
+                <a16:creationId xmlns:a16="http://schemas.microsoft.com/office/drawing/2014/main" id="{2B39B590-5EB0-4B57-84E1-59934F4C0075}"/>
               </a:ext>
             </a:extLst>
           </p:cNvPr>
@@ -2495,7 +2495,7 @@
           <p:cNvPr id="7" name="box-113">
             <a:extLst xmlns:a="http://schemas.openxmlformats.org/drawingml/2006/main">
               <a:ext uri="{FF2B5EF4-FFF2-40B4-BE49-F238E27FC236}">
-                <a16:creationId xmlns:a16="http://schemas.microsoft.com/office/drawing/2014/main" id="{8FCAA7F2-2D6B-4281-871F-37F294E6587C}"/>
+                <a16:creationId xmlns:a16="http://schemas.microsoft.com/office/drawing/2014/main" id="{A290B810-1799-4846-A51A-8391ECE1A2C9}"/>
               </a:ext>
             </a:extLst>
           </p:cNvPr>
@@ -2528,7 +2528,7 @@
           <p:cNvPr id="8" name="text-114">
             <a:extLst xmlns:a="http://schemas.openxmlformats.org/drawingml/2006/main">
               <a:ext uri="{FF2B5EF4-FFF2-40B4-BE49-F238E27FC236}">
-                <a16:creationId xmlns:a16="http://schemas.microsoft.com/office/drawing/2014/main" id="{7ED8483B-2954-45B0-9C74-BB7CA17FF305}"/>
+                <a16:creationId xmlns:a16="http://schemas.microsoft.com/office/drawing/2014/main" id="{5ABB88AE-798D-4583-8D4C-AB48458A38E4}"/>
               </a:ext>
             </a:extLst>
           </p:cNvPr>
@@ -2584,7 +2584,7 @@
           <p:cNvPr id="9" name="text-115">
             <a:extLst xmlns:a="http://schemas.openxmlformats.org/drawingml/2006/main">
               <a:ext uri="{FF2B5EF4-FFF2-40B4-BE49-F238E27FC236}">
-                <a16:creationId xmlns:a16="http://schemas.microsoft.com/office/drawing/2014/main" id="{05AD73FA-E89A-410C-9DEA-3FB0709855CD}"/>
+                <a16:creationId xmlns:a16="http://schemas.microsoft.com/office/drawing/2014/main" id="{0734C1A0-C64F-4F9B-8A18-1F1036BA920C}"/>
               </a:ext>
             </a:extLst>
           </p:cNvPr>
@@ -2640,7 +2640,7 @@
           <p:cNvPr id="10" name="text-116">
             <a:extLst xmlns:a="http://schemas.openxmlformats.org/drawingml/2006/main">
               <a:ext uri="{FF2B5EF4-FFF2-40B4-BE49-F238E27FC236}">
-                <a16:creationId xmlns:a16="http://schemas.microsoft.com/office/drawing/2014/main" id="{39EC5162-97A4-4691-99E5-29111D875AA2}"/>
+                <a16:creationId xmlns:a16="http://schemas.microsoft.com/office/drawing/2014/main" id="{97B2ADFD-5A48-4724-AB6C-93A1A848FFAC}"/>
               </a:ext>
             </a:extLst>
           </p:cNvPr>
@@ -2696,7 +2696,7 @@
           <p:cNvPr id="11" name="box-117">
             <a:extLst xmlns:a="http://schemas.openxmlformats.org/drawingml/2006/main">
               <a:ext uri="{FF2B5EF4-FFF2-40B4-BE49-F238E27FC236}">
-                <a16:creationId xmlns:a16="http://schemas.microsoft.com/office/drawing/2014/main" id="{554BED1B-121D-4DFB-8FA2-C06470458E31}"/>
+                <a16:creationId xmlns:a16="http://schemas.microsoft.com/office/drawing/2014/main" id="{1C900957-791B-4884-94BE-AB08E25176C3}"/>
               </a:ext>
             </a:extLst>
           </p:cNvPr>
@@ -2733,7 +2733,7 @@
           <p:nvPr/>
         </p:nvPicPr>
         <p:blipFill>
-          <a:blip xmlns:r="http://schemas.openxmlformats.org/officeDocument/2006/relationships" xmlns:a="http://schemas.openxmlformats.org/drawingml/2006/main" r:embed="R49d967df62594ceb"/>
+          <a:blip xmlns:r="http://schemas.openxmlformats.org/officeDocument/2006/relationships" xmlns:a="http://schemas.openxmlformats.org/drawingml/2006/main" r:embed="R8c47797256d04ebb"/>
           <a:stretch xmlns:a="http://schemas.openxmlformats.org/drawingml/2006/main"/>
         </p:blipFill>
         <p:spPr>
@@ -2751,7 +2751,7 @@
           <p:cNvPr id="13" name="text-118">
             <a:extLst xmlns:a="http://schemas.openxmlformats.org/drawingml/2006/main">
               <a:ext uri="{FF2B5EF4-FFF2-40B4-BE49-F238E27FC236}">
-                <a16:creationId xmlns:a16="http://schemas.microsoft.com/office/drawing/2014/main" id="{A6A722DF-21F1-4327-88A3-2ABE1F0D5BFC}"/>
+                <a16:creationId xmlns:a16="http://schemas.microsoft.com/office/drawing/2014/main" id="{8175A902-0960-471B-B828-66E9936780DC}"/>
               </a:ext>
             </a:extLst>
           </p:cNvPr>
@@ -2805,7 +2805,7 @@
     </p:spTree>
     <p:extLst>
       <p:ext uri="{BB962C8B-B14F-4D97-AF65-F5344CB8AC3E}">
-        <p14:creationId xmlns:p14="http://schemas.microsoft.com/office/powerpoint/2010/main" val="1405598557"/>
+        <p14:creationId xmlns:p14="http://schemas.microsoft.com/office/powerpoint/2010/main" val="856126503"/>
       </p:ext>
     </p:extLst>
   </p:cSld>
@@ -2836,7 +2836,7 @@
           <p:cNvPr id="19" name="box-119">
             <a:extLst xmlns:a="http://schemas.openxmlformats.org/drawingml/2006/main">
               <a:ext uri="{FF2B5EF4-FFF2-40B4-BE49-F238E27FC236}">
-                <a16:creationId xmlns:a16="http://schemas.microsoft.com/office/drawing/2014/main" id="{645B2F92-03C1-4312-80C3-C05FAD6FC533}"/>
+                <a16:creationId xmlns:a16="http://schemas.microsoft.com/office/drawing/2014/main" id="{84BC7223-A342-4B02-9D4B-380E7C2E8393}"/>
               </a:ext>
             </a:extLst>
           </p:cNvPr>
@@ -2869,7 +2869,7 @@
           <p:cNvPr id="2" name="text-120">
             <a:extLst xmlns:a="http://schemas.openxmlformats.org/drawingml/2006/main">
               <a:ext uri="{FF2B5EF4-FFF2-40B4-BE49-F238E27FC236}">
-                <a16:creationId xmlns:a16="http://schemas.microsoft.com/office/drawing/2014/main" id="{4F156F7F-F5ED-478E-93C2-DFC2DD971EF5}"/>
+                <a16:creationId xmlns:a16="http://schemas.microsoft.com/office/drawing/2014/main" id="{3C4A7342-DA06-4BAC-9536-AA193E31537E}"/>
               </a:ext>
             </a:extLst>
           </p:cNvPr>
@@ -2925,7 +2925,7 @@
           <p:cNvPr id="3" name="text-121">
             <a:extLst xmlns:a="http://schemas.openxmlformats.org/drawingml/2006/main">
               <a:ext uri="{FF2B5EF4-FFF2-40B4-BE49-F238E27FC236}">
-                <a16:creationId xmlns:a16="http://schemas.microsoft.com/office/drawing/2014/main" id="{1C069278-951F-4E78-A7AA-CDC86CC6231A}"/>
+                <a16:creationId xmlns:a16="http://schemas.microsoft.com/office/drawing/2014/main" id="{5EDC0491-CAA2-4379-90AD-37D63BAE71B7}"/>
               </a:ext>
             </a:extLst>
           </p:cNvPr>
@@ -2981,7 +2981,7 @@
           <p:cNvPr id="4" name="text-122">
             <a:extLst xmlns:a="http://schemas.openxmlformats.org/drawingml/2006/main">
               <a:ext uri="{FF2B5EF4-FFF2-40B4-BE49-F238E27FC236}">
-                <a16:creationId xmlns:a16="http://schemas.microsoft.com/office/drawing/2014/main" id="{86181F2E-9EA7-47C8-998F-0807699596FF}"/>
+                <a16:creationId xmlns:a16="http://schemas.microsoft.com/office/drawing/2014/main" id="{D192008C-B04C-4801-A636-7E161EC3EBCD}"/>
               </a:ext>
             </a:extLst>
           </p:cNvPr>
@@ -3037,7 +3037,7 @@
           <p:cNvPr id="5" name="text-123">
             <a:extLst xmlns:a="http://schemas.openxmlformats.org/drawingml/2006/main">
               <a:ext uri="{FF2B5EF4-FFF2-40B4-BE49-F238E27FC236}">
-                <a16:creationId xmlns:a16="http://schemas.microsoft.com/office/drawing/2014/main" id="{CF8172CB-2091-4BF4-BB1A-4643067BDAEC}"/>
+                <a16:creationId xmlns:a16="http://schemas.microsoft.com/office/drawing/2014/main" id="{B02D286A-F404-406A-BE6D-371C8DA9E00C}"/>
               </a:ext>
             </a:extLst>
           </p:cNvPr>
@@ -3093,7 +3093,7 @@
           <p:cNvPr id="6" name="text-124">
             <a:extLst xmlns:a="http://schemas.openxmlformats.org/drawingml/2006/main">
               <a:ext uri="{FF2B5EF4-FFF2-40B4-BE49-F238E27FC236}">
-                <a16:creationId xmlns:a16="http://schemas.microsoft.com/office/drawing/2014/main" id="{58D681B1-EA95-47C6-88B2-1F4F66BB7670}"/>
+                <a16:creationId xmlns:a16="http://schemas.microsoft.com/office/drawing/2014/main" id="{2FD8DB01-85C4-495B-AB16-9C9644EB4A1A}"/>
               </a:ext>
             </a:extLst>
           </p:cNvPr>
@@ -3149,7 +3149,7 @@
           <p:cNvPr id="7" name="box-125">
             <a:extLst xmlns:a="http://schemas.openxmlformats.org/drawingml/2006/main">
               <a:ext uri="{FF2B5EF4-FFF2-40B4-BE49-F238E27FC236}">
-                <a16:creationId xmlns:a16="http://schemas.microsoft.com/office/drawing/2014/main" id="{6E161F96-48C0-4FEB-A4EB-0118EE5C90A9}"/>
+                <a16:creationId xmlns:a16="http://schemas.microsoft.com/office/drawing/2014/main" id="{32AAAA30-B0AD-4841-B445-C948FC496FDC}"/>
               </a:ext>
             </a:extLst>
           </p:cNvPr>
@@ -3182,7 +3182,7 @@
           <p:cNvPr id="8" name="text-126">
             <a:extLst xmlns:a="http://schemas.openxmlformats.org/drawingml/2006/main">
               <a:ext uri="{FF2B5EF4-FFF2-40B4-BE49-F238E27FC236}">
-                <a16:creationId xmlns:a16="http://schemas.microsoft.com/office/drawing/2014/main" id="{070BB71D-5755-4B8A-9CED-6A1CFE6B46BE}"/>
+                <a16:creationId xmlns:a16="http://schemas.microsoft.com/office/drawing/2014/main" id="{FB0A372F-1FB8-4FA2-AAC7-EBFBD96F3193}"/>
               </a:ext>
             </a:extLst>
           </p:cNvPr>
@@ -3238,7 +3238,7 @@
           <p:cNvPr id="9" name="text-127">
             <a:extLst xmlns:a="http://schemas.openxmlformats.org/drawingml/2006/main">
               <a:ext uri="{FF2B5EF4-FFF2-40B4-BE49-F238E27FC236}">
-                <a16:creationId xmlns:a16="http://schemas.microsoft.com/office/drawing/2014/main" id="{0EE48D0F-9FF3-4BE1-8507-29D939AACC48}"/>
+                <a16:creationId xmlns:a16="http://schemas.microsoft.com/office/drawing/2014/main" id="{560D61AE-41F8-41C8-96E5-DAA21E81A4C8}"/>
               </a:ext>
             </a:extLst>
           </p:cNvPr>
@@ -3294,7 +3294,7 @@
           <p:cNvPr id="10" name="text-128">
             <a:extLst xmlns:a="http://schemas.openxmlformats.org/drawingml/2006/main">
               <a:ext uri="{FF2B5EF4-FFF2-40B4-BE49-F238E27FC236}">
-                <a16:creationId xmlns:a16="http://schemas.microsoft.com/office/drawing/2014/main" id="{35188F13-30F0-452F-9607-6A951CB48A5F}"/>
+                <a16:creationId xmlns:a16="http://schemas.microsoft.com/office/drawing/2014/main" id="{648EF23B-62E9-440D-8ED9-9543B9FC5DED}"/>
               </a:ext>
             </a:extLst>
           </p:cNvPr>
@@ -3350,7 +3350,7 @@
           <p:cNvPr id="11" name="box-129">
             <a:extLst xmlns:a="http://schemas.openxmlformats.org/drawingml/2006/main">
               <a:ext uri="{FF2B5EF4-FFF2-40B4-BE49-F238E27FC236}">
-                <a16:creationId xmlns:a16="http://schemas.microsoft.com/office/drawing/2014/main" id="{1005AB76-EF33-4F78-BA97-2566A940DDAD}"/>
+                <a16:creationId xmlns:a16="http://schemas.microsoft.com/office/drawing/2014/main" id="{07E0E4E6-8AF8-41A9-B391-690F51365FC1}"/>
               </a:ext>
             </a:extLst>
           </p:cNvPr>
@@ -3383,7 +3383,7 @@
           <p:cNvPr id="12" name="text-130">
             <a:extLst xmlns:a="http://schemas.openxmlformats.org/drawingml/2006/main">
               <a:ext uri="{FF2B5EF4-FFF2-40B4-BE49-F238E27FC236}">
-                <a16:creationId xmlns:a16="http://schemas.microsoft.com/office/drawing/2014/main" id="{2ECC8B5D-DAC4-4F78-B2BC-188DB2185B30}"/>
+                <a16:creationId xmlns:a16="http://schemas.microsoft.com/office/drawing/2014/main" id="{87F4024D-FFCD-4D43-98EA-6499858ABFC1}"/>
               </a:ext>
             </a:extLst>
           </p:cNvPr>
@@ -3439,7 +3439,7 @@
           <p:cNvPr id="13" name="text-131">
             <a:extLst xmlns:a="http://schemas.openxmlformats.org/drawingml/2006/main">
               <a:ext uri="{FF2B5EF4-FFF2-40B4-BE49-F238E27FC236}">
-                <a16:creationId xmlns:a16="http://schemas.microsoft.com/office/drawing/2014/main" id="{78C50BB5-2016-4266-946E-CF7085E2734F}"/>
+                <a16:creationId xmlns:a16="http://schemas.microsoft.com/office/drawing/2014/main" id="{7ABCE6C3-7FFE-4247-967F-3784C8471277}"/>
               </a:ext>
             </a:extLst>
           </p:cNvPr>
@@ -3495,7 +3495,7 @@
           <p:cNvPr id="14" name="text-132">
             <a:extLst xmlns:a="http://schemas.openxmlformats.org/drawingml/2006/main">
               <a:ext uri="{FF2B5EF4-FFF2-40B4-BE49-F238E27FC236}">
-                <a16:creationId xmlns:a16="http://schemas.microsoft.com/office/drawing/2014/main" id="{1C72D1B6-13DE-450A-888A-EDAE750A03A0}"/>
+                <a16:creationId xmlns:a16="http://schemas.microsoft.com/office/drawing/2014/main" id="{403AF54B-D5D1-4924-8C98-505DD8CAC2AE}"/>
               </a:ext>
             </a:extLst>
           </p:cNvPr>
@@ -3551,7 +3551,7 @@
           <p:cNvPr id="15" name="box-133">
             <a:extLst xmlns:a="http://schemas.openxmlformats.org/drawingml/2006/main">
               <a:ext uri="{FF2B5EF4-FFF2-40B4-BE49-F238E27FC236}">
-                <a16:creationId xmlns:a16="http://schemas.microsoft.com/office/drawing/2014/main" id="{35FB3CBF-8FC4-495C-9028-A8592379DBBD}"/>
+                <a16:creationId xmlns:a16="http://schemas.microsoft.com/office/drawing/2014/main" id="{92BB9DE6-E196-410B-A032-0431CA6CFD6A}"/>
               </a:ext>
             </a:extLst>
           </p:cNvPr>
@@ -3584,7 +3584,7 @@
           <p:cNvPr id="16" name="text-134">
             <a:extLst xmlns:a="http://schemas.openxmlformats.org/drawingml/2006/main">
               <a:ext uri="{FF2B5EF4-FFF2-40B4-BE49-F238E27FC236}">
-                <a16:creationId xmlns:a16="http://schemas.microsoft.com/office/drawing/2014/main" id="{68111909-0FFA-44A2-A022-F6612B821BC5}"/>
+                <a16:creationId xmlns:a16="http://schemas.microsoft.com/office/drawing/2014/main" id="{80423748-BBE4-47B2-8BEE-9864D8416D61}"/>
               </a:ext>
             </a:extLst>
           </p:cNvPr>
@@ -3640,7 +3640,7 @@
           <p:cNvPr id="17" name="text-135">
             <a:extLst xmlns:a="http://schemas.openxmlformats.org/drawingml/2006/main">
               <a:ext uri="{FF2B5EF4-FFF2-40B4-BE49-F238E27FC236}">
-                <a16:creationId xmlns:a16="http://schemas.microsoft.com/office/drawing/2014/main" id="{54BCB78B-F3A2-4A50-85D4-6368D0EC82A3}"/>
+                <a16:creationId xmlns:a16="http://schemas.microsoft.com/office/drawing/2014/main" id="{00BB5B91-7A80-4C49-BF98-232739F36042}"/>
               </a:ext>
             </a:extLst>
           </p:cNvPr>
@@ -3696,7 +3696,7 @@
           <p:cNvPr id="18" name="text-136">
             <a:extLst xmlns:a="http://schemas.openxmlformats.org/drawingml/2006/main">
               <a:ext uri="{FF2B5EF4-FFF2-40B4-BE49-F238E27FC236}">
-                <a16:creationId xmlns:a16="http://schemas.microsoft.com/office/drawing/2014/main" id="{49FE4950-FF56-47A5-9B8D-6389AB3C2A28}"/>
+                <a16:creationId xmlns:a16="http://schemas.microsoft.com/office/drawing/2014/main" id="{F9DD2DEE-4D74-473B-AF46-08790169C402}"/>
               </a:ext>
             </a:extLst>
           </p:cNvPr>
@@ -3750,7 +3750,7 @@
     </p:spTree>
     <p:extLst>
       <p:ext uri="{BB962C8B-B14F-4D97-AF65-F5344CB8AC3E}">
-        <p14:creationId xmlns:p14="http://schemas.microsoft.com/office/powerpoint/2010/main" val="2035615234"/>
+        <p14:creationId xmlns:p14="http://schemas.microsoft.com/office/powerpoint/2010/main" val="1855660492"/>
       </p:ext>
     </p:extLst>
   </p:cSld>
@@ -3781,7 +3781,7 @@
           <p:cNvPr id="18" name="box-137">
             <a:extLst xmlns:a="http://schemas.openxmlformats.org/drawingml/2006/main">
               <a:ext uri="{FF2B5EF4-FFF2-40B4-BE49-F238E27FC236}">
-                <a16:creationId xmlns:a16="http://schemas.microsoft.com/office/drawing/2014/main" id="{F6B3E68E-DD21-41EB-BA02-940692D07D01}"/>
+                <a16:creationId xmlns:a16="http://schemas.microsoft.com/office/drawing/2014/main" id="{74A0E605-4158-458F-B729-482AA225E0A4}"/>
               </a:ext>
             </a:extLst>
           </p:cNvPr>
@@ -3814,7 +3814,7 @@
           <p:cNvPr id="2" name="text-138">
             <a:extLst xmlns:a="http://schemas.openxmlformats.org/drawingml/2006/main">
               <a:ext uri="{FF2B5EF4-FFF2-40B4-BE49-F238E27FC236}">
-                <a16:creationId xmlns:a16="http://schemas.microsoft.com/office/drawing/2014/main" id="{77924F79-F1B5-427B-8702-18D57B5E37DE}"/>
+                <a16:creationId xmlns:a16="http://schemas.microsoft.com/office/drawing/2014/main" id="{916EDC24-2128-44C1-95CD-E77E8C8E2C35}"/>
               </a:ext>
             </a:extLst>
           </p:cNvPr>
@@ -3870,7 +3870,7 @@
           <p:cNvPr id="3" name="text-139">
             <a:extLst xmlns:a="http://schemas.openxmlformats.org/drawingml/2006/main">
               <a:ext uri="{FF2B5EF4-FFF2-40B4-BE49-F238E27FC236}">
-                <a16:creationId xmlns:a16="http://schemas.microsoft.com/office/drawing/2014/main" id="{DF3FE5E9-1A51-4960-A223-2B4D8C6F2B9F}"/>
+                <a16:creationId xmlns:a16="http://schemas.microsoft.com/office/drawing/2014/main" id="{C9756EA8-2078-4A5C-98CB-042D183E702E}"/>
               </a:ext>
             </a:extLst>
           </p:cNvPr>
@@ -3926,7 +3926,7 @@
           <p:cNvPr id="4" name="text-140">
             <a:extLst xmlns:a="http://schemas.openxmlformats.org/drawingml/2006/main">
               <a:ext uri="{FF2B5EF4-FFF2-40B4-BE49-F238E27FC236}">
-                <a16:creationId xmlns:a16="http://schemas.microsoft.com/office/drawing/2014/main" id="{D8AFE7BC-3521-4A45-8B8E-985E8769398C}"/>
+                <a16:creationId xmlns:a16="http://schemas.microsoft.com/office/drawing/2014/main" id="{EF8111DE-A994-461D-A1AE-46FA0DB23C55}"/>
               </a:ext>
             </a:extLst>
           </p:cNvPr>
@@ -3982,7 +3982,7 @@
           <p:cNvPr id="5" name="text-141">
             <a:extLst xmlns:a="http://schemas.openxmlformats.org/drawingml/2006/main">
               <a:ext uri="{FF2B5EF4-FFF2-40B4-BE49-F238E27FC236}">
-                <a16:creationId xmlns:a16="http://schemas.microsoft.com/office/drawing/2014/main" id="{9E72C852-F597-4EEE-BC9A-23C6E4036511}"/>
+                <a16:creationId xmlns:a16="http://schemas.microsoft.com/office/drawing/2014/main" id="{43163461-FF35-4BE3-B259-B864F54F4827}"/>
               </a:ext>
             </a:extLst>
           </p:cNvPr>
@@ -4038,7 +4038,7 @@
           <p:cNvPr id="6" name="box-142">
             <a:extLst xmlns:a="http://schemas.openxmlformats.org/drawingml/2006/main">
               <a:ext uri="{FF2B5EF4-FFF2-40B4-BE49-F238E27FC236}">
-                <a16:creationId xmlns:a16="http://schemas.microsoft.com/office/drawing/2014/main" id="{EBC1341D-D3E5-4CA7-953F-7BC75BC6AA7F}"/>
+                <a16:creationId xmlns:a16="http://schemas.microsoft.com/office/drawing/2014/main" id="{A15BDFFD-6498-4322-9780-2E001ED75554}"/>
               </a:ext>
             </a:extLst>
           </p:cNvPr>
@@ -4071,7 +4071,7 @@
           <p:cNvPr id="7" name="text-143">
             <a:extLst xmlns:a="http://schemas.openxmlformats.org/drawingml/2006/main">
               <a:ext uri="{FF2B5EF4-FFF2-40B4-BE49-F238E27FC236}">
-                <a16:creationId xmlns:a16="http://schemas.microsoft.com/office/drawing/2014/main" id="{1ADC355D-1471-49BA-901F-9288AA433A4B}"/>
+                <a16:creationId xmlns:a16="http://schemas.microsoft.com/office/drawing/2014/main" id="{72308B1C-B09A-4D67-BC9E-F06C3A7B3AE7}"/>
               </a:ext>
             </a:extLst>
           </p:cNvPr>
@@ -4127,7 +4127,7 @@
           <p:cNvPr id="8" name="text-144">
             <a:extLst xmlns:a="http://schemas.openxmlformats.org/drawingml/2006/main">
               <a:ext uri="{FF2B5EF4-FFF2-40B4-BE49-F238E27FC236}">
-                <a16:creationId xmlns:a16="http://schemas.microsoft.com/office/drawing/2014/main" id="{14593660-C45E-4E96-89E3-FEF5533BB0D4}"/>
+                <a16:creationId xmlns:a16="http://schemas.microsoft.com/office/drawing/2014/main" id="{C15EB099-774A-42D8-97DB-B469BAB65AAF}"/>
               </a:ext>
             </a:extLst>
           </p:cNvPr>
@@ -4183,7 +4183,7 @@
           <p:cNvPr id="9" name="box-145">
             <a:extLst xmlns:a="http://schemas.openxmlformats.org/drawingml/2006/main">
               <a:ext uri="{FF2B5EF4-FFF2-40B4-BE49-F238E27FC236}">
-                <a16:creationId xmlns:a16="http://schemas.microsoft.com/office/drawing/2014/main" id="{02C6714D-D85D-47A8-926E-9065CB1670C9}"/>
+                <a16:creationId xmlns:a16="http://schemas.microsoft.com/office/drawing/2014/main" id="{6C7E5C7E-9D64-427F-9C0C-C6A8F42CC545}"/>
               </a:ext>
             </a:extLst>
           </p:cNvPr>
@@ -4216,7 +4216,7 @@
           <p:cNvPr id="10" name="text-146">
             <a:extLst xmlns:a="http://schemas.openxmlformats.org/drawingml/2006/main">
               <a:ext uri="{FF2B5EF4-FFF2-40B4-BE49-F238E27FC236}">
-                <a16:creationId xmlns:a16="http://schemas.microsoft.com/office/drawing/2014/main" id="{4A69BEE8-19BC-4F4B-9D84-4BBD4DAAF4F5}"/>
+                <a16:creationId xmlns:a16="http://schemas.microsoft.com/office/drawing/2014/main" id="{08A65BA3-3242-48EE-B2C4-931D75F5E3C7}"/>
               </a:ext>
             </a:extLst>
           </p:cNvPr>
@@ -4272,7 +4272,7 @@
           <p:cNvPr id="11" name="text-147">
             <a:extLst xmlns:a="http://schemas.openxmlformats.org/drawingml/2006/main">
               <a:ext uri="{FF2B5EF4-FFF2-40B4-BE49-F238E27FC236}">
-                <a16:creationId xmlns:a16="http://schemas.microsoft.com/office/drawing/2014/main" id="{119ED5FB-908A-421A-8F2B-7E9727D5A25D}"/>
+                <a16:creationId xmlns:a16="http://schemas.microsoft.com/office/drawing/2014/main" id="{A5ACE380-2510-4C79-A7F6-889D011786E6}"/>
               </a:ext>
             </a:extLst>
           </p:cNvPr>
@@ -4328,7 +4328,7 @@
           <p:cNvPr id="12" name="box-148">
             <a:extLst xmlns:a="http://schemas.openxmlformats.org/drawingml/2006/main">
               <a:ext uri="{FF2B5EF4-FFF2-40B4-BE49-F238E27FC236}">
-                <a16:creationId xmlns:a16="http://schemas.microsoft.com/office/drawing/2014/main" id="{28654B31-631C-4BF0-9F02-EB55F4042CA7}"/>
+                <a16:creationId xmlns:a16="http://schemas.microsoft.com/office/drawing/2014/main" id="{259D98CF-4F5D-44BE-98AB-E244EFC1B773}"/>
               </a:ext>
             </a:extLst>
           </p:cNvPr>
@@ -4361,7 +4361,7 @@
           <p:cNvPr id="13" name="text-149">
             <a:extLst xmlns:a="http://schemas.openxmlformats.org/drawingml/2006/main">
               <a:ext uri="{FF2B5EF4-FFF2-40B4-BE49-F238E27FC236}">
-                <a16:creationId xmlns:a16="http://schemas.microsoft.com/office/drawing/2014/main" id="{34DBD6C4-CA5E-47F9-9488-3CA2115BE26F}"/>
+                <a16:creationId xmlns:a16="http://schemas.microsoft.com/office/drawing/2014/main" id="{9C38C09E-0EA5-4C9A-BB32-B7961629BB5E}"/>
               </a:ext>
             </a:extLst>
           </p:cNvPr>
@@ -4417,7 +4417,7 @@
           <p:cNvPr id="14" name="text-150">
             <a:extLst xmlns:a="http://schemas.openxmlformats.org/drawingml/2006/main">
               <a:ext uri="{FF2B5EF4-FFF2-40B4-BE49-F238E27FC236}">
-                <a16:creationId xmlns:a16="http://schemas.microsoft.com/office/drawing/2014/main" id="{2D6AD33A-1967-4399-A68E-2A790E9B0837}"/>
+                <a16:creationId xmlns:a16="http://schemas.microsoft.com/office/drawing/2014/main" id="{DEB329FF-ECDA-4D71-8FA6-40254D42E5F1}"/>
               </a:ext>
             </a:extLst>
           </p:cNvPr>
@@ -4473,7 +4473,7 @@
           <p:cNvPr id="15" name="box-151">
             <a:extLst xmlns:a="http://schemas.openxmlformats.org/drawingml/2006/main">
               <a:ext uri="{FF2B5EF4-FFF2-40B4-BE49-F238E27FC236}">
-                <a16:creationId xmlns:a16="http://schemas.microsoft.com/office/drawing/2014/main" id="{ACDFEA24-0433-4B94-BF66-3AAA10A5FADC}"/>
+                <a16:creationId xmlns:a16="http://schemas.microsoft.com/office/drawing/2014/main" id="{B23BED54-D622-42A0-9BE2-6E625AFD9D2B}"/>
               </a:ext>
             </a:extLst>
           </p:cNvPr>
@@ -4506,7 +4506,7 @@
           <p:cNvPr id="16" name="text-152">
             <a:extLst xmlns:a="http://schemas.openxmlformats.org/drawingml/2006/main">
               <a:ext uri="{FF2B5EF4-FFF2-40B4-BE49-F238E27FC236}">
-                <a16:creationId xmlns:a16="http://schemas.microsoft.com/office/drawing/2014/main" id="{DD16DA29-8069-40A8-80BB-F00CDCE3B62D}"/>
+                <a16:creationId xmlns:a16="http://schemas.microsoft.com/office/drawing/2014/main" id="{4FEE9D18-DC96-44EE-AE0E-5CDDB19D6418}"/>
               </a:ext>
             </a:extLst>
           </p:cNvPr>
@@ -4562,7 +4562,7 @@
           <p:cNvPr id="17" name="text-153">
             <a:extLst xmlns:a="http://schemas.openxmlformats.org/drawingml/2006/main">
               <a:ext uri="{FF2B5EF4-FFF2-40B4-BE49-F238E27FC236}">
-                <a16:creationId xmlns:a16="http://schemas.microsoft.com/office/drawing/2014/main" id="{4C276E28-A23F-4484-878B-0B51E4F6DB6C}"/>
+                <a16:creationId xmlns:a16="http://schemas.microsoft.com/office/drawing/2014/main" id="{2BA86DAE-9913-4CE2-A107-EF23851B6B0A}"/>
               </a:ext>
             </a:extLst>
           </p:cNvPr>
@@ -4616,7 +4616,7 @@
     </p:spTree>
     <p:extLst>
       <p:ext uri="{BB962C8B-B14F-4D97-AF65-F5344CB8AC3E}">
-        <p14:creationId xmlns:p14="http://schemas.microsoft.com/office/powerpoint/2010/main" val="1240659910"/>
+        <p14:creationId xmlns:p14="http://schemas.microsoft.com/office/powerpoint/2010/main" val="1098168377"/>
       </p:ext>
     </p:extLst>
   </p:cSld>
@@ -4647,7 +4647,7 @@
           <p:cNvPr id="21" name="box-154">
             <a:extLst xmlns:a="http://schemas.openxmlformats.org/drawingml/2006/main">
               <a:ext uri="{FF2B5EF4-FFF2-40B4-BE49-F238E27FC236}">
-                <a16:creationId xmlns:a16="http://schemas.microsoft.com/office/drawing/2014/main" id="{217470D2-AB29-4763-9E2B-7E9B02E9D534}"/>
+                <a16:creationId xmlns:a16="http://schemas.microsoft.com/office/drawing/2014/main" id="{E1F6B360-AE18-4A78-8B35-7D8BE87CBEA5}"/>
               </a:ext>
             </a:extLst>
           </p:cNvPr>
@@ -4680,7 +4680,7 @@
           <p:cNvPr id="2" name="text-155">
             <a:extLst xmlns:a="http://schemas.openxmlformats.org/drawingml/2006/main">
               <a:ext uri="{FF2B5EF4-FFF2-40B4-BE49-F238E27FC236}">
-                <a16:creationId xmlns:a16="http://schemas.microsoft.com/office/drawing/2014/main" id="{D4B816BC-B6A5-4A81-8963-EE10852CADA0}"/>
+                <a16:creationId xmlns:a16="http://schemas.microsoft.com/office/drawing/2014/main" id="{F9A1D0EC-1E60-429F-B5EE-15F1F9D20ACD}"/>
               </a:ext>
             </a:extLst>
           </p:cNvPr>
@@ -4736,7 +4736,7 @@
           <p:cNvPr id="3" name="text-156">
             <a:extLst xmlns:a="http://schemas.openxmlformats.org/drawingml/2006/main">
               <a:ext uri="{FF2B5EF4-FFF2-40B4-BE49-F238E27FC236}">
-                <a16:creationId xmlns:a16="http://schemas.microsoft.com/office/drawing/2014/main" id="{4BD157BB-57D0-492E-A6DA-A57B7F9592E1}"/>
+                <a16:creationId xmlns:a16="http://schemas.microsoft.com/office/drawing/2014/main" id="{F35F6FEC-77F7-4A70-8D52-656459700011}"/>
               </a:ext>
             </a:extLst>
           </p:cNvPr>
@@ -4792,7 +4792,7 @@
           <p:cNvPr id="4" name="text-157">
             <a:extLst xmlns:a="http://schemas.openxmlformats.org/drawingml/2006/main">
               <a:ext uri="{FF2B5EF4-FFF2-40B4-BE49-F238E27FC236}">
-                <a16:creationId xmlns:a16="http://schemas.microsoft.com/office/drawing/2014/main" id="{85A5B55D-03F1-4218-9AE1-1362BBAB0510}"/>
+                <a16:creationId xmlns:a16="http://schemas.microsoft.com/office/drawing/2014/main" id="{9F3A1E72-0F18-446F-A5B5-D56324C78A14}"/>
               </a:ext>
             </a:extLst>
           </p:cNvPr>
@@ -4848,7 +4848,7 @@
           <p:cNvPr id="5" name="text-158">
             <a:extLst xmlns:a="http://schemas.openxmlformats.org/drawingml/2006/main">
               <a:ext uri="{FF2B5EF4-FFF2-40B4-BE49-F238E27FC236}">
-                <a16:creationId xmlns:a16="http://schemas.microsoft.com/office/drawing/2014/main" id="{8D026EED-2399-48FB-B08F-5B28AA81C233}"/>
+                <a16:creationId xmlns:a16="http://schemas.microsoft.com/office/drawing/2014/main" id="{9A5BBBF5-7327-4945-A343-3DB4A81463DE}"/>
               </a:ext>
             </a:extLst>
           </p:cNvPr>
@@ -4904,7 +4904,7 @@
           <p:cNvPr id="6" name="box-159">
             <a:extLst xmlns:a="http://schemas.openxmlformats.org/drawingml/2006/main">
               <a:ext uri="{FF2B5EF4-FFF2-40B4-BE49-F238E27FC236}">
-                <a16:creationId xmlns:a16="http://schemas.microsoft.com/office/drawing/2014/main" id="{0D3B9DAE-E519-4036-A23E-27613D2700C9}"/>
+                <a16:creationId xmlns:a16="http://schemas.microsoft.com/office/drawing/2014/main" id="{E475A90E-FB97-49F5-8E91-00BAF9F89617}"/>
               </a:ext>
             </a:extLst>
           </p:cNvPr>
@@ -4937,7 +4937,7 @@
           <p:cNvPr id="7" name="dot-160">
             <a:extLst xmlns:a="http://schemas.openxmlformats.org/drawingml/2006/main">
               <a:ext uri="{FF2B5EF4-FFF2-40B4-BE49-F238E27FC236}">
-                <a16:creationId xmlns:a16="http://schemas.microsoft.com/office/drawing/2014/main" id="{40234F09-542D-42CF-8128-FB7B5C24CB5A}"/>
+                <a16:creationId xmlns:a16="http://schemas.microsoft.com/office/drawing/2014/main" id="{7C134415-CE4F-4B83-9EF5-7C88389873B3}"/>
               </a:ext>
             </a:extLst>
           </p:cNvPr>
@@ -4968,7 +4968,7 @@
           <p:cNvPr id="8" name="text-161">
             <a:extLst xmlns:a="http://schemas.openxmlformats.org/drawingml/2006/main">
               <a:ext uri="{FF2B5EF4-FFF2-40B4-BE49-F238E27FC236}">
-                <a16:creationId xmlns:a16="http://schemas.microsoft.com/office/drawing/2014/main" id="{5E4861EE-C0F2-49A2-AC48-93DDDB31157D}"/>
+                <a16:creationId xmlns:a16="http://schemas.microsoft.com/office/drawing/2014/main" id="{E3F645B5-6B4A-4314-8940-FC8F58C3D1EC}"/>
               </a:ext>
             </a:extLst>
           </p:cNvPr>
@@ -5024,7 +5024,7 @@
           <p:cNvPr id="9" name="text-162">
             <a:extLst xmlns:a="http://schemas.openxmlformats.org/drawingml/2006/main">
               <a:ext uri="{FF2B5EF4-FFF2-40B4-BE49-F238E27FC236}">
-                <a16:creationId xmlns:a16="http://schemas.microsoft.com/office/drawing/2014/main" id="{77F29146-CDC5-43CA-A7EA-7C086F81B445}"/>
+                <a16:creationId xmlns:a16="http://schemas.microsoft.com/office/drawing/2014/main" id="{DF1D03DA-4793-47AA-B466-BA50B4EAF47B}"/>
               </a:ext>
             </a:extLst>
           </p:cNvPr>
@@ -5080,7 +5080,7 @@
           <p:cNvPr id="10" name="text-163">
             <a:extLst xmlns:a="http://schemas.openxmlformats.org/drawingml/2006/main">
               <a:ext uri="{FF2B5EF4-FFF2-40B4-BE49-F238E27FC236}">
-                <a16:creationId xmlns:a16="http://schemas.microsoft.com/office/drawing/2014/main" id="{951C1656-4B31-4984-B193-266001FAA8B0}"/>
+                <a16:creationId xmlns:a16="http://schemas.microsoft.com/office/drawing/2014/main" id="{066F1501-118C-40C2-8636-6D7E15081E3F}"/>
               </a:ext>
             </a:extLst>
           </p:cNvPr>
@@ -5136,7 +5136,7 @@
           <p:cNvPr id="11" name="dot-164">
             <a:extLst xmlns:a="http://schemas.openxmlformats.org/drawingml/2006/main">
               <a:ext uri="{FF2B5EF4-FFF2-40B4-BE49-F238E27FC236}">
-                <a16:creationId xmlns:a16="http://schemas.microsoft.com/office/drawing/2014/main" id="{A8C101B6-384D-4045-8B91-8CDBDD1F306D}"/>
+                <a16:creationId xmlns:a16="http://schemas.microsoft.com/office/drawing/2014/main" id="{C70A4765-FDC0-485A-8860-5B2F633A21E8}"/>
               </a:ext>
             </a:extLst>
           </p:cNvPr>
@@ -5167,7 +5167,7 @@
           <p:cNvPr id="12" name="text-165">
             <a:extLst xmlns:a="http://schemas.openxmlformats.org/drawingml/2006/main">
               <a:ext uri="{FF2B5EF4-FFF2-40B4-BE49-F238E27FC236}">
-                <a16:creationId xmlns:a16="http://schemas.microsoft.com/office/drawing/2014/main" id="{908B8F1D-3B1B-4A72-9A1C-793F5CF51491}"/>
+                <a16:creationId xmlns:a16="http://schemas.microsoft.com/office/drawing/2014/main" id="{03357B3A-BBC8-46EC-A701-4D2769A17B6A}"/>
               </a:ext>
             </a:extLst>
           </p:cNvPr>
@@ -5223,7 +5223,7 @@
           <p:cNvPr id="13" name="text-166">
             <a:extLst xmlns:a="http://schemas.openxmlformats.org/drawingml/2006/main">
               <a:ext uri="{FF2B5EF4-FFF2-40B4-BE49-F238E27FC236}">
-                <a16:creationId xmlns:a16="http://schemas.microsoft.com/office/drawing/2014/main" id="{9C0B0016-67F0-4283-A129-1FB9F6DEDEF0}"/>
+                <a16:creationId xmlns:a16="http://schemas.microsoft.com/office/drawing/2014/main" id="{EA749CE8-BD48-4EF7-ACB0-3C35463B9651}"/>
               </a:ext>
             </a:extLst>
           </p:cNvPr>
@@ -5279,7 +5279,7 @@
           <p:cNvPr id="14" name="text-167">
             <a:extLst xmlns:a="http://schemas.openxmlformats.org/drawingml/2006/main">
               <a:ext uri="{FF2B5EF4-FFF2-40B4-BE49-F238E27FC236}">
-                <a16:creationId xmlns:a16="http://schemas.microsoft.com/office/drawing/2014/main" id="{BD9E2099-2B9D-4EBE-BF39-1BDB8688B623}"/>
+                <a16:creationId xmlns:a16="http://schemas.microsoft.com/office/drawing/2014/main" id="{1C1215DB-3DC7-4B67-925F-27AA25515363}"/>
               </a:ext>
             </a:extLst>
           </p:cNvPr>
@@ -5335,7 +5335,7 @@
           <p:cNvPr id="15" name="dot-168">
             <a:extLst xmlns:a="http://schemas.openxmlformats.org/drawingml/2006/main">
               <a:ext uri="{FF2B5EF4-FFF2-40B4-BE49-F238E27FC236}">
-                <a16:creationId xmlns:a16="http://schemas.microsoft.com/office/drawing/2014/main" id="{4DF352B7-E2C2-4888-8EF3-A967F1E43A8A}"/>
+                <a16:creationId xmlns:a16="http://schemas.microsoft.com/office/drawing/2014/main" id="{887965AE-5F16-4A3F-AD8A-CB81617B6C94}"/>
               </a:ext>
             </a:extLst>
           </p:cNvPr>
@@ -5366,7 +5366,7 @@
           <p:cNvPr id="16" name="text-169">
             <a:extLst xmlns:a="http://schemas.openxmlformats.org/drawingml/2006/main">
               <a:ext uri="{FF2B5EF4-FFF2-40B4-BE49-F238E27FC236}">
-                <a16:creationId xmlns:a16="http://schemas.microsoft.com/office/drawing/2014/main" id="{2583DD93-8CDB-498E-A0B3-C3EEB528BA4D}"/>
+                <a16:creationId xmlns:a16="http://schemas.microsoft.com/office/drawing/2014/main" id="{432832C1-0A64-480B-B3C5-3BC1690404A5}"/>
               </a:ext>
             </a:extLst>
           </p:cNvPr>
@@ -5422,7 +5422,7 @@
           <p:cNvPr id="17" name="text-170">
             <a:extLst xmlns:a="http://schemas.openxmlformats.org/drawingml/2006/main">
               <a:ext uri="{FF2B5EF4-FFF2-40B4-BE49-F238E27FC236}">
-                <a16:creationId xmlns:a16="http://schemas.microsoft.com/office/drawing/2014/main" id="{4B6CC549-5DEB-44B3-AC6D-8857E16884F0}"/>
+                <a16:creationId xmlns:a16="http://schemas.microsoft.com/office/drawing/2014/main" id="{AC21ADA9-87D3-4C3B-A18D-800260850E53}"/>
               </a:ext>
             </a:extLst>
           </p:cNvPr>
@@ -5478,7 +5478,7 @@
           <p:cNvPr id="18" name="text-171">
             <a:extLst xmlns:a="http://schemas.openxmlformats.org/drawingml/2006/main">
               <a:ext uri="{FF2B5EF4-FFF2-40B4-BE49-F238E27FC236}">
-                <a16:creationId xmlns:a16="http://schemas.microsoft.com/office/drawing/2014/main" id="{3B87D022-B072-4DA7-B833-988B0507AE4D}"/>
+                <a16:creationId xmlns:a16="http://schemas.microsoft.com/office/drawing/2014/main" id="{2C312B1C-2689-4F12-8C17-0A035F539768}"/>
               </a:ext>
             </a:extLst>
           </p:cNvPr>
@@ -5534,7 +5534,7 @@
           <p:cNvPr id="19" name="box-172">
             <a:extLst xmlns:a="http://schemas.openxmlformats.org/drawingml/2006/main">
               <a:ext uri="{FF2B5EF4-FFF2-40B4-BE49-F238E27FC236}">
-                <a16:creationId xmlns:a16="http://schemas.microsoft.com/office/drawing/2014/main" id="{8614EBDE-81F2-40E8-8E7F-AFD4AFBE08BE}"/>
+                <a16:creationId xmlns:a16="http://schemas.microsoft.com/office/drawing/2014/main" id="{675B809B-3A73-407A-8888-0E4C240A2B10}"/>
               </a:ext>
             </a:extLst>
           </p:cNvPr>
@@ -5567,7 +5567,7 @@
           <p:cNvPr id="20" name="text-173">
             <a:extLst xmlns:a="http://schemas.openxmlformats.org/drawingml/2006/main">
               <a:ext uri="{FF2B5EF4-FFF2-40B4-BE49-F238E27FC236}">
-                <a16:creationId xmlns:a16="http://schemas.microsoft.com/office/drawing/2014/main" id="{92F764CF-70B0-4A66-AE49-064C10E38719}"/>
+                <a16:creationId xmlns:a16="http://schemas.microsoft.com/office/drawing/2014/main" id="{7BFB0F8F-9BE6-49AE-868B-E6B905BCC2AC}"/>
               </a:ext>
             </a:extLst>
           </p:cNvPr>
@@ -5621,7 +5621,7 @@
     </p:spTree>
     <p:extLst>
       <p:ext uri="{BB962C8B-B14F-4D97-AF65-F5344CB8AC3E}">
-        <p14:creationId xmlns:p14="http://schemas.microsoft.com/office/powerpoint/2010/main" val="1210115824"/>
+        <p14:creationId xmlns:p14="http://schemas.microsoft.com/office/powerpoint/2010/main" val="2138527392"/>
       </p:ext>
     </p:extLst>
   </p:cSld>
@@ -5652,7 +5652,7 @@
           <p:cNvPr id="18" name="box-174">
             <a:extLst xmlns:a="http://schemas.openxmlformats.org/drawingml/2006/main">
               <a:ext uri="{FF2B5EF4-FFF2-40B4-BE49-F238E27FC236}">
-                <a16:creationId xmlns:a16="http://schemas.microsoft.com/office/drawing/2014/main" id="{2F0CE2E5-4D87-4185-86D2-D301A55845E1}"/>
+                <a16:creationId xmlns:a16="http://schemas.microsoft.com/office/drawing/2014/main" id="{7C03D1C4-0459-4B1A-A42C-2F9F621341BD}"/>
               </a:ext>
             </a:extLst>
           </p:cNvPr>
@@ -5685,7 +5685,7 @@
           <p:cNvPr id="2" name="text-175">
             <a:extLst xmlns:a="http://schemas.openxmlformats.org/drawingml/2006/main">
               <a:ext uri="{FF2B5EF4-FFF2-40B4-BE49-F238E27FC236}">
-                <a16:creationId xmlns:a16="http://schemas.microsoft.com/office/drawing/2014/main" id="{AED2F882-158B-4D54-AA47-03EDC9BBAC74}"/>
+                <a16:creationId xmlns:a16="http://schemas.microsoft.com/office/drawing/2014/main" id="{C54311EC-7182-433E-9DCC-86F17391F873}"/>
               </a:ext>
             </a:extLst>
           </p:cNvPr>
@@ -5741,7 +5741,7 @@
           <p:cNvPr id="3" name="text-176">
             <a:extLst xmlns:a="http://schemas.openxmlformats.org/drawingml/2006/main">
               <a:ext uri="{FF2B5EF4-FFF2-40B4-BE49-F238E27FC236}">
-                <a16:creationId xmlns:a16="http://schemas.microsoft.com/office/drawing/2014/main" id="{849D29BC-10A8-44FB-98B4-53E691BC708E}"/>
+                <a16:creationId xmlns:a16="http://schemas.microsoft.com/office/drawing/2014/main" id="{11002338-B945-415A-8E2D-169EF953E1F3}"/>
               </a:ext>
             </a:extLst>
           </p:cNvPr>
@@ -5797,7 +5797,7 @@
           <p:cNvPr id="4" name="text-177">
             <a:extLst xmlns:a="http://schemas.openxmlformats.org/drawingml/2006/main">
               <a:ext uri="{FF2B5EF4-FFF2-40B4-BE49-F238E27FC236}">
-                <a16:creationId xmlns:a16="http://schemas.microsoft.com/office/drawing/2014/main" id="{0CA01E1A-EAC5-41EE-8D01-C4D7E7C49EAF}"/>
+                <a16:creationId xmlns:a16="http://schemas.microsoft.com/office/drawing/2014/main" id="{871CBDBD-5C14-461D-B70A-3F14ED8B189E}"/>
               </a:ext>
             </a:extLst>
           </p:cNvPr>
@@ -5853,7 +5853,7 @@
           <p:cNvPr id="5" name="text-178">
             <a:extLst xmlns:a="http://schemas.openxmlformats.org/drawingml/2006/main">
               <a:ext uri="{FF2B5EF4-FFF2-40B4-BE49-F238E27FC236}">
-                <a16:creationId xmlns:a16="http://schemas.microsoft.com/office/drawing/2014/main" id="{06A57ECE-4AB5-4822-9C94-F807FA3A1F47}"/>
+                <a16:creationId xmlns:a16="http://schemas.microsoft.com/office/drawing/2014/main" id="{F49FB5BD-EBB3-4E08-AD3F-3E5CB235CD51}"/>
               </a:ext>
             </a:extLst>
           </p:cNvPr>
@@ -5909,7 +5909,7 @@
           <p:cNvPr id="6" name="text-179">
             <a:extLst xmlns:a="http://schemas.openxmlformats.org/drawingml/2006/main">
               <a:ext uri="{FF2B5EF4-FFF2-40B4-BE49-F238E27FC236}">
-                <a16:creationId xmlns:a16="http://schemas.microsoft.com/office/drawing/2014/main" id="{2026FCB3-54EE-43A7-8735-1F92C5C58D73}"/>
+                <a16:creationId xmlns:a16="http://schemas.microsoft.com/office/drawing/2014/main" id="{4A92FC5F-4083-42C9-B80A-1086BF9BEADF}"/>
               </a:ext>
             </a:extLst>
           </p:cNvPr>
@@ -5965,7 +5965,7 @@
           <p:cNvPr id="7" name="text-180">
             <a:extLst xmlns:a="http://schemas.openxmlformats.org/drawingml/2006/main">
               <a:ext uri="{FF2B5EF4-FFF2-40B4-BE49-F238E27FC236}">
-                <a16:creationId xmlns:a16="http://schemas.microsoft.com/office/drawing/2014/main" id="{D0B64BD7-9089-431C-BF00-4C241937DC28}"/>
+                <a16:creationId xmlns:a16="http://schemas.microsoft.com/office/drawing/2014/main" id="{0D3C8851-4414-4A71-A5BA-D0A875DAE598}"/>
               </a:ext>
             </a:extLst>
           </p:cNvPr>
@@ -6021,7 +6021,7 @@
           <p:cNvPr id="8" name="text-181">
             <a:extLst xmlns:a="http://schemas.openxmlformats.org/drawingml/2006/main">
               <a:ext uri="{FF2B5EF4-FFF2-40B4-BE49-F238E27FC236}">
-                <a16:creationId xmlns:a16="http://schemas.microsoft.com/office/drawing/2014/main" id="{81427581-B9B3-4C96-887B-88F3FCFF89F4}"/>
+                <a16:creationId xmlns:a16="http://schemas.microsoft.com/office/drawing/2014/main" id="{77BB4A10-A209-4363-8254-5CA806EB5FB8}"/>
               </a:ext>
             </a:extLst>
           </p:cNvPr>
@@ -6077,7 +6077,7 @@
           <p:cNvPr id="9" name="text-182">
             <a:extLst xmlns:a="http://schemas.openxmlformats.org/drawingml/2006/main">
               <a:ext uri="{FF2B5EF4-FFF2-40B4-BE49-F238E27FC236}">
-                <a16:creationId xmlns:a16="http://schemas.microsoft.com/office/drawing/2014/main" id="{40A5D830-8400-4687-A74D-31D58F761822}"/>
+                <a16:creationId xmlns:a16="http://schemas.microsoft.com/office/drawing/2014/main" id="{F9ADD1DB-BCF2-4F9C-840E-A603BA9E6F8A}"/>
               </a:ext>
             </a:extLst>
           </p:cNvPr>
@@ -6133,7 +6133,7 @@
           <p:cNvPr id="10" name="text-183">
             <a:extLst xmlns:a="http://schemas.openxmlformats.org/drawingml/2006/main">
               <a:ext uri="{FF2B5EF4-FFF2-40B4-BE49-F238E27FC236}">
-                <a16:creationId xmlns:a16="http://schemas.microsoft.com/office/drawing/2014/main" id="{57251E17-13CA-4C86-9B47-F3D56E55234E}"/>
+                <a16:creationId xmlns:a16="http://schemas.microsoft.com/office/drawing/2014/main" id="{1E9727FA-E4E9-46DC-90F7-44A4415517DC}"/>
               </a:ext>
             </a:extLst>
           </p:cNvPr>
@@ -6235,7 +6235,7 @@
           <p:cNvPr id="11" name="text-184">
             <a:extLst xmlns:a="http://schemas.openxmlformats.org/drawingml/2006/main">
               <a:ext uri="{FF2B5EF4-FFF2-40B4-BE49-F238E27FC236}">
-                <a16:creationId xmlns:a16="http://schemas.microsoft.com/office/drawing/2014/main" id="{692488E3-61AD-49F0-8CB3-E84169E561E6}"/>
+                <a16:creationId xmlns:a16="http://schemas.microsoft.com/office/drawing/2014/main" id="{CEEEB783-FAEB-41C9-B9B0-F48255062105}"/>
               </a:ext>
             </a:extLst>
           </p:cNvPr>
@@ -6337,7 +6337,7 @@
           <p:cNvPr id="12" name="text-185">
             <a:extLst xmlns:a="http://schemas.openxmlformats.org/drawingml/2006/main">
               <a:ext uri="{FF2B5EF4-FFF2-40B4-BE49-F238E27FC236}">
-                <a16:creationId xmlns:a16="http://schemas.microsoft.com/office/drawing/2014/main" id="{5F72090B-B17E-4FAE-981A-151E986A7CC3}"/>
+                <a16:creationId xmlns:a16="http://schemas.microsoft.com/office/drawing/2014/main" id="{2003E75B-0C60-4867-A9D0-4188DC053C7D}"/>
               </a:ext>
             </a:extLst>
           </p:cNvPr>
@@ -6439,7 +6439,7 @@
           <p:cNvPr id="13" name="box-186">
             <a:extLst xmlns:a="http://schemas.openxmlformats.org/drawingml/2006/main">
               <a:ext uri="{FF2B5EF4-FFF2-40B4-BE49-F238E27FC236}">
-                <a16:creationId xmlns:a16="http://schemas.microsoft.com/office/drawing/2014/main" id="{917AA589-A296-4650-B36A-BC87F646491C}"/>
+                <a16:creationId xmlns:a16="http://schemas.microsoft.com/office/drawing/2014/main" id="{241D796C-F329-476B-A8C8-57B6F7FCB35B}"/>
               </a:ext>
             </a:extLst>
           </p:cNvPr>
@@ -6472,7 +6472,7 @@
           <p:cNvPr id="14" name="text-187">
             <a:extLst xmlns:a="http://schemas.openxmlformats.org/drawingml/2006/main">
               <a:ext uri="{FF2B5EF4-FFF2-40B4-BE49-F238E27FC236}">
-                <a16:creationId xmlns:a16="http://schemas.microsoft.com/office/drawing/2014/main" id="{103421F0-4F69-4DB4-B9C0-33F50511FFC1}"/>
+                <a16:creationId xmlns:a16="http://schemas.microsoft.com/office/drawing/2014/main" id="{FD72346C-155D-4427-AEA1-0543A08A417F}"/>
               </a:ext>
             </a:extLst>
           </p:cNvPr>
@@ -6528,7 +6528,7 @@
           <p:cNvPr id="15" name="text-188">
             <a:extLst xmlns:a="http://schemas.openxmlformats.org/drawingml/2006/main">
               <a:ext uri="{FF2B5EF4-FFF2-40B4-BE49-F238E27FC236}">
-                <a16:creationId xmlns:a16="http://schemas.microsoft.com/office/drawing/2014/main" id="{939E1FC9-BEC9-4A06-9D1E-7987E288B1E6}"/>
+                <a16:creationId xmlns:a16="http://schemas.microsoft.com/office/drawing/2014/main" id="{B7C9C7EB-0F5F-402E-AFD8-21A9DEEA1D28}"/>
               </a:ext>
             </a:extLst>
           </p:cNvPr>
@@ -6584,7 +6584,7 @@
           <p:cNvPr id="16" name="text-189">
             <a:extLst xmlns:a="http://schemas.openxmlformats.org/drawingml/2006/main">
               <a:ext uri="{FF2B5EF4-FFF2-40B4-BE49-F238E27FC236}">
-                <a16:creationId xmlns:a16="http://schemas.microsoft.com/office/drawing/2014/main" id="{FA51F38E-7AE1-40E4-B62C-77A26EA613FF}"/>
+                <a16:creationId xmlns:a16="http://schemas.microsoft.com/office/drawing/2014/main" id="{130D5899-3F70-4B1E-8AD7-5ED584DD9B52}"/>
               </a:ext>
             </a:extLst>
           </p:cNvPr>
@@ -6640,7 +6640,7 @@
           <p:cNvPr id="17" name="text-190">
             <a:extLst xmlns:a="http://schemas.openxmlformats.org/drawingml/2006/main">
               <a:ext uri="{FF2B5EF4-FFF2-40B4-BE49-F238E27FC236}">
-                <a16:creationId xmlns:a16="http://schemas.microsoft.com/office/drawing/2014/main" id="{A2C63F1C-16F8-4E4E-AD10-7F9FD2CB1F1B}"/>
+                <a16:creationId xmlns:a16="http://schemas.microsoft.com/office/drawing/2014/main" id="{3EF7474F-AEEA-46BF-BB3F-1F29037F818B}"/>
               </a:ext>
             </a:extLst>
           </p:cNvPr>
@@ -6694,7 +6694,7 @@
     </p:spTree>
     <p:extLst>
       <p:ext uri="{BB962C8B-B14F-4D97-AF65-F5344CB8AC3E}">
-        <p14:creationId xmlns:p14="http://schemas.microsoft.com/office/powerpoint/2010/main" val="1301196440"/>
+        <p14:creationId xmlns:p14="http://schemas.microsoft.com/office/powerpoint/2010/main" val="307167576"/>
       </p:ext>
     </p:extLst>
   </p:cSld>

</xml_diff>